<commit_message>
Original-Firmenlogo in Präsentationsmaster einsetzen
logo-dark.png (schwarz, helle Folien) und logo-light.png (weiß, dunkle
Folien) aus der Original-SVG-Vorlage gerendert und PPTX/POTX neu gebaut.

Co-Authored-By: Claude Fable 5.1 <noreply@anthropic.com>
</commit_message>
<xml_diff>
--- a/presentation/dist/Maiershirts_Master.pptx
+++ b/presentation/dist/Maiershirts_Master.pptx
@@ -1656,7 +1656,7 @@
       </p:grpSpPr>
       <p:pic>
         <p:nvPicPr>
-          <p:cNvPr id="2" name="Image 0" descr="/home/user/lexware-angebot-tool/presentation/assets/logo-light.png">    </p:cNvPr>
+          <p:cNvPr id="2" name="Image 0" descr="/Users/stefanmaier/Documents/GitHub/lexware-angebot-tool/presentation/assets/logo-light.png">    </p:cNvPr>
           <p:cNvPicPr>
             <a:picLocks noChangeAspect="1"/>
           </p:cNvPicPr>
@@ -1863,7 +1863,7 @@
       </p:grpSpPr>
       <p:pic>
         <p:nvPicPr>
-          <p:cNvPr id="2" name="Image 0" descr="/home/user/lexware-angebot-tool/presentation/assets/logo-light.png">    </p:cNvPr>
+          <p:cNvPr id="2" name="Image 0" descr="/Users/stefanmaier/Documents/GitHub/lexware-angebot-tool/presentation/assets/logo-light.png">    </p:cNvPr>
           <p:cNvPicPr>
             <a:picLocks noChangeAspect="1"/>
           </p:cNvPicPr>
@@ -2077,7 +2077,7 @@
       </p:grpSpPr>
       <p:pic>
         <p:nvPicPr>
-          <p:cNvPr id="2" name="Image 0" descr="/home/user/lexware-angebot-tool/presentation/assets/logo-dark.png">    </p:cNvPr>
+          <p:cNvPr id="2" name="Image 0" descr="/Users/stefanmaier/Documents/GitHub/lexware-angebot-tool/presentation/assets/logo-dark.png">    </p:cNvPr>
           <p:cNvPicPr>
             <a:picLocks noChangeAspect="1"/>
           </p:cNvPicPr>
@@ -2279,7 +2279,7 @@
       </p:grpSpPr>
       <p:pic>
         <p:nvPicPr>
-          <p:cNvPr id="2" name="Image 0" descr="/home/user/lexware-angebot-tool/presentation/assets/logo-light.png">    </p:cNvPr>
+          <p:cNvPr id="2" name="Image 0" descr="/Users/stefanmaier/Documents/GitHub/lexware-angebot-tool/presentation/assets/logo-light.png">    </p:cNvPr>
           <p:cNvPicPr>
             <a:picLocks noChangeAspect="1"/>
           </p:cNvPicPr>

</xml_diff>

<commit_message>
Referenzfolie mit Kundenlogos füllen
Logos aus assets/referenzen/ (alphabetisch) werden in die zwölf Felder
eingesetzt, freie Felder bleiben Platzhalter. Sieben Kundenlogos von den
Kunden-Webseiten übernommen.

Co-Authored-By: Claude Fable 5.1 <noreply@anthropic.com>
</commit_message>
<xml_diff>
--- a/presentation/dist/Maiershirts_Master.pptx
+++ b/presentation/dist/Maiershirts_Master.pptx
@@ -940,7 +940,7 @@
           <a:p>
             <a:r>
               <a:rPr lang="en-US" dirty="0"/>
-              <a:t>Layout MS_REFERENZEN: zwölf Logo-Felder. Logo per Klick auf das Platzhalterbild einsetzen; bei Beschnitt: Bildformat → Zuschneiden → Anpassen.</a:t>
+              <a:t>Layout MS_REFERENZEN: zwölf Logo-Felder. 7 Logo(s) aus assets/referenzen eingesetzt. Logo per Klick auf das Platzhalterbild einsetzen; bei Beschnitt: Bildformat → Zuschneiden → Anpassen.</a:t>
             </a:r>
             <a:endParaRPr lang="en-US" dirty="0"/>
           </a:p>
@@ -12314,7 +12314,7 @@
       </p:sp>
       <p:pic>
         <p:nvPicPr>
-          <p:cNvPr id="3" name="Image 0" descr="/var/folders/hm/sgq6d80d0vq133k7n8dc9bnw0000gn/T/maiershirts-sXhBDw/ph-logo-446x194.png">    </p:cNvPr>
+          <p:cNvPr id="3" name="Image 0" descr="/Users/stefanmaier/Documents/GitHub/lexware-angebot-tool/presentation/assets/referenzen/01-seibold.png">    </p:cNvPr>
           <p:cNvPicPr>
             <a:picLocks noChangeAspect="1"/>
           </p:cNvPicPr>
@@ -12324,14 +12324,13 @@
         </p:nvPicPr>
         <p:blipFill>
           <a:blip r:embed="rId1"/>
-          <a:stretch>
-            <a:fillRect/>
-          </a:stretch>
+          <a:srcRect l="0" r="0" t="0" b="0"/>
+          <a:stretch/>
         </p:blipFill>
         <p:spPr>
           <a:xfrm>
             <a:off x="566928" y="1344168"/>
-            <a:ext cx="1700784" cy="740664"/>
+            <a:ext cx="1444752" cy="484632"/>
           </a:xfrm>
           <a:prstGeom prst="rect">
             <a:avLst/>
@@ -12340,7 +12339,7 @@
       </p:pic>
       <p:pic>
         <p:nvPicPr>
-          <p:cNvPr id="4" name="Image 1" descr="/var/folders/hm/sgq6d80d0vq133k7n8dc9bnw0000gn/T/maiershirts-sXhBDw/ph-logo-446x194.png">    </p:cNvPr>
+          <p:cNvPr id="4" name="Image 1" descr="/Users/stefanmaier/Documents/GitHub/lexware-angebot-tool/presentation/assets/referenzen/02-bego-bau.png">    </p:cNvPr>
           <p:cNvPicPr>
             <a:picLocks noChangeAspect="1"/>
           </p:cNvPicPr>
@@ -12350,14 +12349,13 @@
         </p:nvPicPr>
         <p:blipFill>
           <a:blip r:embed="rId2"/>
-          <a:stretch>
-            <a:fillRect/>
-          </a:stretch>
+          <a:srcRect l="0" r="0" t="0" b="0"/>
+          <a:stretch/>
         </p:blipFill>
         <p:spPr>
           <a:xfrm>
             <a:off x="2670048" y="1344168"/>
-            <a:ext cx="1700784" cy="740664"/>
+            <a:ext cx="1444752" cy="484632"/>
           </a:xfrm>
           <a:prstGeom prst="rect">
             <a:avLst/>
@@ -12366,7 +12364,7 @@
       </p:pic>
       <p:pic>
         <p:nvPicPr>
-          <p:cNvPr id="5" name="Image 2" descr="/var/folders/hm/sgq6d80d0vq133k7n8dc9bnw0000gn/T/maiershirts-sXhBDw/ph-logo-446x194.png">    </p:cNvPr>
+          <p:cNvPr id="5" name="Image 2" descr="/Users/stefanmaier/Documents/GitHub/lexware-angebot-tool/presentation/assets/referenzen/03-elektro-stuerz.png">    </p:cNvPr>
           <p:cNvPicPr>
             <a:picLocks noChangeAspect="1"/>
           </p:cNvPicPr>
@@ -12376,14 +12374,13 @@
         </p:nvPicPr>
         <p:blipFill>
           <a:blip r:embed="rId3"/>
-          <a:stretch>
-            <a:fillRect/>
-          </a:stretch>
+          <a:srcRect l="0" r="0" t="0" b="0"/>
+          <a:stretch/>
         </p:blipFill>
         <p:spPr>
           <a:xfrm>
             <a:off x="4773168" y="1344168"/>
-            <a:ext cx="1700784" cy="740664"/>
+            <a:ext cx="1444752" cy="484632"/>
           </a:xfrm>
           <a:prstGeom prst="rect">
             <a:avLst/>
@@ -12392,7 +12389,7 @@
       </p:pic>
       <p:pic>
         <p:nvPicPr>
-          <p:cNvPr id="6" name="Image 3" descr="/var/folders/hm/sgq6d80d0vq133k7n8dc9bnw0000gn/T/maiershirts-sXhBDw/ph-logo-446x194.png">    </p:cNvPr>
+          <p:cNvPr id="6" name="Image 3" descr="/Users/stefanmaier/Documents/GitHub/lexware-angebot-tool/presentation/assets/referenzen/04-dav-tuebingen.jpg">    </p:cNvPr>
           <p:cNvPicPr>
             <a:picLocks noChangeAspect="1"/>
           </p:cNvPicPr>
@@ -12402,14 +12399,13 @@
         </p:nvPicPr>
         <p:blipFill>
           <a:blip r:embed="rId4"/>
-          <a:stretch>
-            <a:fillRect/>
-          </a:stretch>
+          <a:srcRect l="0" r="0" t="0" b="0"/>
+          <a:stretch/>
         </p:blipFill>
         <p:spPr>
           <a:xfrm>
             <a:off x="6876288" y="1344168"/>
-            <a:ext cx="1700784" cy="740664"/>
+            <a:ext cx="1444752" cy="484632"/>
           </a:xfrm>
           <a:prstGeom prst="rect">
             <a:avLst/>
@@ -12418,7 +12414,7 @@
       </p:pic>
       <p:pic>
         <p:nvPicPr>
-          <p:cNvPr id="7" name="Image 4" descr="/var/folders/hm/sgq6d80d0vq133k7n8dc9bnw0000gn/T/maiershirts-sXhBDw/ph-logo-446x194.png">    </p:cNvPr>
+          <p:cNvPr id="7" name="Image 4" descr="/Users/stefanmaier/Documents/GitHub/lexware-angebot-tool/presentation/assets/referenzen/05-rox-herrenberg.jpg">    </p:cNvPr>
           <p:cNvPicPr>
             <a:picLocks noChangeAspect="1"/>
           </p:cNvPicPr>
@@ -12428,14 +12424,13 @@
         </p:nvPicPr>
         <p:blipFill>
           <a:blip r:embed="rId5"/>
-          <a:stretch>
-            <a:fillRect/>
-          </a:stretch>
+          <a:srcRect l="0" r="0" t="0" b="0"/>
+          <a:stretch/>
         </p:blipFill>
         <p:spPr>
           <a:xfrm>
             <a:off x="566928" y="2441448"/>
-            <a:ext cx="1700784" cy="740664"/>
+            <a:ext cx="1444752" cy="484632"/>
           </a:xfrm>
           <a:prstGeom prst="rect">
             <a:avLst/>
@@ -12444,7 +12439,7 @@
       </p:pic>
       <p:pic>
         <p:nvPicPr>
-          <p:cNvPr id="8" name="Image 5" descr="/var/folders/hm/sgq6d80d0vq133k7n8dc9bnw0000gn/T/maiershirts-sXhBDw/ph-logo-446x194.png">    </p:cNvPr>
+          <p:cNvPr id="8" name="Image 5" descr="/Users/stefanmaier/Documents/GitHub/lexware-angebot-tool/presentation/assets/referenzen/06-paarsch-schaefer.png">    </p:cNvPr>
           <p:cNvPicPr>
             <a:picLocks noChangeAspect="1"/>
           </p:cNvPicPr>
@@ -12454,14 +12449,13 @@
         </p:nvPicPr>
         <p:blipFill>
           <a:blip r:embed="rId6"/>
-          <a:stretch>
-            <a:fillRect/>
-          </a:stretch>
+          <a:srcRect l="0" r="0" t="0" b="0"/>
+          <a:stretch/>
         </p:blipFill>
         <p:spPr>
           <a:xfrm>
             <a:off x="2670048" y="2441448"/>
-            <a:ext cx="1700784" cy="740664"/>
+            <a:ext cx="1444752" cy="484632"/>
           </a:xfrm>
           <a:prstGeom prst="rect">
             <a:avLst/>
@@ -12470,7 +12464,7 @@
       </p:pic>
       <p:pic>
         <p:nvPicPr>
-          <p:cNvPr id="9" name="Image 6" descr="/var/folders/hm/sgq6d80d0vq133k7n8dc9bnw0000gn/T/maiershirts-sXhBDw/ph-logo-446x194.png">    </p:cNvPr>
+          <p:cNvPr id="9" name="Image 6" descr="/Users/stefanmaier/Documents/GitHub/lexware-angebot-tool/presentation/assets/referenzen/07-suedweststrom.png">    </p:cNvPr>
           <p:cNvPicPr>
             <a:picLocks noChangeAspect="1"/>
           </p:cNvPicPr>
@@ -12480,14 +12474,13 @@
         </p:nvPicPr>
         <p:blipFill>
           <a:blip r:embed="rId7"/>
-          <a:stretch>
-            <a:fillRect/>
-          </a:stretch>
+          <a:srcRect l="0" r="0" t="0" b="0"/>
+          <a:stretch/>
         </p:blipFill>
         <p:spPr>
           <a:xfrm>
             <a:off x="4773168" y="2441448"/>
-            <a:ext cx="1700784" cy="740664"/>
+            <a:ext cx="1444752" cy="484632"/>
           </a:xfrm>
           <a:prstGeom prst="rect">
             <a:avLst/>
@@ -12496,7 +12489,7 @@
       </p:pic>
       <p:pic>
         <p:nvPicPr>
-          <p:cNvPr id="10" name="Image 7" descr="/var/folders/hm/sgq6d80d0vq133k7n8dc9bnw0000gn/T/maiershirts-sXhBDw/ph-logo-446x194.png">    </p:cNvPr>
+          <p:cNvPr id="10" name="Image 7" descr="/var/folders/hm/sgq6d80d0vq133k7n8dc9bnw0000gn/T/maiershirts-HMJAPF/ph-logo-446x194.png">    </p:cNvPr>
           <p:cNvPicPr>
             <a:picLocks noChangeAspect="1"/>
           </p:cNvPicPr>
@@ -12522,7 +12515,7 @@
       </p:pic>
       <p:pic>
         <p:nvPicPr>
-          <p:cNvPr id="11" name="Image 8" descr="/var/folders/hm/sgq6d80d0vq133k7n8dc9bnw0000gn/T/maiershirts-sXhBDw/ph-logo-446x194.png">    </p:cNvPr>
+          <p:cNvPr id="11" name="Image 8" descr="/var/folders/hm/sgq6d80d0vq133k7n8dc9bnw0000gn/T/maiershirts-HMJAPF/ph-logo-446x194.png">    </p:cNvPr>
           <p:cNvPicPr>
             <a:picLocks noChangeAspect="1"/>
           </p:cNvPicPr>
@@ -12548,7 +12541,7 @@
       </p:pic>
       <p:pic>
         <p:nvPicPr>
-          <p:cNvPr id="12" name="Image 9" descr="/var/folders/hm/sgq6d80d0vq133k7n8dc9bnw0000gn/T/maiershirts-sXhBDw/ph-logo-446x194.png">    </p:cNvPr>
+          <p:cNvPr id="12" name="Image 9" descr="/var/folders/hm/sgq6d80d0vq133k7n8dc9bnw0000gn/T/maiershirts-HMJAPF/ph-logo-446x194.png">    </p:cNvPr>
           <p:cNvPicPr>
             <a:picLocks noChangeAspect="1"/>
           </p:cNvPicPr>
@@ -12574,7 +12567,7 @@
       </p:pic>
       <p:pic>
         <p:nvPicPr>
-          <p:cNvPr id="13" name="Image 10" descr="/var/folders/hm/sgq6d80d0vq133k7n8dc9bnw0000gn/T/maiershirts-sXhBDw/ph-logo-446x194.png">    </p:cNvPr>
+          <p:cNvPr id="13" name="Image 10" descr="/var/folders/hm/sgq6d80d0vq133k7n8dc9bnw0000gn/T/maiershirts-HMJAPF/ph-logo-446x194.png">    </p:cNvPr>
           <p:cNvPicPr>
             <a:picLocks noChangeAspect="1"/>
           </p:cNvPicPr>
@@ -12600,7 +12593,7 @@
       </p:pic>
       <p:pic>
         <p:nvPicPr>
-          <p:cNvPr id="14" name="Image 11" descr="/var/folders/hm/sgq6d80d0vq133k7n8dc9bnw0000gn/T/maiershirts-sXhBDw/ph-logo-446x194.png">    </p:cNvPr>
+          <p:cNvPr id="14" name="Image 11" descr="/var/folders/hm/sgq6d80d0vq133k7n8dc9bnw0000gn/T/maiershirts-HMJAPF/ph-logo-446x194.png">    </p:cNvPr>
           <p:cNvPicPr>
             <a:picLocks noChangeAspect="1"/>
           </p:cNvPicPr>
@@ -12740,7 +12733,7 @@
       </p:sp>
       <p:pic>
         <p:nvPicPr>
-          <p:cNvPr id="3" name="Image 0" descr="/var/folders/hm/sgq6d80d0vq133k7n8dc9bnw0000gn/T/maiershirts-sXhBDw/ph-foto-1056x840.png">    </p:cNvPr>
+          <p:cNvPr id="3" name="Image 0" descr="/var/folders/hm/sgq6d80d0vq133k7n8dc9bnw0000gn/T/maiershirts-HMJAPF/ph-foto-1056x840.png">    </p:cNvPr>
           <p:cNvPicPr>
             <a:picLocks noChangeAspect="1"/>
           </p:cNvPicPr>
@@ -13552,7 +13545,7 @@
       </p:sp>
       <p:pic>
         <p:nvPicPr>
-          <p:cNvPr id="4" name="Image 0" descr="/var/folders/hm/sgq6d80d0vq133k7n8dc9bnw0000gn/T/maiershirts-sXhBDw/ph-portrait-252x252.png">    </p:cNvPr>
+          <p:cNvPr id="4" name="Image 0" descr="/var/folders/hm/sgq6d80d0vq133k7n8dc9bnw0000gn/T/maiershirts-HMJAPF/ph-portrait-252x252.png">    </p:cNvPr>
           <p:cNvPicPr>
             <a:picLocks noChangeAspect="1"/>
           </p:cNvPicPr>
@@ -13761,7 +13754,7 @@
       </p:sp>
       <p:pic>
         <p:nvPicPr>
-          <p:cNvPr id="9" name="Image 1" descr="/var/folders/hm/sgq6d80d0vq133k7n8dc9bnw0000gn/T/maiershirts-sXhBDw/ph-qr-240x240.png">    </p:cNvPr>
+          <p:cNvPr id="9" name="Image 1" descr="/var/folders/hm/sgq6d80d0vq133k7n8dc9bnw0000gn/T/maiershirts-HMJAPF/ph-qr-240x240.png">    </p:cNvPr>
           <p:cNvPicPr>
             <a:picLocks noChangeAspect="1"/>
           </p:cNvPicPr>
@@ -15177,7 +15170,7 @@
       </p:grpSpPr>
       <p:pic>
         <p:nvPicPr>
-          <p:cNvPr id="2" name="Image 0" descr="/var/folders/hm/sgq6d80d0vq133k7n8dc9bnw0000gn/T/maiershirts-sXhBDw/ph-foto-2400x1008.png">    </p:cNvPr>
+          <p:cNvPr id="2" name="Image 0" descr="/var/folders/hm/sgq6d80d0vq133k7n8dc9bnw0000gn/T/maiershirts-HMJAPF/ph-foto-2400x1008.png">    </p:cNvPr>
           <p:cNvPicPr>
             <a:picLocks noChangeAspect="1"/>
           </p:cNvPicPr>
@@ -16335,7 +16328,7 @@
       </p:sp>
       <p:pic>
         <p:nvPicPr>
-          <p:cNvPr id="3" name="Image 0" descr="/var/folders/hm/sgq6d80d0vq133k7n8dc9bnw0000gn/T/maiershirts-sXhBDw/ph-foto-696x456.png">    </p:cNvPr>
+          <p:cNvPr id="3" name="Image 0" descr="/var/folders/hm/sgq6d80d0vq133k7n8dc9bnw0000gn/T/maiershirts-HMJAPF/ph-foto-696x456.png">    </p:cNvPr>
           <p:cNvPicPr>
             <a:picLocks noChangeAspect="1"/>
           </p:cNvPicPr>
@@ -16505,7 +16498,7 @@
       </p:sp>
       <p:pic>
         <p:nvPicPr>
-          <p:cNvPr id="7" name="Image 1" descr="/var/folders/hm/sgq6d80d0vq133k7n8dc9bnw0000gn/T/maiershirts-sXhBDw/ph-foto-696x456.png">    </p:cNvPr>
+          <p:cNvPr id="7" name="Image 1" descr="/var/folders/hm/sgq6d80d0vq133k7n8dc9bnw0000gn/T/maiershirts-HMJAPF/ph-foto-696x456.png">    </p:cNvPr>
           <p:cNvPicPr>
             <a:picLocks noChangeAspect="1"/>
           </p:cNvPicPr>
@@ -16675,7 +16668,7 @@
       </p:sp>
       <p:pic>
         <p:nvPicPr>
-          <p:cNvPr id="11" name="Image 2" descr="/var/folders/hm/sgq6d80d0vq133k7n8dc9bnw0000gn/T/maiershirts-sXhBDw/ph-foto-696x456.png">    </p:cNvPr>
+          <p:cNvPr id="11" name="Image 2" descr="/var/folders/hm/sgq6d80d0vq133k7n8dc9bnw0000gn/T/maiershirts-HMJAPF/ph-foto-696x456.png">    </p:cNvPr>
           <p:cNvPicPr>
             <a:picLocks noChangeAspect="1"/>
           </p:cNvPicPr>

</xml_diff>

<commit_message>
Referenzfolie: Gottlieb Binder, Emin Isic Montagebau, Karnick ergänzen
Co-Authored-By: Claude Fable 5.1 <noreply@anthropic.com>
</commit_message>
<xml_diff>
--- a/presentation/dist/Maiershirts_Master.pptx
+++ b/presentation/dist/Maiershirts_Master.pptx
@@ -940,7 +940,7 @@
           <a:p>
             <a:r>
               <a:rPr lang="en-US" dirty="0"/>
-              <a:t>Layout MS_REFERENZEN: zwölf Logo-Felder. 7 Logo(s) aus assets/referenzen eingesetzt. Logo per Klick auf das Platzhalterbild einsetzen; bei Beschnitt: Bildformat → Zuschneiden → Anpassen.</a:t>
+              <a:t>Layout MS_REFERENZEN: zwölf Logo-Felder. 10 Logo(s) aus assets/referenzen eingesetzt. Logo per Klick auf das Platzhalterbild einsetzen; bei Beschnitt: Bildformat → Zuschneiden → Anpassen.</a:t>
             </a:r>
             <a:endParaRPr lang="en-US" dirty="0"/>
           </a:p>
@@ -12489,7 +12489,7 @@
       </p:pic>
       <p:pic>
         <p:nvPicPr>
-          <p:cNvPr id="10" name="Image 7" descr="/var/folders/hm/sgq6d80d0vq133k7n8dc9bnw0000gn/T/maiershirts-HMJAPF/ph-logo-446x194.png">    </p:cNvPr>
+          <p:cNvPr id="10" name="Image 7" descr="/Users/stefanmaier/Documents/GitHub/lexware-angebot-tool/presentation/assets/referenzen/08-gottlieb-binder.png">    </p:cNvPr>
           <p:cNvPicPr>
             <a:picLocks noChangeAspect="1"/>
           </p:cNvPicPr>
@@ -12499,14 +12499,13 @@
         </p:nvPicPr>
         <p:blipFill>
           <a:blip r:embed="rId8"/>
-          <a:stretch>
-            <a:fillRect/>
-          </a:stretch>
+          <a:srcRect l="0" r="0" t="0" b="0"/>
+          <a:stretch/>
         </p:blipFill>
         <p:spPr>
           <a:xfrm>
             <a:off x="6876288" y="2441448"/>
-            <a:ext cx="1700784" cy="740664"/>
+            <a:ext cx="1444752" cy="484632"/>
           </a:xfrm>
           <a:prstGeom prst="rect">
             <a:avLst/>
@@ -12515,7 +12514,7 @@
       </p:pic>
       <p:pic>
         <p:nvPicPr>
-          <p:cNvPr id="11" name="Image 8" descr="/var/folders/hm/sgq6d80d0vq133k7n8dc9bnw0000gn/T/maiershirts-HMJAPF/ph-logo-446x194.png">    </p:cNvPr>
+          <p:cNvPr id="11" name="Image 8" descr="/Users/stefanmaier/Documents/GitHub/lexware-angebot-tool/presentation/assets/referenzen/09-emin-isic.png">    </p:cNvPr>
           <p:cNvPicPr>
             <a:picLocks noChangeAspect="1"/>
           </p:cNvPicPr>
@@ -12525,14 +12524,13 @@
         </p:nvPicPr>
         <p:blipFill>
           <a:blip r:embed="rId9"/>
-          <a:stretch>
-            <a:fillRect/>
-          </a:stretch>
+          <a:srcRect l="0" r="0" t="0" b="0"/>
+          <a:stretch/>
         </p:blipFill>
         <p:spPr>
           <a:xfrm>
             <a:off x="566928" y="3538728"/>
-            <a:ext cx="1700784" cy="740664"/>
+            <a:ext cx="1444752" cy="484632"/>
           </a:xfrm>
           <a:prstGeom prst="rect">
             <a:avLst/>
@@ -12541,7 +12539,7 @@
       </p:pic>
       <p:pic>
         <p:nvPicPr>
-          <p:cNvPr id="12" name="Image 9" descr="/var/folders/hm/sgq6d80d0vq133k7n8dc9bnw0000gn/T/maiershirts-HMJAPF/ph-logo-446x194.png">    </p:cNvPr>
+          <p:cNvPr id="12" name="Image 9" descr="/Users/stefanmaier/Documents/GitHub/lexware-angebot-tool/presentation/assets/referenzen/10-karnick.png">    </p:cNvPr>
           <p:cNvPicPr>
             <a:picLocks noChangeAspect="1"/>
           </p:cNvPicPr>
@@ -12551,14 +12549,13 @@
         </p:nvPicPr>
         <p:blipFill>
           <a:blip r:embed="rId10"/>
-          <a:stretch>
-            <a:fillRect/>
-          </a:stretch>
+          <a:srcRect l="0" r="0" t="0" b="0"/>
+          <a:stretch/>
         </p:blipFill>
         <p:spPr>
           <a:xfrm>
             <a:off x="2670048" y="3538728"/>
-            <a:ext cx="1700784" cy="740664"/>
+            <a:ext cx="1444752" cy="484632"/>
           </a:xfrm>
           <a:prstGeom prst="rect">
             <a:avLst/>
@@ -12567,7 +12564,7 @@
       </p:pic>
       <p:pic>
         <p:nvPicPr>
-          <p:cNvPr id="13" name="Image 10" descr="/var/folders/hm/sgq6d80d0vq133k7n8dc9bnw0000gn/T/maiershirts-HMJAPF/ph-logo-446x194.png">    </p:cNvPr>
+          <p:cNvPr id="13" name="Image 10" descr="/var/folders/hm/sgq6d80d0vq133k7n8dc9bnw0000gn/T/maiershirts-xNybMV/ph-logo-446x194.png">    </p:cNvPr>
           <p:cNvPicPr>
             <a:picLocks noChangeAspect="1"/>
           </p:cNvPicPr>
@@ -12593,7 +12590,7 @@
       </p:pic>
       <p:pic>
         <p:nvPicPr>
-          <p:cNvPr id="14" name="Image 11" descr="/var/folders/hm/sgq6d80d0vq133k7n8dc9bnw0000gn/T/maiershirts-HMJAPF/ph-logo-446x194.png">    </p:cNvPr>
+          <p:cNvPr id="14" name="Image 11" descr="/var/folders/hm/sgq6d80d0vq133k7n8dc9bnw0000gn/T/maiershirts-xNybMV/ph-logo-446x194.png">    </p:cNvPr>
           <p:cNvPicPr>
             <a:picLocks noChangeAspect="1"/>
           </p:cNvPicPr>
@@ -12733,7 +12730,7 @@
       </p:sp>
       <p:pic>
         <p:nvPicPr>
-          <p:cNvPr id="3" name="Image 0" descr="/var/folders/hm/sgq6d80d0vq133k7n8dc9bnw0000gn/T/maiershirts-HMJAPF/ph-foto-1056x840.png">    </p:cNvPr>
+          <p:cNvPr id="3" name="Image 0" descr="/var/folders/hm/sgq6d80d0vq133k7n8dc9bnw0000gn/T/maiershirts-xNybMV/ph-foto-1056x840.png">    </p:cNvPr>
           <p:cNvPicPr>
             <a:picLocks noChangeAspect="1"/>
           </p:cNvPicPr>
@@ -13545,7 +13542,7 @@
       </p:sp>
       <p:pic>
         <p:nvPicPr>
-          <p:cNvPr id="4" name="Image 0" descr="/var/folders/hm/sgq6d80d0vq133k7n8dc9bnw0000gn/T/maiershirts-HMJAPF/ph-portrait-252x252.png">    </p:cNvPr>
+          <p:cNvPr id="4" name="Image 0" descr="/var/folders/hm/sgq6d80d0vq133k7n8dc9bnw0000gn/T/maiershirts-xNybMV/ph-portrait-252x252.png">    </p:cNvPr>
           <p:cNvPicPr>
             <a:picLocks noChangeAspect="1"/>
           </p:cNvPicPr>
@@ -13754,7 +13751,7 @@
       </p:sp>
       <p:pic>
         <p:nvPicPr>
-          <p:cNvPr id="9" name="Image 1" descr="/var/folders/hm/sgq6d80d0vq133k7n8dc9bnw0000gn/T/maiershirts-HMJAPF/ph-qr-240x240.png">    </p:cNvPr>
+          <p:cNvPr id="9" name="Image 1" descr="/var/folders/hm/sgq6d80d0vq133k7n8dc9bnw0000gn/T/maiershirts-xNybMV/ph-qr-240x240.png">    </p:cNvPr>
           <p:cNvPicPr>
             <a:picLocks noChangeAspect="1"/>
           </p:cNvPicPr>
@@ -15170,7 +15167,7 @@
       </p:grpSpPr>
       <p:pic>
         <p:nvPicPr>
-          <p:cNvPr id="2" name="Image 0" descr="/var/folders/hm/sgq6d80d0vq133k7n8dc9bnw0000gn/T/maiershirts-HMJAPF/ph-foto-2400x1008.png">    </p:cNvPr>
+          <p:cNvPr id="2" name="Image 0" descr="/var/folders/hm/sgq6d80d0vq133k7n8dc9bnw0000gn/T/maiershirts-xNybMV/ph-foto-2400x1008.png">    </p:cNvPr>
           <p:cNvPicPr>
             <a:picLocks noChangeAspect="1"/>
           </p:cNvPicPr>
@@ -16328,7 +16325,7 @@
       </p:sp>
       <p:pic>
         <p:nvPicPr>
-          <p:cNvPr id="3" name="Image 0" descr="/var/folders/hm/sgq6d80d0vq133k7n8dc9bnw0000gn/T/maiershirts-HMJAPF/ph-foto-696x456.png">    </p:cNvPr>
+          <p:cNvPr id="3" name="Image 0" descr="/var/folders/hm/sgq6d80d0vq133k7n8dc9bnw0000gn/T/maiershirts-xNybMV/ph-foto-696x456.png">    </p:cNvPr>
           <p:cNvPicPr>
             <a:picLocks noChangeAspect="1"/>
           </p:cNvPicPr>
@@ -16498,7 +16495,7 @@
       </p:sp>
       <p:pic>
         <p:nvPicPr>
-          <p:cNvPr id="7" name="Image 1" descr="/var/folders/hm/sgq6d80d0vq133k7n8dc9bnw0000gn/T/maiershirts-HMJAPF/ph-foto-696x456.png">    </p:cNvPr>
+          <p:cNvPr id="7" name="Image 1" descr="/var/folders/hm/sgq6d80d0vq133k7n8dc9bnw0000gn/T/maiershirts-xNybMV/ph-foto-696x456.png">    </p:cNvPr>
           <p:cNvPicPr>
             <a:picLocks noChangeAspect="1"/>
           </p:cNvPicPr>
@@ -16668,7 +16665,7 @@
       </p:sp>
       <p:pic>
         <p:nvPicPr>
-          <p:cNvPr id="11" name="Image 2" descr="/var/folders/hm/sgq6d80d0vq133k7n8dc9bnw0000gn/T/maiershirts-HMJAPF/ph-foto-696x456.png">    </p:cNvPr>
+          <p:cNvPr id="11" name="Image 2" descr="/var/folders/hm/sgq6d80d0vq133k7n8dc9bnw0000gn/T/maiershirts-xNybMV/ph-foto-696x456.png">    </p:cNvPr>
           <p:cNvPicPr>
             <a:picLocks noChangeAspect="1"/>
           </p:cNvPicPr>

</xml_diff>

<commit_message>
Referenzfolie: Logos proportional zentriert, TC Ammerbuch ergänzen
Logos werden vor dem Einpassen beschnitten, anhand ihrer Bildmaße
proportional in die Felder eingepasst und zentriert. pptxgenjs übernimmt
bei platzhaltergebundenen Bildern die Platzhalterposition, deshalb wird
die zentrierte Position beim Nachbearbeiten des Pakets nachgetragen.

Co-Authored-By: Claude Fable 5.1 <noreply@anthropic.com>
</commit_message>
<xml_diff>
--- a/presentation/dist/Maiershirts_Master.pptx
+++ b/presentation/dist/Maiershirts_Master.pptx
@@ -940,7 +940,7 @@
           <a:p>
             <a:r>
               <a:rPr lang="en-US" dirty="0"/>
-              <a:t>Layout MS_REFERENZEN: zwölf Logo-Felder. 10 Logo(s) aus assets/referenzen eingesetzt. Logo per Klick auf das Platzhalterbild einsetzen; bei Beschnitt: Bildformat → Zuschneiden → Anpassen.</a:t>
+              <a:t>Layout MS_REFERENZEN: zwölf Logo-Felder. 11 Logo(s) aus assets/referenzen eingesetzt. Logo per Klick auf das Platzhalterbild einsetzen; bei Beschnitt: Bildformat → Zuschneiden → Anpassen.</a:t>
             </a:r>
             <a:endParaRPr lang="en-US" dirty="0"/>
           </a:p>
@@ -12314,7 +12314,7 @@
       </p:sp>
       <p:pic>
         <p:nvPicPr>
-          <p:cNvPr id="3" name="Image 0" descr="/Users/stefanmaier/Documents/GitHub/lexware-angebot-tool/presentation/assets/referenzen/01-seibold.png">    </p:cNvPr>
+          <p:cNvPr id="3" name="Image 0" descr="/var/folders/hm/sgq6d80d0vq133k7n8dc9bnw0000gn/T/maiershirts-dzZNxb/ref-0.png">    </p:cNvPr>
           <p:cNvPicPr>
             <a:picLocks noChangeAspect="1"/>
           </p:cNvPicPr>
@@ -12324,13 +12324,14 @@
         </p:nvPicPr>
         <p:blipFill>
           <a:blip r:embed="rId1"/>
-          <a:srcRect l="0" r="0" t="0" b="0"/>
-          <a:stretch/>
+          <a:stretch>
+            <a:fillRect/>
+          </a:stretch>
         </p:blipFill>
         <p:spPr>
           <a:xfrm>
-            <a:off x="566928" y="1344168"/>
-            <a:ext cx="1444752" cy="484632"/>
+            <a:off x="713232" y="1519438"/>
+            <a:ext cx="1408176" cy="390124"/>
           </a:xfrm>
           <a:prstGeom prst="rect">
             <a:avLst/>
@@ -12339,7 +12340,7 @@
       </p:pic>
       <p:pic>
         <p:nvPicPr>
-          <p:cNvPr id="4" name="Image 1" descr="/Users/stefanmaier/Documents/GitHub/lexware-angebot-tool/presentation/assets/referenzen/02-bego-bau.png">    </p:cNvPr>
+          <p:cNvPr id="4" name="Image 1" descr="/var/folders/hm/sgq6d80d0vq133k7n8dc9bnw0000gn/T/maiershirts-dzZNxb/ref-1.png">    </p:cNvPr>
           <p:cNvPicPr>
             <a:picLocks noChangeAspect="1"/>
           </p:cNvPicPr>
@@ -12349,13 +12350,14 @@
         </p:nvPicPr>
         <p:blipFill>
           <a:blip r:embed="rId2"/>
-          <a:srcRect l="0" r="0" t="0" b="0"/>
-          <a:stretch/>
+          <a:stretch>
+            <a:fillRect/>
+          </a:stretch>
         </p:blipFill>
         <p:spPr>
           <a:xfrm>
-            <a:off x="2670048" y="1344168"/>
-            <a:ext cx="1444752" cy="484632"/>
+            <a:off x="2816352" y="1607820"/>
+            <a:ext cx="1408176" cy="213360"/>
           </a:xfrm>
           <a:prstGeom prst="rect">
             <a:avLst/>
@@ -12364,7 +12366,7 @@
       </p:pic>
       <p:pic>
         <p:nvPicPr>
-          <p:cNvPr id="5" name="Image 2" descr="/Users/stefanmaier/Documents/GitHub/lexware-angebot-tool/presentation/assets/referenzen/03-elektro-stuerz.png">    </p:cNvPr>
+          <p:cNvPr id="5" name="Image 2" descr="/var/folders/hm/sgq6d80d0vq133k7n8dc9bnw0000gn/T/maiershirts-dzZNxb/ref-2.png">    </p:cNvPr>
           <p:cNvPicPr>
             <a:picLocks noChangeAspect="1"/>
           </p:cNvPicPr>
@@ -12374,13 +12376,14 @@
         </p:nvPicPr>
         <p:blipFill>
           <a:blip r:embed="rId3"/>
-          <a:srcRect l="0" r="0" t="0" b="0"/>
-          <a:stretch/>
+          <a:stretch>
+            <a:fillRect/>
+          </a:stretch>
         </p:blipFill>
         <p:spPr>
           <a:xfrm>
-            <a:off x="4773168" y="1344168"/>
-            <a:ext cx="1444752" cy="484632"/>
+            <a:off x="4919472" y="1562265"/>
+            <a:ext cx="1408176" cy="304470"/>
           </a:xfrm>
           <a:prstGeom prst="rect">
             <a:avLst/>
@@ -12389,7 +12392,7 @@
       </p:pic>
       <p:pic>
         <p:nvPicPr>
-          <p:cNvPr id="6" name="Image 3" descr="/Users/stefanmaier/Documents/GitHub/lexware-angebot-tool/presentation/assets/referenzen/04-dav-tuebingen.jpg">    </p:cNvPr>
+          <p:cNvPr id="6" name="Image 3" descr="/var/folders/hm/sgq6d80d0vq133k7n8dc9bnw0000gn/T/maiershirts-dzZNxb/ref-3.png">    </p:cNvPr>
           <p:cNvPicPr>
             <a:picLocks noChangeAspect="1"/>
           </p:cNvPicPr>
@@ -12399,13 +12402,14 @@
         </p:nvPicPr>
         <p:blipFill>
           <a:blip r:embed="rId4"/>
-          <a:srcRect l="0" r="0" t="0" b="0"/>
-          <a:stretch/>
+          <a:stretch>
+            <a:fillRect/>
+          </a:stretch>
         </p:blipFill>
         <p:spPr>
           <a:xfrm>
-            <a:off x="6876288" y="1344168"/>
-            <a:ext cx="1444752" cy="484632"/>
+            <a:off x="7341461" y="1490472"/>
+            <a:ext cx="770438" cy="448056"/>
           </a:xfrm>
           <a:prstGeom prst="rect">
             <a:avLst/>
@@ -12414,7 +12418,7 @@
       </p:pic>
       <p:pic>
         <p:nvPicPr>
-          <p:cNvPr id="7" name="Image 4" descr="/Users/stefanmaier/Documents/GitHub/lexware-angebot-tool/presentation/assets/referenzen/05-rox-herrenberg.jpg">    </p:cNvPr>
+          <p:cNvPr id="7" name="Image 4" descr="/var/folders/hm/sgq6d80d0vq133k7n8dc9bnw0000gn/T/maiershirts-dzZNxb/ref-4.png">    </p:cNvPr>
           <p:cNvPicPr>
             <a:picLocks noChangeAspect="1"/>
           </p:cNvPicPr>
@@ -12424,13 +12428,14 @@
         </p:nvPicPr>
         <p:blipFill>
           <a:blip r:embed="rId5"/>
-          <a:srcRect l="0" r="0" t="0" b="0"/>
-          <a:stretch/>
+          <a:stretch>
+            <a:fillRect/>
+          </a:stretch>
         </p:blipFill>
         <p:spPr>
           <a:xfrm>
-            <a:off x="566928" y="2441448"/>
-            <a:ext cx="1444752" cy="484632"/>
+            <a:off x="972998" y="2587752"/>
+            <a:ext cx="888644" cy="448056"/>
           </a:xfrm>
           <a:prstGeom prst="rect">
             <a:avLst/>
@@ -12439,7 +12444,7 @@
       </p:pic>
       <p:pic>
         <p:nvPicPr>
-          <p:cNvPr id="8" name="Image 5" descr="/Users/stefanmaier/Documents/GitHub/lexware-angebot-tool/presentation/assets/referenzen/06-paarsch-schaefer.png">    </p:cNvPr>
+          <p:cNvPr id="8" name="Image 5" descr="/var/folders/hm/sgq6d80d0vq133k7n8dc9bnw0000gn/T/maiershirts-dzZNxb/ref-5.png">    </p:cNvPr>
           <p:cNvPicPr>
             <a:picLocks noChangeAspect="1"/>
           </p:cNvPicPr>
@@ -12449,13 +12454,14 @@
         </p:nvPicPr>
         <p:blipFill>
           <a:blip r:embed="rId6"/>
-          <a:srcRect l="0" r="0" t="0" b="0"/>
-          <a:stretch/>
+          <a:stretch>
+            <a:fillRect/>
+          </a:stretch>
         </p:blipFill>
         <p:spPr>
           <a:xfrm>
-            <a:off x="2670048" y="2441448"/>
-            <a:ext cx="1444752" cy="484632"/>
+            <a:off x="2967838" y="2587752"/>
+            <a:ext cx="1105205" cy="448056"/>
           </a:xfrm>
           <a:prstGeom prst="rect">
             <a:avLst/>
@@ -12464,7 +12470,7 @@
       </p:pic>
       <p:pic>
         <p:nvPicPr>
-          <p:cNvPr id="9" name="Image 6" descr="/Users/stefanmaier/Documents/GitHub/lexware-angebot-tool/presentation/assets/referenzen/07-suedweststrom.png">    </p:cNvPr>
+          <p:cNvPr id="9" name="Image 6" descr="/var/folders/hm/sgq6d80d0vq133k7n8dc9bnw0000gn/T/maiershirts-dzZNxb/ref-6.png">    </p:cNvPr>
           <p:cNvPicPr>
             <a:picLocks noChangeAspect="1"/>
           </p:cNvPicPr>
@@ -12474,13 +12480,14 @@
         </p:nvPicPr>
         <p:blipFill>
           <a:blip r:embed="rId7"/>
-          <a:srcRect l="0" r="0" t="0" b="0"/>
-          <a:stretch/>
+          <a:stretch>
+            <a:fillRect/>
+          </a:stretch>
         </p:blipFill>
         <p:spPr>
           <a:xfrm>
-            <a:off x="4773168" y="2441448"/>
-            <a:ext cx="1444752" cy="484632"/>
+            <a:off x="5296660" y="2587752"/>
+            <a:ext cx="653799" cy="448056"/>
           </a:xfrm>
           <a:prstGeom prst="rect">
             <a:avLst/>
@@ -12489,7 +12496,7 @@
       </p:pic>
       <p:pic>
         <p:nvPicPr>
-          <p:cNvPr id="10" name="Image 7" descr="/Users/stefanmaier/Documents/GitHub/lexware-angebot-tool/presentation/assets/referenzen/08-gottlieb-binder.png">    </p:cNvPr>
+          <p:cNvPr id="10" name="Image 7" descr="/var/folders/hm/sgq6d80d0vq133k7n8dc9bnw0000gn/T/maiershirts-dzZNxb/ref-7.png">    </p:cNvPr>
           <p:cNvPicPr>
             <a:picLocks noChangeAspect="1"/>
           </p:cNvPicPr>
@@ -12499,13 +12506,14 @@
         </p:nvPicPr>
         <p:blipFill>
           <a:blip r:embed="rId8"/>
-          <a:srcRect l="0" r="0" t="0" b="0"/>
-          <a:stretch/>
+          <a:stretch>
+            <a:fillRect/>
+          </a:stretch>
         </p:blipFill>
         <p:spPr>
           <a:xfrm>
-            <a:off x="6876288" y="2441448"/>
-            <a:ext cx="1444752" cy="484632"/>
+            <a:off x="7067042" y="2587752"/>
+            <a:ext cx="1319276" cy="448056"/>
           </a:xfrm>
           <a:prstGeom prst="rect">
             <a:avLst/>
@@ -12514,7 +12522,7 @@
       </p:pic>
       <p:pic>
         <p:nvPicPr>
-          <p:cNvPr id="11" name="Image 8" descr="/Users/stefanmaier/Documents/GitHub/lexware-angebot-tool/presentation/assets/referenzen/09-emin-isic.png">    </p:cNvPr>
+          <p:cNvPr id="11" name="Image 8" descr="/var/folders/hm/sgq6d80d0vq133k7n8dc9bnw0000gn/T/maiershirts-dzZNxb/ref-8.png">    </p:cNvPr>
           <p:cNvPicPr>
             <a:picLocks noChangeAspect="1"/>
           </p:cNvPicPr>
@@ -12524,13 +12532,14 @@
         </p:nvPicPr>
         <p:blipFill>
           <a:blip r:embed="rId9"/>
-          <a:srcRect l="0" r="0" t="0" b="0"/>
-          <a:stretch/>
+          <a:stretch>
+            <a:fillRect/>
+          </a:stretch>
         </p:blipFill>
         <p:spPr>
           <a:xfrm>
-            <a:off x="566928" y="3538728"/>
-            <a:ext cx="1444752" cy="484632"/>
+            <a:off x="1150941" y="3685032"/>
+            <a:ext cx="532758" cy="448056"/>
           </a:xfrm>
           <a:prstGeom prst="rect">
             <a:avLst/>
@@ -12539,7 +12548,7 @@
       </p:pic>
       <p:pic>
         <p:nvPicPr>
-          <p:cNvPr id="12" name="Image 9" descr="/Users/stefanmaier/Documents/GitHub/lexware-angebot-tool/presentation/assets/referenzen/10-karnick.png">    </p:cNvPr>
+          <p:cNvPr id="12" name="Image 9" descr="/var/folders/hm/sgq6d80d0vq133k7n8dc9bnw0000gn/T/maiershirts-dzZNxb/ref-9.png">    </p:cNvPr>
           <p:cNvPicPr>
             <a:picLocks noChangeAspect="1"/>
           </p:cNvPicPr>
@@ -12549,13 +12558,14 @@
         </p:nvPicPr>
         <p:blipFill>
           <a:blip r:embed="rId10"/>
-          <a:srcRect l="0" r="0" t="0" b="0"/>
-          <a:stretch/>
+          <a:stretch>
+            <a:fillRect/>
+          </a:stretch>
         </p:blipFill>
         <p:spPr>
           <a:xfrm>
-            <a:off x="2670048" y="3538728"/>
-            <a:ext cx="1444752" cy="484632"/>
+            <a:off x="3017937" y="3685032"/>
+            <a:ext cx="1005007" cy="448056"/>
           </a:xfrm>
           <a:prstGeom prst="rect">
             <a:avLst/>
@@ -12564,7 +12574,7 @@
       </p:pic>
       <p:pic>
         <p:nvPicPr>
-          <p:cNvPr id="13" name="Image 10" descr="/var/folders/hm/sgq6d80d0vq133k7n8dc9bnw0000gn/T/maiershirts-xNybMV/ph-logo-446x194.png">    </p:cNvPr>
+          <p:cNvPr id="13" name="Image 10" descr="/var/folders/hm/sgq6d80d0vq133k7n8dc9bnw0000gn/T/maiershirts-dzZNxb/ref-10.png">    </p:cNvPr>
           <p:cNvPicPr>
             <a:picLocks noChangeAspect="1"/>
           </p:cNvPicPr>
@@ -12580,8 +12590,8 @@
         </p:blipFill>
         <p:spPr>
           <a:xfrm>
-            <a:off x="4773168" y="3538728"/>
-            <a:ext cx="1700784" cy="740664"/>
+            <a:off x="5179067" y="3685032"/>
+            <a:ext cx="888987" cy="448056"/>
           </a:xfrm>
           <a:prstGeom prst="rect">
             <a:avLst/>
@@ -12590,7 +12600,7 @@
       </p:pic>
       <p:pic>
         <p:nvPicPr>
-          <p:cNvPr id="14" name="Image 11" descr="/var/folders/hm/sgq6d80d0vq133k7n8dc9bnw0000gn/T/maiershirts-xNybMV/ph-logo-446x194.png">    </p:cNvPr>
+          <p:cNvPr id="14" name="Image 11" descr="/var/folders/hm/sgq6d80d0vq133k7n8dc9bnw0000gn/T/maiershirts-dzZNxb/ph-logo-446x194.png">    </p:cNvPr>
           <p:cNvPicPr>
             <a:picLocks noChangeAspect="1"/>
           </p:cNvPicPr>
@@ -12730,7 +12740,7 @@
       </p:sp>
       <p:pic>
         <p:nvPicPr>
-          <p:cNvPr id="3" name="Image 0" descr="/var/folders/hm/sgq6d80d0vq133k7n8dc9bnw0000gn/T/maiershirts-xNybMV/ph-foto-1056x840.png">    </p:cNvPr>
+          <p:cNvPr id="3" name="Image 0" descr="/var/folders/hm/sgq6d80d0vq133k7n8dc9bnw0000gn/T/maiershirts-dzZNxb/ph-foto-1056x840.png">    </p:cNvPr>
           <p:cNvPicPr>
             <a:picLocks noChangeAspect="1"/>
           </p:cNvPicPr>
@@ -13542,7 +13552,7 @@
       </p:sp>
       <p:pic>
         <p:nvPicPr>
-          <p:cNvPr id="4" name="Image 0" descr="/var/folders/hm/sgq6d80d0vq133k7n8dc9bnw0000gn/T/maiershirts-xNybMV/ph-portrait-252x252.png">    </p:cNvPr>
+          <p:cNvPr id="4" name="Image 0" descr="/var/folders/hm/sgq6d80d0vq133k7n8dc9bnw0000gn/T/maiershirts-dzZNxb/ph-portrait-252x252.png">    </p:cNvPr>
           <p:cNvPicPr>
             <a:picLocks noChangeAspect="1"/>
           </p:cNvPicPr>
@@ -13751,7 +13761,7 @@
       </p:sp>
       <p:pic>
         <p:nvPicPr>
-          <p:cNvPr id="9" name="Image 1" descr="/var/folders/hm/sgq6d80d0vq133k7n8dc9bnw0000gn/T/maiershirts-xNybMV/ph-qr-240x240.png">    </p:cNvPr>
+          <p:cNvPr id="9" name="Image 1" descr="/var/folders/hm/sgq6d80d0vq133k7n8dc9bnw0000gn/T/maiershirts-dzZNxb/ph-qr-240x240.png">    </p:cNvPr>
           <p:cNvPicPr>
             <a:picLocks noChangeAspect="1"/>
           </p:cNvPicPr>
@@ -15167,7 +15177,7 @@
       </p:grpSpPr>
       <p:pic>
         <p:nvPicPr>
-          <p:cNvPr id="2" name="Image 0" descr="/var/folders/hm/sgq6d80d0vq133k7n8dc9bnw0000gn/T/maiershirts-xNybMV/ph-foto-2400x1008.png">    </p:cNvPr>
+          <p:cNvPr id="2" name="Image 0" descr="/var/folders/hm/sgq6d80d0vq133k7n8dc9bnw0000gn/T/maiershirts-dzZNxb/ph-foto-2400x1008.png">    </p:cNvPr>
           <p:cNvPicPr>
             <a:picLocks noChangeAspect="1"/>
           </p:cNvPicPr>
@@ -16325,7 +16335,7 @@
       </p:sp>
       <p:pic>
         <p:nvPicPr>
-          <p:cNvPr id="3" name="Image 0" descr="/var/folders/hm/sgq6d80d0vq133k7n8dc9bnw0000gn/T/maiershirts-xNybMV/ph-foto-696x456.png">    </p:cNvPr>
+          <p:cNvPr id="3" name="Image 0" descr="/var/folders/hm/sgq6d80d0vq133k7n8dc9bnw0000gn/T/maiershirts-dzZNxb/ph-foto-696x456.png">    </p:cNvPr>
           <p:cNvPicPr>
             <a:picLocks noChangeAspect="1"/>
           </p:cNvPicPr>
@@ -16495,7 +16505,7 @@
       </p:sp>
       <p:pic>
         <p:nvPicPr>
-          <p:cNvPr id="7" name="Image 1" descr="/var/folders/hm/sgq6d80d0vq133k7n8dc9bnw0000gn/T/maiershirts-xNybMV/ph-foto-696x456.png">    </p:cNvPr>
+          <p:cNvPr id="7" name="Image 1" descr="/var/folders/hm/sgq6d80d0vq133k7n8dc9bnw0000gn/T/maiershirts-dzZNxb/ph-foto-696x456.png">    </p:cNvPr>
           <p:cNvPicPr>
             <a:picLocks noChangeAspect="1"/>
           </p:cNvPicPr>
@@ -16665,7 +16675,7 @@
       </p:sp>
       <p:pic>
         <p:nvPicPr>
-          <p:cNvPr id="11" name="Image 2" descr="/var/folders/hm/sgq6d80d0vq133k7n8dc9bnw0000gn/T/maiershirts-xNybMV/ph-foto-696x456.png">    </p:cNvPr>
+          <p:cNvPr id="11" name="Image 2" descr="/var/folders/hm/sgq6d80d0vq133k7n8dc9bnw0000gn/T/maiershirts-dzZNxb/ph-foto-696x456.png">    </p:cNvPr>
           <p:cNvPicPr>
             <a:picLocks noChangeAspect="1"/>
           </p:cNvPicPr>

</xml_diff>

<commit_message>
Referenzen auf zwei Folien: Unternehmen und Vereine
- Logos liegen in assets/referenzen/unternehmen und /vereine, je Ordner
  eine Folie
- Neues Layout MS_REFERENZEN_WAPPEN (4 x 2 hohe Felder) für Vereinswappen
- Fünf Vereinslogos ergänzt: TGV Entringen, Hooriger Hund Sulzbach,
  SF Dußlingen, SV Germania Bietigheim, TV Mühlacker

Co-Authored-By: Claude Fable 5.1 <noreply@anthropic.com>
</commit_message>
<xml_diff>
--- a/presentation/dist/Maiershirts_Master.pptx
+++ b/presentation/dist/Maiershirts_Master.pptx
@@ -20,9 +20,10 @@
     <p:sldId id="268" r:id="rId14"/>
     <p:sldId id="269" r:id="rId15"/>
     <p:sldId id="270" r:id="rId16"/>
+    <p:sldId id="271" r:id="rId17"/>
   </p:sldIdLst>
   <p:notesMasterIdLst>
-    <p:notesMasterId r:id="rId17"/>
+    <p:notesMasterId r:id="rId18"/>
   </p:notesMasterIdLst>
   <p:sldSz cx="9144000" cy="5143500"/>
   <p:notesSz cx="5143500" cy="9144000"/>
@@ -940,7 +941,7 @@
           <a:p>
             <a:r>
               <a:rPr lang="en-US" dirty="0"/>
-              <a:t>Layout MS_REFERENZEN: zwölf Logo-Felder. 11 Logo(s) aus assets/referenzen eingesetzt. Logo per Klick auf das Platzhalterbild einsetzen; bei Beschnitt: Bildformat → Zuschneiden → Anpassen.</a:t>
+              <a:t>Layout MS_REFERENZEN: 12 Logo-Felder. 9 Logo(s) aus assets/referenzen/unternehmen eingesetzt. Logo per Klick auf das Platzhalterbild einsetzen; bei Beschnitt: Bildformat → Zuschneiden → Anpassen.</a:t>
             </a:r>
             <a:endParaRPr lang="en-US" dirty="0"/>
           </a:p>
@@ -1028,7 +1029,7 @@
           <a:p>
             <a:r>
               <a:rPr lang="en-US" dirty="0"/>
-              <a:t>Layout MS_BILD: Foto links, Textkörper rechts.</a:t>
+              <a:t>Layout MS_REFERENZEN_WAPPEN: 8 Logo-Felder. 7 Logo(s) aus assets/referenzen/vereine eingesetzt. Logo per Klick auf das Platzhalterbild einsetzen; bei Beschnitt: Bildformat → Zuschneiden → Anpassen.</a:t>
             </a:r>
             <a:endParaRPr lang="en-US" dirty="0"/>
           </a:p>
@@ -1116,7 +1117,7 @@
           <a:p>
             <a:r>
               <a:rPr lang="en-US" dirty="0"/>
-              <a:t>Layout MS_FREI mit nativem Säulendiagramm links und Kernaussage rechts.</a:t>
+              <a:t>Layout MS_BILD: Foto links, Textkörper rechts.</a:t>
             </a:r>
             <a:endParaRPr lang="en-US" dirty="0"/>
           </a:p>
@@ -1204,7 +1205,7 @@
           <a:p>
             <a:r>
               <a:rPr lang="en-US" dirty="0"/>
-              <a:t>Layout MS_INHALT: Titel und Textkörper mit Aufzählung.</a:t>
+              <a:t>Layout MS_FREI mit nativem Säulendiagramm links und Kernaussage rechts.</a:t>
             </a:r>
             <a:endParaRPr lang="en-US" dirty="0"/>
           </a:p>
@@ -1292,7 +1293,7 @@
           <a:p>
             <a:r>
               <a:rPr lang="en-US" dirty="0"/>
-              <a:t>Layout MS_ABSCHLUSS: Handlungsaufforderung, Ansprechpartner mit Foto, nächster Schritt mit Termin, QR-Code. Kontaktdaten sind Platzhalter.</a:t>
+              <a:t>Layout MS_INHALT: Titel und Textkörper mit Aufzählung.</a:t>
             </a:r>
             <a:endParaRPr lang="en-US" dirty="0"/>
           </a:p>
@@ -1316,6 +1317,94 @@
             <a:fld id="{F7021451-1387-4CA6-816F-3879F97B5CBC}" type="slidenum">
               <a:rPr lang="en-US"/>
               <a:t>15</a:t>
+            </a:fld>
+            <a:endParaRPr lang="en-US"/>
+          </a:p>
+        </p:txBody>
+      </p:sp>
+    </p:spTree>
+    <p:extLst>
+      <p:ext uri="{BB962C8B-B14F-4D97-AF65-F5344CB8AC3E}">
+        <p14:creationId xmlns:p14="http://schemas.microsoft.com/office/powerpoint/2010/main" val="1024086991"/>
+      </p:ext>
+    </p:extLst>
+  </p:cSld>
+  <p:clrMapOvr>
+    <a:masterClrMapping/>
+  </p:clrMapOvr>
+</p:notes>
+</file>
+
+<file path=ppt/notesSlides/notesSlide16.xml><?xml version="1.0" encoding="utf-8"?>
+<p:notes xmlns:a="http://schemas.openxmlformats.org/drawingml/2006/main" xmlns:r="http://schemas.openxmlformats.org/officeDocument/2006/relationships" xmlns:p="http://schemas.openxmlformats.org/presentationml/2006/main">
+  <p:cSld>
+    <p:spTree>
+      <p:nvGrpSpPr>
+        <p:cNvPr id="1" name=""/>
+        <p:cNvGrpSpPr/>
+        <p:nvPr/>
+      </p:nvGrpSpPr>
+      <p:grpSpPr>
+        <a:xfrm>
+          <a:off x="0" y="0"/>
+          <a:ext cx="0" cy="0"/>
+          <a:chOff x="0" y="0"/>
+          <a:chExt cx="0" cy="0"/>
+        </a:xfrm>
+      </p:grpSpPr>
+      <p:sp>
+        <p:nvSpPr>
+          <p:cNvPr id="2" name="Slide Image Placeholder 1"/>
+          <p:cNvSpPr>
+            <a:spLocks noGrp="1" noRot="1" noChangeAspect="1"/>
+          </p:cNvSpPr>
+          <p:nvPr>
+            <p:ph type="sldImg"/>
+          </p:nvPr>
+        </p:nvSpPr>
+        <p:spPr/>
+      </p:sp>
+      <p:sp>
+        <p:nvSpPr>
+          <p:cNvPr id="3" name="Notes Placeholder 2"/>
+          <p:cNvSpPr>
+            <a:spLocks noGrp="1"/>
+          </p:cNvSpPr>
+          <p:nvPr>
+            <p:ph type="body" idx="1"/>
+          </p:nvPr>
+        </p:nvSpPr>
+        <p:spPr/>
+        <p:txBody>
+          <a:bodyPr/>
+          <a:lstStyle/>
+          <a:p>
+            <a:r>
+              <a:rPr lang="en-US" dirty="0"/>
+              <a:t>Layout MS_ABSCHLUSS: Handlungsaufforderung, Ansprechpartner mit Foto, nächster Schritt mit Termin, QR-Code. Kontaktdaten sind Platzhalter.</a:t>
+            </a:r>
+            <a:endParaRPr lang="en-US" dirty="0"/>
+          </a:p>
+        </p:txBody>
+      </p:sp>
+      <p:sp>
+        <p:nvSpPr>
+          <p:cNvPr id="4" name="Slide Number Placeholder 3"/>
+          <p:cNvSpPr>
+            <a:spLocks noGrp="1"/>
+          </p:cNvSpPr>
+          <p:nvPr>
+            <p:ph type="sldNum" sz="quarter" idx="10"/>
+          </p:nvPr>
+        </p:nvSpPr>
+        <p:spPr/>
+        <p:txBody>
+          <a:bodyPr/>
+          <a:lstStyle/>
+          <a:p>
+            <a:fld id="{F7021451-1387-4CA6-816F-3879F97B5CBC}" type="slidenum">
+              <a:rPr lang="en-US"/>
+              <a:t>16</a:t>
             </a:fld>
             <a:endParaRPr lang="en-US"/>
           </a:p>
@@ -6815,6 +6904,666 @@
 
 <file path=ppt/slideLayouts/slideLayout16.xml><?xml version="1.0" encoding="utf-8"?>
 <p:sldLayout xmlns:a="http://schemas.openxmlformats.org/drawingml/2006/main" xmlns:r="http://schemas.openxmlformats.org/officeDocument/2006/relationships" xmlns:p="http://schemas.openxmlformats.org/presentationml/2006/main" preserve="1">
+  <p:cSld name="MS_REFERENZEN_WAPPEN">
+    <p:bg>
+      <p:bgPr>
+        <a:blipFill dpi="0" rotWithShape="1">
+          <a:blip r:embed="rId2">
+            <a:lum/>
+          </a:blip>
+          <a:srcRect/>
+          <a:stretch>
+            <a:fillRect/>
+          </a:stretch>
+        </a:blipFill>
+        <a:effectLst/>
+      </p:bgPr>
+    </p:bg>
+    <p:spTree>
+      <p:nvGrpSpPr>
+        <p:cNvPr id="1" name=""/>
+        <p:cNvGrpSpPr/>
+        <p:nvPr/>
+      </p:nvGrpSpPr>
+      <p:grpSpPr>
+        <a:xfrm>
+          <a:off x="0" y="0"/>
+          <a:ext cx="0" cy="0"/>
+          <a:chOff x="0" y="0"/>
+          <a:chExt cx="0" cy="0"/>
+        </a:xfrm>
+      </p:grpSpPr>
+      <p:pic>
+        <p:nvPicPr>
+          <p:cNvPr id="2" name="Image 0" descr="/Users/stefanmaier/Documents/GitHub/lexware-angebot-tool/presentation/assets/logo-dark.png">    </p:cNvPr>
+          <p:cNvPicPr>
+            <a:picLocks noChangeAspect="1"/>
+          </p:cNvPicPr>
+          <p:nvPr/>
+        </p:nvPicPr>
+        <p:blipFill>
+          <a:blip r:embed="rId1"/>
+          <a:srcRect l="0" r="0" t="0" b="0"/>
+          <a:stretch/>
+        </p:blipFill>
+        <p:spPr>
+          <a:xfrm>
+            <a:off x="7818120" y="365760"/>
+            <a:ext cx="868680" cy="457200"/>
+          </a:xfrm>
+          <a:prstGeom prst="rect">
+            <a:avLst/>
+          </a:prstGeom>
+        </p:spPr>
+      </p:pic>
+      <p:sp>
+        <p:nvSpPr>
+          <p:cNvPr id="3" name="Text 0"/>
+          <p:cNvSpPr/>
+          <p:nvPr>
+            <p:ph idx="101" type="title" hasCustomPrompt="1"/>
+          </p:nvPr>
+        </p:nvSpPr>
+        <p:spPr>
+          <a:xfrm>
+            <a:off x="457200" y="320040"/>
+            <a:ext cx="7132320" cy="640080"/>
+          </a:xfrm>
+          <a:prstGeom prst="rect">
+            <a:avLst/>
+          </a:prstGeom>
+          <a:noFill/>
+          <a:ln/>
+        </p:spPr>
+        <p:txBody>
+          <a:bodyPr wrap="square" rtlCol="0"/>
+          <a:lstStyle>
+            <a:lvl1pPr algn="l" indent="0" marL="0">
+              <a:buNone/>
+              <a:defRPr lang="en-US" sz="2800" b="1" dirty="0">
+                <a:solidFill>
+                  <a:srgbClr val="0F0F0F"/>
+                </a:solidFill>
+                <a:latin typeface="Inter" pitchFamily="34" charset="0"/>
+                <a:ea typeface="Inter" pitchFamily="34" charset="-122"/>
+                <a:cs typeface="Inter" pitchFamily="34" charset="-120"/>
+              </a:defRPr>
+            </a:lvl1pPr>
+          </a:lstStyle>
+          <a:p>
+            <a:pPr algn="l" indent="0" marL="0">
+              <a:buNone/>
+            </a:pPr>
+            <a:r>
+              <a:rPr lang="en-US" sz="2800" b="1" dirty="0">
+                <a:solidFill>
+                  <a:srgbClr val="0F0F0F"/>
+                </a:solidFill>
+                <a:latin typeface="Inter" pitchFamily="34" charset="0"/>
+                <a:ea typeface="Inter" pitchFamily="34" charset="-122"/>
+                <a:cs typeface="Inter" pitchFamily="34" charset="-120"/>
+              </a:rPr>
+              <a:t>Folientitel</a:t>
+            </a:r>
+            <a:endParaRPr lang="en-US" sz="2800" dirty="0"/>
+          </a:p>
+        </p:txBody>
+      </p:sp>
+      <p:sp>
+        <p:nvSpPr>
+          <p:cNvPr id="4" name="Text 0"/>
+          <p:cNvSpPr/>
+          <p:nvPr>
+            <p:ph idx="102" type="pic" hasCustomPrompt="1"/>
+          </p:nvPr>
+        </p:nvSpPr>
+        <p:spPr>
+          <a:xfrm>
+            <a:off x="566928" y="1344168"/>
+            <a:ext cx="1700784" cy="1243584"/>
+          </a:xfrm>
+          <a:prstGeom prst="rect">
+            <a:avLst/>
+          </a:prstGeom>
+          <a:noFill/>
+          <a:ln/>
+        </p:spPr>
+        <p:txBody>
+          <a:bodyPr wrap="square" rtlCol="0"/>
+          <a:lstStyle>
+            <a:lvl1pPr algn="ctr" indent="0" marL="0">
+              <a:buNone/>
+              <a:defRPr lang="en-US" sz="1200" dirty="0">
+                <a:solidFill>
+                  <a:srgbClr val="0F0F0F">
+                    <a:alpha val="60000"/>
+                  </a:srgbClr>
+                </a:solidFill>
+                <a:latin typeface="Inter" pitchFamily="34" charset="0"/>
+                <a:ea typeface="Inter" pitchFamily="34" charset="-122"/>
+                <a:cs typeface="Inter" pitchFamily="34" charset="-120"/>
+              </a:defRPr>
+            </a:lvl1pPr>
+          </a:lstStyle>
+          <a:p>
+            <a:pPr algn="ctr" indent="0" marL="0">
+              <a:buNone/>
+            </a:pPr>
+            <a:r>
+              <a:rPr lang="en-US" sz="1200" dirty="0">
+                <a:solidFill>
+                  <a:srgbClr val="0F0F0F">
+                    <a:alpha val="60000"/>
+                  </a:srgbClr>
+                </a:solidFill>
+                <a:latin typeface="Inter" pitchFamily="34" charset="0"/>
+                <a:ea typeface="Inter" pitchFamily="34" charset="-122"/>
+                <a:cs typeface="Inter" pitchFamily="34" charset="-120"/>
+              </a:rPr>
+              <a:t>Logo einfügen</a:t>
+            </a:r>
+            <a:endParaRPr lang="en-US" sz="1200" dirty="0"/>
+          </a:p>
+        </p:txBody>
+      </p:sp>
+      <p:sp>
+        <p:nvSpPr>
+          <p:cNvPr id="5" name="Text 0"/>
+          <p:cNvSpPr/>
+          <p:nvPr>
+            <p:ph idx="103" type="pic" hasCustomPrompt="1"/>
+          </p:nvPr>
+        </p:nvSpPr>
+        <p:spPr>
+          <a:xfrm>
+            <a:off x="2670048" y="1344168"/>
+            <a:ext cx="1700784" cy="1243584"/>
+          </a:xfrm>
+          <a:prstGeom prst="rect">
+            <a:avLst/>
+          </a:prstGeom>
+          <a:noFill/>
+          <a:ln/>
+        </p:spPr>
+        <p:txBody>
+          <a:bodyPr wrap="square" rtlCol="0"/>
+          <a:lstStyle>
+            <a:lvl1pPr algn="ctr" indent="0" marL="0">
+              <a:buNone/>
+              <a:defRPr lang="en-US" sz="1200" dirty="0">
+                <a:solidFill>
+                  <a:srgbClr val="0F0F0F">
+                    <a:alpha val="60000"/>
+                  </a:srgbClr>
+                </a:solidFill>
+                <a:latin typeface="Inter" pitchFamily="34" charset="0"/>
+                <a:ea typeface="Inter" pitchFamily="34" charset="-122"/>
+                <a:cs typeface="Inter" pitchFamily="34" charset="-120"/>
+              </a:defRPr>
+            </a:lvl1pPr>
+          </a:lstStyle>
+          <a:p>
+            <a:pPr algn="ctr" indent="0" marL="0">
+              <a:buNone/>
+            </a:pPr>
+            <a:r>
+              <a:rPr lang="en-US" sz="1200" dirty="0">
+                <a:solidFill>
+                  <a:srgbClr val="0F0F0F">
+                    <a:alpha val="60000"/>
+                  </a:srgbClr>
+                </a:solidFill>
+                <a:latin typeface="Inter" pitchFamily="34" charset="0"/>
+                <a:ea typeface="Inter" pitchFamily="34" charset="-122"/>
+                <a:cs typeface="Inter" pitchFamily="34" charset="-120"/>
+              </a:rPr>
+              <a:t>Logo einfügen</a:t>
+            </a:r>
+            <a:endParaRPr lang="en-US" sz="1200" dirty="0"/>
+          </a:p>
+        </p:txBody>
+      </p:sp>
+      <p:sp>
+        <p:nvSpPr>
+          <p:cNvPr id="6" name="Text 0"/>
+          <p:cNvSpPr/>
+          <p:nvPr>
+            <p:ph idx="104" type="pic" hasCustomPrompt="1"/>
+          </p:nvPr>
+        </p:nvSpPr>
+        <p:spPr>
+          <a:xfrm>
+            <a:off x="4773168" y="1344168"/>
+            <a:ext cx="1700784" cy="1243584"/>
+          </a:xfrm>
+          <a:prstGeom prst="rect">
+            <a:avLst/>
+          </a:prstGeom>
+          <a:noFill/>
+          <a:ln/>
+        </p:spPr>
+        <p:txBody>
+          <a:bodyPr wrap="square" rtlCol="0"/>
+          <a:lstStyle>
+            <a:lvl1pPr algn="ctr" indent="0" marL="0">
+              <a:buNone/>
+              <a:defRPr lang="en-US" sz="1200" dirty="0">
+                <a:solidFill>
+                  <a:srgbClr val="0F0F0F">
+                    <a:alpha val="60000"/>
+                  </a:srgbClr>
+                </a:solidFill>
+                <a:latin typeface="Inter" pitchFamily="34" charset="0"/>
+                <a:ea typeface="Inter" pitchFamily="34" charset="-122"/>
+                <a:cs typeface="Inter" pitchFamily="34" charset="-120"/>
+              </a:defRPr>
+            </a:lvl1pPr>
+          </a:lstStyle>
+          <a:p>
+            <a:pPr algn="ctr" indent="0" marL="0">
+              <a:buNone/>
+            </a:pPr>
+            <a:r>
+              <a:rPr lang="en-US" sz="1200" dirty="0">
+                <a:solidFill>
+                  <a:srgbClr val="0F0F0F">
+                    <a:alpha val="60000"/>
+                  </a:srgbClr>
+                </a:solidFill>
+                <a:latin typeface="Inter" pitchFamily="34" charset="0"/>
+                <a:ea typeface="Inter" pitchFamily="34" charset="-122"/>
+                <a:cs typeface="Inter" pitchFamily="34" charset="-120"/>
+              </a:rPr>
+              <a:t>Logo einfügen</a:t>
+            </a:r>
+            <a:endParaRPr lang="en-US" sz="1200" dirty="0"/>
+          </a:p>
+        </p:txBody>
+      </p:sp>
+      <p:sp>
+        <p:nvSpPr>
+          <p:cNvPr id="7" name="Text 0"/>
+          <p:cNvSpPr/>
+          <p:nvPr>
+            <p:ph idx="105" type="pic" hasCustomPrompt="1"/>
+          </p:nvPr>
+        </p:nvSpPr>
+        <p:spPr>
+          <a:xfrm>
+            <a:off x="6876288" y="1344168"/>
+            <a:ext cx="1700784" cy="1243584"/>
+          </a:xfrm>
+          <a:prstGeom prst="rect">
+            <a:avLst/>
+          </a:prstGeom>
+          <a:noFill/>
+          <a:ln/>
+        </p:spPr>
+        <p:txBody>
+          <a:bodyPr wrap="square" rtlCol="0"/>
+          <a:lstStyle>
+            <a:lvl1pPr algn="ctr" indent="0" marL="0">
+              <a:buNone/>
+              <a:defRPr lang="en-US" sz="1200" dirty="0">
+                <a:solidFill>
+                  <a:srgbClr val="0F0F0F">
+                    <a:alpha val="60000"/>
+                  </a:srgbClr>
+                </a:solidFill>
+                <a:latin typeface="Inter" pitchFamily="34" charset="0"/>
+                <a:ea typeface="Inter" pitchFamily="34" charset="-122"/>
+                <a:cs typeface="Inter" pitchFamily="34" charset="-120"/>
+              </a:defRPr>
+            </a:lvl1pPr>
+          </a:lstStyle>
+          <a:p>
+            <a:pPr algn="ctr" indent="0" marL="0">
+              <a:buNone/>
+            </a:pPr>
+            <a:r>
+              <a:rPr lang="en-US" sz="1200" dirty="0">
+                <a:solidFill>
+                  <a:srgbClr val="0F0F0F">
+                    <a:alpha val="60000"/>
+                  </a:srgbClr>
+                </a:solidFill>
+                <a:latin typeface="Inter" pitchFamily="34" charset="0"/>
+                <a:ea typeface="Inter" pitchFamily="34" charset="-122"/>
+                <a:cs typeface="Inter" pitchFamily="34" charset="-120"/>
+              </a:rPr>
+              <a:t>Logo einfügen</a:t>
+            </a:r>
+            <a:endParaRPr lang="en-US" sz="1200" dirty="0"/>
+          </a:p>
+        </p:txBody>
+      </p:sp>
+      <p:sp>
+        <p:nvSpPr>
+          <p:cNvPr id="8" name="Text 0"/>
+          <p:cNvSpPr/>
+          <p:nvPr>
+            <p:ph idx="106" type="pic" hasCustomPrompt="1"/>
+          </p:nvPr>
+        </p:nvSpPr>
+        <p:spPr>
+          <a:xfrm>
+            <a:off x="566928" y="2944368"/>
+            <a:ext cx="1700784" cy="1243584"/>
+          </a:xfrm>
+          <a:prstGeom prst="rect">
+            <a:avLst/>
+          </a:prstGeom>
+          <a:noFill/>
+          <a:ln/>
+        </p:spPr>
+        <p:txBody>
+          <a:bodyPr wrap="square" rtlCol="0"/>
+          <a:lstStyle>
+            <a:lvl1pPr algn="ctr" indent="0" marL="0">
+              <a:buNone/>
+              <a:defRPr lang="en-US" sz="1200" dirty="0">
+                <a:solidFill>
+                  <a:srgbClr val="0F0F0F">
+                    <a:alpha val="60000"/>
+                  </a:srgbClr>
+                </a:solidFill>
+                <a:latin typeface="Inter" pitchFamily="34" charset="0"/>
+                <a:ea typeface="Inter" pitchFamily="34" charset="-122"/>
+                <a:cs typeface="Inter" pitchFamily="34" charset="-120"/>
+              </a:defRPr>
+            </a:lvl1pPr>
+          </a:lstStyle>
+          <a:p>
+            <a:pPr algn="ctr" indent="0" marL="0">
+              <a:buNone/>
+            </a:pPr>
+            <a:r>
+              <a:rPr lang="en-US" sz="1200" dirty="0">
+                <a:solidFill>
+                  <a:srgbClr val="0F0F0F">
+                    <a:alpha val="60000"/>
+                  </a:srgbClr>
+                </a:solidFill>
+                <a:latin typeface="Inter" pitchFamily="34" charset="0"/>
+                <a:ea typeface="Inter" pitchFamily="34" charset="-122"/>
+                <a:cs typeface="Inter" pitchFamily="34" charset="-120"/>
+              </a:rPr>
+              <a:t>Logo einfügen</a:t>
+            </a:r>
+            <a:endParaRPr lang="en-US" sz="1200" dirty="0"/>
+          </a:p>
+        </p:txBody>
+      </p:sp>
+      <p:sp>
+        <p:nvSpPr>
+          <p:cNvPr id="9" name="Text 0"/>
+          <p:cNvSpPr/>
+          <p:nvPr>
+            <p:ph idx="107" type="pic" hasCustomPrompt="1"/>
+          </p:nvPr>
+        </p:nvSpPr>
+        <p:spPr>
+          <a:xfrm>
+            <a:off x="2670048" y="2944368"/>
+            <a:ext cx="1700784" cy="1243584"/>
+          </a:xfrm>
+          <a:prstGeom prst="rect">
+            <a:avLst/>
+          </a:prstGeom>
+          <a:noFill/>
+          <a:ln/>
+        </p:spPr>
+        <p:txBody>
+          <a:bodyPr wrap="square" rtlCol="0"/>
+          <a:lstStyle>
+            <a:lvl1pPr algn="ctr" indent="0" marL="0">
+              <a:buNone/>
+              <a:defRPr lang="en-US" sz="1200" dirty="0">
+                <a:solidFill>
+                  <a:srgbClr val="0F0F0F">
+                    <a:alpha val="60000"/>
+                  </a:srgbClr>
+                </a:solidFill>
+                <a:latin typeface="Inter" pitchFamily="34" charset="0"/>
+                <a:ea typeface="Inter" pitchFamily="34" charset="-122"/>
+                <a:cs typeface="Inter" pitchFamily="34" charset="-120"/>
+              </a:defRPr>
+            </a:lvl1pPr>
+          </a:lstStyle>
+          <a:p>
+            <a:pPr algn="ctr" indent="0" marL="0">
+              <a:buNone/>
+            </a:pPr>
+            <a:r>
+              <a:rPr lang="en-US" sz="1200" dirty="0">
+                <a:solidFill>
+                  <a:srgbClr val="0F0F0F">
+                    <a:alpha val="60000"/>
+                  </a:srgbClr>
+                </a:solidFill>
+                <a:latin typeface="Inter" pitchFamily="34" charset="0"/>
+                <a:ea typeface="Inter" pitchFamily="34" charset="-122"/>
+                <a:cs typeface="Inter" pitchFamily="34" charset="-120"/>
+              </a:rPr>
+              <a:t>Logo einfügen</a:t>
+            </a:r>
+            <a:endParaRPr lang="en-US" sz="1200" dirty="0"/>
+          </a:p>
+        </p:txBody>
+      </p:sp>
+      <p:sp>
+        <p:nvSpPr>
+          <p:cNvPr id="10" name="Text 0"/>
+          <p:cNvSpPr/>
+          <p:nvPr>
+            <p:ph idx="108" type="pic" hasCustomPrompt="1"/>
+          </p:nvPr>
+        </p:nvSpPr>
+        <p:spPr>
+          <a:xfrm>
+            <a:off x="4773168" y="2944368"/>
+            <a:ext cx="1700784" cy="1243584"/>
+          </a:xfrm>
+          <a:prstGeom prst="rect">
+            <a:avLst/>
+          </a:prstGeom>
+          <a:noFill/>
+          <a:ln/>
+        </p:spPr>
+        <p:txBody>
+          <a:bodyPr wrap="square" rtlCol="0"/>
+          <a:lstStyle>
+            <a:lvl1pPr algn="ctr" indent="0" marL="0">
+              <a:buNone/>
+              <a:defRPr lang="en-US" sz="1200" dirty="0">
+                <a:solidFill>
+                  <a:srgbClr val="0F0F0F">
+                    <a:alpha val="60000"/>
+                  </a:srgbClr>
+                </a:solidFill>
+                <a:latin typeface="Inter" pitchFamily="34" charset="0"/>
+                <a:ea typeface="Inter" pitchFamily="34" charset="-122"/>
+                <a:cs typeface="Inter" pitchFamily="34" charset="-120"/>
+              </a:defRPr>
+            </a:lvl1pPr>
+          </a:lstStyle>
+          <a:p>
+            <a:pPr algn="ctr" indent="0" marL="0">
+              <a:buNone/>
+            </a:pPr>
+            <a:r>
+              <a:rPr lang="en-US" sz="1200" dirty="0">
+                <a:solidFill>
+                  <a:srgbClr val="0F0F0F">
+                    <a:alpha val="60000"/>
+                  </a:srgbClr>
+                </a:solidFill>
+                <a:latin typeface="Inter" pitchFamily="34" charset="0"/>
+                <a:ea typeface="Inter" pitchFamily="34" charset="-122"/>
+                <a:cs typeface="Inter" pitchFamily="34" charset="-120"/>
+              </a:rPr>
+              <a:t>Logo einfügen</a:t>
+            </a:r>
+            <a:endParaRPr lang="en-US" sz="1200" dirty="0"/>
+          </a:p>
+        </p:txBody>
+      </p:sp>
+      <p:sp>
+        <p:nvSpPr>
+          <p:cNvPr id="11" name="Text 0"/>
+          <p:cNvSpPr/>
+          <p:nvPr>
+            <p:ph idx="109" type="pic" hasCustomPrompt="1"/>
+          </p:nvPr>
+        </p:nvSpPr>
+        <p:spPr>
+          <a:xfrm>
+            <a:off x="6876288" y="2944368"/>
+            <a:ext cx="1700784" cy="1243584"/>
+          </a:xfrm>
+          <a:prstGeom prst="rect">
+            <a:avLst/>
+          </a:prstGeom>
+          <a:noFill/>
+          <a:ln/>
+        </p:spPr>
+        <p:txBody>
+          <a:bodyPr wrap="square" rtlCol="0"/>
+          <a:lstStyle>
+            <a:lvl1pPr algn="ctr" indent="0" marL="0">
+              <a:buNone/>
+              <a:defRPr lang="en-US" sz="1200" dirty="0">
+                <a:solidFill>
+                  <a:srgbClr val="0F0F0F">
+                    <a:alpha val="60000"/>
+                  </a:srgbClr>
+                </a:solidFill>
+                <a:latin typeface="Inter" pitchFamily="34" charset="0"/>
+                <a:ea typeface="Inter" pitchFamily="34" charset="-122"/>
+                <a:cs typeface="Inter" pitchFamily="34" charset="-120"/>
+              </a:defRPr>
+            </a:lvl1pPr>
+          </a:lstStyle>
+          <a:p>
+            <a:pPr algn="ctr" indent="0" marL="0">
+              <a:buNone/>
+            </a:pPr>
+            <a:r>
+              <a:rPr lang="en-US" sz="1200" dirty="0">
+                <a:solidFill>
+                  <a:srgbClr val="0F0F0F">
+                    <a:alpha val="60000"/>
+                  </a:srgbClr>
+                </a:solidFill>
+                <a:latin typeface="Inter" pitchFamily="34" charset="0"/>
+                <a:ea typeface="Inter" pitchFamily="34" charset="-122"/>
+                <a:cs typeface="Inter" pitchFamily="34" charset="-120"/>
+              </a:rPr>
+              <a:t>Logo einfügen</a:t>
+            </a:r>
+            <a:endParaRPr lang="en-US" sz="1200" dirty="0"/>
+          </a:p>
+        </p:txBody>
+      </p:sp>
+      <p:sp>
+        <p:nvSpPr>
+          <p:cNvPr id="12" name="Text 0"/>
+          <p:cNvSpPr/>
+          <p:nvPr/>
+        </p:nvSpPr>
+        <p:spPr>
+          <a:xfrm>
+            <a:off x="457200" y="4709160"/>
+            <a:ext cx="2743200" cy="274320"/>
+          </a:xfrm>
+          <a:prstGeom prst="rect">
+            <a:avLst/>
+          </a:prstGeom>
+          <a:noFill/>
+          <a:ln/>
+        </p:spPr>
+        <p:txBody>
+          <a:bodyPr wrap="square" lIns="0" tIns="0" rIns="0" bIns="0" rtlCol="0" anchor="ctr"/>
+          <a:lstStyle/>
+          <a:p>
+            <a:pPr indent="0" marL="0">
+              <a:buNone/>
+            </a:pPr>
+            <a:r>
+              <a:rPr lang="en-US" sz="1000" dirty="0">
+                <a:solidFill>
+                  <a:srgbClr val="0F0F0F">
+                    <a:alpha val="60000"/>
+                  </a:srgbClr>
+                </a:solidFill>
+                <a:latin typeface="Inter" pitchFamily="34" charset="0"/>
+                <a:ea typeface="Inter" pitchFamily="34" charset="-122"/>
+                <a:cs typeface="Inter" pitchFamily="34" charset="-120"/>
+              </a:rPr>
+              <a:t>maiershirts.de</a:t>
+            </a:r>
+            <a:endParaRPr lang="en-US" sz="1000" dirty="0"/>
+          </a:p>
+        </p:txBody>
+      </p:sp>
+      <p:sp>
+        <p:nvSpPr>
+          <p:cNvPr id="25" name="Slide Number Placeholder 0"/>
+          <p:cNvSpPr>
+            <a:spLocks noGrp="1"/>
+          </p:cNvSpPr>
+          <p:nvPr>
+            <p:ph type="sldNum" sz="quarter" idx="4294967295"/>
+          </p:nvPr>
+        </p:nvSpPr>
+        <p:spPr>
+          <a:xfrm>
+            <a:off x="8229600" y="4709160"/>
+            <a:ext cx="457200" cy="274320"/>
+          </a:xfrm>
+          <a:prstGeom prst="rect">
+            <a:avLst/>
+          </a:prstGeom>
+          <a:extLst>
+            <a:ext uri="{C572A759-6A51-4108-AA02-DFA0A04FC94B}">
+              <ma14:wrappingTextBoxFlag xmlns:ma14="http://schemas.microsoft.com/office/mac/drawingml/2011/main" val="0"/>
+            </a:ext>
+          </a:extLst>
+        </p:spPr>
+        <p:txBody>
+          <a:bodyPr lIns="0" tIns="0" rIns="0" bIns="0"/>
+          <a:lstStyle>
+            <a:lvl1pPr>
+              <a:defRPr sz="1000">
+                <a:solidFill>
+                  <a:srgbClr val="0F0F0F"/>
+                </a:solidFill>
+                <a:latin typeface="Inter"/>
+                <a:ea typeface="Inter"/>
+                <a:cs typeface="Inter"/>
+              </a:defRPr>
+            </a:lvl1pPr>
+          </a:lstStyle>
+          <a:p>
+            <a:pPr algn="r"/>
+            <a:fld id="{F7021451-1387-4CA6-816F-3879F97B5CBC}" type="slidenum">
+              <a:rPr b="0" lang="en-US"/>
+              <a:t>1016</a:t>
+            </a:fld>
+            <a:endParaRPr lang="en-US"/>
+          </a:p>
+        </p:txBody>
+      </p:sp>
+    </p:spTree>
+  </p:cSld>
+  <p:clrMapOvr>
+    <a:masterClrMapping/>
+  </p:clrMapOvr>
+</p:sldLayout>
+</file>
+
+<file path=ppt/slideLayouts/slideLayout17.xml><?xml version="1.0" encoding="utf-8"?>
+<p:sldLayout xmlns:a="http://schemas.openxmlformats.org/drawingml/2006/main" xmlns:r="http://schemas.openxmlformats.org/officeDocument/2006/relationships" xmlns:p="http://schemas.openxmlformats.org/presentationml/2006/main" preserve="1">
   <p:cSld name="MS_ABSCHLUSS">
     <p:bg>
       <p:bgPr>
@@ -9474,6 +10223,7 @@
     <p:sldLayoutId id="2147483662" r:id="rId14"/>
     <p:sldLayoutId id="2147483663" r:id="rId15"/>
     <p:sldLayoutId id="2147483664" r:id="rId16"/>
+    <p:sldLayoutId id="2147483665" r:id="rId17"/>
   </p:sldLayoutIdLst>
   <p:hf sldNum="0" hdr="0" ftr="0" dt="0"/>
   <p:txStyles>
@@ -12306,7 +13056,7 @@
                 <a:ea typeface="Inter" pitchFamily="34" charset="-122"/>
                 <a:cs typeface="Inter" pitchFamily="34" charset="-120"/>
               </a:rPr>
-              <a:t>Vereine und Unternehmen, die uns vertrauen</a:t>
+              <a:t>Unternehmen, die uns vertrauen</a:t>
             </a:r>
             <a:endParaRPr lang="en-US" sz="2800" dirty="0"/>
           </a:p>
@@ -12314,7 +13064,7 @@
       </p:sp>
       <p:pic>
         <p:nvPicPr>
-          <p:cNvPr id="3" name="Image 0" descr="/var/folders/hm/sgq6d80d0vq133k7n8dc9bnw0000gn/T/maiershirts-dzZNxb/ref-0.png">    </p:cNvPr>
+          <p:cNvPr id="3" name="Image 0" descr="/var/folders/hm/sgq6d80d0vq133k7n8dc9bnw0000gn/T/maiershirts-J4Eovy/ref-unternehmen-0.png">    </p:cNvPr>
           <p:cNvPicPr>
             <a:picLocks noChangeAspect="1"/>
           </p:cNvPicPr>
@@ -12340,7 +13090,7 @@
       </p:pic>
       <p:pic>
         <p:nvPicPr>
-          <p:cNvPr id="4" name="Image 1" descr="/var/folders/hm/sgq6d80d0vq133k7n8dc9bnw0000gn/T/maiershirts-dzZNxb/ref-1.png">    </p:cNvPr>
+          <p:cNvPr id="4" name="Image 1" descr="/var/folders/hm/sgq6d80d0vq133k7n8dc9bnw0000gn/T/maiershirts-J4Eovy/ref-unternehmen-1.png">    </p:cNvPr>
           <p:cNvPicPr>
             <a:picLocks noChangeAspect="1"/>
           </p:cNvPicPr>
@@ -12366,7 +13116,7 @@
       </p:pic>
       <p:pic>
         <p:nvPicPr>
-          <p:cNvPr id="5" name="Image 2" descr="/var/folders/hm/sgq6d80d0vq133k7n8dc9bnw0000gn/T/maiershirts-dzZNxb/ref-2.png">    </p:cNvPr>
+          <p:cNvPr id="5" name="Image 2" descr="/var/folders/hm/sgq6d80d0vq133k7n8dc9bnw0000gn/T/maiershirts-J4Eovy/ref-unternehmen-2.png">    </p:cNvPr>
           <p:cNvPicPr>
             <a:picLocks noChangeAspect="1"/>
           </p:cNvPicPr>
@@ -12392,7 +13142,7 @@
       </p:pic>
       <p:pic>
         <p:nvPicPr>
-          <p:cNvPr id="6" name="Image 3" descr="/var/folders/hm/sgq6d80d0vq133k7n8dc9bnw0000gn/T/maiershirts-dzZNxb/ref-3.png">    </p:cNvPr>
+          <p:cNvPr id="6" name="Image 3" descr="/var/folders/hm/sgq6d80d0vq133k7n8dc9bnw0000gn/T/maiershirts-J4Eovy/ref-unternehmen-3.png">    </p:cNvPr>
           <p:cNvPicPr>
             <a:picLocks noChangeAspect="1"/>
           </p:cNvPicPr>
@@ -12408,8 +13158,8 @@
         </p:blipFill>
         <p:spPr>
           <a:xfrm>
-            <a:off x="7341461" y="1490472"/>
-            <a:ext cx="770438" cy="448056"/>
+            <a:off x="7174078" y="1490472"/>
+            <a:ext cx="1105205" cy="448056"/>
           </a:xfrm>
           <a:prstGeom prst="rect">
             <a:avLst/>
@@ -12418,7 +13168,7 @@
       </p:pic>
       <p:pic>
         <p:nvPicPr>
-          <p:cNvPr id="7" name="Image 4" descr="/var/folders/hm/sgq6d80d0vq133k7n8dc9bnw0000gn/T/maiershirts-dzZNxb/ref-4.png">    </p:cNvPr>
+          <p:cNvPr id="7" name="Image 4" descr="/var/folders/hm/sgq6d80d0vq133k7n8dc9bnw0000gn/T/maiershirts-J4Eovy/ref-unternehmen-4.png">    </p:cNvPr>
           <p:cNvPicPr>
             <a:picLocks noChangeAspect="1"/>
           </p:cNvPicPr>
@@ -12434,8 +13184,8 @@
         </p:blipFill>
         <p:spPr>
           <a:xfrm>
-            <a:off x="972998" y="2587752"/>
-            <a:ext cx="888644" cy="448056"/>
+            <a:off x="1090420" y="2587752"/>
+            <a:ext cx="653799" cy="448056"/>
           </a:xfrm>
           <a:prstGeom prst="rect">
             <a:avLst/>
@@ -12444,7 +13194,7 @@
       </p:pic>
       <p:pic>
         <p:nvPicPr>
-          <p:cNvPr id="8" name="Image 5" descr="/var/folders/hm/sgq6d80d0vq133k7n8dc9bnw0000gn/T/maiershirts-dzZNxb/ref-5.png">    </p:cNvPr>
+          <p:cNvPr id="8" name="Image 5" descr="/var/folders/hm/sgq6d80d0vq133k7n8dc9bnw0000gn/T/maiershirts-J4Eovy/ref-unternehmen-5.png">    </p:cNvPr>
           <p:cNvPicPr>
             <a:picLocks noChangeAspect="1"/>
           </p:cNvPicPr>
@@ -12460,8 +13210,8 @@
         </p:blipFill>
         <p:spPr>
           <a:xfrm>
-            <a:off x="2967838" y="2587752"/>
-            <a:ext cx="1105205" cy="448056"/>
+            <a:off x="2860802" y="2587752"/>
+            <a:ext cx="1319276" cy="448056"/>
           </a:xfrm>
           <a:prstGeom prst="rect">
             <a:avLst/>
@@ -12470,7 +13220,7 @@
       </p:pic>
       <p:pic>
         <p:nvPicPr>
-          <p:cNvPr id="9" name="Image 6" descr="/var/folders/hm/sgq6d80d0vq133k7n8dc9bnw0000gn/T/maiershirts-dzZNxb/ref-6.png">    </p:cNvPr>
+          <p:cNvPr id="9" name="Image 6" descr="/var/folders/hm/sgq6d80d0vq133k7n8dc9bnw0000gn/T/maiershirts-J4Eovy/ref-unternehmen-6.png">    </p:cNvPr>
           <p:cNvPicPr>
             <a:picLocks noChangeAspect="1"/>
           </p:cNvPicPr>
@@ -12486,8 +13236,8 @@
         </p:blipFill>
         <p:spPr>
           <a:xfrm>
-            <a:off x="5296660" y="2587752"/>
-            <a:ext cx="653799" cy="448056"/>
+            <a:off x="5357181" y="2587752"/>
+            <a:ext cx="532758" cy="448056"/>
           </a:xfrm>
           <a:prstGeom prst="rect">
             <a:avLst/>
@@ -12496,7 +13246,7 @@
       </p:pic>
       <p:pic>
         <p:nvPicPr>
-          <p:cNvPr id="10" name="Image 7" descr="/var/folders/hm/sgq6d80d0vq133k7n8dc9bnw0000gn/T/maiershirts-dzZNxb/ref-7.png">    </p:cNvPr>
+          <p:cNvPr id="10" name="Image 7" descr="/var/folders/hm/sgq6d80d0vq133k7n8dc9bnw0000gn/T/maiershirts-J4Eovy/ref-unternehmen-7.png">    </p:cNvPr>
           <p:cNvPicPr>
             <a:picLocks noChangeAspect="1"/>
           </p:cNvPicPr>
@@ -12512,8 +13262,8 @@
         </p:blipFill>
         <p:spPr>
           <a:xfrm>
-            <a:off x="7067042" y="2587752"/>
-            <a:ext cx="1319276" cy="448056"/>
+            <a:off x="7224177" y="2587752"/>
+            <a:ext cx="1005007" cy="448056"/>
           </a:xfrm>
           <a:prstGeom prst="rect">
             <a:avLst/>
@@ -12522,7 +13272,7 @@
       </p:pic>
       <p:pic>
         <p:nvPicPr>
-          <p:cNvPr id="11" name="Image 8" descr="/var/folders/hm/sgq6d80d0vq133k7n8dc9bnw0000gn/T/maiershirts-dzZNxb/ref-8.png">    </p:cNvPr>
+          <p:cNvPr id="11" name="Image 8" descr="/var/folders/hm/sgq6d80d0vq133k7n8dc9bnw0000gn/T/maiershirts-J4Eovy/ref-unternehmen-8.png">    </p:cNvPr>
           <p:cNvPicPr>
             <a:picLocks noChangeAspect="1"/>
           </p:cNvPicPr>
@@ -12538,8 +13288,8 @@
         </p:blipFill>
         <p:spPr>
           <a:xfrm>
-            <a:off x="1150941" y="3685032"/>
-            <a:ext cx="532758" cy="448056"/>
+            <a:off x="972998" y="3685032"/>
+            <a:ext cx="888644" cy="448056"/>
           </a:xfrm>
           <a:prstGeom prst="rect">
             <a:avLst/>
@@ -12548,7 +13298,7 @@
       </p:pic>
       <p:pic>
         <p:nvPicPr>
-          <p:cNvPr id="12" name="Image 9" descr="/var/folders/hm/sgq6d80d0vq133k7n8dc9bnw0000gn/T/maiershirts-dzZNxb/ref-9.png">    </p:cNvPr>
+          <p:cNvPr id="12" name="Image 9" descr="/var/folders/hm/sgq6d80d0vq133k7n8dc9bnw0000gn/T/maiershirts-J4Eovy/ph-logo-446x194.png">    </p:cNvPr>
           <p:cNvPicPr>
             <a:picLocks noChangeAspect="1"/>
           </p:cNvPicPr>
@@ -12564,8 +13314,8 @@
         </p:blipFill>
         <p:spPr>
           <a:xfrm>
-            <a:off x="3017937" y="3685032"/>
-            <a:ext cx="1005007" cy="448056"/>
+            <a:off x="2670048" y="3538728"/>
+            <a:ext cx="1700784" cy="740664"/>
           </a:xfrm>
           <a:prstGeom prst="rect">
             <a:avLst/>
@@ -12574,7 +13324,7 @@
       </p:pic>
       <p:pic>
         <p:nvPicPr>
-          <p:cNvPr id="13" name="Image 10" descr="/var/folders/hm/sgq6d80d0vq133k7n8dc9bnw0000gn/T/maiershirts-dzZNxb/ref-10.png">    </p:cNvPr>
+          <p:cNvPr id="13" name="Image 10" descr="/var/folders/hm/sgq6d80d0vq133k7n8dc9bnw0000gn/T/maiershirts-J4Eovy/ph-logo-446x194.png">    </p:cNvPr>
           <p:cNvPicPr>
             <a:picLocks noChangeAspect="1"/>
           </p:cNvPicPr>
@@ -12590,8 +13340,8 @@
         </p:blipFill>
         <p:spPr>
           <a:xfrm>
-            <a:off x="5179067" y="3685032"/>
-            <a:ext cx="888987" cy="448056"/>
+            <a:off x="4773168" y="3538728"/>
+            <a:ext cx="1700784" cy="740664"/>
           </a:xfrm>
           <a:prstGeom prst="rect">
             <a:avLst/>
@@ -12600,7 +13350,7 @@
       </p:pic>
       <p:pic>
         <p:nvPicPr>
-          <p:cNvPr id="14" name="Image 11" descr="/var/folders/hm/sgq6d80d0vq133k7n8dc9bnw0000gn/T/maiershirts-dzZNxb/ph-logo-446x194.png">    </p:cNvPr>
+          <p:cNvPr id="14" name="Image 11" descr="/var/folders/hm/sgq6d80d0vq133k7n8dc9bnw0000gn/T/maiershirts-J4Eovy/ph-logo-446x194.png">    </p:cNvPr>
           <p:cNvPicPr>
             <a:picLocks noChangeAspect="1"/>
           </p:cNvPicPr>
@@ -12732,7 +13482,7 @@
                 <a:ea typeface="Inter" pitchFamily="34" charset="-122"/>
                 <a:cs typeface="Inter" pitchFamily="34" charset="-120"/>
               </a:rPr>
-              <a:t>Stickerei im Detail</a:t>
+              <a:t>Vereine, die uns vertrauen</a:t>
             </a:r>
             <a:endParaRPr lang="en-US" sz="2800" dirty="0"/>
           </a:p>
@@ -12740,7 +13490,7 @@
       </p:sp>
       <p:pic>
         <p:nvPicPr>
-          <p:cNvPr id="3" name="Image 0" descr="/var/folders/hm/sgq6d80d0vq133k7n8dc9bnw0000gn/T/maiershirts-dzZNxb/ph-foto-1056x840.png">    </p:cNvPr>
+          <p:cNvPr id="3" name="Image 0" descr="/var/folders/hm/sgq6d80d0vq133k7n8dc9bnw0000gn/T/maiershirts-J4Eovy/ref-vereine-0.png">    </p:cNvPr>
           <p:cNvPicPr>
             <a:picLocks noChangeAspect="1"/>
           </p:cNvPicPr>
@@ -12756,122 +13506,196 @@
         </p:blipFill>
         <p:spPr>
           <a:xfrm>
-            <a:off x="457200" y="1234440"/>
-            <a:ext cx="4023360" cy="3200400"/>
+            <a:off x="713232" y="1556490"/>
+            <a:ext cx="1408176" cy="818939"/>
           </a:xfrm>
           <a:prstGeom prst="rect">
             <a:avLst/>
           </a:prstGeom>
         </p:spPr>
       </p:pic>
-      <p:sp>
-        <p:nvSpPr>
-          <p:cNvPr id="4" name="Text 0"/>
-          <p:cNvSpPr txBox="1"/>
-          <p:nvPr>
-            <p:ph idx="103" type="body" hasCustomPrompt="1"/>
-          </p:nvPr>
-        </p:nvSpPr>
-        <p:spPr>
-          <a:xfrm>
-            <a:off x="4846320" y="1234440"/>
-            <a:ext cx="3840480" cy="3200400"/>
-          </a:xfrm>
-          <a:prstGeom prst="rect">
-            <a:avLst/>
-          </a:prstGeom>
-          <a:noFill/>
-          <a:ln/>
-        </p:spPr>
-        <p:txBody>
-          <a:bodyPr wrap="square" lIns="0" tIns="0" rIns="0" bIns="0" rtlCol="0" anchor="t"/>
-          <a:lstStyle/>
-          <a:p>
-            <a:pPr algn="l" marL="342900" indent="-342900">
-              <a:spcAft>
-                <a:spcPts val="800"/>
-              </a:spcAft>
-              <a:buSzPct val="100000"/>
-              <a:buChar char="•"/>
-            </a:pPr>
-            <a:r>
-              <a:rPr lang="en-US" sz="1600" dirty="0">
-                <a:solidFill>
-                  <a:srgbClr val="0F0F0F"/>
-                </a:solidFill>
-                <a:latin typeface="Inter" pitchFamily="34" charset="0"/>
-                <a:ea typeface="Inter" pitchFamily="34" charset="-122"/>
-                <a:cs typeface="Inter" pitchFamily="34" charset="-120"/>
-              </a:rPr>
-              <a:t>Bis zu 12 Garnfarben pro Motiv</a:t>
-            </a:r>
-            <a:endParaRPr lang="en-US" sz="1600" dirty="0"/>
-          </a:p>
-          <a:p>
-            <a:pPr algn="l" marL="342900" indent="-342900">
-              <a:spcAft>
-                <a:spcPts val="800"/>
-              </a:spcAft>
-              <a:buSzPct val="100000"/>
-              <a:buChar char="•"/>
-            </a:pPr>
-            <a:r>
-              <a:rPr lang="en-US" sz="1600" dirty="0">
-                <a:solidFill>
-                  <a:srgbClr val="0F0F0F"/>
-                </a:solidFill>
-                <a:latin typeface="Inter" pitchFamily="34" charset="0"/>
-                <a:ea typeface="Inter" pitchFamily="34" charset="-122"/>
-                <a:cs typeface="Inter" pitchFamily="34" charset="-120"/>
-              </a:rPr>
-              <a:t>Waschbeständig bis 60 °C</a:t>
-            </a:r>
-            <a:endParaRPr lang="en-US" sz="1600" dirty="0"/>
-          </a:p>
-          <a:p>
-            <a:pPr algn="l" marL="342900" indent="-342900">
-              <a:spcAft>
-                <a:spcPts val="800"/>
-              </a:spcAft>
-              <a:buSzPct val="100000"/>
-              <a:buChar char="•"/>
-            </a:pPr>
-            <a:r>
-              <a:rPr lang="en-US" sz="1600" dirty="0">
-                <a:solidFill>
-                  <a:srgbClr val="0F0F0F"/>
-                </a:solidFill>
-                <a:latin typeface="Inter" pitchFamily="34" charset="0"/>
-                <a:ea typeface="Inter" pitchFamily="34" charset="-122"/>
-                <a:cs typeface="Inter" pitchFamily="34" charset="-120"/>
-              </a:rPr>
-              <a:t>Ideal für Polos, Jacken und Caps</a:t>
-            </a:r>
-            <a:endParaRPr lang="en-US" sz="1600" dirty="0"/>
-          </a:p>
-          <a:p>
-            <a:pPr algn="l" marL="342900" indent="-342900">
-              <a:spcAft>
-                <a:spcPts val="800"/>
-              </a:spcAft>
-              <a:buSzPct val="100000"/>
-              <a:buChar char="•"/>
-            </a:pPr>
-            <a:r>
-              <a:rPr lang="en-US" sz="1600" dirty="0">
-                <a:solidFill>
-                  <a:srgbClr val="0F0F0F"/>
-                </a:solidFill>
-                <a:latin typeface="Inter" pitchFamily="34" charset="0"/>
-                <a:ea typeface="Inter" pitchFamily="34" charset="-122"/>
-                <a:cs typeface="Inter" pitchFamily="34" charset="-120"/>
-              </a:rPr>
-              <a:t>Motivdigitalisierung im Haus</a:t>
-            </a:r>
-            <a:endParaRPr lang="en-US" sz="1600" dirty="0"/>
-          </a:p>
-        </p:txBody>
-      </p:sp>
+      <p:pic>
+        <p:nvPicPr>
+          <p:cNvPr id="4" name="Image 1" descr="/var/folders/hm/sgq6d80d0vq133k7n8dc9bnw0000gn/T/maiershirts-J4Eovy/ref-vereine-1.png">    </p:cNvPr>
+          <p:cNvPicPr>
+            <a:picLocks noChangeAspect="1"/>
+          </p:cNvPicPr>
+          <p:nvPr>
+            <p:ph idx="103" type="pic" hasCustomPrompt="1"/>
+          </p:nvPr>
+        </p:nvPicPr>
+        <p:blipFill>
+          <a:blip r:embed="rId2"/>
+          <a:stretch>
+            <a:fillRect/>
+          </a:stretch>
+        </p:blipFill>
+        <p:spPr>
+          <a:xfrm>
+            <a:off x="2816352" y="1611094"/>
+            <a:ext cx="1408176" cy="709731"/>
+          </a:xfrm>
+          <a:prstGeom prst="rect">
+            <a:avLst/>
+          </a:prstGeom>
+        </p:spPr>
+      </p:pic>
+      <p:pic>
+        <p:nvPicPr>
+          <p:cNvPr id="5" name="Image 2" descr="/var/folders/hm/sgq6d80d0vq133k7n8dc9bnw0000gn/T/maiershirts-J4Eovy/ref-vereine-2.png">    </p:cNvPr>
+          <p:cNvPicPr>
+            <a:picLocks noChangeAspect="1"/>
+          </p:cNvPicPr>
+          <p:nvPr>
+            <p:ph idx="104" type="pic" hasCustomPrompt="1"/>
+          </p:nvPr>
+        </p:nvPicPr>
+        <p:blipFill>
+          <a:blip r:embed="rId3"/>
+          <a:stretch>
+            <a:fillRect/>
+          </a:stretch>
+        </p:blipFill>
+        <p:spPr>
+          <a:xfrm>
+            <a:off x="5261000" y="1490472"/>
+            <a:ext cx="725119" cy="950976"/>
+          </a:xfrm>
+          <a:prstGeom prst="rect">
+            <a:avLst/>
+          </a:prstGeom>
+        </p:spPr>
+      </p:pic>
+      <p:pic>
+        <p:nvPicPr>
+          <p:cNvPr id="6" name="Image 3" descr="/var/folders/hm/sgq6d80d0vq133k7n8dc9bnw0000gn/T/maiershirts-J4Eovy/ref-vereine-3.png">    </p:cNvPr>
+          <p:cNvPicPr>
+            <a:picLocks noChangeAspect="1"/>
+          </p:cNvPicPr>
+          <p:nvPr>
+            <p:ph idx="105" type="pic" hasCustomPrompt="1"/>
+          </p:nvPr>
+        </p:nvPicPr>
+        <p:blipFill>
+          <a:blip r:embed="rId4"/>
+          <a:stretch>
+            <a:fillRect/>
+          </a:stretch>
+        </p:blipFill>
+        <p:spPr>
+          <a:xfrm>
+            <a:off x="7251192" y="1490472"/>
+            <a:ext cx="950976" cy="950976"/>
+          </a:xfrm>
+          <a:prstGeom prst="rect">
+            <a:avLst/>
+          </a:prstGeom>
+        </p:spPr>
+      </p:pic>
+      <p:pic>
+        <p:nvPicPr>
+          <p:cNvPr id="7" name="Image 4" descr="/var/folders/hm/sgq6d80d0vq133k7n8dc9bnw0000gn/T/maiershirts-J4Eovy/ref-vereine-4.png">    </p:cNvPr>
+          <p:cNvPicPr>
+            <a:picLocks noChangeAspect="1"/>
+          </p:cNvPicPr>
+          <p:nvPr>
+            <p:ph idx="106" type="pic" hasCustomPrompt="1"/>
+          </p:nvPr>
+        </p:nvPicPr>
+        <p:blipFill>
+          <a:blip r:embed="rId5"/>
+          <a:stretch>
+            <a:fillRect/>
+          </a:stretch>
+        </p:blipFill>
+        <p:spPr>
+          <a:xfrm>
+            <a:off x="927202" y="3090672"/>
+            <a:ext cx="980237" cy="950976"/>
+          </a:xfrm>
+          <a:prstGeom prst="rect">
+            <a:avLst/>
+          </a:prstGeom>
+        </p:spPr>
+      </p:pic>
+      <p:pic>
+        <p:nvPicPr>
+          <p:cNvPr id="8" name="Image 5" descr="/var/folders/hm/sgq6d80d0vq133k7n8dc9bnw0000gn/T/maiershirts-J4Eovy/ref-vereine-5.png">    </p:cNvPr>
+          <p:cNvPicPr>
+            <a:picLocks noChangeAspect="1"/>
+          </p:cNvPicPr>
+          <p:nvPr>
+            <p:ph idx="107" type="pic" hasCustomPrompt="1"/>
+          </p:nvPr>
+        </p:nvPicPr>
+        <p:blipFill>
+          <a:blip r:embed="rId6"/>
+          <a:stretch>
+            <a:fillRect/>
+          </a:stretch>
+        </p:blipFill>
+        <p:spPr>
+          <a:xfrm>
+            <a:off x="3044952" y="3090672"/>
+            <a:ext cx="950976" cy="950976"/>
+          </a:xfrm>
+          <a:prstGeom prst="rect">
+            <a:avLst/>
+          </a:prstGeom>
+        </p:spPr>
+      </p:pic>
+      <p:pic>
+        <p:nvPicPr>
+          <p:cNvPr id="9" name="Image 6" descr="/var/folders/hm/sgq6d80d0vq133k7n8dc9bnw0000gn/T/maiershirts-J4Eovy/ref-vereine-6.png">    </p:cNvPr>
+          <p:cNvPicPr>
+            <a:picLocks noChangeAspect="1"/>
+          </p:cNvPicPr>
+          <p:nvPr>
+            <p:ph idx="108" type="pic" hasCustomPrompt="1"/>
+          </p:nvPr>
+        </p:nvPicPr>
+        <p:blipFill>
+          <a:blip r:embed="rId7"/>
+          <a:stretch>
+            <a:fillRect/>
+          </a:stretch>
+        </p:blipFill>
+        <p:spPr>
+          <a:xfrm>
+            <a:off x="5146014" y="3090672"/>
+            <a:ext cx="955093" cy="950976"/>
+          </a:xfrm>
+          <a:prstGeom prst="rect">
+            <a:avLst/>
+          </a:prstGeom>
+        </p:spPr>
+      </p:pic>
+      <p:pic>
+        <p:nvPicPr>
+          <p:cNvPr id="10" name="Image 7" descr="/var/folders/hm/sgq6d80d0vq133k7n8dc9bnw0000gn/T/maiershirts-J4Eovy/ph-logo-446x326.png">    </p:cNvPr>
+          <p:cNvPicPr>
+            <a:picLocks noChangeAspect="1"/>
+          </p:cNvPicPr>
+          <p:nvPr>
+            <p:ph idx="109" type="pic" hasCustomPrompt="1"/>
+          </p:nvPr>
+        </p:nvPicPr>
+        <p:blipFill>
+          <a:blip r:embed="rId8"/>
+          <a:stretch>
+            <a:fillRect/>
+          </a:stretch>
+        </p:blipFill>
+        <p:spPr>
+          <a:xfrm>
+            <a:off x="6876288" y="2944368"/>
+            <a:ext cx="1700784" cy="1243584"/>
+          </a:xfrm>
+          <a:prstGeom prst="rect">
+            <a:avLst/>
+          </a:prstGeom>
+        </p:spPr>
+      </p:pic>
       <p:sp>
         <p:nvSpPr>
           <p:cNvPr id="25" name="Slide Number Placeholder 0"/>
@@ -12980,145 +13804,50 @@
                 <a:ea typeface="Inter" pitchFamily="34" charset="-122"/>
                 <a:cs typeface="Inter" pitchFamily="34" charset="-120"/>
               </a:rPr>
-              <a:t>Auftragsvolumen nach Produktgruppe</a:t>
+              <a:t>Stickerei im Detail</a:t>
             </a:r>
             <a:endParaRPr lang="en-US" sz="2800" dirty="0"/>
           </a:p>
         </p:txBody>
       </p:sp>
-      <p:graphicFrame>
-        <p:nvGraphicFramePr>
-          <p:cNvPr id="3" name="Chart 0" descr=""/>
-          <p:cNvGraphicFramePr/>
-          <p:nvPr/>
-        </p:nvGraphicFramePr>
-        <p:xfrm>
-          <a:off x="457200" y="1188720"/>
-          <a:ext cx="5303520" cy="3291840"/>
-        </p:xfrm>
-        <a:graphic xmlns:a="http://schemas.openxmlformats.org/drawingml/2006/main">
-          <a:graphicData uri="http://schemas.openxmlformats.org/drawingml/2006/chart">
-            <c:chart xmlns:c="http://schemas.openxmlformats.org/drawingml/2006/chart" r:id="rId1"/>
-          </a:graphicData>
-        </a:graphic>
-      </p:graphicFrame>
-      <p:sp>
-        <p:nvSpPr>
-          <p:cNvPr id="4" name="Shape 1"/>
-          <p:cNvSpPr/>
-          <p:nvPr/>
-        </p:nvSpPr>
-        <p:spPr>
-          <a:xfrm>
-            <a:off x="6035040" y="1188720"/>
-            <a:ext cx="2651760" cy="3291840"/>
-          </a:xfrm>
-          <a:prstGeom prst="roundRect">
-            <a:avLst>
-              <a:gd name="adj" fmla="val 4138"/>
-            </a:avLst>
-          </a:prstGeom>
-          <a:solidFill>
-            <a:srgbClr val="E8DFD0"/>
-          </a:solidFill>
-          <a:ln w="12700">
-            <a:solidFill>
-              <a:srgbClr val="E8DFD0"/>
-            </a:solidFill>
-            <a:prstDash val="solid"/>
-          </a:ln>
-        </p:spPr>
-      </p:sp>
-      <p:sp>
-        <p:nvSpPr>
-          <p:cNvPr id="5" name="Text 2"/>
+      <p:pic>
+        <p:nvPicPr>
+          <p:cNvPr id="3" name="Image 0" descr="/var/folders/hm/sgq6d80d0vq133k7n8dc9bnw0000gn/T/maiershirts-J4Eovy/ph-foto-1056x840.png">    </p:cNvPr>
+          <p:cNvPicPr>
+            <a:picLocks noChangeAspect="1"/>
+          </p:cNvPicPr>
+          <p:nvPr>
+            <p:ph idx="102" type="pic" hasCustomPrompt="1"/>
+          </p:nvPr>
+        </p:nvPicPr>
+        <p:blipFill>
+          <a:blip r:embed="rId1"/>
+          <a:stretch>
+            <a:fillRect/>
+          </a:stretch>
+        </p:blipFill>
+        <p:spPr>
+          <a:xfrm>
+            <a:off x="457200" y="1234440"/>
+            <a:ext cx="4023360" cy="3200400"/>
+          </a:xfrm>
+          <a:prstGeom prst="rect">
+            <a:avLst/>
+          </a:prstGeom>
+        </p:spPr>
+      </p:pic>
+      <p:sp>
+        <p:nvSpPr>
+          <p:cNvPr id="4" name="Text 0"/>
           <p:cNvSpPr txBox="1"/>
-          <p:nvPr/>
-        </p:nvSpPr>
-        <p:spPr>
-          <a:xfrm>
-            <a:off x="6263640" y="1371600"/>
-            <a:ext cx="2194560" cy="274320"/>
-          </a:xfrm>
-          <a:prstGeom prst="rect">
-            <a:avLst/>
-          </a:prstGeom>
-          <a:noFill/>
-          <a:ln/>
-        </p:spPr>
-        <p:txBody>
-          <a:bodyPr wrap="square" lIns="0" tIns="0" rIns="0" bIns="0" rtlCol="0" anchor="ctr"/>
-          <a:lstStyle/>
-          <a:p>
-            <a:pPr indent="0" marL="0">
-              <a:buNone/>
-            </a:pPr>
-            <a:r>
-              <a:rPr lang="en-US" sz="1200" dirty="0">
-                <a:solidFill>
-                  <a:srgbClr val="0F0F0F">
-                    <a:alpha val="60000"/>
-                  </a:srgbClr>
-                </a:solidFill>
-                <a:latin typeface="Inter" pitchFamily="34" charset="0"/>
-                <a:ea typeface="Inter" pitchFamily="34" charset="-122"/>
-                <a:cs typeface="Inter" pitchFamily="34" charset="-120"/>
-              </a:rPr>
-              <a:t>Beispieldaten</a:t>
-            </a:r>
-            <a:endParaRPr lang="en-US" sz="1200" dirty="0"/>
-          </a:p>
-        </p:txBody>
-      </p:sp>
-      <p:sp>
-        <p:nvSpPr>
-          <p:cNvPr id="6" name="Text 3"/>
-          <p:cNvSpPr txBox="1"/>
-          <p:nvPr/>
-        </p:nvSpPr>
-        <p:spPr>
-          <a:xfrm>
-            <a:off x="6263640" y="1691640"/>
-            <a:ext cx="2194560" cy="640080"/>
-          </a:xfrm>
-          <a:prstGeom prst="rect">
-            <a:avLst/>
-          </a:prstGeom>
-          <a:noFill/>
-          <a:ln/>
-        </p:spPr>
-        <p:txBody>
-          <a:bodyPr wrap="square" lIns="0" tIns="0" rIns="0" bIns="0" rtlCol="0" anchor="ctr"/>
-          <a:lstStyle/>
-          <a:p>
-            <a:pPr indent="0" marL="0">
-              <a:buNone/>
-            </a:pPr>
-            <a:r>
-              <a:rPr lang="en-US" sz="1600" b="1" dirty="0">
-                <a:solidFill>
-                  <a:srgbClr val="0F0F0F"/>
-                </a:solidFill>
-                <a:latin typeface="Inter" pitchFamily="34" charset="0"/>
-                <a:ea typeface="Inter" pitchFamily="34" charset="-122"/>
-                <a:cs typeface="Inter" pitchFamily="34" charset="-120"/>
-              </a:rPr>
-              <a:t>T-Shirts machen den größten Anteil aus</a:t>
-            </a:r>
-            <a:endParaRPr lang="en-US" sz="1600" dirty="0"/>
-          </a:p>
-        </p:txBody>
-      </p:sp>
-      <p:sp>
-        <p:nvSpPr>
-          <p:cNvPr id="7" name="Text 4"/>
-          <p:cNvSpPr txBox="1"/>
-          <p:nvPr/>
-        </p:nvSpPr>
-        <p:spPr>
-          <a:xfrm>
-            <a:off x="6263640" y="2423160"/>
-            <a:ext cx="2194560" cy="1097280"/>
+          <p:nvPr>
+            <p:ph idx="103" type="body" hasCustomPrompt="1"/>
+          </p:nvPr>
+        </p:nvSpPr>
+        <p:spPr>
+          <a:xfrm>
+            <a:off x="4846320" y="1234440"/>
+            <a:ext cx="3840480" cy="3200400"/>
           </a:xfrm>
           <a:prstGeom prst="rect">
             <a:avLst/>
@@ -13130,23 +13859,88 @@
           <a:bodyPr wrap="square" lIns="0" tIns="0" rIns="0" bIns="0" rtlCol="0" anchor="t"/>
           <a:lstStyle/>
           <a:p>
-            <a:pPr indent="0" marL="0">
-              <a:buNone/>
-            </a:pPr>
-            <a:r>
-              <a:rPr lang="en-US" sz="1200" dirty="0">
-                <a:solidFill>
-                  <a:srgbClr val="0F0F0F">
-                    <a:alpha val="60000"/>
-                  </a:srgbClr>
-                </a:solidFill>
-                <a:latin typeface="Inter" pitchFamily="34" charset="0"/>
-                <a:ea typeface="Inter" pitchFamily="34" charset="-122"/>
-                <a:cs typeface="Inter" pitchFamily="34" charset="-120"/>
-              </a:rPr>
-              <a:t>Natives Diagramm: Werte per Rechtsklick → „Daten bearbeiten“ ändern.</a:t>
-            </a:r>
-            <a:endParaRPr lang="en-US" sz="1200" dirty="0"/>
+            <a:pPr algn="l" marL="342900" indent="-342900">
+              <a:spcAft>
+                <a:spcPts val="800"/>
+              </a:spcAft>
+              <a:buSzPct val="100000"/>
+              <a:buChar char="•"/>
+            </a:pPr>
+            <a:r>
+              <a:rPr lang="en-US" sz="1600" dirty="0">
+                <a:solidFill>
+                  <a:srgbClr val="0F0F0F"/>
+                </a:solidFill>
+                <a:latin typeface="Inter" pitchFamily="34" charset="0"/>
+                <a:ea typeface="Inter" pitchFamily="34" charset="-122"/>
+                <a:cs typeface="Inter" pitchFamily="34" charset="-120"/>
+              </a:rPr>
+              <a:t>Bis zu 12 Garnfarben pro Motiv</a:t>
+            </a:r>
+            <a:endParaRPr lang="en-US" sz="1600" dirty="0"/>
+          </a:p>
+          <a:p>
+            <a:pPr algn="l" marL="342900" indent="-342900">
+              <a:spcAft>
+                <a:spcPts val="800"/>
+              </a:spcAft>
+              <a:buSzPct val="100000"/>
+              <a:buChar char="•"/>
+            </a:pPr>
+            <a:r>
+              <a:rPr lang="en-US" sz="1600" dirty="0">
+                <a:solidFill>
+                  <a:srgbClr val="0F0F0F"/>
+                </a:solidFill>
+                <a:latin typeface="Inter" pitchFamily="34" charset="0"/>
+                <a:ea typeface="Inter" pitchFamily="34" charset="-122"/>
+                <a:cs typeface="Inter" pitchFamily="34" charset="-120"/>
+              </a:rPr>
+              <a:t>Waschbeständig bis 60 °C</a:t>
+            </a:r>
+            <a:endParaRPr lang="en-US" sz="1600" dirty="0"/>
+          </a:p>
+          <a:p>
+            <a:pPr algn="l" marL="342900" indent="-342900">
+              <a:spcAft>
+                <a:spcPts val="800"/>
+              </a:spcAft>
+              <a:buSzPct val="100000"/>
+              <a:buChar char="•"/>
+            </a:pPr>
+            <a:r>
+              <a:rPr lang="en-US" sz="1600" dirty="0">
+                <a:solidFill>
+                  <a:srgbClr val="0F0F0F"/>
+                </a:solidFill>
+                <a:latin typeface="Inter" pitchFamily="34" charset="0"/>
+                <a:ea typeface="Inter" pitchFamily="34" charset="-122"/>
+                <a:cs typeface="Inter" pitchFamily="34" charset="-120"/>
+              </a:rPr>
+              <a:t>Ideal für Polos, Jacken und Caps</a:t>
+            </a:r>
+            <a:endParaRPr lang="en-US" sz="1600" dirty="0"/>
+          </a:p>
+          <a:p>
+            <a:pPr algn="l" marL="342900" indent="-342900">
+              <a:spcAft>
+                <a:spcPts val="800"/>
+              </a:spcAft>
+              <a:buSzPct val="100000"/>
+              <a:buChar char="•"/>
+            </a:pPr>
+            <a:r>
+              <a:rPr lang="en-US" sz="1600" dirty="0">
+                <a:solidFill>
+                  <a:srgbClr val="0F0F0F"/>
+                </a:solidFill>
+                <a:latin typeface="Inter" pitchFamily="34" charset="0"/>
+                <a:ea typeface="Inter" pitchFamily="34" charset="-122"/>
+                <a:cs typeface="Inter" pitchFamily="34" charset="-120"/>
+              </a:rPr>
+              <a:t>Motivdigitalisierung im Haus</a:t>
+            </a:r>
+            <a:endParaRPr lang="en-US" sz="1600" dirty="0"/>
           </a:p>
         </p:txBody>
       </p:sp>
@@ -13258,24 +14052,145 @@
                 <a:ea typeface="Inter" pitchFamily="34" charset="-122"/>
                 <a:cs typeface="Inter" pitchFamily="34" charset="-120"/>
               </a:rPr>
-              <a:t>Folientitel</a:t>
+              <a:t>Auftragsvolumen nach Produktgruppe</a:t>
             </a:r>
             <a:endParaRPr lang="en-US" sz="2800" dirty="0"/>
           </a:p>
         </p:txBody>
       </p:sp>
-      <p:sp>
-        <p:nvSpPr>
-          <p:cNvPr id="3" name="Text 0"/>
+      <p:graphicFrame>
+        <p:nvGraphicFramePr>
+          <p:cNvPr id="3" name="Chart 0" descr=""/>
+          <p:cNvGraphicFramePr/>
+          <p:nvPr/>
+        </p:nvGraphicFramePr>
+        <p:xfrm>
+          <a:off x="457200" y="1188720"/>
+          <a:ext cx="5303520" cy="3291840"/>
+        </p:xfrm>
+        <a:graphic xmlns:a="http://schemas.openxmlformats.org/drawingml/2006/main">
+          <a:graphicData uri="http://schemas.openxmlformats.org/drawingml/2006/chart">
+            <c:chart xmlns:c="http://schemas.openxmlformats.org/drawingml/2006/chart" r:id="rId1"/>
+          </a:graphicData>
+        </a:graphic>
+      </p:graphicFrame>
+      <p:sp>
+        <p:nvSpPr>
+          <p:cNvPr id="4" name="Shape 1"/>
+          <p:cNvSpPr/>
+          <p:nvPr/>
+        </p:nvSpPr>
+        <p:spPr>
+          <a:xfrm>
+            <a:off x="6035040" y="1188720"/>
+            <a:ext cx="2651760" cy="3291840"/>
+          </a:xfrm>
+          <a:prstGeom prst="roundRect">
+            <a:avLst>
+              <a:gd name="adj" fmla="val 4138"/>
+            </a:avLst>
+          </a:prstGeom>
+          <a:solidFill>
+            <a:srgbClr val="E8DFD0"/>
+          </a:solidFill>
+          <a:ln w="12700">
+            <a:solidFill>
+              <a:srgbClr val="E8DFD0"/>
+            </a:solidFill>
+            <a:prstDash val="solid"/>
+          </a:ln>
+        </p:spPr>
+      </p:sp>
+      <p:sp>
+        <p:nvSpPr>
+          <p:cNvPr id="5" name="Text 2"/>
           <p:cNvSpPr txBox="1"/>
-          <p:nvPr>
-            <p:ph idx="102" type="body" hasCustomPrompt="1"/>
-          </p:nvPr>
-        </p:nvSpPr>
-        <p:spPr>
-          <a:xfrm>
-            <a:off x="457200" y="1234440"/>
-            <a:ext cx="8229600" cy="3200400"/>
+          <p:nvPr/>
+        </p:nvSpPr>
+        <p:spPr>
+          <a:xfrm>
+            <a:off x="6263640" y="1371600"/>
+            <a:ext cx="2194560" cy="274320"/>
+          </a:xfrm>
+          <a:prstGeom prst="rect">
+            <a:avLst/>
+          </a:prstGeom>
+          <a:noFill/>
+          <a:ln/>
+        </p:spPr>
+        <p:txBody>
+          <a:bodyPr wrap="square" lIns="0" tIns="0" rIns="0" bIns="0" rtlCol="0" anchor="ctr"/>
+          <a:lstStyle/>
+          <a:p>
+            <a:pPr indent="0" marL="0">
+              <a:buNone/>
+            </a:pPr>
+            <a:r>
+              <a:rPr lang="en-US" sz="1200" dirty="0">
+                <a:solidFill>
+                  <a:srgbClr val="0F0F0F">
+                    <a:alpha val="60000"/>
+                  </a:srgbClr>
+                </a:solidFill>
+                <a:latin typeface="Inter" pitchFamily="34" charset="0"/>
+                <a:ea typeface="Inter" pitchFamily="34" charset="-122"/>
+                <a:cs typeface="Inter" pitchFamily="34" charset="-120"/>
+              </a:rPr>
+              <a:t>Beispieldaten</a:t>
+            </a:r>
+            <a:endParaRPr lang="en-US" sz="1200" dirty="0"/>
+          </a:p>
+        </p:txBody>
+      </p:sp>
+      <p:sp>
+        <p:nvSpPr>
+          <p:cNvPr id="6" name="Text 3"/>
+          <p:cNvSpPr txBox="1"/>
+          <p:nvPr/>
+        </p:nvSpPr>
+        <p:spPr>
+          <a:xfrm>
+            <a:off x="6263640" y="1691640"/>
+            <a:ext cx="2194560" cy="640080"/>
+          </a:xfrm>
+          <a:prstGeom prst="rect">
+            <a:avLst/>
+          </a:prstGeom>
+          <a:noFill/>
+          <a:ln/>
+        </p:spPr>
+        <p:txBody>
+          <a:bodyPr wrap="square" lIns="0" tIns="0" rIns="0" bIns="0" rtlCol="0" anchor="ctr"/>
+          <a:lstStyle/>
+          <a:p>
+            <a:pPr indent="0" marL="0">
+              <a:buNone/>
+            </a:pPr>
+            <a:r>
+              <a:rPr lang="en-US" sz="1600" b="1" dirty="0">
+                <a:solidFill>
+                  <a:srgbClr val="0F0F0F"/>
+                </a:solidFill>
+                <a:latin typeface="Inter" pitchFamily="34" charset="0"/>
+                <a:ea typeface="Inter" pitchFamily="34" charset="-122"/>
+                <a:cs typeface="Inter" pitchFamily="34" charset="-120"/>
+              </a:rPr>
+              <a:t>T-Shirts machen den größten Anteil aus</a:t>
+            </a:r>
+            <a:endParaRPr lang="en-US" sz="1600" dirty="0"/>
+          </a:p>
+        </p:txBody>
+      </p:sp>
+      <p:sp>
+        <p:nvSpPr>
+          <p:cNvPr id="7" name="Text 4"/>
+          <p:cNvSpPr txBox="1"/>
+          <p:nvPr/>
+        </p:nvSpPr>
+        <p:spPr>
+          <a:xfrm>
+            <a:off x="6263640" y="2423160"/>
+            <a:ext cx="2194560" cy="1097280"/>
           </a:xfrm>
           <a:prstGeom prst="rect">
             <a:avLst/>
@@ -13287,109 +14202,23 @@
           <a:bodyPr wrap="square" lIns="0" tIns="0" rIns="0" bIns="0" rtlCol="0" anchor="t"/>
           <a:lstStyle/>
           <a:p>
-            <a:pPr algn="l" marL="342900" indent="-342900">
-              <a:spcAft>
-                <a:spcPts val="800"/>
-              </a:spcAft>
-              <a:buSzPct val="100000"/>
-              <a:buChar char="•"/>
-            </a:pPr>
-            <a:r>
-              <a:rPr lang="en-US" sz="1600" dirty="0">
-                <a:solidFill>
-                  <a:srgbClr val="0F0F0F"/>
-                </a:solidFill>
-                <a:latin typeface="Inter" pitchFamily="34" charset="0"/>
-                <a:ea typeface="Inter" pitchFamily="34" charset="-122"/>
-                <a:cs typeface="Inter" pitchFamily="34" charset="-120"/>
-              </a:rPr>
-              <a:t>Erste Aussage der Folie</a:t>
-            </a:r>
-            <a:endParaRPr lang="en-US" sz="1600" dirty="0"/>
-          </a:p>
-          <a:p>
-            <a:pPr algn="l" marL="342900" indent="-342900">
-              <a:spcAft>
-                <a:spcPts val="800"/>
-              </a:spcAft>
-              <a:buSzPct val="100000"/>
-              <a:buChar char="•"/>
-            </a:pPr>
-            <a:r>
-              <a:rPr lang="en-US" sz="1600" dirty="0">
-                <a:solidFill>
-                  <a:srgbClr val="0F0F0F"/>
-                </a:solidFill>
-                <a:latin typeface="Inter" pitchFamily="34" charset="0"/>
-                <a:ea typeface="Inter" pitchFamily="34" charset="-122"/>
-                <a:cs typeface="Inter" pitchFamily="34" charset="-120"/>
-              </a:rPr>
-              <a:t>Zweite Aussage mit einer kurzen Erläuterung</a:t>
-            </a:r>
-            <a:endParaRPr lang="en-US" sz="1600" dirty="0"/>
-          </a:p>
-          <a:p>
-            <a:pPr algn="l" marL="342900" indent="-342900">
-              <a:spcAft>
-                <a:spcPts val="800"/>
-              </a:spcAft>
-              <a:buSzPct val="100000"/>
-              <a:buChar char="•"/>
-            </a:pPr>
-            <a:r>
-              <a:rPr lang="en-US" sz="1600" dirty="0">
-                <a:solidFill>
-                  <a:srgbClr val="0F0F0F"/>
-                </a:solidFill>
-                <a:latin typeface="Inter" pitchFamily="34" charset="0"/>
-                <a:ea typeface="Inter" pitchFamily="34" charset="-122"/>
-                <a:cs typeface="Inter" pitchFamily="34" charset="-120"/>
-              </a:rPr>
-              <a:t>Dritte Aussage</a:t>
-            </a:r>
-            <a:endParaRPr lang="en-US" sz="1600" dirty="0"/>
-          </a:p>
-          <a:p>
-            <a:pPr algn="l" lvl="1" marL="685800" indent="-342900">
-              <a:spcAft>
-                <a:spcPts val="800"/>
-              </a:spcAft>
-              <a:buSzPct val="100000"/>
-              <a:buChar char="•"/>
-            </a:pPr>
-            <a:r>
-              <a:rPr lang="en-US" sz="1600" dirty="0">
-                <a:solidFill>
-                  <a:srgbClr val="0F0F0F"/>
-                </a:solidFill>
-                <a:latin typeface="Inter" pitchFamily="34" charset="0"/>
-                <a:ea typeface="Inter" pitchFamily="34" charset="-122"/>
-                <a:cs typeface="Inter" pitchFamily="34" charset="-120"/>
-              </a:rPr>
-              <a:t>Unterpunkt zur dritten Aussage</a:t>
-            </a:r>
-            <a:endParaRPr lang="en-US" sz="1600" dirty="0"/>
-          </a:p>
-          <a:p>
-            <a:pPr algn="l" lvl="1" marL="685800" indent="-342900">
-              <a:spcAft>
-                <a:spcPts val="800"/>
-              </a:spcAft>
-              <a:buSzPct val="100000"/>
-              <a:buChar char="•"/>
-            </a:pPr>
-            <a:r>
-              <a:rPr lang="en-US" sz="1600" dirty="0">
-                <a:solidFill>
-                  <a:srgbClr val="0F0F0F"/>
-                </a:solidFill>
-                <a:latin typeface="Inter" pitchFamily="34" charset="0"/>
-                <a:ea typeface="Inter" pitchFamily="34" charset="-122"/>
-                <a:cs typeface="Inter" pitchFamily="34" charset="-120"/>
-              </a:rPr>
-              <a:t>Weiterer Unterpunkt</a:t>
-            </a:r>
-            <a:endParaRPr lang="en-US" sz="1600" dirty="0"/>
+            <a:pPr indent="0" marL="0">
+              <a:buNone/>
+            </a:pPr>
+            <a:r>
+              <a:rPr lang="en-US" sz="1200" dirty="0">
+                <a:solidFill>
+                  <a:srgbClr val="0F0F0F">
+                    <a:alpha val="60000"/>
+                  </a:srgbClr>
+                </a:solidFill>
+                <a:latin typeface="Inter" pitchFamily="34" charset="0"/>
+                <a:ea typeface="Inter" pitchFamily="34" charset="-122"/>
+                <a:cs typeface="Inter" pitchFamily="34" charset="-120"/>
+              </a:rPr>
+              <a:t>Natives Diagramm: Werte per Rechtsklick → „Daten bearbeiten“ ändern.</a:t>
+            </a:r>
+            <a:endParaRPr lang="en-US" sz="1200" dirty="0"/>
           </a:p>
         </p:txBody>
       </p:sp>
@@ -13476,6 +14305,249 @@
         </p:nvSpPr>
         <p:spPr>
           <a:xfrm>
+            <a:off x="457200" y="320040"/>
+            <a:ext cx="7132320" cy="640080"/>
+          </a:xfrm>
+          <a:prstGeom prst="rect">
+            <a:avLst/>
+          </a:prstGeom>
+          <a:noFill/>
+          <a:ln/>
+        </p:spPr>
+        <p:txBody>
+          <a:bodyPr wrap="square" lIns="0" tIns="0" rIns="0" bIns="0" rtlCol="0" anchor="ctr"/>
+          <a:lstStyle/>
+          <a:p>
+            <a:pPr algn="l" indent="0" marL="0">
+              <a:buNone/>
+            </a:pPr>
+            <a:r>
+              <a:rPr lang="en-US" sz="2800" b="1" dirty="0">
+                <a:solidFill>
+                  <a:srgbClr val="0F0F0F"/>
+                </a:solidFill>
+                <a:latin typeface="Inter" pitchFamily="34" charset="0"/>
+                <a:ea typeface="Inter" pitchFamily="34" charset="-122"/>
+                <a:cs typeface="Inter" pitchFamily="34" charset="-120"/>
+              </a:rPr>
+              <a:t>Folientitel</a:t>
+            </a:r>
+            <a:endParaRPr lang="en-US" sz="2800" dirty="0"/>
+          </a:p>
+        </p:txBody>
+      </p:sp>
+      <p:sp>
+        <p:nvSpPr>
+          <p:cNvPr id="3" name="Text 0"/>
+          <p:cNvSpPr txBox="1"/>
+          <p:nvPr>
+            <p:ph idx="102" type="body" hasCustomPrompt="1"/>
+          </p:nvPr>
+        </p:nvSpPr>
+        <p:spPr>
+          <a:xfrm>
+            <a:off x="457200" y="1234440"/>
+            <a:ext cx="8229600" cy="3200400"/>
+          </a:xfrm>
+          <a:prstGeom prst="rect">
+            <a:avLst/>
+          </a:prstGeom>
+          <a:noFill/>
+          <a:ln/>
+        </p:spPr>
+        <p:txBody>
+          <a:bodyPr wrap="square" lIns="0" tIns="0" rIns="0" bIns="0" rtlCol="0" anchor="t"/>
+          <a:lstStyle/>
+          <a:p>
+            <a:pPr algn="l" marL="342900" indent="-342900">
+              <a:spcAft>
+                <a:spcPts val="800"/>
+              </a:spcAft>
+              <a:buSzPct val="100000"/>
+              <a:buChar char="•"/>
+            </a:pPr>
+            <a:r>
+              <a:rPr lang="en-US" sz="1600" dirty="0">
+                <a:solidFill>
+                  <a:srgbClr val="0F0F0F"/>
+                </a:solidFill>
+                <a:latin typeface="Inter" pitchFamily="34" charset="0"/>
+                <a:ea typeface="Inter" pitchFamily="34" charset="-122"/>
+                <a:cs typeface="Inter" pitchFamily="34" charset="-120"/>
+              </a:rPr>
+              <a:t>Erste Aussage der Folie</a:t>
+            </a:r>
+            <a:endParaRPr lang="en-US" sz="1600" dirty="0"/>
+          </a:p>
+          <a:p>
+            <a:pPr algn="l" marL="342900" indent="-342900">
+              <a:spcAft>
+                <a:spcPts val="800"/>
+              </a:spcAft>
+              <a:buSzPct val="100000"/>
+              <a:buChar char="•"/>
+            </a:pPr>
+            <a:r>
+              <a:rPr lang="en-US" sz="1600" dirty="0">
+                <a:solidFill>
+                  <a:srgbClr val="0F0F0F"/>
+                </a:solidFill>
+                <a:latin typeface="Inter" pitchFamily="34" charset="0"/>
+                <a:ea typeface="Inter" pitchFamily="34" charset="-122"/>
+                <a:cs typeface="Inter" pitchFamily="34" charset="-120"/>
+              </a:rPr>
+              <a:t>Zweite Aussage mit einer kurzen Erläuterung</a:t>
+            </a:r>
+            <a:endParaRPr lang="en-US" sz="1600" dirty="0"/>
+          </a:p>
+          <a:p>
+            <a:pPr algn="l" marL="342900" indent="-342900">
+              <a:spcAft>
+                <a:spcPts val="800"/>
+              </a:spcAft>
+              <a:buSzPct val="100000"/>
+              <a:buChar char="•"/>
+            </a:pPr>
+            <a:r>
+              <a:rPr lang="en-US" sz="1600" dirty="0">
+                <a:solidFill>
+                  <a:srgbClr val="0F0F0F"/>
+                </a:solidFill>
+                <a:latin typeface="Inter" pitchFamily="34" charset="0"/>
+                <a:ea typeface="Inter" pitchFamily="34" charset="-122"/>
+                <a:cs typeface="Inter" pitchFamily="34" charset="-120"/>
+              </a:rPr>
+              <a:t>Dritte Aussage</a:t>
+            </a:r>
+            <a:endParaRPr lang="en-US" sz="1600" dirty="0"/>
+          </a:p>
+          <a:p>
+            <a:pPr algn="l" lvl="1" marL="685800" indent="-342900">
+              <a:spcAft>
+                <a:spcPts val="800"/>
+              </a:spcAft>
+              <a:buSzPct val="100000"/>
+              <a:buChar char="•"/>
+            </a:pPr>
+            <a:r>
+              <a:rPr lang="en-US" sz="1600" dirty="0">
+                <a:solidFill>
+                  <a:srgbClr val="0F0F0F"/>
+                </a:solidFill>
+                <a:latin typeface="Inter" pitchFamily="34" charset="0"/>
+                <a:ea typeface="Inter" pitchFamily="34" charset="-122"/>
+                <a:cs typeface="Inter" pitchFamily="34" charset="-120"/>
+              </a:rPr>
+              <a:t>Unterpunkt zur dritten Aussage</a:t>
+            </a:r>
+            <a:endParaRPr lang="en-US" sz="1600" dirty="0"/>
+          </a:p>
+          <a:p>
+            <a:pPr algn="l" lvl="1" marL="685800" indent="-342900">
+              <a:spcAft>
+                <a:spcPts val="800"/>
+              </a:spcAft>
+              <a:buSzPct val="100000"/>
+              <a:buChar char="•"/>
+            </a:pPr>
+            <a:r>
+              <a:rPr lang="en-US" sz="1600" dirty="0">
+                <a:solidFill>
+                  <a:srgbClr val="0F0F0F"/>
+                </a:solidFill>
+                <a:latin typeface="Inter" pitchFamily="34" charset="0"/>
+                <a:ea typeface="Inter" pitchFamily="34" charset="-122"/>
+                <a:cs typeface="Inter" pitchFamily="34" charset="-120"/>
+              </a:rPr>
+              <a:t>Weiterer Unterpunkt</a:t>
+            </a:r>
+            <a:endParaRPr lang="en-US" sz="1600" dirty="0"/>
+          </a:p>
+        </p:txBody>
+      </p:sp>
+      <p:sp>
+        <p:nvSpPr>
+          <p:cNvPr id="25" name="Slide Number Placeholder 0"/>
+          <p:cNvSpPr>
+            <a:spLocks noGrp="1"/>
+          </p:cNvSpPr>
+          <p:nvPr>
+            <p:ph type="sldNum" sz="quarter" idx="4294967295"/>
+          </p:nvPr>
+        </p:nvSpPr>
+        <p:spPr>
+          <a:xfrm>
+            <a:off x="8229600" y="4709160"/>
+            <a:ext cx="457200" cy="274320"/>
+          </a:xfrm>
+          <a:prstGeom prst="rect">
+            <a:avLst/>
+          </a:prstGeom>
+          <a:extLst>
+            <a:ext uri="{C572A759-6A51-4108-AA02-DFA0A04FC94B}">
+              <ma14:wrappingTextBoxFlag xmlns:ma14="http://schemas.microsoft.com/office/mac/drawingml/2011/main" val="0"/>
+            </a:ext>
+          </a:extLst>
+        </p:spPr>
+        <p:txBody>
+          <a:bodyPr lIns="0" tIns="0" rIns="0" bIns="0"/>
+          <a:lstStyle>
+            <a:lvl1pPr>
+              <a:defRPr sz="1000">
+                <a:solidFill>
+                  <a:srgbClr val="0F0F0F"/>
+                </a:solidFill>
+                <a:latin typeface="Inter"/>
+                <a:ea typeface="Inter"/>
+                <a:cs typeface="Inter"/>
+              </a:defRPr>
+            </a:lvl1pPr>
+          </a:lstStyle>
+          <a:p>
+            <a:pPr algn="r"/>
+            <a:fld id="{F7021451-1387-4CA6-816F-3879F97B5CBC}" type="slidenum">
+              <a:rPr b="0" lang="en-US"/>
+              <a:t>15</a:t>
+            </a:fld>
+            <a:endParaRPr lang="en-US"/>
+          </a:p>
+        </p:txBody>
+      </p:sp>
+    </p:spTree>
+  </p:cSld>
+  <p:clrMapOvr>
+    <a:masterClrMapping/>
+  </p:clrMapOvr>
+</p:sld>
+</file>
+
+<file path=ppt/slides/slide16.xml><?xml version="1.0" encoding="utf-8"?>
+<p:sld xmlns:a="http://schemas.openxmlformats.org/drawingml/2006/main" xmlns:r="http://schemas.openxmlformats.org/officeDocument/2006/relationships" xmlns:p="http://schemas.openxmlformats.org/presentationml/2006/main">
+  <p:cSld name="Slide 16">
+    <p:spTree>
+      <p:nvGrpSpPr>
+        <p:cNvPr id="1" name=""/>
+        <p:cNvGrpSpPr/>
+        <p:nvPr/>
+      </p:nvGrpSpPr>
+      <p:grpSpPr>
+        <a:xfrm>
+          <a:off x="0" y="0"/>
+          <a:ext cx="0" cy="0"/>
+          <a:chOff x="0" y="0"/>
+          <a:chExt cx="0" cy="0"/>
+        </a:xfrm>
+      </p:grpSpPr>
+      <p:sp>
+        <p:nvSpPr>
+          <p:cNvPr id="2" name="Text 0"/>
+          <p:cNvSpPr txBox="1"/>
+          <p:nvPr>
+            <p:ph idx="101" type="title" hasCustomPrompt="1"/>
+          </p:nvPr>
+        </p:nvSpPr>
+        <p:spPr>
+          <a:xfrm>
             <a:off x="548640" y="1371600"/>
             <a:ext cx="4846320" cy="1005840"/>
           </a:xfrm>
@@ -13552,7 +14624,7 @@
       </p:sp>
       <p:pic>
         <p:nvPicPr>
-          <p:cNvPr id="4" name="Image 0" descr="/var/folders/hm/sgq6d80d0vq133k7n8dc9bnw0000gn/T/maiershirts-dzZNxb/ph-portrait-252x252.png">    </p:cNvPr>
+          <p:cNvPr id="4" name="Image 0" descr="/var/folders/hm/sgq6d80d0vq133k7n8dc9bnw0000gn/T/maiershirts-J4Eovy/ph-portrait-252x252.png">    </p:cNvPr>
           <p:cNvPicPr>
             <a:picLocks noChangeAspect="1"/>
           </p:cNvPicPr>
@@ -13761,7 +14833,7 @@
       </p:sp>
       <p:pic>
         <p:nvPicPr>
-          <p:cNvPr id="9" name="Image 1" descr="/var/folders/hm/sgq6d80d0vq133k7n8dc9bnw0000gn/T/maiershirts-dzZNxb/ph-qr-240x240.png">    </p:cNvPr>
+          <p:cNvPr id="9" name="Image 1" descr="/var/folders/hm/sgq6d80d0vq133k7n8dc9bnw0000gn/T/maiershirts-J4Eovy/ph-qr-240x240.png">    </p:cNvPr>
           <p:cNvPicPr>
             <a:picLocks noChangeAspect="1"/>
           </p:cNvPicPr>
@@ -15177,7 +16249,7 @@
       </p:grpSpPr>
       <p:pic>
         <p:nvPicPr>
-          <p:cNvPr id="2" name="Image 0" descr="/var/folders/hm/sgq6d80d0vq133k7n8dc9bnw0000gn/T/maiershirts-dzZNxb/ph-foto-2400x1008.png">    </p:cNvPr>
+          <p:cNvPr id="2" name="Image 0" descr="/var/folders/hm/sgq6d80d0vq133k7n8dc9bnw0000gn/T/maiershirts-J4Eovy/ph-foto-2400x1008.png">    </p:cNvPr>
           <p:cNvPicPr>
             <a:picLocks noChangeAspect="1"/>
           </p:cNvPicPr>
@@ -16335,7 +17407,7 @@
       </p:sp>
       <p:pic>
         <p:nvPicPr>
-          <p:cNvPr id="3" name="Image 0" descr="/var/folders/hm/sgq6d80d0vq133k7n8dc9bnw0000gn/T/maiershirts-dzZNxb/ph-foto-696x456.png">    </p:cNvPr>
+          <p:cNvPr id="3" name="Image 0" descr="/var/folders/hm/sgq6d80d0vq133k7n8dc9bnw0000gn/T/maiershirts-J4Eovy/ph-foto-696x456.png">    </p:cNvPr>
           <p:cNvPicPr>
             <a:picLocks noChangeAspect="1"/>
           </p:cNvPicPr>
@@ -16505,7 +17577,7 @@
       </p:sp>
       <p:pic>
         <p:nvPicPr>
-          <p:cNvPr id="7" name="Image 1" descr="/var/folders/hm/sgq6d80d0vq133k7n8dc9bnw0000gn/T/maiershirts-dzZNxb/ph-foto-696x456.png">    </p:cNvPr>
+          <p:cNvPr id="7" name="Image 1" descr="/var/folders/hm/sgq6d80d0vq133k7n8dc9bnw0000gn/T/maiershirts-J4Eovy/ph-foto-696x456.png">    </p:cNvPr>
           <p:cNvPicPr>
             <a:picLocks noChangeAspect="1"/>
           </p:cNvPicPr>
@@ -16675,7 +17747,7 @@
       </p:sp>
       <p:pic>
         <p:nvPicPr>
-          <p:cNvPr id="11" name="Image 2" descr="/var/folders/hm/sgq6d80d0vq133k7n8dc9bnw0000gn/T/maiershirts-dzZNxb/ph-foto-696x456.png">    </p:cNvPr>
+          <p:cNvPr id="11" name="Image 2" descr="/var/folders/hm/sgq6d80d0vq133k7n8dc9bnw0000gn/T/maiershirts-J4Eovy/ph-foto-696x456.png">    </p:cNvPr>
           <p:cNvPicPr>
             <a:picLocks noChangeAspect="1"/>
           </p:cNvPicPr>

</xml_diff>

<commit_message>
Vereinsfolie: Namen unter den Wappen
Layout MS_REFERENZEN_WAPPEN bekommt je Feld einen Namensplatzhalter,
Namen kommen aus assets/referenzen/vereine/namen.json.

Co-Authored-By: Claude Fable 5.1 <noreply@anthropic.com>
</commit_message>
<xml_diff>
--- a/presentation/dist/Maiershirts_Master.pptx
+++ b/presentation/dist/Maiershirts_Master.pptx
@@ -7020,7 +7020,7 @@
         <p:spPr>
           <a:xfrm>
             <a:off x="566928" y="1344168"/>
-            <a:ext cx="1700784" cy="1243584"/>
+            <a:ext cx="1700784" cy="960120"/>
           </a:xfrm>
           <a:prstGeom prst="rect">
             <a:avLst/>
@@ -7071,13 +7071,13 @@
           <p:cNvPr id="5" name="Text 0"/>
           <p:cNvSpPr/>
           <p:nvPr>
-            <p:ph idx="103" type="pic" hasCustomPrompt="1"/>
-          </p:nvPr>
-        </p:nvSpPr>
-        <p:spPr>
-          <a:xfrm>
-            <a:off x="2670048" y="1344168"/>
-            <a:ext cx="1700784" cy="1243584"/>
+            <p:ph idx="103" type="body" hasCustomPrompt="1"/>
+          </p:nvPr>
+        </p:nvSpPr>
+        <p:spPr>
+          <a:xfrm>
+            <a:off x="566928" y="2414016"/>
+            <a:ext cx="1700784" cy="274320"/>
           </a:xfrm>
           <a:prstGeom prst="rect">
             <a:avLst/>
@@ -7090,6 +7090,59 @@
           <a:lstStyle>
             <a:lvl1pPr algn="ctr" indent="0" marL="0">
               <a:buNone/>
+              <a:defRPr lang="en-US" sz="1100" b="1" dirty="0">
+                <a:solidFill>
+                  <a:srgbClr val="0F0F0F"/>
+                </a:solidFill>
+                <a:latin typeface="Inter" pitchFamily="34" charset="0"/>
+                <a:ea typeface="Inter" pitchFamily="34" charset="-122"/>
+                <a:cs typeface="Inter" pitchFamily="34" charset="-120"/>
+              </a:defRPr>
+            </a:lvl1pPr>
+          </a:lstStyle>
+          <a:p>
+            <a:pPr algn="ctr" indent="0" marL="0">
+              <a:buNone/>
+            </a:pPr>
+            <a:r>
+              <a:rPr lang="en-US" sz="1100" b="1" dirty="0">
+                <a:solidFill>
+                  <a:srgbClr val="0F0F0F"/>
+                </a:solidFill>
+                <a:latin typeface="Inter" pitchFamily="34" charset="0"/>
+                <a:ea typeface="Inter" pitchFamily="34" charset="-122"/>
+                <a:cs typeface="Inter" pitchFamily="34" charset="-120"/>
+              </a:rPr>
+              <a:t>Vereinsname</a:t>
+            </a:r>
+            <a:endParaRPr lang="en-US" sz="1100" dirty="0"/>
+          </a:p>
+        </p:txBody>
+      </p:sp>
+      <p:sp>
+        <p:nvSpPr>
+          <p:cNvPr id="6" name="Text 0"/>
+          <p:cNvSpPr/>
+          <p:nvPr>
+            <p:ph idx="104" type="pic" hasCustomPrompt="1"/>
+          </p:nvPr>
+        </p:nvSpPr>
+        <p:spPr>
+          <a:xfrm>
+            <a:off x="2670048" y="1344168"/>
+            <a:ext cx="1700784" cy="960120"/>
+          </a:xfrm>
+          <a:prstGeom prst="rect">
+            <a:avLst/>
+          </a:prstGeom>
+          <a:noFill/>
+          <a:ln/>
+        </p:spPr>
+        <p:txBody>
+          <a:bodyPr wrap="square" rtlCol="0"/>
+          <a:lstStyle>
+            <a:lvl1pPr algn="ctr" indent="0" marL="0">
+              <a:buNone/>
               <a:defRPr lang="en-US" sz="1200" dirty="0">
                 <a:solidFill>
                   <a:srgbClr val="0F0F0F">
@@ -7125,16 +7178,16 @@
       </p:sp>
       <p:sp>
         <p:nvSpPr>
-          <p:cNvPr id="6" name="Text 0"/>
+          <p:cNvPr id="7" name="Text 0"/>
           <p:cNvSpPr/>
           <p:nvPr>
-            <p:ph idx="104" type="pic" hasCustomPrompt="1"/>
-          </p:nvPr>
-        </p:nvSpPr>
-        <p:spPr>
-          <a:xfrm>
-            <a:off x="4773168" y="1344168"/>
-            <a:ext cx="1700784" cy="1243584"/>
+            <p:ph idx="105" type="body" hasCustomPrompt="1"/>
+          </p:nvPr>
+        </p:nvSpPr>
+        <p:spPr>
+          <a:xfrm>
+            <a:off x="2670048" y="2414016"/>
+            <a:ext cx="1700784" cy="274320"/>
           </a:xfrm>
           <a:prstGeom prst="rect">
             <a:avLst/>
@@ -7147,6 +7200,59 @@
           <a:lstStyle>
             <a:lvl1pPr algn="ctr" indent="0" marL="0">
               <a:buNone/>
+              <a:defRPr lang="en-US" sz="1100" b="1" dirty="0">
+                <a:solidFill>
+                  <a:srgbClr val="0F0F0F"/>
+                </a:solidFill>
+                <a:latin typeface="Inter" pitchFamily="34" charset="0"/>
+                <a:ea typeface="Inter" pitchFamily="34" charset="-122"/>
+                <a:cs typeface="Inter" pitchFamily="34" charset="-120"/>
+              </a:defRPr>
+            </a:lvl1pPr>
+          </a:lstStyle>
+          <a:p>
+            <a:pPr algn="ctr" indent="0" marL="0">
+              <a:buNone/>
+            </a:pPr>
+            <a:r>
+              <a:rPr lang="en-US" sz="1100" b="1" dirty="0">
+                <a:solidFill>
+                  <a:srgbClr val="0F0F0F"/>
+                </a:solidFill>
+                <a:latin typeface="Inter" pitchFamily="34" charset="0"/>
+                <a:ea typeface="Inter" pitchFamily="34" charset="-122"/>
+                <a:cs typeface="Inter" pitchFamily="34" charset="-120"/>
+              </a:rPr>
+              <a:t>Vereinsname</a:t>
+            </a:r>
+            <a:endParaRPr lang="en-US" sz="1100" dirty="0"/>
+          </a:p>
+        </p:txBody>
+      </p:sp>
+      <p:sp>
+        <p:nvSpPr>
+          <p:cNvPr id="8" name="Text 0"/>
+          <p:cNvSpPr/>
+          <p:nvPr>
+            <p:ph idx="106" type="pic" hasCustomPrompt="1"/>
+          </p:nvPr>
+        </p:nvSpPr>
+        <p:spPr>
+          <a:xfrm>
+            <a:off x="4773168" y="1344168"/>
+            <a:ext cx="1700784" cy="960120"/>
+          </a:xfrm>
+          <a:prstGeom prst="rect">
+            <a:avLst/>
+          </a:prstGeom>
+          <a:noFill/>
+          <a:ln/>
+        </p:spPr>
+        <p:txBody>
+          <a:bodyPr wrap="square" rtlCol="0"/>
+          <a:lstStyle>
+            <a:lvl1pPr algn="ctr" indent="0" marL="0">
+              <a:buNone/>
               <a:defRPr lang="en-US" sz="1200" dirty="0">
                 <a:solidFill>
                   <a:srgbClr val="0F0F0F">
@@ -7182,16 +7288,16 @@
       </p:sp>
       <p:sp>
         <p:nvSpPr>
-          <p:cNvPr id="7" name="Text 0"/>
+          <p:cNvPr id="9" name="Text 0"/>
           <p:cNvSpPr/>
           <p:nvPr>
-            <p:ph idx="105" type="pic" hasCustomPrompt="1"/>
-          </p:nvPr>
-        </p:nvSpPr>
-        <p:spPr>
-          <a:xfrm>
-            <a:off x="6876288" y="1344168"/>
-            <a:ext cx="1700784" cy="1243584"/>
+            <p:ph idx="107" type="body" hasCustomPrompt="1"/>
+          </p:nvPr>
+        </p:nvSpPr>
+        <p:spPr>
+          <a:xfrm>
+            <a:off x="4773168" y="2414016"/>
+            <a:ext cx="1700784" cy="274320"/>
           </a:xfrm>
           <a:prstGeom prst="rect">
             <a:avLst/>
@@ -7204,6 +7310,59 @@
           <a:lstStyle>
             <a:lvl1pPr algn="ctr" indent="0" marL="0">
               <a:buNone/>
+              <a:defRPr lang="en-US" sz="1100" b="1" dirty="0">
+                <a:solidFill>
+                  <a:srgbClr val="0F0F0F"/>
+                </a:solidFill>
+                <a:latin typeface="Inter" pitchFamily="34" charset="0"/>
+                <a:ea typeface="Inter" pitchFamily="34" charset="-122"/>
+                <a:cs typeface="Inter" pitchFamily="34" charset="-120"/>
+              </a:defRPr>
+            </a:lvl1pPr>
+          </a:lstStyle>
+          <a:p>
+            <a:pPr algn="ctr" indent="0" marL="0">
+              <a:buNone/>
+            </a:pPr>
+            <a:r>
+              <a:rPr lang="en-US" sz="1100" b="1" dirty="0">
+                <a:solidFill>
+                  <a:srgbClr val="0F0F0F"/>
+                </a:solidFill>
+                <a:latin typeface="Inter" pitchFamily="34" charset="0"/>
+                <a:ea typeface="Inter" pitchFamily="34" charset="-122"/>
+                <a:cs typeface="Inter" pitchFamily="34" charset="-120"/>
+              </a:rPr>
+              <a:t>Vereinsname</a:t>
+            </a:r>
+            <a:endParaRPr lang="en-US" sz="1100" dirty="0"/>
+          </a:p>
+        </p:txBody>
+      </p:sp>
+      <p:sp>
+        <p:nvSpPr>
+          <p:cNvPr id="10" name="Text 0"/>
+          <p:cNvSpPr/>
+          <p:nvPr>
+            <p:ph idx="108" type="pic" hasCustomPrompt="1"/>
+          </p:nvPr>
+        </p:nvSpPr>
+        <p:spPr>
+          <a:xfrm>
+            <a:off x="6876288" y="1344168"/>
+            <a:ext cx="1700784" cy="960120"/>
+          </a:xfrm>
+          <a:prstGeom prst="rect">
+            <a:avLst/>
+          </a:prstGeom>
+          <a:noFill/>
+          <a:ln/>
+        </p:spPr>
+        <p:txBody>
+          <a:bodyPr wrap="square" rtlCol="0"/>
+          <a:lstStyle>
+            <a:lvl1pPr algn="ctr" indent="0" marL="0">
+              <a:buNone/>
               <a:defRPr lang="en-US" sz="1200" dirty="0">
                 <a:solidFill>
                   <a:srgbClr val="0F0F0F">
@@ -7239,16 +7398,16 @@
       </p:sp>
       <p:sp>
         <p:nvSpPr>
-          <p:cNvPr id="8" name="Text 0"/>
+          <p:cNvPr id="11" name="Text 0"/>
           <p:cNvSpPr/>
           <p:nvPr>
-            <p:ph idx="106" type="pic" hasCustomPrompt="1"/>
-          </p:nvPr>
-        </p:nvSpPr>
-        <p:spPr>
-          <a:xfrm>
-            <a:off x="566928" y="2944368"/>
-            <a:ext cx="1700784" cy="1243584"/>
+            <p:ph idx="109" type="body" hasCustomPrompt="1"/>
+          </p:nvPr>
+        </p:nvSpPr>
+        <p:spPr>
+          <a:xfrm>
+            <a:off x="6876288" y="2414016"/>
+            <a:ext cx="1700784" cy="274320"/>
           </a:xfrm>
           <a:prstGeom prst="rect">
             <a:avLst/>
@@ -7261,6 +7420,59 @@
           <a:lstStyle>
             <a:lvl1pPr algn="ctr" indent="0" marL="0">
               <a:buNone/>
+              <a:defRPr lang="en-US" sz="1100" b="1" dirty="0">
+                <a:solidFill>
+                  <a:srgbClr val="0F0F0F"/>
+                </a:solidFill>
+                <a:latin typeface="Inter" pitchFamily="34" charset="0"/>
+                <a:ea typeface="Inter" pitchFamily="34" charset="-122"/>
+                <a:cs typeface="Inter" pitchFamily="34" charset="-120"/>
+              </a:defRPr>
+            </a:lvl1pPr>
+          </a:lstStyle>
+          <a:p>
+            <a:pPr algn="ctr" indent="0" marL="0">
+              <a:buNone/>
+            </a:pPr>
+            <a:r>
+              <a:rPr lang="en-US" sz="1100" b="1" dirty="0">
+                <a:solidFill>
+                  <a:srgbClr val="0F0F0F"/>
+                </a:solidFill>
+                <a:latin typeface="Inter" pitchFamily="34" charset="0"/>
+                <a:ea typeface="Inter" pitchFamily="34" charset="-122"/>
+                <a:cs typeface="Inter" pitchFamily="34" charset="-120"/>
+              </a:rPr>
+              <a:t>Vereinsname</a:t>
+            </a:r>
+            <a:endParaRPr lang="en-US" sz="1100" dirty="0"/>
+          </a:p>
+        </p:txBody>
+      </p:sp>
+      <p:sp>
+        <p:nvSpPr>
+          <p:cNvPr id="12" name="Text 0"/>
+          <p:cNvSpPr/>
+          <p:nvPr>
+            <p:ph idx="110" type="pic" hasCustomPrompt="1"/>
+          </p:nvPr>
+        </p:nvSpPr>
+        <p:spPr>
+          <a:xfrm>
+            <a:off x="566928" y="2944368"/>
+            <a:ext cx="1700784" cy="960120"/>
+          </a:xfrm>
+          <a:prstGeom prst="rect">
+            <a:avLst/>
+          </a:prstGeom>
+          <a:noFill/>
+          <a:ln/>
+        </p:spPr>
+        <p:txBody>
+          <a:bodyPr wrap="square" rtlCol="0"/>
+          <a:lstStyle>
+            <a:lvl1pPr algn="ctr" indent="0" marL="0">
+              <a:buNone/>
               <a:defRPr lang="en-US" sz="1200" dirty="0">
                 <a:solidFill>
                   <a:srgbClr val="0F0F0F">
@@ -7296,16 +7508,16 @@
       </p:sp>
       <p:sp>
         <p:nvSpPr>
-          <p:cNvPr id="9" name="Text 0"/>
+          <p:cNvPr id="13" name="Text 0"/>
           <p:cNvSpPr/>
           <p:nvPr>
-            <p:ph idx="107" type="pic" hasCustomPrompt="1"/>
-          </p:nvPr>
-        </p:nvSpPr>
-        <p:spPr>
-          <a:xfrm>
-            <a:off x="2670048" y="2944368"/>
-            <a:ext cx="1700784" cy="1243584"/>
+            <p:ph idx="111" type="body" hasCustomPrompt="1"/>
+          </p:nvPr>
+        </p:nvSpPr>
+        <p:spPr>
+          <a:xfrm>
+            <a:off x="566928" y="4014216"/>
+            <a:ext cx="1700784" cy="274320"/>
           </a:xfrm>
           <a:prstGeom prst="rect">
             <a:avLst/>
@@ -7318,6 +7530,59 @@
           <a:lstStyle>
             <a:lvl1pPr algn="ctr" indent="0" marL="0">
               <a:buNone/>
+              <a:defRPr lang="en-US" sz="1100" b="1" dirty="0">
+                <a:solidFill>
+                  <a:srgbClr val="0F0F0F"/>
+                </a:solidFill>
+                <a:latin typeface="Inter" pitchFamily="34" charset="0"/>
+                <a:ea typeface="Inter" pitchFamily="34" charset="-122"/>
+                <a:cs typeface="Inter" pitchFamily="34" charset="-120"/>
+              </a:defRPr>
+            </a:lvl1pPr>
+          </a:lstStyle>
+          <a:p>
+            <a:pPr algn="ctr" indent="0" marL="0">
+              <a:buNone/>
+            </a:pPr>
+            <a:r>
+              <a:rPr lang="en-US" sz="1100" b="1" dirty="0">
+                <a:solidFill>
+                  <a:srgbClr val="0F0F0F"/>
+                </a:solidFill>
+                <a:latin typeface="Inter" pitchFamily="34" charset="0"/>
+                <a:ea typeface="Inter" pitchFamily="34" charset="-122"/>
+                <a:cs typeface="Inter" pitchFamily="34" charset="-120"/>
+              </a:rPr>
+              <a:t>Vereinsname</a:t>
+            </a:r>
+            <a:endParaRPr lang="en-US" sz="1100" dirty="0"/>
+          </a:p>
+        </p:txBody>
+      </p:sp>
+      <p:sp>
+        <p:nvSpPr>
+          <p:cNvPr id="14" name="Text 0"/>
+          <p:cNvSpPr/>
+          <p:nvPr>
+            <p:ph idx="112" type="pic" hasCustomPrompt="1"/>
+          </p:nvPr>
+        </p:nvSpPr>
+        <p:spPr>
+          <a:xfrm>
+            <a:off x="2670048" y="2944368"/>
+            <a:ext cx="1700784" cy="960120"/>
+          </a:xfrm>
+          <a:prstGeom prst="rect">
+            <a:avLst/>
+          </a:prstGeom>
+          <a:noFill/>
+          <a:ln/>
+        </p:spPr>
+        <p:txBody>
+          <a:bodyPr wrap="square" rtlCol="0"/>
+          <a:lstStyle>
+            <a:lvl1pPr algn="ctr" indent="0" marL="0">
+              <a:buNone/>
               <a:defRPr lang="en-US" sz="1200" dirty="0">
                 <a:solidFill>
                   <a:srgbClr val="0F0F0F">
@@ -7353,16 +7618,16 @@
       </p:sp>
       <p:sp>
         <p:nvSpPr>
-          <p:cNvPr id="10" name="Text 0"/>
+          <p:cNvPr id="15" name="Text 0"/>
           <p:cNvSpPr/>
           <p:nvPr>
-            <p:ph idx="108" type="pic" hasCustomPrompt="1"/>
-          </p:nvPr>
-        </p:nvSpPr>
-        <p:spPr>
-          <a:xfrm>
-            <a:off x="4773168" y="2944368"/>
-            <a:ext cx="1700784" cy="1243584"/>
+            <p:ph idx="113" type="body" hasCustomPrompt="1"/>
+          </p:nvPr>
+        </p:nvSpPr>
+        <p:spPr>
+          <a:xfrm>
+            <a:off x="2670048" y="4014216"/>
+            <a:ext cx="1700784" cy="274320"/>
           </a:xfrm>
           <a:prstGeom prst="rect">
             <a:avLst/>
@@ -7375,6 +7640,59 @@
           <a:lstStyle>
             <a:lvl1pPr algn="ctr" indent="0" marL="0">
               <a:buNone/>
+              <a:defRPr lang="en-US" sz="1100" b="1" dirty="0">
+                <a:solidFill>
+                  <a:srgbClr val="0F0F0F"/>
+                </a:solidFill>
+                <a:latin typeface="Inter" pitchFamily="34" charset="0"/>
+                <a:ea typeface="Inter" pitchFamily="34" charset="-122"/>
+                <a:cs typeface="Inter" pitchFamily="34" charset="-120"/>
+              </a:defRPr>
+            </a:lvl1pPr>
+          </a:lstStyle>
+          <a:p>
+            <a:pPr algn="ctr" indent="0" marL="0">
+              <a:buNone/>
+            </a:pPr>
+            <a:r>
+              <a:rPr lang="en-US" sz="1100" b="1" dirty="0">
+                <a:solidFill>
+                  <a:srgbClr val="0F0F0F"/>
+                </a:solidFill>
+                <a:latin typeface="Inter" pitchFamily="34" charset="0"/>
+                <a:ea typeface="Inter" pitchFamily="34" charset="-122"/>
+                <a:cs typeface="Inter" pitchFamily="34" charset="-120"/>
+              </a:rPr>
+              <a:t>Vereinsname</a:t>
+            </a:r>
+            <a:endParaRPr lang="en-US" sz="1100" dirty="0"/>
+          </a:p>
+        </p:txBody>
+      </p:sp>
+      <p:sp>
+        <p:nvSpPr>
+          <p:cNvPr id="16" name="Text 0"/>
+          <p:cNvSpPr/>
+          <p:nvPr>
+            <p:ph idx="114" type="pic" hasCustomPrompt="1"/>
+          </p:nvPr>
+        </p:nvSpPr>
+        <p:spPr>
+          <a:xfrm>
+            <a:off x="4773168" y="2944368"/>
+            <a:ext cx="1700784" cy="960120"/>
+          </a:xfrm>
+          <a:prstGeom prst="rect">
+            <a:avLst/>
+          </a:prstGeom>
+          <a:noFill/>
+          <a:ln/>
+        </p:spPr>
+        <p:txBody>
+          <a:bodyPr wrap="square" rtlCol="0"/>
+          <a:lstStyle>
+            <a:lvl1pPr algn="ctr" indent="0" marL="0">
+              <a:buNone/>
               <a:defRPr lang="en-US" sz="1200" dirty="0">
                 <a:solidFill>
                   <a:srgbClr val="0F0F0F">
@@ -7410,16 +7728,16 @@
       </p:sp>
       <p:sp>
         <p:nvSpPr>
-          <p:cNvPr id="11" name="Text 0"/>
+          <p:cNvPr id="17" name="Text 0"/>
           <p:cNvSpPr/>
           <p:nvPr>
-            <p:ph idx="109" type="pic" hasCustomPrompt="1"/>
-          </p:nvPr>
-        </p:nvSpPr>
-        <p:spPr>
-          <a:xfrm>
-            <a:off x="6876288" y="2944368"/>
-            <a:ext cx="1700784" cy="1243584"/>
+            <p:ph idx="115" type="body" hasCustomPrompt="1"/>
+          </p:nvPr>
+        </p:nvSpPr>
+        <p:spPr>
+          <a:xfrm>
+            <a:off x="4773168" y="4014216"/>
+            <a:ext cx="1700784" cy="274320"/>
           </a:xfrm>
           <a:prstGeom prst="rect">
             <a:avLst/>
@@ -7432,6 +7750,59 @@
           <a:lstStyle>
             <a:lvl1pPr algn="ctr" indent="0" marL="0">
               <a:buNone/>
+              <a:defRPr lang="en-US" sz="1100" b="1" dirty="0">
+                <a:solidFill>
+                  <a:srgbClr val="0F0F0F"/>
+                </a:solidFill>
+                <a:latin typeface="Inter" pitchFamily="34" charset="0"/>
+                <a:ea typeface="Inter" pitchFamily="34" charset="-122"/>
+                <a:cs typeface="Inter" pitchFamily="34" charset="-120"/>
+              </a:defRPr>
+            </a:lvl1pPr>
+          </a:lstStyle>
+          <a:p>
+            <a:pPr algn="ctr" indent="0" marL="0">
+              <a:buNone/>
+            </a:pPr>
+            <a:r>
+              <a:rPr lang="en-US" sz="1100" b="1" dirty="0">
+                <a:solidFill>
+                  <a:srgbClr val="0F0F0F"/>
+                </a:solidFill>
+                <a:latin typeface="Inter" pitchFamily="34" charset="0"/>
+                <a:ea typeface="Inter" pitchFamily="34" charset="-122"/>
+                <a:cs typeface="Inter" pitchFamily="34" charset="-120"/>
+              </a:rPr>
+              <a:t>Vereinsname</a:t>
+            </a:r>
+            <a:endParaRPr lang="en-US" sz="1100" dirty="0"/>
+          </a:p>
+        </p:txBody>
+      </p:sp>
+      <p:sp>
+        <p:nvSpPr>
+          <p:cNvPr id="18" name="Text 0"/>
+          <p:cNvSpPr/>
+          <p:nvPr>
+            <p:ph idx="116" type="pic" hasCustomPrompt="1"/>
+          </p:nvPr>
+        </p:nvSpPr>
+        <p:spPr>
+          <a:xfrm>
+            <a:off x="6876288" y="2944368"/>
+            <a:ext cx="1700784" cy="960120"/>
+          </a:xfrm>
+          <a:prstGeom prst="rect">
+            <a:avLst/>
+          </a:prstGeom>
+          <a:noFill/>
+          <a:ln/>
+        </p:spPr>
+        <p:txBody>
+          <a:bodyPr wrap="square" rtlCol="0"/>
+          <a:lstStyle>
+            <a:lvl1pPr algn="ctr" indent="0" marL="0">
+              <a:buNone/>
               <a:defRPr lang="en-US" sz="1200" dirty="0">
                 <a:solidFill>
                   <a:srgbClr val="0F0F0F">
@@ -7467,7 +7838,60 @@
       </p:sp>
       <p:sp>
         <p:nvSpPr>
-          <p:cNvPr id="12" name="Text 0"/>
+          <p:cNvPr id="19" name="Text 0"/>
+          <p:cNvSpPr/>
+          <p:nvPr>
+            <p:ph idx="117" type="body" hasCustomPrompt="1"/>
+          </p:nvPr>
+        </p:nvSpPr>
+        <p:spPr>
+          <a:xfrm>
+            <a:off x="6876288" y="4014216"/>
+            <a:ext cx="1700784" cy="274320"/>
+          </a:xfrm>
+          <a:prstGeom prst="rect">
+            <a:avLst/>
+          </a:prstGeom>
+          <a:noFill/>
+          <a:ln/>
+        </p:spPr>
+        <p:txBody>
+          <a:bodyPr wrap="square" rtlCol="0"/>
+          <a:lstStyle>
+            <a:lvl1pPr algn="ctr" indent="0" marL="0">
+              <a:buNone/>
+              <a:defRPr lang="en-US" sz="1100" b="1" dirty="0">
+                <a:solidFill>
+                  <a:srgbClr val="0F0F0F"/>
+                </a:solidFill>
+                <a:latin typeface="Inter" pitchFamily="34" charset="0"/>
+                <a:ea typeface="Inter" pitchFamily="34" charset="-122"/>
+                <a:cs typeface="Inter" pitchFamily="34" charset="-120"/>
+              </a:defRPr>
+            </a:lvl1pPr>
+          </a:lstStyle>
+          <a:p>
+            <a:pPr algn="ctr" indent="0" marL="0">
+              <a:buNone/>
+            </a:pPr>
+            <a:r>
+              <a:rPr lang="en-US" sz="1100" b="1" dirty="0">
+                <a:solidFill>
+                  <a:srgbClr val="0F0F0F"/>
+                </a:solidFill>
+                <a:latin typeface="Inter" pitchFamily="34" charset="0"/>
+                <a:ea typeface="Inter" pitchFamily="34" charset="-122"/>
+                <a:cs typeface="Inter" pitchFamily="34" charset="-120"/>
+              </a:rPr>
+              <a:t>Vereinsname</a:t>
+            </a:r>
+            <a:endParaRPr lang="en-US" sz="1100" dirty="0"/>
+          </a:p>
+        </p:txBody>
+      </p:sp>
+      <p:sp>
+        <p:nvSpPr>
+          <p:cNvPr id="20" name="Text 0"/>
           <p:cNvSpPr/>
           <p:nvPr/>
         </p:nvSpPr>
@@ -13064,7 +13488,7 @@
       </p:sp>
       <p:pic>
         <p:nvPicPr>
-          <p:cNvPr id="3" name="Image 0" descr="/var/folders/hm/sgq6d80d0vq133k7n8dc9bnw0000gn/T/maiershirts-J4Eovy/ref-unternehmen-0.png">    </p:cNvPr>
+          <p:cNvPr id="3" name="Image 0" descr="/var/folders/hm/sgq6d80d0vq133k7n8dc9bnw0000gn/T/maiershirts-skcBUc/ref-unternehmen-0.png">    </p:cNvPr>
           <p:cNvPicPr>
             <a:picLocks noChangeAspect="1"/>
           </p:cNvPicPr>
@@ -13090,7 +13514,7 @@
       </p:pic>
       <p:pic>
         <p:nvPicPr>
-          <p:cNvPr id="4" name="Image 1" descr="/var/folders/hm/sgq6d80d0vq133k7n8dc9bnw0000gn/T/maiershirts-J4Eovy/ref-unternehmen-1.png">    </p:cNvPr>
+          <p:cNvPr id="4" name="Image 1" descr="/var/folders/hm/sgq6d80d0vq133k7n8dc9bnw0000gn/T/maiershirts-skcBUc/ref-unternehmen-1.png">    </p:cNvPr>
           <p:cNvPicPr>
             <a:picLocks noChangeAspect="1"/>
           </p:cNvPicPr>
@@ -13116,7 +13540,7 @@
       </p:pic>
       <p:pic>
         <p:nvPicPr>
-          <p:cNvPr id="5" name="Image 2" descr="/var/folders/hm/sgq6d80d0vq133k7n8dc9bnw0000gn/T/maiershirts-J4Eovy/ref-unternehmen-2.png">    </p:cNvPr>
+          <p:cNvPr id="5" name="Image 2" descr="/var/folders/hm/sgq6d80d0vq133k7n8dc9bnw0000gn/T/maiershirts-skcBUc/ref-unternehmen-2.png">    </p:cNvPr>
           <p:cNvPicPr>
             <a:picLocks noChangeAspect="1"/>
           </p:cNvPicPr>
@@ -13142,7 +13566,7 @@
       </p:pic>
       <p:pic>
         <p:nvPicPr>
-          <p:cNvPr id="6" name="Image 3" descr="/var/folders/hm/sgq6d80d0vq133k7n8dc9bnw0000gn/T/maiershirts-J4Eovy/ref-unternehmen-3.png">    </p:cNvPr>
+          <p:cNvPr id="6" name="Image 3" descr="/var/folders/hm/sgq6d80d0vq133k7n8dc9bnw0000gn/T/maiershirts-skcBUc/ref-unternehmen-3.png">    </p:cNvPr>
           <p:cNvPicPr>
             <a:picLocks noChangeAspect="1"/>
           </p:cNvPicPr>
@@ -13168,7 +13592,7 @@
       </p:pic>
       <p:pic>
         <p:nvPicPr>
-          <p:cNvPr id="7" name="Image 4" descr="/var/folders/hm/sgq6d80d0vq133k7n8dc9bnw0000gn/T/maiershirts-J4Eovy/ref-unternehmen-4.png">    </p:cNvPr>
+          <p:cNvPr id="7" name="Image 4" descr="/var/folders/hm/sgq6d80d0vq133k7n8dc9bnw0000gn/T/maiershirts-skcBUc/ref-unternehmen-4.png">    </p:cNvPr>
           <p:cNvPicPr>
             <a:picLocks noChangeAspect="1"/>
           </p:cNvPicPr>
@@ -13194,7 +13618,7 @@
       </p:pic>
       <p:pic>
         <p:nvPicPr>
-          <p:cNvPr id="8" name="Image 5" descr="/var/folders/hm/sgq6d80d0vq133k7n8dc9bnw0000gn/T/maiershirts-J4Eovy/ref-unternehmen-5.png">    </p:cNvPr>
+          <p:cNvPr id="8" name="Image 5" descr="/var/folders/hm/sgq6d80d0vq133k7n8dc9bnw0000gn/T/maiershirts-skcBUc/ref-unternehmen-5.png">    </p:cNvPr>
           <p:cNvPicPr>
             <a:picLocks noChangeAspect="1"/>
           </p:cNvPicPr>
@@ -13220,7 +13644,7 @@
       </p:pic>
       <p:pic>
         <p:nvPicPr>
-          <p:cNvPr id="9" name="Image 6" descr="/var/folders/hm/sgq6d80d0vq133k7n8dc9bnw0000gn/T/maiershirts-J4Eovy/ref-unternehmen-6.png">    </p:cNvPr>
+          <p:cNvPr id="9" name="Image 6" descr="/var/folders/hm/sgq6d80d0vq133k7n8dc9bnw0000gn/T/maiershirts-skcBUc/ref-unternehmen-6.png">    </p:cNvPr>
           <p:cNvPicPr>
             <a:picLocks noChangeAspect="1"/>
           </p:cNvPicPr>
@@ -13246,7 +13670,7 @@
       </p:pic>
       <p:pic>
         <p:nvPicPr>
-          <p:cNvPr id="10" name="Image 7" descr="/var/folders/hm/sgq6d80d0vq133k7n8dc9bnw0000gn/T/maiershirts-J4Eovy/ref-unternehmen-7.png">    </p:cNvPr>
+          <p:cNvPr id="10" name="Image 7" descr="/var/folders/hm/sgq6d80d0vq133k7n8dc9bnw0000gn/T/maiershirts-skcBUc/ref-unternehmen-7.png">    </p:cNvPr>
           <p:cNvPicPr>
             <a:picLocks noChangeAspect="1"/>
           </p:cNvPicPr>
@@ -13272,7 +13696,7 @@
       </p:pic>
       <p:pic>
         <p:nvPicPr>
-          <p:cNvPr id="11" name="Image 8" descr="/var/folders/hm/sgq6d80d0vq133k7n8dc9bnw0000gn/T/maiershirts-J4Eovy/ref-unternehmen-8.png">    </p:cNvPr>
+          <p:cNvPr id="11" name="Image 8" descr="/var/folders/hm/sgq6d80d0vq133k7n8dc9bnw0000gn/T/maiershirts-skcBUc/ref-unternehmen-8.png">    </p:cNvPr>
           <p:cNvPicPr>
             <a:picLocks noChangeAspect="1"/>
           </p:cNvPicPr>
@@ -13298,7 +13722,7 @@
       </p:pic>
       <p:pic>
         <p:nvPicPr>
-          <p:cNvPr id="12" name="Image 9" descr="/var/folders/hm/sgq6d80d0vq133k7n8dc9bnw0000gn/T/maiershirts-J4Eovy/ph-logo-446x194.png">    </p:cNvPr>
+          <p:cNvPr id="12" name="Image 9" descr="/var/folders/hm/sgq6d80d0vq133k7n8dc9bnw0000gn/T/maiershirts-skcBUc/ph-logo-446x194.png">    </p:cNvPr>
           <p:cNvPicPr>
             <a:picLocks noChangeAspect="1"/>
           </p:cNvPicPr>
@@ -13324,7 +13748,7 @@
       </p:pic>
       <p:pic>
         <p:nvPicPr>
-          <p:cNvPr id="13" name="Image 10" descr="/var/folders/hm/sgq6d80d0vq133k7n8dc9bnw0000gn/T/maiershirts-J4Eovy/ph-logo-446x194.png">    </p:cNvPr>
+          <p:cNvPr id="13" name="Image 10" descr="/var/folders/hm/sgq6d80d0vq133k7n8dc9bnw0000gn/T/maiershirts-skcBUc/ph-logo-446x194.png">    </p:cNvPr>
           <p:cNvPicPr>
             <a:picLocks noChangeAspect="1"/>
           </p:cNvPicPr>
@@ -13350,7 +13774,7 @@
       </p:pic>
       <p:pic>
         <p:nvPicPr>
-          <p:cNvPr id="14" name="Image 11" descr="/var/folders/hm/sgq6d80d0vq133k7n8dc9bnw0000gn/T/maiershirts-J4Eovy/ph-logo-446x194.png">    </p:cNvPr>
+          <p:cNvPr id="14" name="Image 11" descr="/var/folders/hm/sgq6d80d0vq133k7n8dc9bnw0000gn/T/maiershirts-skcBUc/ph-logo-446x194.png">    </p:cNvPr>
           <p:cNvPicPr>
             <a:picLocks noChangeAspect="1"/>
           </p:cNvPicPr>
@@ -13490,7 +13914,7 @@
       </p:sp>
       <p:pic>
         <p:nvPicPr>
-          <p:cNvPr id="3" name="Image 0" descr="/var/folders/hm/sgq6d80d0vq133k7n8dc9bnw0000gn/T/maiershirts-J4Eovy/ref-vereine-0.png">    </p:cNvPr>
+          <p:cNvPr id="3" name="Image 0" descr="/var/folders/hm/sgq6d80d0vq133k7n8dc9bnw0000gn/T/maiershirts-skcBUc/ref-vereine-0.png">    </p:cNvPr>
           <p:cNvPicPr>
             <a:picLocks noChangeAspect="1"/>
           </p:cNvPicPr>
@@ -13506,22 +13930,63 @@
         </p:blipFill>
         <p:spPr>
           <a:xfrm>
-            <a:off x="713232" y="1556490"/>
-            <a:ext cx="1408176" cy="818939"/>
+            <a:off x="843422" y="1490472"/>
+            <a:ext cx="1147795" cy="667512"/>
           </a:xfrm>
           <a:prstGeom prst="rect">
             <a:avLst/>
           </a:prstGeom>
         </p:spPr>
       </p:pic>
+      <p:sp>
+        <p:nvSpPr>
+          <p:cNvPr id="4" name="Text 0"/>
+          <p:cNvSpPr txBox="1"/>
+          <p:nvPr>
+            <p:ph idx="103" type="body" hasCustomPrompt="1"/>
+          </p:nvPr>
+        </p:nvSpPr>
+        <p:spPr>
+          <a:xfrm>
+            <a:off x="566928" y="2414016"/>
+            <a:ext cx="1700784" cy="274320"/>
+          </a:xfrm>
+          <a:prstGeom prst="rect">
+            <a:avLst/>
+          </a:prstGeom>
+          <a:noFill/>
+          <a:ln/>
+        </p:spPr>
+        <p:txBody>
+          <a:bodyPr wrap="square" lIns="0" tIns="0" rIns="0" bIns="0" rtlCol="0" anchor="ctr"/>
+          <a:lstStyle/>
+          <a:p>
+            <a:pPr algn="ctr" indent="0" marL="0">
+              <a:buNone/>
+            </a:pPr>
+            <a:r>
+              <a:rPr lang="en-US" sz="1100" b="1" dirty="0">
+                <a:solidFill>
+                  <a:srgbClr val="0F0F0F"/>
+                </a:solidFill>
+                <a:latin typeface="Inter" pitchFamily="34" charset="0"/>
+                <a:ea typeface="Inter" pitchFamily="34" charset="-122"/>
+                <a:cs typeface="Inter" pitchFamily="34" charset="-120"/>
+              </a:rPr>
+              <a:t>DAV Sektion Tübingen</a:t>
+            </a:r>
+            <a:endParaRPr lang="en-US" sz="1100" dirty="0"/>
+          </a:p>
+        </p:txBody>
+      </p:sp>
       <p:pic>
         <p:nvPicPr>
-          <p:cNvPr id="4" name="Image 1" descr="/var/folders/hm/sgq6d80d0vq133k7n8dc9bnw0000gn/T/maiershirts-J4Eovy/ref-vereine-1.png">    </p:cNvPr>
+          <p:cNvPr id="5" name="Image 1" descr="/var/folders/hm/sgq6d80d0vq133k7n8dc9bnw0000gn/T/maiershirts-skcBUc/ref-vereine-1.png">    </p:cNvPr>
           <p:cNvPicPr>
             <a:picLocks noChangeAspect="1"/>
           </p:cNvPicPr>
           <p:nvPr>
-            <p:ph idx="103" type="pic" hasCustomPrompt="1"/>
+            <p:ph idx="104" type="pic" hasCustomPrompt="1"/>
           </p:nvPr>
         </p:nvPicPr>
         <p:blipFill>
@@ -13532,22 +13997,63 @@
         </p:blipFill>
         <p:spPr>
           <a:xfrm>
-            <a:off x="2816352" y="1611094"/>
-            <a:ext cx="1408176" cy="709731"/>
+            <a:off x="2858236" y="1490472"/>
+            <a:ext cx="1324409" cy="667512"/>
           </a:xfrm>
           <a:prstGeom prst="rect">
             <a:avLst/>
           </a:prstGeom>
         </p:spPr>
       </p:pic>
+      <p:sp>
+        <p:nvSpPr>
+          <p:cNvPr id="6" name="Text 0"/>
+          <p:cNvSpPr txBox="1"/>
+          <p:nvPr>
+            <p:ph idx="105" type="body" hasCustomPrompt="1"/>
+          </p:nvPr>
+        </p:nvSpPr>
+        <p:spPr>
+          <a:xfrm>
+            <a:off x="2670048" y="2414016"/>
+            <a:ext cx="1700784" cy="274320"/>
+          </a:xfrm>
+          <a:prstGeom prst="rect">
+            <a:avLst/>
+          </a:prstGeom>
+          <a:noFill/>
+          <a:ln/>
+        </p:spPr>
+        <p:txBody>
+          <a:bodyPr wrap="square" lIns="0" tIns="0" rIns="0" bIns="0" rtlCol="0" anchor="ctr"/>
+          <a:lstStyle/>
+          <a:p>
+            <a:pPr algn="ctr" indent="0" marL="0">
+              <a:buNone/>
+            </a:pPr>
+            <a:r>
+              <a:rPr lang="en-US" sz="1100" b="1" dirty="0">
+                <a:solidFill>
+                  <a:srgbClr val="0F0F0F"/>
+                </a:solidFill>
+                <a:latin typeface="Inter" pitchFamily="34" charset="0"/>
+                <a:ea typeface="Inter" pitchFamily="34" charset="-122"/>
+                <a:cs typeface="Inter" pitchFamily="34" charset="-120"/>
+              </a:rPr>
+              <a:t>Tennisclub Ammerbuch</a:t>
+            </a:r>
+            <a:endParaRPr lang="en-US" sz="1100" dirty="0"/>
+          </a:p>
+        </p:txBody>
+      </p:sp>
       <p:pic>
         <p:nvPicPr>
-          <p:cNvPr id="5" name="Image 2" descr="/var/folders/hm/sgq6d80d0vq133k7n8dc9bnw0000gn/T/maiershirts-J4Eovy/ref-vereine-2.png">    </p:cNvPr>
+          <p:cNvPr id="7" name="Image 2" descr="/var/folders/hm/sgq6d80d0vq133k7n8dc9bnw0000gn/T/maiershirts-skcBUc/ref-vereine-2.png">    </p:cNvPr>
           <p:cNvPicPr>
             <a:picLocks noChangeAspect="1"/>
           </p:cNvPicPr>
           <p:nvPr>
-            <p:ph idx="104" type="pic" hasCustomPrompt="1"/>
+            <p:ph idx="106" type="pic" hasCustomPrompt="1"/>
           </p:nvPr>
         </p:nvPicPr>
         <p:blipFill>
@@ -13558,22 +14064,63 @@
         </p:blipFill>
         <p:spPr>
           <a:xfrm>
-            <a:off x="5261000" y="1490472"/>
-            <a:ext cx="725119" cy="950976"/>
+            <a:off x="5369071" y="1490472"/>
+            <a:ext cx="508978" cy="667512"/>
           </a:xfrm>
           <a:prstGeom prst="rect">
             <a:avLst/>
           </a:prstGeom>
         </p:spPr>
       </p:pic>
+      <p:sp>
+        <p:nvSpPr>
+          <p:cNvPr id="8" name="Text 0"/>
+          <p:cNvSpPr txBox="1"/>
+          <p:nvPr>
+            <p:ph idx="107" type="body" hasCustomPrompt="1"/>
+          </p:nvPr>
+        </p:nvSpPr>
+        <p:spPr>
+          <a:xfrm>
+            <a:off x="4773168" y="2414016"/>
+            <a:ext cx="1700784" cy="274320"/>
+          </a:xfrm>
+          <a:prstGeom prst="rect">
+            <a:avLst/>
+          </a:prstGeom>
+          <a:noFill/>
+          <a:ln/>
+        </p:spPr>
+        <p:txBody>
+          <a:bodyPr wrap="square" lIns="0" tIns="0" rIns="0" bIns="0" rtlCol="0" anchor="ctr"/>
+          <a:lstStyle/>
+          <a:p>
+            <a:pPr algn="ctr" indent="0" marL="0">
+              <a:buNone/>
+            </a:pPr>
+            <a:r>
+              <a:rPr lang="en-US" sz="1100" b="1" dirty="0">
+                <a:solidFill>
+                  <a:srgbClr val="0F0F0F"/>
+                </a:solidFill>
+                <a:latin typeface="Inter" pitchFamily="34" charset="0"/>
+                <a:ea typeface="Inter" pitchFamily="34" charset="-122"/>
+                <a:cs typeface="Inter" pitchFamily="34" charset="-120"/>
+              </a:rPr>
+              <a:t>TGV Entringen</a:t>
+            </a:r>
+            <a:endParaRPr lang="en-US" sz="1100" dirty="0"/>
+          </a:p>
+        </p:txBody>
+      </p:sp>
       <p:pic>
         <p:nvPicPr>
-          <p:cNvPr id="6" name="Image 3" descr="/var/folders/hm/sgq6d80d0vq133k7n8dc9bnw0000gn/T/maiershirts-J4Eovy/ref-vereine-3.png">    </p:cNvPr>
+          <p:cNvPr id="9" name="Image 3" descr="/var/folders/hm/sgq6d80d0vq133k7n8dc9bnw0000gn/T/maiershirts-skcBUc/ref-vereine-3.png">    </p:cNvPr>
           <p:cNvPicPr>
             <a:picLocks noChangeAspect="1"/>
           </p:cNvPicPr>
           <p:nvPr>
-            <p:ph idx="105" type="pic" hasCustomPrompt="1"/>
+            <p:ph idx="108" type="pic" hasCustomPrompt="1"/>
           </p:nvPr>
         </p:nvPicPr>
         <p:blipFill>
@@ -13584,22 +14131,63 @@
         </p:blipFill>
         <p:spPr>
           <a:xfrm>
-            <a:off x="7251192" y="1490472"/>
-            <a:ext cx="950976" cy="950976"/>
+            <a:off x="7392924" y="1490472"/>
+            <a:ext cx="667512" cy="667512"/>
           </a:xfrm>
           <a:prstGeom prst="rect">
             <a:avLst/>
           </a:prstGeom>
         </p:spPr>
       </p:pic>
+      <p:sp>
+        <p:nvSpPr>
+          <p:cNvPr id="10" name="Text 0"/>
+          <p:cNvSpPr txBox="1"/>
+          <p:nvPr>
+            <p:ph idx="109" type="body" hasCustomPrompt="1"/>
+          </p:nvPr>
+        </p:nvSpPr>
+        <p:spPr>
+          <a:xfrm>
+            <a:off x="6876288" y="2414016"/>
+            <a:ext cx="1700784" cy="274320"/>
+          </a:xfrm>
+          <a:prstGeom prst="rect">
+            <a:avLst/>
+          </a:prstGeom>
+          <a:noFill/>
+          <a:ln/>
+        </p:spPr>
+        <p:txBody>
+          <a:bodyPr wrap="square" lIns="0" tIns="0" rIns="0" bIns="0" rtlCol="0" anchor="ctr"/>
+          <a:lstStyle/>
+          <a:p>
+            <a:pPr algn="ctr" indent="0" marL="0">
+              <a:buNone/>
+            </a:pPr>
+            <a:r>
+              <a:rPr lang="en-US" sz="1100" b="1" dirty="0">
+                <a:solidFill>
+                  <a:srgbClr val="0F0F0F"/>
+                </a:solidFill>
+                <a:latin typeface="Inter" pitchFamily="34" charset="0"/>
+                <a:ea typeface="Inter" pitchFamily="34" charset="-122"/>
+                <a:cs typeface="Inter" pitchFamily="34" charset="-120"/>
+              </a:rPr>
+              <a:t>Hooriger Hund Sulzbach</a:t>
+            </a:r>
+            <a:endParaRPr lang="en-US" sz="1100" dirty="0"/>
+          </a:p>
+        </p:txBody>
+      </p:sp>
       <p:pic>
         <p:nvPicPr>
-          <p:cNvPr id="7" name="Image 4" descr="/var/folders/hm/sgq6d80d0vq133k7n8dc9bnw0000gn/T/maiershirts-J4Eovy/ref-vereine-4.png">    </p:cNvPr>
+          <p:cNvPr id="11" name="Image 4" descr="/var/folders/hm/sgq6d80d0vq133k7n8dc9bnw0000gn/T/maiershirts-skcBUc/ref-vereine-4.png">    </p:cNvPr>
           <p:cNvPicPr>
             <a:picLocks noChangeAspect="1"/>
           </p:cNvPicPr>
           <p:nvPr>
-            <p:ph idx="106" type="pic" hasCustomPrompt="1"/>
+            <p:ph idx="110" type="pic" hasCustomPrompt="1"/>
           </p:nvPr>
         </p:nvPicPr>
         <p:blipFill>
@@ -13610,22 +14198,63 @@
         </p:blipFill>
         <p:spPr>
           <a:xfrm>
-            <a:off x="927202" y="3090672"/>
-            <a:ext cx="980237" cy="950976"/>
+            <a:off x="1073295" y="3090672"/>
+            <a:ext cx="688051" cy="667512"/>
           </a:xfrm>
           <a:prstGeom prst="rect">
             <a:avLst/>
           </a:prstGeom>
         </p:spPr>
       </p:pic>
+      <p:sp>
+        <p:nvSpPr>
+          <p:cNvPr id="12" name="Text 0"/>
+          <p:cNvSpPr txBox="1"/>
+          <p:nvPr>
+            <p:ph idx="111" type="body" hasCustomPrompt="1"/>
+          </p:nvPr>
+        </p:nvSpPr>
+        <p:spPr>
+          <a:xfrm>
+            <a:off x="566928" y="4014216"/>
+            <a:ext cx="1700784" cy="274320"/>
+          </a:xfrm>
+          <a:prstGeom prst="rect">
+            <a:avLst/>
+          </a:prstGeom>
+          <a:noFill/>
+          <a:ln/>
+        </p:spPr>
+        <p:txBody>
+          <a:bodyPr wrap="square" lIns="0" tIns="0" rIns="0" bIns="0" rtlCol="0" anchor="ctr"/>
+          <a:lstStyle/>
+          <a:p>
+            <a:pPr algn="ctr" indent="0" marL="0">
+              <a:buNone/>
+            </a:pPr>
+            <a:r>
+              <a:rPr lang="en-US" sz="1100" b="1" dirty="0">
+                <a:solidFill>
+                  <a:srgbClr val="0F0F0F"/>
+                </a:solidFill>
+                <a:latin typeface="Inter" pitchFamily="34" charset="0"/>
+                <a:ea typeface="Inter" pitchFamily="34" charset="-122"/>
+                <a:cs typeface="Inter" pitchFamily="34" charset="-120"/>
+              </a:rPr>
+              <a:t>Sportfreunde Dußlingen</a:t>
+            </a:r>
+            <a:endParaRPr lang="en-US" sz="1100" dirty="0"/>
+          </a:p>
+        </p:txBody>
+      </p:sp>
       <p:pic>
         <p:nvPicPr>
-          <p:cNvPr id="8" name="Image 5" descr="/var/folders/hm/sgq6d80d0vq133k7n8dc9bnw0000gn/T/maiershirts-J4Eovy/ref-vereine-5.png">    </p:cNvPr>
+          <p:cNvPr id="13" name="Image 5" descr="/var/folders/hm/sgq6d80d0vq133k7n8dc9bnw0000gn/T/maiershirts-skcBUc/ref-vereine-5.png">    </p:cNvPr>
           <p:cNvPicPr>
             <a:picLocks noChangeAspect="1"/>
           </p:cNvPicPr>
           <p:nvPr>
-            <p:ph idx="107" type="pic" hasCustomPrompt="1"/>
+            <p:ph idx="112" type="pic" hasCustomPrompt="1"/>
           </p:nvPr>
         </p:nvPicPr>
         <p:blipFill>
@@ -13636,22 +14265,63 @@
         </p:blipFill>
         <p:spPr>
           <a:xfrm>
-            <a:off x="3044952" y="3090672"/>
-            <a:ext cx="950976" cy="950976"/>
+            <a:off x="3186684" y="3090672"/>
+            <a:ext cx="667512" cy="667512"/>
           </a:xfrm>
           <a:prstGeom prst="rect">
             <a:avLst/>
           </a:prstGeom>
         </p:spPr>
       </p:pic>
+      <p:sp>
+        <p:nvSpPr>
+          <p:cNvPr id="14" name="Text 0"/>
+          <p:cNvSpPr txBox="1"/>
+          <p:nvPr>
+            <p:ph idx="113" type="body" hasCustomPrompt="1"/>
+          </p:nvPr>
+        </p:nvSpPr>
+        <p:spPr>
+          <a:xfrm>
+            <a:off x="2670048" y="4014216"/>
+            <a:ext cx="1700784" cy="274320"/>
+          </a:xfrm>
+          <a:prstGeom prst="rect">
+            <a:avLst/>
+          </a:prstGeom>
+          <a:noFill/>
+          <a:ln/>
+        </p:spPr>
+        <p:txBody>
+          <a:bodyPr wrap="square" lIns="0" tIns="0" rIns="0" bIns="0" rtlCol="0" anchor="ctr"/>
+          <a:lstStyle/>
+          <a:p>
+            <a:pPr algn="ctr" indent="0" marL="0">
+              <a:buNone/>
+            </a:pPr>
+            <a:r>
+              <a:rPr lang="en-US" sz="1100" b="1" dirty="0">
+                <a:solidFill>
+                  <a:srgbClr val="0F0F0F"/>
+                </a:solidFill>
+                <a:latin typeface="Inter" pitchFamily="34" charset="0"/>
+                <a:ea typeface="Inter" pitchFamily="34" charset="-122"/>
+                <a:cs typeface="Inter" pitchFamily="34" charset="-120"/>
+              </a:rPr>
+              <a:t>SV Germania Bietigheim</a:t>
+            </a:r>
+            <a:endParaRPr lang="en-US" sz="1100" dirty="0"/>
+          </a:p>
+        </p:txBody>
+      </p:sp>
       <p:pic>
         <p:nvPicPr>
-          <p:cNvPr id="9" name="Image 6" descr="/var/folders/hm/sgq6d80d0vq133k7n8dc9bnw0000gn/T/maiershirts-J4Eovy/ref-vereine-6.png">    </p:cNvPr>
+          <p:cNvPr id="15" name="Image 6" descr="/var/folders/hm/sgq6d80d0vq133k7n8dc9bnw0000gn/T/maiershirts-skcBUc/ref-vereine-6.png">    </p:cNvPr>
           <p:cNvPicPr>
             <a:picLocks noChangeAspect="1"/>
           </p:cNvPicPr>
           <p:nvPr>
-            <p:ph idx="108" type="pic" hasCustomPrompt="1"/>
+            <p:ph idx="114" type="pic" hasCustomPrompt="1"/>
           </p:nvPr>
         </p:nvPicPr>
         <p:blipFill>
@@ -13662,22 +14332,63 @@
         </p:blipFill>
         <p:spPr>
           <a:xfrm>
-            <a:off x="5146014" y="3090672"/>
-            <a:ext cx="955093" cy="950976"/>
+            <a:off x="5288359" y="3090672"/>
+            <a:ext cx="670402" cy="667512"/>
           </a:xfrm>
           <a:prstGeom prst="rect">
             <a:avLst/>
           </a:prstGeom>
         </p:spPr>
       </p:pic>
+      <p:sp>
+        <p:nvSpPr>
+          <p:cNvPr id="16" name="Text 0"/>
+          <p:cNvSpPr txBox="1"/>
+          <p:nvPr>
+            <p:ph idx="115" type="body" hasCustomPrompt="1"/>
+          </p:nvPr>
+        </p:nvSpPr>
+        <p:spPr>
+          <a:xfrm>
+            <a:off x="4773168" y="4014216"/>
+            <a:ext cx="1700784" cy="274320"/>
+          </a:xfrm>
+          <a:prstGeom prst="rect">
+            <a:avLst/>
+          </a:prstGeom>
+          <a:noFill/>
+          <a:ln/>
+        </p:spPr>
+        <p:txBody>
+          <a:bodyPr wrap="square" lIns="0" tIns="0" rIns="0" bIns="0" rtlCol="0" anchor="ctr"/>
+          <a:lstStyle/>
+          <a:p>
+            <a:pPr algn="ctr" indent="0" marL="0">
+              <a:buNone/>
+            </a:pPr>
+            <a:r>
+              <a:rPr lang="en-US" sz="1100" b="1" dirty="0">
+                <a:solidFill>
+                  <a:srgbClr val="0F0F0F"/>
+                </a:solidFill>
+                <a:latin typeface="Inter" pitchFamily="34" charset="0"/>
+                <a:ea typeface="Inter" pitchFamily="34" charset="-122"/>
+                <a:cs typeface="Inter" pitchFamily="34" charset="-120"/>
+              </a:rPr>
+              <a:t>TV Mühlacker</a:t>
+            </a:r>
+            <a:endParaRPr lang="en-US" sz="1100" dirty="0"/>
+          </a:p>
+        </p:txBody>
+      </p:sp>
       <p:pic>
         <p:nvPicPr>
-          <p:cNvPr id="10" name="Image 7" descr="/var/folders/hm/sgq6d80d0vq133k7n8dc9bnw0000gn/T/maiershirts-J4Eovy/ph-logo-446x326.png">    </p:cNvPr>
+          <p:cNvPr id="17" name="Image 7" descr="/var/folders/hm/sgq6d80d0vq133k7n8dc9bnw0000gn/T/maiershirts-skcBUc/ph-logo-446x252.png">    </p:cNvPr>
           <p:cNvPicPr>
             <a:picLocks noChangeAspect="1"/>
           </p:cNvPicPr>
           <p:nvPr>
-            <p:ph idx="109" type="pic" hasCustomPrompt="1"/>
+            <p:ph idx="116" type="pic" hasCustomPrompt="1"/>
           </p:nvPr>
         </p:nvPicPr>
         <p:blipFill>
@@ -13689,13 +14400,43 @@
         <p:spPr>
           <a:xfrm>
             <a:off x="6876288" y="2944368"/>
-            <a:ext cx="1700784" cy="1243584"/>
+            <a:ext cx="1700784" cy="960120"/>
           </a:xfrm>
           <a:prstGeom prst="rect">
             <a:avLst/>
           </a:prstGeom>
         </p:spPr>
       </p:pic>
+      <p:sp>
+        <p:nvSpPr>
+          <p:cNvPr id="19" name="Text 0"/>
+          <p:cNvSpPr/>
+          <p:nvPr>
+            <p:ph idx="117" type="body" hasCustomPrompt="1"/>
+          </p:nvPr>
+        </p:nvSpPr>
+        <p:spPr>
+          <a:xfrm>
+            <a:off x="6876288" y="4014216"/>
+            <a:ext cx="1700784" cy="274320"/>
+          </a:xfrm>
+          <a:prstGeom prst="rect">
+            <a:avLst/>
+          </a:prstGeom>
+          <a:noFill/>
+          <a:ln/>
+        </p:spPr>
+        <p:txBody>
+          <a:bodyPr wrap="square" lIns="0" tIns="0" rIns="0" bIns="0" rtlCol="0" anchor="ctr"/>
+          <a:lstStyle/>
+          <a:p>
+            <a:pPr algn="ctr" indent="0" marL="0">
+              <a:buNone/>
+            </a:pPr>
+            <a:endParaRPr lang="en-US" sz="1100" dirty="0"/>
+          </a:p>
+        </p:txBody>
+      </p:sp>
       <p:sp>
         <p:nvSpPr>
           <p:cNvPr id="25" name="Slide Number Placeholder 0"/>
@@ -13812,7 +14553,7 @@
       </p:sp>
       <p:pic>
         <p:nvPicPr>
-          <p:cNvPr id="3" name="Image 0" descr="/var/folders/hm/sgq6d80d0vq133k7n8dc9bnw0000gn/T/maiershirts-J4Eovy/ph-foto-1056x840.png">    </p:cNvPr>
+          <p:cNvPr id="3" name="Image 0" descr="/var/folders/hm/sgq6d80d0vq133k7n8dc9bnw0000gn/T/maiershirts-skcBUc/ph-foto-1056x840.png">    </p:cNvPr>
           <p:cNvPicPr>
             <a:picLocks noChangeAspect="1"/>
           </p:cNvPicPr>
@@ -14624,7 +15365,7 @@
       </p:sp>
       <p:pic>
         <p:nvPicPr>
-          <p:cNvPr id="4" name="Image 0" descr="/var/folders/hm/sgq6d80d0vq133k7n8dc9bnw0000gn/T/maiershirts-J4Eovy/ph-portrait-252x252.png">    </p:cNvPr>
+          <p:cNvPr id="4" name="Image 0" descr="/var/folders/hm/sgq6d80d0vq133k7n8dc9bnw0000gn/T/maiershirts-skcBUc/ph-portrait-252x252.png">    </p:cNvPr>
           <p:cNvPicPr>
             <a:picLocks noChangeAspect="1"/>
           </p:cNvPicPr>
@@ -14833,7 +15574,7 @@
       </p:sp>
       <p:pic>
         <p:nvPicPr>
-          <p:cNvPr id="9" name="Image 1" descr="/var/folders/hm/sgq6d80d0vq133k7n8dc9bnw0000gn/T/maiershirts-J4Eovy/ph-qr-240x240.png">    </p:cNvPr>
+          <p:cNvPr id="9" name="Image 1" descr="/var/folders/hm/sgq6d80d0vq133k7n8dc9bnw0000gn/T/maiershirts-skcBUc/ph-qr-240x240.png">    </p:cNvPr>
           <p:cNvPicPr>
             <a:picLocks noChangeAspect="1"/>
           </p:cNvPicPr>
@@ -16249,7 +16990,7 @@
       </p:grpSpPr>
       <p:pic>
         <p:nvPicPr>
-          <p:cNvPr id="2" name="Image 0" descr="/var/folders/hm/sgq6d80d0vq133k7n8dc9bnw0000gn/T/maiershirts-J4Eovy/ph-foto-2400x1008.png">    </p:cNvPr>
+          <p:cNvPr id="2" name="Image 0" descr="/var/folders/hm/sgq6d80d0vq133k7n8dc9bnw0000gn/T/maiershirts-skcBUc/ph-foto-2400x1008.png">    </p:cNvPr>
           <p:cNvPicPr>
             <a:picLocks noChangeAspect="1"/>
           </p:cNvPicPr>
@@ -17407,7 +18148,7 @@
       </p:sp>
       <p:pic>
         <p:nvPicPr>
-          <p:cNvPr id="3" name="Image 0" descr="/var/folders/hm/sgq6d80d0vq133k7n8dc9bnw0000gn/T/maiershirts-J4Eovy/ph-foto-696x456.png">    </p:cNvPr>
+          <p:cNvPr id="3" name="Image 0" descr="/var/folders/hm/sgq6d80d0vq133k7n8dc9bnw0000gn/T/maiershirts-skcBUc/ph-foto-696x456.png">    </p:cNvPr>
           <p:cNvPicPr>
             <a:picLocks noChangeAspect="1"/>
           </p:cNvPicPr>
@@ -17577,7 +18318,7 @@
       </p:sp>
       <p:pic>
         <p:nvPicPr>
-          <p:cNvPr id="7" name="Image 1" descr="/var/folders/hm/sgq6d80d0vq133k7n8dc9bnw0000gn/T/maiershirts-J4Eovy/ph-foto-696x456.png">    </p:cNvPr>
+          <p:cNvPr id="7" name="Image 1" descr="/var/folders/hm/sgq6d80d0vq133k7n8dc9bnw0000gn/T/maiershirts-skcBUc/ph-foto-696x456.png">    </p:cNvPr>
           <p:cNvPicPr>
             <a:picLocks noChangeAspect="1"/>
           </p:cNvPicPr>
@@ -17747,7 +18488,7 @@
       </p:sp>
       <p:pic>
         <p:nvPicPr>
-          <p:cNvPr id="11" name="Image 2" descr="/var/folders/hm/sgq6d80d0vq133k7n8dc9bnw0000gn/T/maiershirts-J4Eovy/ph-foto-696x456.png">    </p:cNvPr>
+          <p:cNvPr id="11" name="Image 2" descr="/var/folders/hm/sgq6d80d0vq133k7n8dc9bnw0000gn/T/maiershirts-skcBUc/ph-foto-696x456.png">    </p:cNvPr>
           <p:cNvPicPr>
             <a:picLocks noChangeAspect="1"/>
           </p:cNvPicPr>

</xml_diff>

<commit_message>
Referenzen: Tennisclub Wurmlingen ergänzen
Co-Authored-By: Claude Fable 5.1 <noreply@anthropic.com>
</commit_message>
<xml_diff>
--- a/presentation/dist/Maiershirts_Master.pptx
+++ b/presentation/dist/Maiershirts_Master.pptx
@@ -1029,7 +1029,7 @@
           <a:p>
             <a:r>
               <a:rPr lang="en-US" dirty="0"/>
-              <a:t>Layout MS_REFERENZEN_WAPPEN: 8 Logo-Felder. 7 Logo(s) aus assets/referenzen/vereine eingesetzt. Logo per Klick auf das Platzhalterbild einsetzen; bei Beschnitt: Bildformat → Zuschneiden → Anpassen.</a:t>
+              <a:t>Layout MS_REFERENZEN_WAPPEN: 8 Logo-Felder. 8 Logo(s) aus assets/referenzen/vereine eingesetzt. Logo per Klick auf das Platzhalterbild einsetzen; bei Beschnitt: Bildformat → Zuschneiden → Anpassen.</a:t>
             </a:r>
             <a:endParaRPr lang="en-US" dirty="0"/>
           </a:p>
@@ -13488,7 +13488,7 @@
       </p:sp>
       <p:pic>
         <p:nvPicPr>
-          <p:cNvPr id="3" name="Image 0" descr="/var/folders/hm/sgq6d80d0vq133k7n8dc9bnw0000gn/T/maiershirts-R3q5bi/ref-unternehmen-0.png">    </p:cNvPr>
+          <p:cNvPr id="3" name="Image 0" descr="/var/folders/hm/sgq6d80d0vq133k7n8dc9bnw0000gn/T/maiershirts-3efGbV/ref-unternehmen-0.png">    </p:cNvPr>
           <p:cNvPicPr>
             <a:picLocks noChangeAspect="1"/>
           </p:cNvPicPr>
@@ -13514,7 +13514,7 @@
       </p:pic>
       <p:pic>
         <p:nvPicPr>
-          <p:cNvPr id="4" name="Image 1" descr="/var/folders/hm/sgq6d80d0vq133k7n8dc9bnw0000gn/T/maiershirts-R3q5bi/ref-unternehmen-1.png">    </p:cNvPr>
+          <p:cNvPr id="4" name="Image 1" descr="/var/folders/hm/sgq6d80d0vq133k7n8dc9bnw0000gn/T/maiershirts-3efGbV/ref-unternehmen-1.png">    </p:cNvPr>
           <p:cNvPicPr>
             <a:picLocks noChangeAspect="1"/>
           </p:cNvPicPr>
@@ -13540,7 +13540,7 @@
       </p:pic>
       <p:pic>
         <p:nvPicPr>
-          <p:cNvPr id="5" name="Image 2" descr="/var/folders/hm/sgq6d80d0vq133k7n8dc9bnw0000gn/T/maiershirts-R3q5bi/ref-unternehmen-2.png">    </p:cNvPr>
+          <p:cNvPr id="5" name="Image 2" descr="/var/folders/hm/sgq6d80d0vq133k7n8dc9bnw0000gn/T/maiershirts-3efGbV/ref-unternehmen-2.png">    </p:cNvPr>
           <p:cNvPicPr>
             <a:picLocks noChangeAspect="1"/>
           </p:cNvPicPr>
@@ -13566,7 +13566,7 @@
       </p:pic>
       <p:pic>
         <p:nvPicPr>
-          <p:cNvPr id="6" name="Image 3" descr="/var/folders/hm/sgq6d80d0vq133k7n8dc9bnw0000gn/T/maiershirts-R3q5bi/ref-unternehmen-3.png">    </p:cNvPr>
+          <p:cNvPr id="6" name="Image 3" descr="/var/folders/hm/sgq6d80d0vq133k7n8dc9bnw0000gn/T/maiershirts-3efGbV/ref-unternehmen-3.png">    </p:cNvPr>
           <p:cNvPicPr>
             <a:picLocks noChangeAspect="1"/>
           </p:cNvPicPr>
@@ -13592,7 +13592,7 @@
       </p:pic>
       <p:pic>
         <p:nvPicPr>
-          <p:cNvPr id="7" name="Image 4" descr="/var/folders/hm/sgq6d80d0vq133k7n8dc9bnw0000gn/T/maiershirts-R3q5bi/ref-unternehmen-4.png">    </p:cNvPr>
+          <p:cNvPr id="7" name="Image 4" descr="/var/folders/hm/sgq6d80d0vq133k7n8dc9bnw0000gn/T/maiershirts-3efGbV/ref-unternehmen-4.png">    </p:cNvPr>
           <p:cNvPicPr>
             <a:picLocks noChangeAspect="1"/>
           </p:cNvPicPr>
@@ -13618,7 +13618,7 @@
       </p:pic>
       <p:pic>
         <p:nvPicPr>
-          <p:cNvPr id="8" name="Image 5" descr="/var/folders/hm/sgq6d80d0vq133k7n8dc9bnw0000gn/T/maiershirts-R3q5bi/ref-unternehmen-5.png">    </p:cNvPr>
+          <p:cNvPr id="8" name="Image 5" descr="/var/folders/hm/sgq6d80d0vq133k7n8dc9bnw0000gn/T/maiershirts-3efGbV/ref-unternehmen-5.png">    </p:cNvPr>
           <p:cNvPicPr>
             <a:picLocks noChangeAspect="1"/>
           </p:cNvPicPr>
@@ -13644,7 +13644,7 @@
       </p:pic>
       <p:pic>
         <p:nvPicPr>
-          <p:cNvPr id="9" name="Image 6" descr="/var/folders/hm/sgq6d80d0vq133k7n8dc9bnw0000gn/T/maiershirts-R3q5bi/ref-unternehmen-6.png">    </p:cNvPr>
+          <p:cNvPr id="9" name="Image 6" descr="/var/folders/hm/sgq6d80d0vq133k7n8dc9bnw0000gn/T/maiershirts-3efGbV/ref-unternehmen-6.png">    </p:cNvPr>
           <p:cNvPicPr>
             <a:picLocks noChangeAspect="1"/>
           </p:cNvPicPr>
@@ -13670,7 +13670,7 @@
       </p:pic>
       <p:pic>
         <p:nvPicPr>
-          <p:cNvPr id="10" name="Image 7" descr="/var/folders/hm/sgq6d80d0vq133k7n8dc9bnw0000gn/T/maiershirts-R3q5bi/ref-unternehmen-7.png">    </p:cNvPr>
+          <p:cNvPr id="10" name="Image 7" descr="/var/folders/hm/sgq6d80d0vq133k7n8dc9bnw0000gn/T/maiershirts-3efGbV/ref-unternehmen-7.png">    </p:cNvPr>
           <p:cNvPicPr>
             <a:picLocks noChangeAspect="1"/>
           </p:cNvPicPr>
@@ -13696,7 +13696,7 @@
       </p:pic>
       <p:pic>
         <p:nvPicPr>
-          <p:cNvPr id="11" name="Image 8" descr="/var/folders/hm/sgq6d80d0vq133k7n8dc9bnw0000gn/T/maiershirts-R3q5bi/ref-unternehmen-8.png">    </p:cNvPr>
+          <p:cNvPr id="11" name="Image 8" descr="/var/folders/hm/sgq6d80d0vq133k7n8dc9bnw0000gn/T/maiershirts-3efGbV/ref-unternehmen-8.png">    </p:cNvPr>
           <p:cNvPicPr>
             <a:picLocks noChangeAspect="1"/>
           </p:cNvPicPr>
@@ -13722,7 +13722,7 @@
       </p:pic>
       <p:pic>
         <p:nvPicPr>
-          <p:cNvPr id="12" name="Image 9" descr="/var/folders/hm/sgq6d80d0vq133k7n8dc9bnw0000gn/T/maiershirts-R3q5bi/ref-unternehmen-9.png">    </p:cNvPr>
+          <p:cNvPr id="12" name="Image 9" descr="/var/folders/hm/sgq6d80d0vq133k7n8dc9bnw0000gn/T/maiershirts-3efGbV/ref-unternehmen-9.png">    </p:cNvPr>
           <p:cNvPicPr>
             <a:picLocks noChangeAspect="1"/>
           </p:cNvPicPr>
@@ -13748,7 +13748,7 @@
       </p:pic>
       <p:pic>
         <p:nvPicPr>
-          <p:cNvPr id="13" name="Image 10" descr="/var/folders/hm/sgq6d80d0vq133k7n8dc9bnw0000gn/T/maiershirts-R3q5bi/ph-logo-446x194.png">    </p:cNvPr>
+          <p:cNvPr id="13" name="Image 10" descr="/var/folders/hm/sgq6d80d0vq133k7n8dc9bnw0000gn/T/maiershirts-3efGbV/ph-logo-446x194.png">    </p:cNvPr>
           <p:cNvPicPr>
             <a:picLocks noChangeAspect="1"/>
           </p:cNvPicPr>
@@ -13774,7 +13774,7 @@
       </p:pic>
       <p:pic>
         <p:nvPicPr>
-          <p:cNvPr id="14" name="Image 11" descr="/var/folders/hm/sgq6d80d0vq133k7n8dc9bnw0000gn/T/maiershirts-R3q5bi/ph-logo-446x194.png">    </p:cNvPr>
+          <p:cNvPr id="14" name="Image 11" descr="/var/folders/hm/sgq6d80d0vq133k7n8dc9bnw0000gn/T/maiershirts-3efGbV/ph-logo-446x194.png">    </p:cNvPr>
           <p:cNvPicPr>
             <a:picLocks noChangeAspect="1"/>
           </p:cNvPicPr>
@@ -13914,7 +13914,7 @@
       </p:sp>
       <p:pic>
         <p:nvPicPr>
-          <p:cNvPr id="3" name="Image 0" descr="/var/folders/hm/sgq6d80d0vq133k7n8dc9bnw0000gn/T/maiershirts-R3q5bi/ref-vereine-0.png">    </p:cNvPr>
+          <p:cNvPr id="3" name="Image 0" descr="/var/folders/hm/sgq6d80d0vq133k7n8dc9bnw0000gn/T/maiershirts-3efGbV/ref-vereine-0.png">    </p:cNvPr>
           <p:cNvPicPr>
             <a:picLocks noChangeAspect="1"/>
           </p:cNvPicPr>
@@ -13981,7 +13981,7 @@
       </p:sp>
       <p:pic>
         <p:nvPicPr>
-          <p:cNvPr id="5" name="Image 1" descr="/var/folders/hm/sgq6d80d0vq133k7n8dc9bnw0000gn/T/maiershirts-R3q5bi/ref-vereine-1.png">    </p:cNvPr>
+          <p:cNvPr id="5" name="Image 1" descr="/var/folders/hm/sgq6d80d0vq133k7n8dc9bnw0000gn/T/maiershirts-3efGbV/ref-vereine-1.png">    </p:cNvPr>
           <p:cNvPicPr>
             <a:picLocks noChangeAspect="1"/>
           </p:cNvPicPr>
@@ -14048,7 +14048,7 @@
       </p:sp>
       <p:pic>
         <p:nvPicPr>
-          <p:cNvPr id="7" name="Image 2" descr="/var/folders/hm/sgq6d80d0vq133k7n8dc9bnw0000gn/T/maiershirts-R3q5bi/ref-vereine-2.png">    </p:cNvPr>
+          <p:cNvPr id="7" name="Image 2" descr="/var/folders/hm/sgq6d80d0vq133k7n8dc9bnw0000gn/T/maiershirts-3efGbV/ref-vereine-2.png">    </p:cNvPr>
           <p:cNvPicPr>
             <a:picLocks noChangeAspect="1"/>
           </p:cNvPicPr>
@@ -14115,7 +14115,7 @@
       </p:sp>
       <p:pic>
         <p:nvPicPr>
-          <p:cNvPr id="9" name="Image 3" descr="/var/folders/hm/sgq6d80d0vq133k7n8dc9bnw0000gn/T/maiershirts-R3q5bi/ref-vereine-3.png">    </p:cNvPr>
+          <p:cNvPr id="9" name="Image 3" descr="/var/folders/hm/sgq6d80d0vq133k7n8dc9bnw0000gn/T/maiershirts-3efGbV/ref-vereine-3.png">    </p:cNvPr>
           <p:cNvPicPr>
             <a:picLocks noChangeAspect="1"/>
           </p:cNvPicPr>
@@ -14182,7 +14182,7 @@
       </p:sp>
       <p:pic>
         <p:nvPicPr>
-          <p:cNvPr id="11" name="Image 4" descr="/var/folders/hm/sgq6d80d0vq133k7n8dc9bnw0000gn/T/maiershirts-R3q5bi/ref-vereine-4.png">    </p:cNvPr>
+          <p:cNvPr id="11" name="Image 4" descr="/var/folders/hm/sgq6d80d0vq133k7n8dc9bnw0000gn/T/maiershirts-3efGbV/ref-vereine-4.png">    </p:cNvPr>
           <p:cNvPicPr>
             <a:picLocks noChangeAspect="1"/>
           </p:cNvPicPr>
@@ -14249,7 +14249,7 @@
       </p:sp>
       <p:pic>
         <p:nvPicPr>
-          <p:cNvPr id="13" name="Image 5" descr="/var/folders/hm/sgq6d80d0vq133k7n8dc9bnw0000gn/T/maiershirts-R3q5bi/ref-vereine-5.png">    </p:cNvPr>
+          <p:cNvPr id="13" name="Image 5" descr="/var/folders/hm/sgq6d80d0vq133k7n8dc9bnw0000gn/T/maiershirts-3efGbV/ref-vereine-5.png">    </p:cNvPr>
           <p:cNvPicPr>
             <a:picLocks noChangeAspect="1"/>
           </p:cNvPicPr>
@@ -14316,7 +14316,7 @@
       </p:sp>
       <p:pic>
         <p:nvPicPr>
-          <p:cNvPr id="15" name="Image 6" descr="/var/folders/hm/sgq6d80d0vq133k7n8dc9bnw0000gn/T/maiershirts-R3q5bi/ref-vereine-6.png">    </p:cNvPr>
+          <p:cNvPr id="15" name="Image 6" descr="/var/folders/hm/sgq6d80d0vq133k7n8dc9bnw0000gn/T/maiershirts-3efGbV/ref-vereine-6.png">    </p:cNvPr>
           <p:cNvPicPr>
             <a:picLocks noChangeAspect="1"/>
           </p:cNvPicPr>
@@ -14383,7 +14383,7 @@
       </p:sp>
       <p:pic>
         <p:nvPicPr>
-          <p:cNvPr id="17" name="Image 7" descr="/var/folders/hm/sgq6d80d0vq133k7n8dc9bnw0000gn/T/maiershirts-R3q5bi/ph-logo-446x252.png">    </p:cNvPr>
+          <p:cNvPr id="17" name="Image 7" descr="/var/folders/hm/sgq6d80d0vq133k7n8dc9bnw0000gn/T/maiershirts-3efGbV/ref-vereine-7.png">    </p:cNvPr>
           <p:cNvPicPr>
             <a:picLocks noChangeAspect="1"/>
           </p:cNvPicPr>
@@ -14399,8 +14399,8 @@
         </p:blipFill>
         <p:spPr>
           <a:xfrm>
-            <a:off x="6876288" y="2944368"/>
-            <a:ext cx="1700784" cy="960120"/>
+            <a:off x="7022592" y="3098331"/>
+            <a:ext cx="1408176" cy="652193"/>
           </a:xfrm>
           <a:prstGeom prst="rect">
             <a:avLst/>
@@ -14409,8 +14409,8 @@
       </p:pic>
       <p:sp>
         <p:nvSpPr>
-          <p:cNvPr id="19" name="Text 0"/>
-          <p:cNvSpPr/>
+          <p:cNvPr id="18" name="Text 0"/>
+          <p:cNvSpPr txBox="1"/>
           <p:nvPr>
             <p:ph idx="117" type="body" hasCustomPrompt="1"/>
           </p:nvPr>
@@ -14433,6 +14433,17 @@
             <a:pPr algn="ctr" indent="0" marL="0">
               <a:buNone/>
             </a:pPr>
+            <a:r>
+              <a:rPr lang="en-US" sz="1100" b="1" dirty="0">
+                <a:solidFill>
+                  <a:srgbClr val="0F0F0F"/>
+                </a:solidFill>
+                <a:latin typeface="Inter" pitchFamily="34" charset="0"/>
+                <a:ea typeface="Inter" pitchFamily="34" charset="-122"/>
+                <a:cs typeface="Inter" pitchFamily="34" charset="-120"/>
+              </a:rPr>
+              <a:t>Tennisclub Wurmlingen</a:t>
+            </a:r>
             <a:endParaRPr lang="en-US" sz="1100" dirty="0"/>
           </a:p>
         </p:txBody>
@@ -14553,7 +14564,7 @@
       </p:sp>
       <p:pic>
         <p:nvPicPr>
-          <p:cNvPr id="3" name="Image 0" descr="/var/folders/hm/sgq6d80d0vq133k7n8dc9bnw0000gn/T/maiershirts-R3q5bi/ph-foto-1056x840.png">    </p:cNvPr>
+          <p:cNvPr id="3" name="Image 0" descr="/var/folders/hm/sgq6d80d0vq133k7n8dc9bnw0000gn/T/maiershirts-3efGbV/ph-foto-1056x840.png">    </p:cNvPr>
           <p:cNvPicPr>
             <a:picLocks noChangeAspect="1"/>
           </p:cNvPicPr>
@@ -15365,7 +15376,7 @@
       </p:sp>
       <p:pic>
         <p:nvPicPr>
-          <p:cNvPr id="4" name="Image 0" descr="/var/folders/hm/sgq6d80d0vq133k7n8dc9bnw0000gn/T/maiershirts-R3q5bi/ph-portrait-252x252.png">    </p:cNvPr>
+          <p:cNvPr id="4" name="Image 0" descr="/var/folders/hm/sgq6d80d0vq133k7n8dc9bnw0000gn/T/maiershirts-3efGbV/ph-portrait-252x252.png">    </p:cNvPr>
           <p:cNvPicPr>
             <a:picLocks noChangeAspect="1"/>
           </p:cNvPicPr>
@@ -15574,7 +15585,7 @@
       </p:sp>
       <p:pic>
         <p:nvPicPr>
-          <p:cNvPr id="9" name="Image 1" descr="/var/folders/hm/sgq6d80d0vq133k7n8dc9bnw0000gn/T/maiershirts-R3q5bi/ph-qr-240x240.png">    </p:cNvPr>
+          <p:cNvPr id="9" name="Image 1" descr="/var/folders/hm/sgq6d80d0vq133k7n8dc9bnw0000gn/T/maiershirts-3efGbV/ph-qr-240x240.png">    </p:cNvPr>
           <p:cNvPicPr>
             <a:picLocks noChangeAspect="1"/>
           </p:cNvPicPr>
@@ -16990,7 +17001,7 @@
       </p:grpSpPr>
       <p:pic>
         <p:nvPicPr>
-          <p:cNvPr id="2" name="Image 0" descr="/var/folders/hm/sgq6d80d0vq133k7n8dc9bnw0000gn/T/maiershirts-R3q5bi/ph-foto-2400x1008.png">    </p:cNvPr>
+          <p:cNvPr id="2" name="Image 0" descr="/var/folders/hm/sgq6d80d0vq133k7n8dc9bnw0000gn/T/maiershirts-3efGbV/ph-foto-2400x1008.png">    </p:cNvPr>
           <p:cNvPicPr>
             <a:picLocks noChangeAspect="1"/>
           </p:cNvPicPr>
@@ -18148,7 +18159,7 @@
       </p:sp>
       <p:pic>
         <p:nvPicPr>
-          <p:cNvPr id="3" name="Image 0" descr="/var/folders/hm/sgq6d80d0vq133k7n8dc9bnw0000gn/T/maiershirts-R3q5bi/ph-foto-696x456.png">    </p:cNvPr>
+          <p:cNvPr id="3" name="Image 0" descr="/var/folders/hm/sgq6d80d0vq133k7n8dc9bnw0000gn/T/maiershirts-3efGbV/ph-foto-696x456.png">    </p:cNvPr>
           <p:cNvPicPr>
             <a:picLocks noChangeAspect="1"/>
           </p:cNvPicPr>
@@ -18318,7 +18329,7 @@
       </p:sp>
       <p:pic>
         <p:nvPicPr>
-          <p:cNvPr id="7" name="Image 1" descr="/var/folders/hm/sgq6d80d0vq133k7n8dc9bnw0000gn/T/maiershirts-R3q5bi/ph-foto-696x456.png">    </p:cNvPr>
+          <p:cNvPr id="7" name="Image 1" descr="/var/folders/hm/sgq6d80d0vq133k7n8dc9bnw0000gn/T/maiershirts-3efGbV/ph-foto-696x456.png">    </p:cNvPr>
           <p:cNvPicPr>
             <a:picLocks noChangeAspect="1"/>
           </p:cNvPicPr>
@@ -18488,7 +18499,7 @@
       </p:sp>
       <p:pic>
         <p:nvPicPr>
-          <p:cNvPr id="11" name="Image 2" descr="/var/folders/hm/sgq6d80d0vq133k7n8dc9bnw0000gn/T/maiershirts-R3q5bi/ph-foto-696x456.png">    </p:cNvPr>
+          <p:cNvPr id="11" name="Image 2" descr="/var/folders/hm/sgq6d80d0vq133k7n8dc9bnw0000gn/T/maiershirts-3efGbV/ph-foto-696x456.png">    </p:cNvPr>
           <p:cNvPicPr>
             <a:picLocks noChangeAspect="1"/>
           </p:cNvPicPr>

</xml_diff>

<commit_message>
Referenzen: FDF Landesverband Bayern und KLARUNDWERTVOLL ergänzen
Co-Authored-By: Claude Fable 5.1 <noreply@anthropic.com>
</commit_message>
<xml_diff>
--- a/presentation/dist/Maiershirts_Master.pptx
+++ b/presentation/dist/Maiershirts_Master.pptx
@@ -941,7 +941,7 @@
           <a:p>
             <a:r>
               <a:rPr lang="en-US" dirty="0"/>
-              <a:t>Layout MS_REFERENZEN: 12 Logo-Felder. 10 Logo(s) aus assets/referenzen/unternehmen eingesetzt. Logo per Klick auf das Platzhalterbild einsetzen; bei Beschnitt: Bildformat → Zuschneiden → Anpassen.</a:t>
+              <a:t>Layout MS_REFERENZEN: 12 Logo-Felder. 12 Logo(s) aus assets/referenzen/unternehmen eingesetzt. Logo per Klick auf das Platzhalterbild einsetzen; bei Beschnitt: Bildformat → Zuschneiden → Anpassen.</a:t>
             </a:r>
             <a:endParaRPr lang="en-US" dirty="0"/>
           </a:p>
@@ -13488,7 +13488,7 @@
       </p:sp>
       <p:pic>
         <p:nvPicPr>
-          <p:cNvPr id="3" name="Image 0" descr="/var/folders/hm/sgq6d80d0vq133k7n8dc9bnw0000gn/T/maiershirts-3efGbV/ref-unternehmen-0.png">    </p:cNvPr>
+          <p:cNvPr id="3" name="Image 0" descr="/var/folders/hm/sgq6d80d0vq133k7n8dc9bnw0000gn/T/maiershirts-2HUvCI/ref-unternehmen-0.png">    </p:cNvPr>
           <p:cNvPicPr>
             <a:picLocks noChangeAspect="1"/>
           </p:cNvPicPr>
@@ -13514,7 +13514,7 @@
       </p:pic>
       <p:pic>
         <p:nvPicPr>
-          <p:cNvPr id="4" name="Image 1" descr="/var/folders/hm/sgq6d80d0vq133k7n8dc9bnw0000gn/T/maiershirts-3efGbV/ref-unternehmen-1.png">    </p:cNvPr>
+          <p:cNvPr id="4" name="Image 1" descr="/var/folders/hm/sgq6d80d0vq133k7n8dc9bnw0000gn/T/maiershirts-2HUvCI/ref-unternehmen-1.png">    </p:cNvPr>
           <p:cNvPicPr>
             <a:picLocks noChangeAspect="1"/>
           </p:cNvPicPr>
@@ -13540,7 +13540,7 @@
       </p:pic>
       <p:pic>
         <p:nvPicPr>
-          <p:cNvPr id="5" name="Image 2" descr="/var/folders/hm/sgq6d80d0vq133k7n8dc9bnw0000gn/T/maiershirts-3efGbV/ref-unternehmen-2.png">    </p:cNvPr>
+          <p:cNvPr id="5" name="Image 2" descr="/var/folders/hm/sgq6d80d0vq133k7n8dc9bnw0000gn/T/maiershirts-2HUvCI/ref-unternehmen-2.png">    </p:cNvPr>
           <p:cNvPicPr>
             <a:picLocks noChangeAspect="1"/>
           </p:cNvPicPr>
@@ -13566,7 +13566,7 @@
       </p:pic>
       <p:pic>
         <p:nvPicPr>
-          <p:cNvPr id="6" name="Image 3" descr="/var/folders/hm/sgq6d80d0vq133k7n8dc9bnw0000gn/T/maiershirts-3efGbV/ref-unternehmen-3.png">    </p:cNvPr>
+          <p:cNvPr id="6" name="Image 3" descr="/var/folders/hm/sgq6d80d0vq133k7n8dc9bnw0000gn/T/maiershirts-2HUvCI/ref-unternehmen-3.png">    </p:cNvPr>
           <p:cNvPicPr>
             <a:picLocks noChangeAspect="1"/>
           </p:cNvPicPr>
@@ -13592,7 +13592,7 @@
       </p:pic>
       <p:pic>
         <p:nvPicPr>
-          <p:cNvPr id="7" name="Image 4" descr="/var/folders/hm/sgq6d80d0vq133k7n8dc9bnw0000gn/T/maiershirts-3efGbV/ref-unternehmen-4.png">    </p:cNvPr>
+          <p:cNvPr id="7" name="Image 4" descr="/var/folders/hm/sgq6d80d0vq133k7n8dc9bnw0000gn/T/maiershirts-2HUvCI/ref-unternehmen-4.png">    </p:cNvPr>
           <p:cNvPicPr>
             <a:picLocks noChangeAspect="1"/>
           </p:cNvPicPr>
@@ -13618,7 +13618,7 @@
       </p:pic>
       <p:pic>
         <p:nvPicPr>
-          <p:cNvPr id="8" name="Image 5" descr="/var/folders/hm/sgq6d80d0vq133k7n8dc9bnw0000gn/T/maiershirts-3efGbV/ref-unternehmen-5.png">    </p:cNvPr>
+          <p:cNvPr id="8" name="Image 5" descr="/var/folders/hm/sgq6d80d0vq133k7n8dc9bnw0000gn/T/maiershirts-2HUvCI/ref-unternehmen-5.png">    </p:cNvPr>
           <p:cNvPicPr>
             <a:picLocks noChangeAspect="1"/>
           </p:cNvPicPr>
@@ -13644,7 +13644,7 @@
       </p:pic>
       <p:pic>
         <p:nvPicPr>
-          <p:cNvPr id="9" name="Image 6" descr="/var/folders/hm/sgq6d80d0vq133k7n8dc9bnw0000gn/T/maiershirts-3efGbV/ref-unternehmen-6.png">    </p:cNvPr>
+          <p:cNvPr id="9" name="Image 6" descr="/var/folders/hm/sgq6d80d0vq133k7n8dc9bnw0000gn/T/maiershirts-2HUvCI/ref-unternehmen-6.png">    </p:cNvPr>
           <p:cNvPicPr>
             <a:picLocks noChangeAspect="1"/>
           </p:cNvPicPr>
@@ -13670,7 +13670,7 @@
       </p:pic>
       <p:pic>
         <p:nvPicPr>
-          <p:cNvPr id="10" name="Image 7" descr="/var/folders/hm/sgq6d80d0vq133k7n8dc9bnw0000gn/T/maiershirts-3efGbV/ref-unternehmen-7.png">    </p:cNvPr>
+          <p:cNvPr id="10" name="Image 7" descr="/var/folders/hm/sgq6d80d0vq133k7n8dc9bnw0000gn/T/maiershirts-2HUvCI/ref-unternehmen-7.png">    </p:cNvPr>
           <p:cNvPicPr>
             <a:picLocks noChangeAspect="1"/>
           </p:cNvPicPr>
@@ -13696,7 +13696,7 @@
       </p:pic>
       <p:pic>
         <p:nvPicPr>
-          <p:cNvPr id="11" name="Image 8" descr="/var/folders/hm/sgq6d80d0vq133k7n8dc9bnw0000gn/T/maiershirts-3efGbV/ref-unternehmen-8.png">    </p:cNvPr>
+          <p:cNvPr id="11" name="Image 8" descr="/var/folders/hm/sgq6d80d0vq133k7n8dc9bnw0000gn/T/maiershirts-2HUvCI/ref-unternehmen-8.png">    </p:cNvPr>
           <p:cNvPicPr>
             <a:picLocks noChangeAspect="1"/>
           </p:cNvPicPr>
@@ -13722,7 +13722,7 @@
       </p:pic>
       <p:pic>
         <p:nvPicPr>
-          <p:cNvPr id="12" name="Image 9" descr="/var/folders/hm/sgq6d80d0vq133k7n8dc9bnw0000gn/T/maiershirts-3efGbV/ref-unternehmen-9.png">    </p:cNvPr>
+          <p:cNvPr id="12" name="Image 9" descr="/var/folders/hm/sgq6d80d0vq133k7n8dc9bnw0000gn/T/maiershirts-2HUvCI/ref-unternehmen-9.png">    </p:cNvPr>
           <p:cNvPicPr>
             <a:picLocks noChangeAspect="1"/>
           </p:cNvPicPr>
@@ -13748,7 +13748,7 @@
       </p:pic>
       <p:pic>
         <p:nvPicPr>
-          <p:cNvPr id="13" name="Image 10" descr="/var/folders/hm/sgq6d80d0vq133k7n8dc9bnw0000gn/T/maiershirts-3efGbV/ph-logo-446x194.png">    </p:cNvPr>
+          <p:cNvPr id="13" name="Image 10" descr="/var/folders/hm/sgq6d80d0vq133k7n8dc9bnw0000gn/T/maiershirts-2HUvCI/ref-unternehmen-10.png">    </p:cNvPr>
           <p:cNvPicPr>
             <a:picLocks noChangeAspect="1"/>
           </p:cNvPicPr>
@@ -13764,8 +13764,8 @@
         </p:blipFill>
         <p:spPr>
           <a:xfrm>
-            <a:off x="4773168" y="3538728"/>
-            <a:ext cx="1700784" cy="740664"/>
+            <a:off x="5398727" y="3685032"/>
+            <a:ext cx="449666" cy="448056"/>
           </a:xfrm>
           <a:prstGeom prst="rect">
             <a:avLst/>
@@ -13774,7 +13774,7 @@
       </p:pic>
       <p:pic>
         <p:nvPicPr>
-          <p:cNvPr id="14" name="Image 11" descr="/var/folders/hm/sgq6d80d0vq133k7n8dc9bnw0000gn/T/maiershirts-3efGbV/ph-logo-446x194.png">    </p:cNvPr>
+          <p:cNvPr id="14" name="Image 11" descr="/var/folders/hm/sgq6d80d0vq133k7n8dc9bnw0000gn/T/maiershirts-2HUvCI/ref-unternehmen-11.png">    </p:cNvPr>
           <p:cNvPicPr>
             <a:picLocks noChangeAspect="1"/>
           </p:cNvPicPr>
@@ -13790,8 +13790,8 @@
         </p:blipFill>
         <p:spPr>
           <a:xfrm>
-            <a:off x="6876288" y="3538728"/>
-            <a:ext cx="1700784" cy="740664"/>
+            <a:off x="7022592" y="3765694"/>
+            <a:ext cx="1408176" cy="286733"/>
           </a:xfrm>
           <a:prstGeom prst="rect">
             <a:avLst/>
@@ -13914,7 +13914,7 @@
       </p:sp>
       <p:pic>
         <p:nvPicPr>
-          <p:cNvPr id="3" name="Image 0" descr="/var/folders/hm/sgq6d80d0vq133k7n8dc9bnw0000gn/T/maiershirts-3efGbV/ref-vereine-0.png">    </p:cNvPr>
+          <p:cNvPr id="3" name="Image 0" descr="/var/folders/hm/sgq6d80d0vq133k7n8dc9bnw0000gn/T/maiershirts-2HUvCI/ref-vereine-0.png">    </p:cNvPr>
           <p:cNvPicPr>
             <a:picLocks noChangeAspect="1"/>
           </p:cNvPicPr>
@@ -13981,7 +13981,7 @@
       </p:sp>
       <p:pic>
         <p:nvPicPr>
-          <p:cNvPr id="5" name="Image 1" descr="/var/folders/hm/sgq6d80d0vq133k7n8dc9bnw0000gn/T/maiershirts-3efGbV/ref-vereine-1.png">    </p:cNvPr>
+          <p:cNvPr id="5" name="Image 1" descr="/var/folders/hm/sgq6d80d0vq133k7n8dc9bnw0000gn/T/maiershirts-2HUvCI/ref-vereine-1.png">    </p:cNvPr>
           <p:cNvPicPr>
             <a:picLocks noChangeAspect="1"/>
           </p:cNvPicPr>
@@ -14048,7 +14048,7 @@
       </p:sp>
       <p:pic>
         <p:nvPicPr>
-          <p:cNvPr id="7" name="Image 2" descr="/var/folders/hm/sgq6d80d0vq133k7n8dc9bnw0000gn/T/maiershirts-3efGbV/ref-vereine-2.png">    </p:cNvPr>
+          <p:cNvPr id="7" name="Image 2" descr="/var/folders/hm/sgq6d80d0vq133k7n8dc9bnw0000gn/T/maiershirts-2HUvCI/ref-vereine-2.png">    </p:cNvPr>
           <p:cNvPicPr>
             <a:picLocks noChangeAspect="1"/>
           </p:cNvPicPr>
@@ -14115,7 +14115,7 @@
       </p:sp>
       <p:pic>
         <p:nvPicPr>
-          <p:cNvPr id="9" name="Image 3" descr="/var/folders/hm/sgq6d80d0vq133k7n8dc9bnw0000gn/T/maiershirts-3efGbV/ref-vereine-3.png">    </p:cNvPr>
+          <p:cNvPr id="9" name="Image 3" descr="/var/folders/hm/sgq6d80d0vq133k7n8dc9bnw0000gn/T/maiershirts-2HUvCI/ref-vereine-3.png">    </p:cNvPr>
           <p:cNvPicPr>
             <a:picLocks noChangeAspect="1"/>
           </p:cNvPicPr>
@@ -14182,7 +14182,7 @@
       </p:sp>
       <p:pic>
         <p:nvPicPr>
-          <p:cNvPr id="11" name="Image 4" descr="/var/folders/hm/sgq6d80d0vq133k7n8dc9bnw0000gn/T/maiershirts-3efGbV/ref-vereine-4.png">    </p:cNvPr>
+          <p:cNvPr id="11" name="Image 4" descr="/var/folders/hm/sgq6d80d0vq133k7n8dc9bnw0000gn/T/maiershirts-2HUvCI/ref-vereine-4.png">    </p:cNvPr>
           <p:cNvPicPr>
             <a:picLocks noChangeAspect="1"/>
           </p:cNvPicPr>
@@ -14249,7 +14249,7 @@
       </p:sp>
       <p:pic>
         <p:nvPicPr>
-          <p:cNvPr id="13" name="Image 5" descr="/var/folders/hm/sgq6d80d0vq133k7n8dc9bnw0000gn/T/maiershirts-3efGbV/ref-vereine-5.png">    </p:cNvPr>
+          <p:cNvPr id="13" name="Image 5" descr="/var/folders/hm/sgq6d80d0vq133k7n8dc9bnw0000gn/T/maiershirts-2HUvCI/ref-vereine-5.png">    </p:cNvPr>
           <p:cNvPicPr>
             <a:picLocks noChangeAspect="1"/>
           </p:cNvPicPr>
@@ -14316,7 +14316,7 @@
       </p:sp>
       <p:pic>
         <p:nvPicPr>
-          <p:cNvPr id="15" name="Image 6" descr="/var/folders/hm/sgq6d80d0vq133k7n8dc9bnw0000gn/T/maiershirts-3efGbV/ref-vereine-6.png">    </p:cNvPr>
+          <p:cNvPr id="15" name="Image 6" descr="/var/folders/hm/sgq6d80d0vq133k7n8dc9bnw0000gn/T/maiershirts-2HUvCI/ref-vereine-6.png">    </p:cNvPr>
           <p:cNvPicPr>
             <a:picLocks noChangeAspect="1"/>
           </p:cNvPicPr>
@@ -14383,7 +14383,7 @@
       </p:sp>
       <p:pic>
         <p:nvPicPr>
-          <p:cNvPr id="17" name="Image 7" descr="/var/folders/hm/sgq6d80d0vq133k7n8dc9bnw0000gn/T/maiershirts-3efGbV/ref-vereine-7.png">    </p:cNvPr>
+          <p:cNvPr id="17" name="Image 7" descr="/var/folders/hm/sgq6d80d0vq133k7n8dc9bnw0000gn/T/maiershirts-2HUvCI/ref-vereine-7.png">    </p:cNvPr>
           <p:cNvPicPr>
             <a:picLocks noChangeAspect="1"/>
           </p:cNvPicPr>
@@ -14564,7 +14564,7 @@
       </p:sp>
       <p:pic>
         <p:nvPicPr>
-          <p:cNvPr id="3" name="Image 0" descr="/var/folders/hm/sgq6d80d0vq133k7n8dc9bnw0000gn/T/maiershirts-3efGbV/ph-foto-1056x840.png">    </p:cNvPr>
+          <p:cNvPr id="3" name="Image 0" descr="/var/folders/hm/sgq6d80d0vq133k7n8dc9bnw0000gn/T/maiershirts-2HUvCI/ph-foto-1056x840.png">    </p:cNvPr>
           <p:cNvPicPr>
             <a:picLocks noChangeAspect="1"/>
           </p:cNvPicPr>
@@ -15376,7 +15376,7 @@
       </p:sp>
       <p:pic>
         <p:nvPicPr>
-          <p:cNvPr id="4" name="Image 0" descr="/var/folders/hm/sgq6d80d0vq133k7n8dc9bnw0000gn/T/maiershirts-3efGbV/ph-portrait-252x252.png">    </p:cNvPr>
+          <p:cNvPr id="4" name="Image 0" descr="/var/folders/hm/sgq6d80d0vq133k7n8dc9bnw0000gn/T/maiershirts-2HUvCI/ph-portrait-252x252.png">    </p:cNvPr>
           <p:cNvPicPr>
             <a:picLocks noChangeAspect="1"/>
           </p:cNvPicPr>
@@ -15585,7 +15585,7 @@
       </p:sp>
       <p:pic>
         <p:nvPicPr>
-          <p:cNvPr id="9" name="Image 1" descr="/var/folders/hm/sgq6d80d0vq133k7n8dc9bnw0000gn/T/maiershirts-3efGbV/ph-qr-240x240.png">    </p:cNvPr>
+          <p:cNvPr id="9" name="Image 1" descr="/var/folders/hm/sgq6d80d0vq133k7n8dc9bnw0000gn/T/maiershirts-2HUvCI/ph-qr-240x240.png">    </p:cNvPr>
           <p:cNvPicPr>
             <a:picLocks noChangeAspect="1"/>
           </p:cNvPicPr>
@@ -17001,7 +17001,7 @@
       </p:grpSpPr>
       <p:pic>
         <p:nvPicPr>
-          <p:cNvPr id="2" name="Image 0" descr="/var/folders/hm/sgq6d80d0vq133k7n8dc9bnw0000gn/T/maiershirts-3efGbV/ph-foto-2400x1008.png">    </p:cNvPr>
+          <p:cNvPr id="2" name="Image 0" descr="/var/folders/hm/sgq6d80d0vq133k7n8dc9bnw0000gn/T/maiershirts-2HUvCI/ph-foto-2400x1008.png">    </p:cNvPr>
           <p:cNvPicPr>
             <a:picLocks noChangeAspect="1"/>
           </p:cNvPicPr>
@@ -18159,7 +18159,7 @@
       </p:sp>
       <p:pic>
         <p:nvPicPr>
-          <p:cNvPr id="3" name="Image 0" descr="/var/folders/hm/sgq6d80d0vq133k7n8dc9bnw0000gn/T/maiershirts-3efGbV/ph-foto-696x456.png">    </p:cNvPr>
+          <p:cNvPr id="3" name="Image 0" descr="/var/folders/hm/sgq6d80d0vq133k7n8dc9bnw0000gn/T/maiershirts-2HUvCI/ph-foto-696x456.png">    </p:cNvPr>
           <p:cNvPicPr>
             <a:picLocks noChangeAspect="1"/>
           </p:cNvPicPr>
@@ -18329,7 +18329,7 @@
       </p:sp>
       <p:pic>
         <p:nvPicPr>
-          <p:cNvPr id="7" name="Image 1" descr="/var/folders/hm/sgq6d80d0vq133k7n8dc9bnw0000gn/T/maiershirts-3efGbV/ph-foto-696x456.png">    </p:cNvPr>
+          <p:cNvPr id="7" name="Image 1" descr="/var/folders/hm/sgq6d80d0vq133k7n8dc9bnw0000gn/T/maiershirts-2HUvCI/ph-foto-696x456.png">    </p:cNvPr>
           <p:cNvPicPr>
             <a:picLocks noChangeAspect="1"/>
           </p:cNvPicPr>
@@ -18499,7 +18499,7 @@
       </p:sp>
       <p:pic>
         <p:nvPicPr>
-          <p:cNvPr id="11" name="Image 2" descr="/var/folders/hm/sgq6d80d0vq133k7n8dc9bnw0000gn/T/maiershirts-3efGbV/ph-foto-696x456.png">    </p:cNvPr>
+          <p:cNvPr id="11" name="Image 2" descr="/var/folders/hm/sgq6d80d0vq133k7n8dc9bnw0000gn/T/maiershirts-2HUvCI/ph-foto-696x456.png">    </p:cNvPr>
           <p:cNvPicPr>
             <a:picLocks noChangeAspect="1"/>
           </p:cNvPicPr>

</xml_diff>

<commit_message>
Referenzen: Fortsetzungsfolie bei mehr Logos als Feldern, Kährs ergänzen
Co-Authored-By: Claude Fable 5.1 <noreply@anthropic.com>
</commit_message>
<xml_diff>
--- a/presentation/dist/Maiershirts_Master.pptx
+++ b/presentation/dist/Maiershirts_Master.pptx
@@ -21,9 +21,10 @@
     <p:sldId id="269" r:id="rId15"/>
     <p:sldId id="270" r:id="rId16"/>
     <p:sldId id="271" r:id="rId17"/>
+    <p:sldId id="272" r:id="rId18"/>
   </p:sldIdLst>
   <p:notesMasterIdLst>
-    <p:notesMasterId r:id="rId18"/>
+    <p:notesMasterId r:id="rId19"/>
   </p:notesMasterIdLst>
   <p:sldSz cx="9144000" cy="5143500"/>
   <p:notesSz cx="5143500" cy="9144000"/>
@@ -941,7 +942,7 @@
           <a:p>
             <a:r>
               <a:rPr lang="en-US" dirty="0"/>
-              <a:t>Layout MS_REFERENZEN: 12 Logo-Felder. 12 Logo(s) aus assets/referenzen/unternehmen eingesetzt. Logo per Klick auf das Platzhalterbild einsetzen; bei Beschnitt: Bildformat → Zuschneiden → Anpassen.</a:t>
+              <a:t>Layout MS_REFERENZEN: 12 Logo-Felder. 12 Logo(s) aus assets/referenzen/unternehmen eingesetzt (Folie 1 von 2). Logo per Klick auf das Platzhalterbild einsetzen; bei Beschnitt: Bildformat → Zuschneiden → Anpassen.</a:t>
             </a:r>
             <a:endParaRPr lang="en-US" dirty="0"/>
           </a:p>
@@ -1029,7 +1030,7 @@
           <a:p>
             <a:r>
               <a:rPr lang="en-US" dirty="0"/>
-              <a:t>Layout MS_REFERENZEN_WAPPEN: 8 Logo-Felder. 8 Logo(s) aus assets/referenzen/vereine eingesetzt. Logo per Klick auf das Platzhalterbild einsetzen; bei Beschnitt: Bildformat → Zuschneiden → Anpassen.</a:t>
+              <a:t>Layout MS_REFERENZEN: 12 Logo-Felder. 1 Logo(s) aus assets/referenzen/unternehmen eingesetzt (Folie 2 von 2). Logo per Klick auf das Platzhalterbild einsetzen; bei Beschnitt: Bildformat → Zuschneiden → Anpassen.</a:t>
             </a:r>
             <a:endParaRPr lang="en-US" dirty="0"/>
           </a:p>
@@ -1117,7 +1118,7 @@
           <a:p>
             <a:r>
               <a:rPr lang="en-US" dirty="0"/>
-              <a:t>Layout MS_BILD: Foto links, Textkörper rechts.</a:t>
+              <a:t>Layout MS_REFERENZEN_WAPPEN: 8 Logo-Felder. 8 Logo(s) aus assets/referenzen/vereine eingesetzt (Folie 1 von 1). Logo per Klick auf das Platzhalterbild einsetzen; bei Beschnitt: Bildformat → Zuschneiden → Anpassen.</a:t>
             </a:r>
             <a:endParaRPr lang="en-US" dirty="0"/>
           </a:p>
@@ -1205,7 +1206,7 @@
           <a:p>
             <a:r>
               <a:rPr lang="en-US" dirty="0"/>
-              <a:t>Layout MS_FREI mit nativem Säulendiagramm links und Kernaussage rechts.</a:t>
+              <a:t>Layout MS_BILD: Foto links, Textkörper rechts.</a:t>
             </a:r>
             <a:endParaRPr lang="en-US" dirty="0"/>
           </a:p>
@@ -1293,7 +1294,7 @@
           <a:p>
             <a:r>
               <a:rPr lang="en-US" dirty="0"/>
-              <a:t>Layout MS_INHALT: Titel und Textkörper mit Aufzählung.</a:t>
+              <a:t>Layout MS_FREI mit nativem Säulendiagramm links und Kernaussage rechts.</a:t>
             </a:r>
             <a:endParaRPr lang="en-US" dirty="0"/>
           </a:p>
@@ -1381,7 +1382,7 @@
           <a:p>
             <a:r>
               <a:rPr lang="en-US" dirty="0"/>
-              <a:t>Layout MS_ABSCHLUSS: Handlungsaufforderung, Ansprechpartner mit Foto, nächster Schritt mit Termin, QR-Code. Kontaktdaten sind Platzhalter.</a:t>
+              <a:t>Layout MS_INHALT: Titel und Textkörper mit Aufzählung.</a:t>
             </a:r>
             <a:endParaRPr lang="en-US" dirty="0"/>
           </a:p>
@@ -1405,6 +1406,94 @@
             <a:fld id="{F7021451-1387-4CA6-816F-3879F97B5CBC}" type="slidenum">
               <a:rPr lang="en-US"/>
               <a:t>16</a:t>
+            </a:fld>
+            <a:endParaRPr lang="en-US"/>
+          </a:p>
+        </p:txBody>
+      </p:sp>
+    </p:spTree>
+    <p:extLst>
+      <p:ext uri="{BB962C8B-B14F-4D97-AF65-F5344CB8AC3E}">
+        <p14:creationId xmlns:p14="http://schemas.microsoft.com/office/powerpoint/2010/main" val="1024086991"/>
+      </p:ext>
+    </p:extLst>
+  </p:cSld>
+  <p:clrMapOvr>
+    <a:masterClrMapping/>
+  </p:clrMapOvr>
+</p:notes>
+</file>
+
+<file path=ppt/notesSlides/notesSlide17.xml><?xml version="1.0" encoding="utf-8"?>
+<p:notes xmlns:a="http://schemas.openxmlformats.org/drawingml/2006/main" xmlns:r="http://schemas.openxmlformats.org/officeDocument/2006/relationships" xmlns:p="http://schemas.openxmlformats.org/presentationml/2006/main">
+  <p:cSld>
+    <p:spTree>
+      <p:nvGrpSpPr>
+        <p:cNvPr id="1" name=""/>
+        <p:cNvGrpSpPr/>
+        <p:nvPr/>
+      </p:nvGrpSpPr>
+      <p:grpSpPr>
+        <a:xfrm>
+          <a:off x="0" y="0"/>
+          <a:ext cx="0" cy="0"/>
+          <a:chOff x="0" y="0"/>
+          <a:chExt cx="0" cy="0"/>
+        </a:xfrm>
+      </p:grpSpPr>
+      <p:sp>
+        <p:nvSpPr>
+          <p:cNvPr id="2" name="Slide Image Placeholder 1"/>
+          <p:cNvSpPr>
+            <a:spLocks noGrp="1" noRot="1" noChangeAspect="1"/>
+          </p:cNvSpPr>
+          <p:nvPr>
+            <p:ph type="sldImg"/>
+          </p:nvPr>
+        </p:nvSpPr>
+        <p:spPr/>
+      </p:sp>
+      <p:sp>
+        <p:nvSpPr>
+          <p:cNvPr id="3" name="Notes Placeholder 2"/>
+          <p:cNvSpPr>
+            <a:spLocks noGrp="1"/>
+          </p:cNvSpPr>
+          <p:nvPr>
+            <p:ph type="body" idx="1"/>
+          </p:nvPr>
+        </p:nvSpPr>
+        <p:spPr/>
+        <p:txBody>
+          <a:bodyPr/>
+          <a:lstStyle/>
+          <a:p>
+            <a:r>
+              <a:rPr lang="en-US" dirty="0"/>
+              <a:t>Layout MS_ABSCHLUSS: Handlungsaufforderung, Ansprechpartner mit Foto, nächster Schritt mit Termin, QR-Code. Kontaktdaten sind Platzhalter.</a:t>
+            </a:r>
+            <a:endParaRPr lang="en-US" dirty="0"/>
+          </a:p>
+        </p:txBody>
+      </p:sp>
+      <p:sp>
+        <p:nvSpPr>
+          <p:cNvPr id="4" name="Slide Number Placeholder 3"/>
+          <p:cNvSpPr>
+            <a:spLocks noGrp="1"/>
+          </p:cNvSpPr>
+          <p:nvPr>
+            <p:ph type="sldNum" sz="quarter" idx="10"/>
+          </p:nvPr>
+        </p:nvSpPr>
+        <p:spPr/>
+        <p:txBody>
+          <a:bodyPr/>
+          <a:lstStyle/>
+          <a:p>
+            <a:fld id="{F7021451-1387-4CA6-816F-3879F97B5CBC}" type="slidenum">
+              <a:rPr lang="en-US"/>
+              <a:t>17</a:t>
             </a:fld>
             <a:endParaRPr lang="en-US"/>
           </a:p>
@@ -13480,7 +13569,7 @@
                 <a:ea typeface="Inter" pitchFamily="34" charset="-122"/>
                 <a:cs typeface="Inter" pitchFamily="34" charset="-120"/>
               </a:rPr>
-              <a:t>Unternehmen, die uns vertrauen</a:t>
+              <a:t>Unternehmen, die uns vertrauen (1/2)</a:t>
             </a:r>
             <a:endParaRPr lang="en-US" sz="2800" dirty="0"/>
           </a:p>
@@ -13488,7 +13577,7 @@
       </p:sp>
       <p:pic>
         <p:nvPicPr>
-          <p:cNvPr id="3" name="Image 0" descr="/var/folders/hm/sgq6d80d0vq133k7n8dc9bnw0000gn/T/maiershirts-2HUvCI/ref-unternehmen-0.png">    </p:cNvPr>
+          <p:cNvPr id="3" name="Image 0" descr="/var/folders/hm/sgq6d80d0vq133k7n8dc9bnw0000gn/T/maiershirts-Os5V18/ref-unternehmen-0-0.png">    </p:cNvPr>
           <p:cNvPicPr>
             <a:picLocks noChangeAspect="1"/>
           </p:cNvPicPr>
@@ -13514,7 +13603,7 @@
       </p:pic>
       <p:pic>
         <p:nvPicPr>
-          <p:cNvPr id="4" name="Image 1" descr="/var/folders/hm/sgq6d80d0vq133k7n8dc9bnw0000gn/T/maiershirts-2HUvCI/ref-unternehmen-1.png">    </p:cNvPr>
+          <p:cNvPr id="4" name="Image 1" descr="/var/folders/hm/sgq6d80d0vq133k7n8dc9bnw0000gn/T/maiershirts-Os5V18/ref-unternehmen-0-1.png">    </p:cNvPr>
           <p:cNvPicPr>
             <a:picLocks noChangeAspect="1"/>
           </p:cNvPicPr>
@@ -13540,7 +13629,7 @@
       </p:pic>
       <p:pic>
         <p:nvPicPr>
-          <p:cNvPr id="5" name="Image 2" descr="/var/folders/hm/sgq6d80d0vq133k7n8dc9bnw0000gn/T/maiershirts-2HUvCI/ref-unternehmen-2.png">    </p:cNvPr>
+          <p:cNvPr id="5" name="Image 2" descr="/var/folders/hm/sgq6d80d0vq133k7n8dc9bnw0000gn/T/maiershirts-Os5V18/ref-unternehmen-0-2.png">    </p:cNvPr>
           <p:cNvPicPr>
             <a:picLocks noChangeAspect="1"/>
           </p:cNvPicPr>
@@ -13566,7 +13655,7 @@
       </p:pic>
       <p:pic>
         <p:nvPicPr>
-          <p:cNvPr id="6" name="Image 3" descr="/var/folders/hm/sgq6d80d0vq133k7n8dc9bnw0000gn/T/maiershirts-2HUvCI/ref-unternehmen-3.png">    </p:cNvPr>
+          <p:cNvPr id="6" name="Image 3" descr="/var/folders/hm/sgq6d80d0vq133k7n8dc9bnw0000gn/T/maiershirts-Os5V18/ref-unternehmen-0-3.png">    </p:cNvPr>
           <p:cNvPicPr>
             <a:picLocks noChangeAspect="1"/>
           </p:cNvPicPr>
@@ -13592,7 +13681,7 @@
       </p:pic>
       <p:pic>
         <p:nvPicPr>
-          <p:cNvPr id="7" name="Image 4" descr="/var/folders/hm/sgq6d80d0vq133k7n8dc9bnw0000gn/T/maiershirts-2HUvCI/ref-unternehmen-4.png">    </p:cNvPr>
+          <p:cNvPr id="7" name="Image 4" descr="/var/folders/hm/sgq6d80d0vq133k7n8dc9bnw0000gn/T/maiershirts-Os5V18/ref-unternehmen-0-4.png">    </p:cNvPr>
           <p:cNvPicPr>
             <a:picLocks noChangeAspect="1"/>
           </p:cNvPicPr>
@@ -13618,7 +13707,7 @@
       </p:pic>
       <p:pic>
         <p:nvPicPr>
-          <p:cNvPr id="8" name="Image 5" descr="/var/folders/hm/sgq6d80d0vq133k7n8dc9bnw0000gn/T/maiershirts-2HUvCI/ref-unternehmen-5.png">    </p:cNvPr>
+          <p:cNvPr id="8" name="Image 5" descr="/var/folders/hm/sgq6d80d0vq133k7n8dc9bnw0000gn/T/maiershirts-Os5V18/ref-unternehmen-0-5.png">    </p:cNvPr>
           <p:cNvPicPr>
             <a:picLocks noChangeAspect="1"/>
           </p:cNvPicPr>
@@ -13644,7 +13733,7 @@
       </p:pic>
       <p:pic>
         <p:nvPicPr>
-          <p:cNvPr id="9" name="Image 6" descr="/var/folders/hm/sgq6d80d0vq133k7n8dc9bnw0000gn/T/maiershirts-2HUvCI/ref-unternehmen-6.png">    </p:cNvPr>
+          <p:cNvPr id="9" name="Image 6" descr="/var/folders/hm/sgq6d80d0vq133k7n8dc9bnw0000gn/T/maiershirts-Os5V18/ref-unternehmen-0-6.png">    </p:cNvPr>
           <p:cNvPicPr>
             <a:picLocks noChangeAspect="1"/>
           </p:cNvPicPr>
@@ -13670,7 +13759,7 @@
       </p:pic>
       <p:pic>
         <p:nvPicPr>
-          <p:cNvPr id="10" name="Image 7" descr="/var/folders/hm/sgq6d80d0vq133k7n8dc9bnw0000gn/T/maiershirts-2HUvCI/ref-unternehmen-7.png">    </p:cNvPr>
+          <p:cNvPr id="10" name="Image 7" descr="/var/folders/hm/sgq6d80d0vq133k7n8dc9bnw0000gn/T/maiershirts-Os5V18/ref-unternehmen-0-7.png">    </p:cNvPr>
           <p:cNvPicPr>
             <a:picLocks noChangeAspect="1"/>
           </p:cNvPicPr>
@@ -13696,7 +13785,7 @@
       </p:pic>
       <p:pic>
         <p:nvPicPr>
-          <p:cNvPr id="11" name="Image 8" descr="/var/folders/hm/sgq6d80d0vq133k7n8dc9bnw0000gn/T/maiershirts-2HUvCI/ref-unternehmen-8.png">    </p:cNvPr>
+          <p:cNvPr id="11" name="Image 8" descr="/var/folders/hm/sgq6d80d0vq133k7n8dc9bnw0000gn/T/maiershirts-Os5V18/ref-unternehmen-0-8.png">    </p:cNvPr>
           <p:cNvPicPr>
             <a:picLocks noChangeAspect="1"/>
           </p:cNvPicPr>
@@ -13722,7 +13811,7 @@
       </p:pic>
       <p:pic>
         <p:nvPicPr>
-          <p:cNvPr id="12" name="Image 9" descr="/var/folders/hm/sgq6d80d0vq133k7n8dc9bnw0000gn/T/maiershirts-2HUvCI/ref-unternehmen-9.png">    </p:cNvPr>
+          <p:cNvPr id="12" name="Image 9" descr="/var/folders/hm/sgq6d80d0vq133k7n8dc9bnw0000gn/T/maiershirts-Os5V18/ref-unternehmen-0-9.png">    </p:cNvPr>
           <p:cNvPicPr>
             <a:picLocks noChangeAspect="1"/>
           </p:cNvPicPr>
@@ -13748,7 +13837,7 @@
       </p:pic>
       <p:pic>
         <p:nvPicPr>
-          <p:cNvPr id="13" name="Image 10" descr="/var/folders/hm/sgq6d80d0vq133k7n8dc9bnw0000gn/T/maiershirts-2HUvCI/ref-unternehmen-10.png">    </p:cNvPr>
+          <p:cNvPr id="13" name="Image 10" descr="/var/folders/hm/sgq6d80d0vq133k7n8dc9bnw0000gn/T/maiershirts-Os5V18/ref-unternehmen-0-10.png">    </p:cNvPr>
           <p:cNvPicPr>
             <a:picLocks noChangeAspect="1"/>
           </p:cNvPicPr>
@@ -13774,7 +13863,7 @@
       </p:pic>
       <p:pic>
         <p:nvPicPr>
-          <p:cNvPr id="14" name="Image 11" descr="/var/folders/hm/sgq6d80d0vq133k7n8dc9bnw0000gn/T/maiershirts-2HUvCI/ref-unternehmen-11.png">    </p:cNvPr>
+          <p:cNvPr id="14" name="Image 11" descr="/var/folders/hm/sgq6d80d0vq133k7n8dc9bnw0000gn/T/maiershirts-Os5V18/ref-unternehmen-0-11.png">    </p:cNvPr>
           <p:cNvPicPr>
             <a:picLocks noChangeAspect="1"/>
           </p:cNvPicPr>
@@ -13906,7 +13995,7 @@
                 <a:ea typeface="Inter" pitchFamily="34" charset="-122"/>
                 <a:cs typeface="Inter" pitchFamily="34" charset="-120"/>
               </a:rPr>
-              <a:t>Vereine, die uns vertrauen</a:t>
+              <a:t>Unternehmen, die uns vertrauen (2/2)</a:t>
             </a:r>
             <a:endParaRPr lang="en-US" sz="2800" dirty="0"/>
           </a:p>
@@ -13914,7 +14003,7 @@
       </p:sp>
       <p:pic>
         <p:nvPicPr>
-          <p:cNvPr id="3" name="Image 0" descr="/var/folders/hm/sgq6d80d0vq133k7n8dc9bnw0000gn/T/maiershirts-2HUvCI/ref-vereine-0.png">    </p:cNvPr>
+          <p:cNvPr id="3" name="Image 0" descr="/var/folders/hm/sgq6d80d0vq133k7n8dc9bnw0000gn/T/maiershirts-Os5V18/ref-unternehmen-1-0.png">    </p:cNvPr>
           <p:cNvPicPr>
             <a:picLocks noChangeAspect="1"/>
           </p:cNvPicPr>
@@ -13930,63 +14019,22 @@
         </p:blipFill>
         <p:spPr>
           <a:xfrm>
-            <a:off x="843422" y="1490472"/>
-            <a:ext cx="1147795" cy="667512"/>
+            <a:off x="1169090" y="1490472"/>
+            <a:ext cx="496461" cy="448056"/>
           </a:xfrm>
           <a:prstGeom prst="rect">
             <a:avLst/>
           </a:prstGeom>
         </p:spPr>
       </p:pic>
-      <p:sp>
-        <p:nvSpPr>
-          <p:cNvPr id="4" name="Text 0"/>
-          <p:cNvSpPr txBox="1"/>
-          <p:nvPr>
-            <p:ph idx="103" type="body" hasCustomPrompt="1"/>
-          </p:nvPr>
-        </p:nvSpPr>
-        <p:spPr>
-          <a:xfrm>
-            <a:off x="566928" y="2414016"/>
-            <a:ext cx="1700784" cy="274320"/>
-          </a:xfrm>
-          <a:prstGeom prst="rect">
-            <a:avLst/>
-          </a:prstGeom>
-          <a:noFill/>
-          <a:ln/>
-        </p:spPr>
-        <p:txBody>
-          <a:bodyPr wrap="square" lIns="0" tIns="0" rIns="0" bIns="0" rtlCol="0" anchor="ctr"/>
-          <a:lstStyle/>
-          <a:p>
-            <a:pPr algn="ctr" indent="0" marL="0">
-              <a:buNone/>
-            </a:pPr>
-            <a:r>
-              <a:rPr lang="en-US" sz="1100" b="1" dirty="0">
-                <a:solidFill>
-                  <a:srgbClr val="0F0F0F"/>
-                </a:solidFill>
-                <a:latin typeface="Inter" pitchFamily="34" charset="0"/>
-                <a:ea typeface="Inter" pitchFamily="34" charset="-122"/>
-                <a:cs typeface="Inter" pitchFamily="34" charset="-120"/>
-              </a:rPr>
-              <a:t>DAV Sektion Tübingen</a:t>
-            </a:r>
-            <a:endParaRPr lang="en-US" sz="1100" dirty="0"/>
-          </a:p>
-        </p:txBody>
-      </p:sp>
       <p:pic>
         <p:nvPicPr>
-          <p:cNvPr id="5" name="Image 1" descr="/var/folders/hm/sgq6d80d0vq133k7n8dc9bnw0000gn/T/maiershirts-2HUvCI/ref-vereine-1.png">    </p:cNvPr>
+          <p:cNvPr id="4" name="Image 1" descr="/var/folders/hm/sgq6d80d0vq133k7n8dc9bnw0000gn/T/maiershirts-Os5V18/ph-logo-446x194.png">    </p:cNvPr>
           <p:cNvPicPr>
             <a:picLocks noChangeAspect="1"/>
           </p:cNvPicPr>
           <p:nvPr>
-            <p:ph idx="104" type="pic" hasCustomPrompt="1"/>
+            <p:ph idx="103" type="pic" hasCustomPrompt="1"/>
           </p:nvPr>
         </p:nvPicPr>
         <p:blipFill>
@@ -13997,63 +14045,22 @@
         </p:blipFill>
         <p:spPr>
           <a:xfrm>
-            <a:off x="2858236" y="1490472"/>
-            <a:ext cx="1324409" cy="667512"/>
+            <a:off x="2670048" y="1344168"/>
+            <a:ext cx="1700784" cy="740664"/>
           </a:xfrm>
           <a:prstGeom prst="rect">
             <a:avLst/>
           </a:prstGeom>
         </p:spPr>
       </p:pic>
-      <p:sp>
-        <p:nvSpPr>
-          <p:cNvPr id="6" name="Text 0"/>
-          <p:cNvSpPr txBox="1"/>
-          <p:nvPr>
-            <p:ph idx="105" type="body" hasCustomPrompt="1"/>
-          </p:nvPr>
-        </p:nvSpPr>
-        <p:spPr>
-          <a:xfrm>
-            <a:off x="2670048" y="2414016"/>
-            <a:ext cx="1700784" cy="274320"/>
-          </a:xfrm>
-          <a:prstGeom prst="rect">
-            <a:avLst/>
-          </a:prstGeom>
-          <a:noFill/>
-          <a:ln/>
-        </p:spPr>
-        <p:txBody>
-          <a:bodyPr wrap="square" lIns="0" tIns="0" rIns="0" bIns="0" rtlCol="0" anchor="ctr"/>
-          <a:lstStyle/>
-          <a:p>
-            <a:pPr algn="ctr" indent="0" marL="0">
-              <a:buNone/>
-            </a:pPr>
-            <a:r>
-              <a:rPr lang="en-US" sz="1100" b="1" dirty="0">
-                <a:solidFill>
-                  <a:srgbClr val="0F0F0F"/>
-                </a:solidFill>
-                <a:latin typeface="Inter" pitchFamily="34" charset="0"/>
-                <a:ea typeface="Inter" pitchFamily="34" charset="-122"/>
-                <a:cs typeface="Inter" pitchFamily="34" charset="-120"/>
-              </a:rPr>
-              <a:t>Tennisclub Ammerbuch</a:t>
-            </a:r>
-            <a:endParaRPr lang="en-US" sz="1100" dirty="0"/>
-          </a:p>
-        </p:txBody>
-      </p:sp>
       <p:pic>
         <p:nvPicPr>
-          <p:cNvPr id="7" name="Image 2" descr="/var/folders/hm/sgq6d80d0vq133k7n8dc9bnw0000gn/T/maiershirts-2HUvCI/ref-vereine-2.png">    </p:cNvPr>
+          <p:cNvPr id="5" name="Image 2" descr="/var/folders/hm/sgq6d80d0vq133k7n8dc9bnw0000gn/T/maiershirts-Os5V18/ph-logo-446x194.png">    </p:cNvPr>
           <p:cNvPicPr>
             <a:picLocks noChangeAspect="1"/>
           </p:cNvPicPr>
           <p:nvPr>
-            <p:ph idx="106" type="pic" hasCustomPrompt="1"/>
+            <p:ph idx="104" type="pic" hasCustomPrompt="1"/>
           </p:nvPr>
         </p:nvPicPr>
         <p:blipFill>
@@ -14064,63 +14071,22 @@
         </p:blipFill>
         <p:spPr>
           <a:xfrm>
-            <a:off x="5369071" y="1490472"/>
-            <a:ext cx="508978" cy="667512"/>
+            <a:off x="4773168" y="1344168"/>
+            <a:ext cx="1700784" cy="740664"/>
           </a:xfrm>
           <a:prstGeom prst="rect">
             <a:avLst/>
           </a:prstGeom>
         </p:spPr>
       </p:pic>
-      <p:sp>
-        <p:nvSpPr>
-          <p:cNvPr id="8" name="Text 0"/>
-          <p:cNvSpPr txBox="1"/>
-          <p:nvPr>
-            <p:ph idx="107" type="body" hasCustomPrompt="1"/>
-          </p:nvPr>
-        </p:nvSpPr>
-        <p:spPr>
-          <a:xfrm>
-            <a:off x="4773168" y="2414016"/>
-            <a:ext cx="1700784" cy="274320"/>
-          </a:xfrm>
-          <a:prstGeom prst="rect">
-            <a:avLst/>
-          </a:prstGeom>
-          <a:noFill/>
-          <a:ln/>
-        </p:spPr>
-        <p:txBody>
-          <a:bodyPr wrap="square" lIns="0" tIns="0" rIns="0" bIns="0" rtlCol="0" anchor="ctr"/>
-          <a:lstStyle/>
-          <a:p>
-            <a:pPr algn="ctr" indent="0" marL="0">
-              <a:buNone/>
-            </a:pPr>
-            <a:r>
-              <a:rPr lang="en-US" sz="1100" b="1" dirty="0">
-                <a:solidFill>
-                  <a:srgbClr val="0F0F0F"/>
-                </a:solidFill>
-                <a:latin typeface="Inter" pitchFamily="34" charset="0"/>
-                <a:ea typeface="Inter" pitchFamily="34" charset="-122"/>
-                <a:cs typeface="Inter" pitchFamily="34" charset="-120"/>
-              </a:rPr>
-              <a:t>TGV Entringen</a:t>
-            </a:r>
-            <a:endParaRPr lang="en-US" sz="1100" dirty="0"/>
-          </a:p>
-        </p:txBody>
-      </p:sp>
       <p:pic>
         <p:nvPicPr>
-          <p:cNvPr id="9" name="Image 3" descr="/var/folders/hm/sgq6d80d0vq133k7n8dc9bnw0000gn/T/maiershirts-2HUvCI/ref-vereine-3.png">    </p:cNvPr>
+          <p:cNvPr id="6" name="Image 3" descr="/var/folders/hm/sgq6d80d0vq133k7n8dc9bnw0000gn/T/maiershirts-Os5V18/ph-logo-446x194.png">    </p:cNvPr>
           <p:cNvPicPr>
             <a:picLocks noChangeAspect="1"/>
           </p:cNvPicPr>
           <p:nvPr>
-            <p:ph idx="108" type="pic" hasCustomPrompt="1"/>
+            <p:ph idx="105" type="pic" hasCustomPrompt="1"/>
           </p:nvPr>
         </p:nvPicPr>
         <p:blipFill>
@@ -14131,63 +14097,22 @@
         </p:blipFill>
         <p:spPr>
           <a:xfrm>
-            <a:off x="7392924" y="1490472"/>
-            <a:ext cx="667512" cy="667512"/>
+            <a:off x="6876288" y="1344168"/>
+            <a:ext cx="1700784" cy="740664"/>
           </a:xfrm>
           <a:prstGeom prst="rect">
             <a:avLst/>
           </a:prstGeom>
         </p:spPr>
       </p:pic>
-      <p:sp>
-        <p:nvSpPr>
-          <p:cNvPr id="10" name="Text 0"/>
-          <p:cNvSpPr txBox="1"/>
-          <p:nvPr>
-            <p:ph idx="109" type="body" hasCustomPrompt="1"/>
-          </p:nvPr>
-        </p:nvSpPr>
-        <p:spPr>
-          <a:xfrm>
-            <a:off x="6876288" y="2414016"/>
-            <a:ext cx="1700784" cy="274320"/>
-          </a:xfrm>
-          <a:prstGeom prst="rect">
-            <a:avLst/>
-          </a:prstGeom>
-          <a:noFill/>
-          <a:ln/>
-        </p:spPr>
-        <p:txBody>
-          <a:bodyPr wrap="square" lIns="0" tIns="0" rIns="0" bIns="0" rtlCol="0" anchor="ctr"/>
-          <a:lstStyle/>
-          <a:p>
-            <a:pPr algn="ctr" indent="0" marL="0">
-              <a:buNone/>
-            </a:pPr>
-            <a:r>
-              <a:rPr lang="en-US" sz="1100" b="1" dirty="0">
-                <a:solidFill>
-                  <a:srgbClr val="0F0F0F"/>
-                </a:solidFill>
-                <a:latin typeface="Inter" pitchFamily="34" charset="0"/>
-                <a:ea typeface="Inter" pitchFamily="34" charset="-122"/>
-                <a:cs typeface="Inter" pitchFamily="34" charset="-120"/>
-              </a:rPr>
-              <a:t>Hooriger Hund Sulzbach</a:t>
-            </a:r>
-            <a:endParaRPr lang="en-US" sz="1100" dirty="0"/>
-          </a:p>
-        </p:txBody>
-      </p:sp>
       <p:pic>
         <p:nvPicPr>
-          <p:cNvPr id="11" name="Image 4" descr="/var/folders/hm/sgq6d80d0vq133k7n8dc9bnw0000gn/T/maiershirts-2HUvCI/ref-vereine-4.png">    </p:cNvPr>
+          <p:cNvPr id="7" name="Image 4" descr="/var/folders/hm/sgq6d80d0vq133k7n8dc9bnw0000gn/T/maiershirts-Os5V18/ph-logo-446x194.png">    </p:cNvPr>
           <p:cNvPicPr>
             <a:picLocks noChangeAspect="1"/>
           </p:cNvPicPr>
           <p:nvPr>
-            <p:ph idx="110" type="pic" hasCustomPrompt="1"/>
+            <p:ph idx="106" type="pic" hasCustomPrompt="1"/>
           </p:nvPr>
         </p:nvPicPr>
         <p:blipFill>
@@ -14198,63 +14123,22 @@
         </p:blipFill>
         <p:spPr>
           <a:xfrm>
-            <a:off x="1073295" y="3090672"/>
-            <a:ext cx="688051" cy="667512"/>
+            <a:off x="566928" y="2441448"/>
+            <a:ext cx="1700784" cy="740664"/>
           </a:xfrm>
           <a:prstGeom prst="rect">
             <a:avLst/>
           </a:prstGeom>
         </p:spPr>
       </p:pic>
-      <p:sp>
-        <p:nvSpPr>
-          <p:cNvPr id="12" name="Text 0"/>
-          <p:cNvSpPr txBox="1"/>
-          <p:nvPr>
-            <p:ph idx="111" type="body" hasCustomPrompt="1"/>
-          </p:nvPr>
-        </p:nvSpPr>
-        <p:spPr>
-          <a:xfrm>
-            <a:off x="566928" y="4014216"/>
-            <a:ext cx="1700784" cy="274320"/>
-          </a:xfrm>
-          <a:prstGeom prst="rect">
-            <a:avLst/>
-          </a:prstGeom>
-          <a:noFill/>
-          <a:ln/>
-        </p:spPr>
-        <p:txBody>
-          <a:bodyPr wrap="square" lIns="0" tIns="0" rIns="0" bIns="0" rtlCol="0" anchor="ctr"/>
-          <a:lstStyle/>
-          <a:p>
-            <a:pPr algn="ctr" indent="0" marL="0">
-              <a:buNone/>
-            </a:pPr>
-            <a:r>
-              <a:rPr lang="en-US" sz="1100" b="1" dirty="0">
-                <a:solidFill>
-                  <a:srgbClr val="0F0F0F"/>
-                </a:solidFill>
-                <a:latin typeface="Inter" pitchFamily="34" charset="0"/>
-                <a:ea typeface="Inter" pitchFamily="34" charset="-122"/>
-                <a:cs typeface="Inter" pitchFamily="34" charset="-120"/>
-              </a:rPr>
-              <a:t>Sportfreunde Dußlingen</a:t>
-            </a:r>
-            <a:endParaRPr lang="en-US" sz="1100" dirty="0"/>
-          </a:p>
-        </p:txBody>
-      </p:sp>
       <p:pic>
         <p:nvPicPr>
-          <p:cNvPr id="13" name="Image 5" descr="/var/folders/hm/sgq6d80d0vq133k7n8dc9bnw0000gn/T/maiershirts-2HUvCI/ref-vereine-5.png">    </p:cNvPr>
+          <p:cNvPr id="8" name="Image 5" descr="/var/folders/hm/sgq6d80d0vq133k7n8dc9bnw0000gn/T/maiershirts-Os5V18/ph-logo-446x194.png">    </p:cNvPr>
           <p:cNvPicPr>
             <a:picLocks noChangeAspect="1"/>
           </p:cNvPicPr>
           <p:nvPr>
-            <p:ph idx="112" type="pic" hasCustomPrompt="1"/>
+            <p:ph idx="107" type="pic" hasCustomPrompt="1"/>
           </p:nvPr>
         </p:nvPicPr>
         <p:blipFill>
@@ -14265,63 +14149,22 @@
         </p:blipFill>
         <p:spPr>
           <a:xfrm>
-            <a:off x="3186684" y="3090672"/>
-            <a:ext cx="667512" cy="667512"/>
+            <a:off x="2670048" y="2441448"/>
+            <a:ext cx="1700784" cy="740664"/>
           </a:xfrm>
           <a:prstGeom prst="rect">
             <a:avLst/>
           </a:prstGeom>
         </p:spPr>
       </p:pic>
-      <p:sp>
-        <p:nvSpPr>
-          <p:cNvPr id="14" name="Text 0"/>
-          <p:cNvSpPr txBox="1"/>
-          <p:nvPr>
-            <p:ph idx="113" type="body" hasCustomPrompt="1"/>
-          </p:nvPr>
-        </p:nvSpPr>
-        <p:spPr>
-          <a:xfrm>
-            <a:off x="2670048" y="4014216"/>
-            <a:ext cx="1700784" cy="274320"/>
-          </a:xfrm>
-          <a:prstGeom prst="rect">
-            <a:avLst/>
-          </a:prstGeom>
-          <a:noFill/>
-          <a:ln/>
-        </p:spPr>
-        <p:txBody>
-          <a:bodyPr wrap="square" lIns="0" tIns="0" rIns="0" bIns="0" rtlCol="0" anchor="ctr"/>
-          <a:lstStyle/>
-          <a:p>
-            <a:pPr algn="ctr" indent="0" marL="0">
-              <a:buNone/>
-            </a:pPr>
-            <a:r>
-              <a:rPr lang="en-US" sz="1100" b="1" dirty="0">
-                <a:solidFill>
-                  <a:srgbClr val="0F0F0F"/>
-                </a:solidFill>
-                <a:latin typeface="Inter" pitchFamily="34" charset="0"/>
-                <a:ea typeface="Inter" pitchFamily="34" charset="-122"/>
-                <a:cs typeface="Inter" pitchFamily="34" charset="-120"/>
-              </a:rPr>
-              <a:t>SV Germania Bietigheim</a:t>
-            </a:r>
-            <a:endParaRPr lang="en-US" sz="1100" dirty="0"/>
-          </a:p>
-        </p:txBody>
-      </p:sp>
       <p:pic>
         <p:nvPicPr>
-          <p:cNvPr id="15" name="Image 6" descr="/var/folders/hm/sgq6d80d0vq133k7n8dc9bnw0000gn/T/maiershirts-2HUvCI/ref-vereine-6.png">    </p:cNvPr>
+          <p:cNvPr id="9" name="Image 6" descr="/var/folders/hm/sgq6d80d0vq133k7n8dc9bnw0000gn/T/maiershirts-Os5V18/ph-logo-446x194.png">    </p:cNvPr>
           <p:cNvPicPr>
             <a:picLocks noChangeAspect="1"/>
           </p:cNvPicPr>
           <p:nvPr>
-            <p:ph idx="114" type="pic" hasCustomPrompt="1"/>
+            <p:ph idx="108" type="pic" hasCustomPrompt="1"/>
           </p:nvPr>
         </p:nvPicPr>
         <p:blipFill>
@@ -14332,63 +14175,22 @@
         </p:blipFill>
         <p:spPr>
           <a:xfrm>
-            <a:off x="5288359" y="3090672"/>
-            <a:ext cx="670402" cy="667512"/>
+            <a:off x="4773168" y="2441448"/>
+            <a:ext cx="1700784" cy="740664"/>
           </a:xfrm>
           <a:prstGeom prst="rect">
             <a:avLst/>
           </a:prstGeom>
         </p:spPr>
       </p:pic>
-      <p:sp>
-        <p:nvSpPr>
-          <p:cNvPr id="16" name="Text 0"/>
-          <p:cNvSpPr txBox="1"/>
-          <p:nvPr>
-            <p:ph idx="115" type="body" hasCustomPrompt="1"/>
-          </p:nvPr>
-        </p:nvSpPr>
-        <p:spPr>
-          <a:xfrm>
-            <a:off x="4773168" y="4014216"/>
-            <a:ext cx="1700784" cy="274320"/>
-          </a:xfrm>
-          <a:prstGeom prst="rect">
-            <a:avLst/>
-          </a:prstGeom>
-          <a:noFill/>
-          <a:ln/>
-        </p:spPr>
-        <p:txBody>
-          <a:bodyPr wrap="square" lIns="0" tIns="0" rIns="0" bIns="0" rtlCol="0" anchor="ctr"/>
-          <a:lstStyle/>
-          <a:p>
-            <a:pPr algn="ctr" indent="0" marL="0">
-              <a:buNone/>
-            </a:pPr>
-            <a:r>
-              <a:rPr lang="en-US" sz="1100" b="1" dirty="0">
-                <a:solidFill>
-                  <a:srgbClr val="0F0F0F"/>
-                </a:solidFill>
-                <a:latin typeface="Inter" pitchFamily="34" charset="0"/>
-                <a:ea typeface="Inter" pitchFamily="34" charset="-122"/>
-                <a:cs typeface="Inter" pitchFamily="34" charset="-120"/>
-              </a:rPr>
-              <a:t>TV Mühlacker</a:t>
-            </a:r>
-            <a:endParaRPr lang="en-US" sz="1100" dirty="0"/>
-          </a:p>
-        </p:txBody>
-      </p:sp>
       <p:pic>
         <p:nvPicPr>
-          <p:cNvPr id="17" name="Image 7" descr="/var/folders/hm/sgq6d80d0vq133k7n8dc9bnw0000gn/T/maiershirts-2HUvCI/ref-vereine-7.png">    </p:cNvPr>
+          <p:cNvPr id="10" name="Image 7" descr="/var/folders/hm/sgq6d80d0vq133k7n8dc9bnw0000gn/T/maiershirts-Os5V18/ph-logo-446x194.png">    </p:cNvPr>
           <p:cNvPicPr>
             <a:picLocks noChangeAspect="1"/>
           </p:cNvPicPr>
           <p:nvPr>
-            <p:ph idx="116" type="pic" hasCustomPrompt="1"/>
+            <p:ph idx="109" type="pic" hasCustomPrompt="1"/>
           </p:nvPr>
         </p:nvPicPr>
         <p:blipFill>
@@ -14399,55 +14201,118 @@
         </p:blipFill>
         <p:spPr>
           <a:xfrm>
-            <a:off x="7022592" y="3098331"/>
-            <a:ext cx="1408176" cy="652193"/>
+            <a:off x="6876288" y="2441448"/>
+            <a:ext cx="1700784" cy="740664"/>
           </a:xfrm>
           <a:prstGeom prst="rect">
             <a:avLst/>
           </a:prstGeom>
         </p:spPr>
       </p:pic>
-      <p:sp>
-        <p:nvSpPr>
-          <p:cNvPr id="18" name="Text 0"/>
-          <p:cNvSpPr txBox="1"/>
-          <p:nvPr>
-            <p:ph idx="117" type="body" hasCustomPrompt="1"/>
-          </p:nvPr>
-        </p:nvSpPr>
-        <p:spPr>
-          <a:xfrm>
-            <a:off x="6876288" y="4014216"/>
-            <a:ext cx="1700784" cy="274320"/>
-          </a:xfrm>
-          <a:prstGeom prst="rect">
-            <a:avLst/>
-          </a:prstGeom>
-          <a:noFill/>
-          <a:ln/>
-        </p:spPr>
-        <p:txBody>
-          <a:bodyPr wrap="square" lIns="0" tIns="0" rIns="0" bIns="0" rtlCol="0" anchor="ctr"/>
-          <a:lstStyle/>
-          <a:p>
-            <a:pPr algn="ctr" indent="0" marL="0">
-              <a:buNone/>
-            </a:pPr>
-            <a:r>
-              <a:rPr lang="en-US" sz="1100" b="1" dirty="0">
-                <a:solidFill>
-                  <a:srgbClr val="0F0F0F"/>
-                </a:solidFill>
-                <a:latin typeface="Inter" pitchFamily="34" charset="0"/>
-                <a:ea typeface="Inter" pitchFamily="34" charset="-122"/>
-                <a:cs typeface="Inter" pitchFamily="34" charset="-120"/>
-              </a:rPr>
-              <a:t>Tennisclub Wurmlingen</a:t>
-            </a:r>
-            <a:endParaRPr lang="en-US" sz="1100" dirty="0"/>
-          </a:p>
-        </p:txBody>
-      </p:sp>
+      <p:pic>
+        <p:nvPicPr>
+          <p:cNvPr id="11" name="Image 8" descr="/var/folders/hm/sgq6d80d0vq133k7n8dc9bnw0000gn/T/maiershirts-Os5V18/ph-logo-446x194.png">    </p:cNvPr>
+          <p:cNvPicPr>
+            <a:picLocks noChangeAspect="1"/>
+          </p:cNvPicPr>
+          <p:nvPr>
+            <p:ph idx="110" type="pic" hasCustomPrompt="1"/>
+          </p:nvPr>
+        </p:nvPicPr>
+        <p:blipFill>
+          <a:blip r:embed="rId9"/>
+          <a:stretch>
+            <a:fillRect/>
+          </a:stretch>
+        </p:blipFill>
+        <p:spPr>
+          <a:xfrm>
+            <a:off x="566928" y="3538728"/>
+            <a:ext cx="1700784" cy="740664"/>
+          </a:xfrm>
+          <a:prstGeom prst="rect">
+            <a:avLst/>
+          </a:prstGeom>
+        </p:spPr>
+      </p:pic>
+      <p:pic>
+        <p:nvPicPr>
+          <p:cNvPr id="12" name="Image 9" descr="/var/folders/hm/sgq6d80d0vq133k7n8dc9bnw0000gn/T/maiershirts-Os5V18/ph-logo-446x194.png">    </p:cNvPr>
+          <p:cNvPicPr>
+            <a:picLocks noChangeAspect="1"/>
+          </p:cNvPicPr>
+          <p:nvPr>
+            <p:ph idx="111" type="pic" hasCustomPrompt="1"/>
+          </p:nvPr>
+        </p:nvPicPr>
+        <p:blipFill>
+          <a:blip r:embed="rId10"/>
+          <a:stretch>
+            <a:fillRect/>
+          </a:stretch>
+        </p:blipFill>
+        <p:spPr>
+          <a:xfrm>
+            <a:off x="2670048" y="3538728"/>
+            <a:ext cx="1700784" cy="740664"/>
+          </a:xfrm>
+          <a:prstGeom prst="rect">
+            <a:avLst/>
+          </a:prstGeom>
+        </p:spPr>
+      </p:pic>
+      <p:pic>
+        <p:nvPicPr>
+          <p:cNvPr id="13" name="Image 10" descr="/var/folders/hm/sgq6d80d0vq133k7n8dc9bnw0000gn/T/maiershirts-Os5V18/ph-logo-446x194.png">    </p:cNvPr>
+          <p:cNvPicPr>
+            <a:picLocks noChangeAspect="1"/>
+          </p:cNvPicPr>
+          <p:nvPr>
+            <p:ph idx="112" type="pic" hasCustomPrompt="1"/>
+          </p:nvPr>
+        </p:nvPicPr>
+        <p:blipFill>
+          <a:blip r:embed="rId11"/>
+          <a:stretch>
+            <a:fillRect/>
+          </a:stretch>
+        </p:blipFill>
+        <p:spPr>
+          <a:xfrm>
+            <a:off x="4773168" y="3538728"/>
+            <a:ext cx="1700784" cy="740664"/>
+          </a:xfrm>
+          <a:prstGeom prst="rect">
+            <a:avLst/>
+          </a:prstGeom>
+        </p:spPr>
+      </p:pic>
+      <p:pic>
+        <p:nvPicPr>
+          <p:cNvPr id="14" name="Image 11" descr="/var/folders/hm/sgq6d80d0vq133k7n8dc9bnw0000gn/T/maiershirts-Os5V18/ph-logo-446x194.png">    </p:cNvPr>
+          <p:cNvPicPr>
+            <a:picLocks noChangeAspect="1"/>
+          </p:cNvPicPr>
+          <p:nvPr>
+            <p:ph idx="113" type="pic" hasCustomPrompt="1"/>
+          </p:nvPr>
+        </p:nvPicPr>
+        <p:blipFill>
+          <a:blip r:embed="rId12"/>
+          <a:stretch>
+            <a:fillRect/>
+          </a:stretch>
+        </p:blipFill>
+        <p:spPr>
+          <a:xfrm>
+            <a:off x="6876288" y="3538728"/>
+            <a:ext cx="1700784" cy="740664"/>
+          </a:xfrm>
+          <a:prstGeom prst="rect">
+            <a:avLst/>
+          </a:prstGeom>
+        </p:spPr>
+      </p:pic>
       <p:sp>
         <p:nvSpPr>
           <p:cNvPr id="25" name="Slide Number Placeholder 0"/>
@@ -14556,7 +14421,7 @@
                 <a:ea typeface="Inter" pitchFamily="34" charset="-122"/>
                 <a:cs typeface="Inter" pitchFamily="34" charset="-120"/>
               </a:rPr>
-              <a:t>Stickerei im Detail</a:t>
+              <a:t>Vereine, die uns vertrauen</a:t>
             </a:r>
             <a:endParaRPr lang="en-US" sz="2800" dirty="0"/>
           </a:p>
@@ -14564,7 +14429,7 @@
       </p:sp>
       <p:pic>
         <p:nvPicPr>
-          <p:cNvPr id="3" name="Image 0" descr="/var/folders/hm/sgq6d80d0vq133k7n8dc9bnw0000gn/T/maiershirts-2HUvCI/ph-foto-1056x840.png">    </p:cNvPr>
+          <p:cNvPr id="3" name="Image 0" descr="/var/folders/hm/sgq6d80d0vq133k7n8dc9bnw0000gn/T/maiershirts-Os5V18/ref-vereine-0-0.png">    </p:cNvPr>
           <p:cNvPicPr>
             <a:picLocks noChangeAspect="1"/>
           </p:cNvPicPr>
@@ -14580,8 +14445,8 @@
         </p:blipFill>
         <p:spPr>
           <a:xfrm>
-            <a:off x="457200" y="1234440"/>
-            <a:ext cx="4023360" cy="3200400"/>
+            <a:off x="843422" y="1490472"/>
+            <a:ext cx="1147795" cy="667512"/>
           </a:xfrm>
           <a:prstGeom prst="rect">
             <a:avLst/>
@@ -14598,28 +14463,24 @@
         </p:nvSpPr>
         <p:spPr>
           <a:xfrm>
-            <a:off x="4846320" y="1234440"/>
-            <a:ext cx="3840480" cy="3200400"/>
-          </a:xfrm>
-          <a:prstGeom prst="rect">
-            <a:avLst/>
-          </a:prstGeom>
-          <a:noFill/>
-          <a:ln/>
-        </p:spPr>
-        <p:txBody>
-          <a:bodyPr wrap="square" lIns="0" tIns="0" rIns="0" bIns="0" rtlCol="0" anchor="t"/>
+            <a:off x="566928" y="2414016"/>
+            <a:ext cx="1700784" cy="274320"/>
+          </a:xfrm>
+          <a:prstGeom prst="rect">
+            <a:avLst/>
+          </a:prstGeom>
+          <a:noFill/>
+          <a:ln/>
+        </p:spPr>
+        <p:txBody>
+          <a:bodyPr wrap="square" lIns="0" tIns="0" rIns="0" bIns="0" rtlCol="0" anchor="ctr"/>
           <a:lstStyle/>
           <a:p>
-            <a:pPr algn="l" marL="342900" indent="-342900">
-              <a:spcAft>
-                <a:spcPts val="800"/>
-              </a:spcAft>
-              <a:buSzPct val="100000"/>
-              <a:buChar char="•"/>
-            </a:pPr>
-            <a:r>
-              <a:rPr lang="en-US" sz="1600" dirty="0">
+            <a:pPr algn="ctr" indent="0" marL="0">
+              <a:buNone/>
+            </a:pPr>
+            <a:r>
+              <a:rPr lang="en-US" sz="1100" b="1" dirty="0">
                 <a:solidFill>
                   <a:srgbClr val="0F0F0F"/>
                 </a:solidFill>
@@ -14627,20 +14488,66 @@
                 <a:ea typeface="Inter" pitchFamily="34" charset="-122"/>
                 <a:cs typeface="Inter" pitchFamily="34" charset="-120"/>
               </a:rPr>
-              <a:t>Bis zu 12 Garnfarben pro Motiv</a:t>
-            </a:r>
-            <a:endParaRPr lang="en-US" sz="1600" dirty="0"/>
-          </a:p>
-          <a:p>
-            <a:pPr algn="l" marL="342900" indent="-342900">
-              <a:spcAft>
-                <a:spcPts val="800"/>
-              </a:spcAft>
-              <a:buSzPct val="100000"/>
-              <a:buChar char="•"/>
-            </a:pPr>
-            <a:r>
-              <a:rPr lang="en-US" sz="1600" dirty="0">
+              <a:t>DAV Sektion Tübingen</a:t>
+            </a:r>
+            <a:endParaRPr lang="en-US" sz="1100" dirty="0"/>
+          </a:p>
+        </p:txBody>
+      </p:sp>
+      <p:pic>
+        <p:nvPicPr>
+          <p:cNvPr id="5" name="Image 1" descr="/var/folders/hm/sgq6d80d0vq133k7n8dc9bnw0000gn/T/maiershirts-Os5V18/ref-vereine-0-1.png">    </p:cNvPr>
+          <p:cNvPicPr>
+            <a:picLocks noChangeAspect="1"/>
+          </p:cNvPicPr>
+          <p:nvPr>
+            <p:ph idx="104" type="pic" hasCustomPrompt="1"/>
+          </p:nvPr>
+        </p:nvPicPr>
+        <p:blipFill>
+          <a:blip r:embed="rId2"/>
+          <a:stretch>
+            <a:fillRect/>
+          </a:stretch>
+        </p:blipFill>
+        <p:spPr>
+          <a:xfrm>
+            <a:off x="2858236" y="1490472"/>
+            <a:ext cx="1324409" cy="667512"/>
+          </a:xfrm>
+          <a:prstGeom prst="rect">
+            <a:avLst/>
+          </a:prstGeom>
+        </p:spPr>
+      </p:pic>
+      <p:sp>
+        <p:nvSpPr>
+          <p:cNvPr id="6" name="Text 0"/>
+          <p:cNvSpPr txBox="1"/>
+          <p:nvPr>
+            <p:ph idx="105" type="body" hasCustomPrompt="1"/>
+          </p:nvPr>
+        </p:nvSpPr>
+        <p:spPr>
+          <a:xfrm>
+            <a:off x="2670048" y="2414016"/>
+            <a:ext cx="1700784" cy="274320"/>
+          </a:xfrm>
+          <a:prstGeom prst="rect">
+            <a:avLst/>
+          </a:prstGeom>
+          <a:noFill/>
+          <a:ln/>
+        </p:spPr>
+        <p:txBody>
+          <a:bodyPr wrap="square" lIns="0" tIns="0" rIns="0" bIns="0" rtlCol="0" anchor="ctr"/>
+          <a:lstStyle/>
+          <a:p>
+            <a:pPr algn="ctr" indent="0" marL="0">
+              <a:buNone/>
+            </a:pPr>
+            <a:r>
+              <a:rPr lang="en-US" sz="1100" b="1" dirty="0">
                 <a:solidFill>
                   <a:srgbClr val="0F0F0F"/>
                 </a:solidFill>
@@ -14648,20 +14555,66 @@
                 <a:ea typeface="Inter" pitchFamily="34" charset="-122"/>
                 <a:cs typeface="Inter" pitchFamily="34" charset="-120"/>
               </a:rPr>
-              <a:t>Waschbeständig bis 60 °C</a:t>
-            </a:r>
-            <a:endParaRPr lang="en-US" sz="1600" dirty="0"/>
-          </a:p>
-          <a:p>
-            <a:pPr algn="l" marL="342900" indent="-342900">
-              <a:spcAft>
-                <a:spcPts val="800"/>
-              </a:spcAft>
-              <a:buSzPct val="100000"/>
-              <a:buChar char="•"/>
-            </a:pPr>
-            <a:r>
-              <a:rPr lang="en-US" sz="1600" dirty="0">
+              <a:t>Tennisclub Ammerbuch</a:t>
+            </a:r>
+            <a:endParaRPr lang="en-US" sz="1100" dirty="0"/>
+          </a:p>
+        </p:txBody>
+      </p:sp>
+      <p:pic>
+        <p:nvPicPr>
+          <p:cNvPr id="7" name="Image 2" descr="/var/folders/hm/sgq6d80d0vq133k7n8dc9bnw0000gn/T/maiershirts-Os5V18/ref-vereine-0-2.png">    </p:cNvPr>
+          <p:cNvPicPr>
+            <a:picLocks noChangeAspect="1"/>
+          </p:cNvPicPr>
+          <p:nvPr>
+            <p:ph idx="106" type="pic" hasCustomPrompt="1"/>
+          </p:nvPr>
+        </p:nvPicPr>
+        <p:blipFill>
+          <a:blip r:embed="rId3"/>
+          <a:stretch>
+            <a:fillRect/>
+          </a:stretch>
+        </p:blipFill>
+        <p:spPr>
+          <a:xfrm>
+            <a:off x="5369071" y="1490472"/>
+            <a:ext cx="508978" cy="667512"/>
+          </a:xfrm>
+          <a:prstGeom prst="rect">
+            <a:avLst/>
+          </a:prstGeom>
+        </p:spPr>
+      </p:pic>
+      <p:sp>
+        <p:nvSpPr>
+          <p:cNvPr id="8" name="Text 0"/>
+          <p:cNvSpPr txBox="1"/>
+          <p:nvPr>
+            <p:ph idx="107" type="body" hasCustomPrompt="1"/>
+          </p:nvPr>
+        </p:nvSpPr>
+        <p:spPr>
+          <a:xfrm>
+            <a:off x="4773168" y="2414016"/>
+            <a:ext cx="1700784" cy="274320"/>
+          </a:xfrm>
+          <a:prstGeom prst="rect">
+            <a:avLst/>
+          </a:prstGeom>
+          <a:noFill/>
+          <a:ln/>
+        </p:spPr>
+        <p:txBody>
+          <a:bodyPr wrap="square" lIns="0" tIns="0" rIns="0" bIns="0" rtlCol="0" anchor="ctr"/>
+          <a:lstStyle/>
+          <a:p>
+            <a:pPr algn="ctr" indent="0" marL="0">
+              <a:buNone/>
+            </a:pPr>
+            <a:r>
+              <a:rPr lang="en-US" sz="1100" b="1" dirty="0">
                 <a:solidFill>
                   <a:srgbClr val="0F0F0F"/>
                 </a:solidFill>
@@ -14669,20 +14622,66 @@
                 <a:ea typeface="Inter" pitchFamily="34" charset="-122"/>
                 <a:cs typeface="Inter" pitchFamily="34" charset="-120"/>
               </a:rPr>
-              <a:t>Ideal für Polos, Jacken und Caps</a:t>
-            </a:r>
-            <a:endParaRPr lang="en-US" sz="1600" dirty="0"/>
-          </a:p>
-          <a:p>
-            <a:pPr algn="l" marL="342900" indent="-342900">
-              <a:spcAft>
-                <a:spcPts val="800"/>
-              </a:spcAft>
-              <a:buSzPct val="100000"/>
-              <a:buChar char="•"/>
-            </a:pPr>
-            <a:r>
-              <a:rPr lang="en-US" sz="1600" dirty="0">
+              <a:t>TGV Entringen</a:t>
+            </a:r>
+            <a:endParaRPr lang="en-US" sz="1100" dirty="0"/>
+          </a:p>
+        </p:txBody>
+      </p:sp>
+      <p:pic>
+        <p:nvPicPr>
+          <p:cNvPr id="9" name="Image 3" descr="/var/folders/hm/sgq6d80d0vq133k7n8dc9bnw0000gn/T/maiershirts-Os5V18/ref-vereine-0-3.png">    </p:cNvPr>
+          <p:cNvPicPr>
+            <a:picLocks noChangeAspect="1"/>
+          </p:cNvPicPr>
+          <p:nvPr>
+            <p:ph idx="108" type="pic" hasCustomPrompt="1"/>
+          </p:nvPr>
+        </p:nvPicPr>
+        <p:blipFill>
+          <a:blip r:embed="rId4"/>
+          <a:stretch>
+            <a:fillRect/>
+          </a:stretch>
+        </p:blipFill>
+        <p:spPr>
+          <a:xfrm>
+            <a:off x="7392924" y="1490472"/>
+            <a:ext cx="667512" cy="667512"/>
+          </a:xfrm>
+          <a:prstGeom prst="rect">
+            <a:avLst/>
+          </a:prstGeom>
+        </p:spPr>
+      </p:pic>
+      <p:sp>
+        <p:nvSpPr>
+          <p:cNvPr id="10" name="Text 0"/>
+          <p:cNvSpPr txBox="1"/>
+          <p:nvPr>
+            <p:ph idx="109" type="body" hasCustomPrompt="1"/>
+          </p:nvPr>
+        </p:nvSpPr>
+        <p:spPr>
+          <a:xfrm>
+            <a:off x="6876288" y="2414016"/>
+            <a:ext cx="1700784" cy="274320"/>
+          </a:xfrm>
+          <a:prstGeom prst="rect">
+            <a:avLst/>
+          </a:prstGeom>
+          <a:noFill/>
+          <a:ln/>
+        </p:spPr>
+        <p:txBody>
+          <a:bodyPr wrap="square" lIns="0" tIns="0" rIns="0" bIns="0" rtlCol="0" anchor="ctr"/>
+          <a:lstStyle/>
+          <a:p>
+            <a:pPr algn="ctr" indent="0" marL="0">
+              <a:buNone/>
+            </a:pPr>
+            <a:r>
+              <a:rPr lang="en-US" sz="1100" b="1" dirty="0">
                 <a:solidFill>
                   <a:srgbClr val="0F0F0F"/>
                 </a:solidFill>
@@ -14690,9 +14689,277 @@
                 <a:ea typeface="Inter" pitchFamily="34" charset="-122"/>
                 <a:cs typeface="Inter" pitchFamily="34" charset="-120"/>
               </a:rPr>
-              <a:t>Motivdigitalisierung im Haus</a:t>
-            </a:r>
-            <a:endParaRPr lang="en-US" sz="1600" dirty="0"/>
+              <a:t>Hooriger Hund Sulzbach</a:t>
+            </a:r>
+            <a:endParaRPr lang="en-US" sz="1100" dirty="0"/>
+          </a:p>
+        </p:txBody>
+      </p:sp>
+      <p:pic>
+        <p:nvPicPr>
+          <p:cNvPr id="11" name="Image 4" descr="/var/folders/hm/sgq6d80d0vq133k7n8dc9bnw0000gn/T/maiershirts-Os5V18/ref-vereine-0-4.png">    </p:cNvPr>
+          <p:cNvPicPr>
+            <a:picLocks noChangeAspect="1"/>
+          </p:cNvPicPr>
+          <p:nvPr>
+            <p:ph idx="110" type="pic" hasCustomPrompt="1"/>
+          </p:nvPr>
+        </p:nvPicPr>
+        <p:blipFill>
+          <a:blip r:embed="rId5"/>
+          <a:stretch>
+            <a:fillRect/>
+          </a:stretch>
+        </p:blipFill>
+        <p:spPr>
+          <a:xfrm>
+            <a:off x="1073295" y="3090672"/>
+            <a:ext cx="688051" cy="667512"/>
+          </a:xfrm>
+          <a:prstGeom prst="rect">
+            <a:avLst/>
+          </a:prstGeom>
+        </p:spPr>
+      </p:pic>
+      <p:sp>
+        <p:nvSpPr>
+          <p:cNvPr id="12" name="Text 0"/>
+          <p:cNvSpPr txBox="1"/>
+          <p:nvPr>
+            <p:ph idx="111" type="body" hasCustomPrompt="1"/>
+          </p:nvPr>
+        </p:nvSpPr>
+        <p:spPr>
+          <a:xfrm>
+            <a:off x="566928" y="4014216"/>
+            <a:ext cx="1700784" cy="274320"/>
+          </a:xfrm>
+          <a:prstGeom prst="rect">
+            <a:avLst/>
+          </a:prstGeom>
+          <a:noFill/>
+          <a:ln/>
+        </p:spPr>
+        <p:txBody>
+          <a:bodyPr wrap="square" lIns="0" tIns="0" rIns="0" bIns="0" rtlCol="0" anchor="ctr"/>
+          <a:lstStyle/>
+          <a:p>
+            <a:pPr algn="ctr" indent="0" marL="0">
+              <a:buNone/>
+            </a:pPr>
+            <a:r>
+              <a:rPr lang="en-US" sz="1100" b="1" dirty="0">
+                <a:solidFill>
+                  <a:srgbClr val="0F0F0F"/>
+                </a:solidFill>
+                <a:latin typeface="Inter" pitchFamily="34" charset="0"/>
+                <a:ea typeface="Inter" pitchFamily="34" charset="-122"/>
+                <a:cs typeface="Inter" pitchFamily="34" charset="-120"/>
+              </a:rPr>
+              <a:t>Sportfreunde Dußlingen</a:t>
+            </a:r>
+            <a:endParaRPr lang="en-US" sz="1100" dirty="0"/>
+          </a:p>
+        </p:txBody>
+      </p:sp>
+      <p:pic>
+        <p:nvPicPr>
+          <p:cNvPr id="13" name="Image 5" descr="/var/folders/hm/sgq6d80d0vq133k7n8dc9bnw0000gn/T/maiershirts-Os5V18/ref-vereine-0-5.png">    </p:cNvPr>
+          <p:cNvPicPr>
+            <a:picLocks noChangeAspect="1"/>
+          </p:cNvPicPr>
+          <p:nvPr>
+            <p:ph idx="112" type="pic" hasCustomPrompt="1"/>
+          </p:nvPr>
+        </p:nvPicPr>
+        <p:blipFill>
+          <a:blip r:embed="rId6"/>
+          <a:stretch>
+            <a:fillRect/>
+          </a:stretch>
+        </p:blipFill>
+        <p:spPr>
+          <a:xfrm>
+            <a:off x="3186684" y="3090672"/>
+            <a:ext cx="667512" cy="667512"/>
+          </a:xfrm>
+          <a:prstGeom prst="rect">
+            <a:avLst/>
+          </a:prstGeom>
+        </p:spPr>
+      </p:pic>
+      <p:sp>
+        <p:nvSpPr>
+          <p:cNvPr id="14" name="Text 0"/>
+          <p:cNvSpPr txBox="1"/>
+          <p:nvPr>
+            <p:ph idx="113" type="body" hasCustomPrompt="1"/>
+          </p:nvPr>
+        </p:nvSpPr>
+        <p:spPr>
+          <a:xfrm>
+            <a:off x="2670048" y="4014216"/>
+            <a:ext cx="1700784" cy="274320"/>
+          </a:xfrm>
+          <a:prstGeom prst="rect">
+            <a:avLst/>
+          </a:prstGeom>
+          <a:noFill/>
+          <a:ln/>
+        </p:spPr>
+        <p:txBody>
+          <a:bodyPr wrap="square" lIns="0" tIns="0" rIns="0" bIns="0" rtlCol="0" anchor="ctr"/>
+          <a:lstStyle/>
+          <a:p>
+            <a:pPr algn="ctr" indent="0" marL="0">
+              <a:buNone/>
+            </a:pPr>
+            <a:r>
+              <a:rPr lang="en-US" sz="1100" b="1" dirty="0">
+                <a:solidFill>
+                  <a:srgbClr val="0F0F0F"/>
+                </a:solidFill>
+                <a:latin typeface="Inter" pitchFamily="34" charset="0"/>
+                <a:ea typeface="Inter" pitchFamily="34" charset="-122"/>
+                <a:cs typeface="Inter" pitchFamily="34" charset="-120"/>
+              </a:rPr>
+              <a:t>SV Germania Bietigheim</a:t>
+            </a:r>
+            <a:endParaRPr lang="en-US" sz="1100" dirty="0"/>
+          </a:p>
+        </p:txBody>
+      </p:sp>
+      <p:pic>
+        <p:nvPicPr>
+          <p:cNvPr id="15" name="Image 6" descr="/var/folders/hm/sgq6d80d0vq133k7n8dc9bnw0000gn/T/maiershirts-Os5V18/ref-vereine-0-6.png">    </p:cNvPr>
+          <p:cNvPicPr>
+            <a:picLocks noChangeAspect="1"/>
+          </p:cNvPicPr>
+          <p:nvPr>
+            <p:ph idx="114" type="pic" hasCustomPrompt="1"/>
+          </p:nvPr>
+        </p:nvPicPr>
+        <p:blipFill>
+          <a:blip r:embed="rId7"/>
+          <a:stretch>
+            <a:fillRect/>
+          </a:stretch>
+        </p:blipFill>
+        <p:spPr>
+          <a:xfrm>
+            <a:off x="5288359" y="3090672"/>
+            <a:ext cx="670402" cy="667512"/>
+          </a:xfrm>
+          <a:prstGeom prst="rect">
+            <a:avLst/>
+          </a:prstGeom>
+        </p:spPr>
+      </p:pic>
+      <p:sp>
+        <p:nvSpPr>
+          <p:cNvPr id="16" name="Text 0"/>
+          <p:cNvSpPr txBox="1"/>
+          <p:nvPr>
+            <p:ph idx="115" type="body" hasCustomPrompt="1"/>
+          </p:nvPr>
+        </p:nvSpPr>
+        <p:spPr>
+          <a:xfrm>
+            <a:off x="4773168" y="4014216"/>
+            <a:ext cx="1700784" cy="274320"/>
+          </a:xfrm>
+          <a:prstGeom prst="rect">
+            <a:avLst/>
+          </a:prstGeom>
+          <a:noFill/>
+          <a:ln/>
+        </p:spPr>
+        <p:txBody>
+          <a:bodyPr wrap="square" lIns="0" tIns="0" rIns="0" bIns="0" rtlCol="0" anchor="ctr"/>
+          <a:lstStyle/>
+          <a:p>
+            <a:pPr algn="ctr" indent="0" marL="0">
+              <a:buNone/>
+            </a:pPr>
+            <a:r>
+              <a:rPr lang="en-US" sz="1100" b="1" dirty="0">
+                <a:solidFill>
+                  <a:srgbClr val="0F0F0F"/>
+                </a:solidFill>
+                <a:latin typeface="Inter" pitchFamily="34" charset="0"/>
+                <a:ea typeface="Inter" pitchFamily="34" charset="-122"/>
+                <a:cs typeface="Inter" pitchFamily="34" charset="-120"/>
+              </a:rPr>
+              <a:t>TV Mühlacker</a:t>
+            </a:r>
+            <a:endParaRPr lang="en-US" sz="1100" dirty="0"/>
+          </a:p>
+        </p:txBody>
+      </p:sp>
+      <p:pic>
+        <p:nvPicPr>
+          <p:cNvPr id="17" name="Image 7" descr="/var/folders/hm/sgq6d80d0vq133k7n8dc9bnw0000gn/T/maiershirts-Os5V18/ref-vereine-0-7.png">    </p:cNvPr>
+          <p:cNvPicPr>
+            <a:picLocks noChangeAspect="1"/>
+          </p:cNvPicPr>
+          <p:nvPr>
+            <p:ph idx="116" type="pic" hasCustomPrompt="1"/>
+          </p:nvPr>
+        </p:nvPicPr>
+        <p:blipFill>
+          <a:blip r:embed="rId8"/>
+          <a:stretch>
+            <a:fillRect/>
+          </a:stretch>
+        </p:blipFill>
+        <p:spPr>
+          <a:xfrm>
+            <a:off x="7022592" y="3098331"/>
+            <a:ext cx="1408176" cy="652193"/>
+          </a:xfrm>
+          <a:prstGeom prst="rect">
+            <a:avLst/>
+          </a:prstGeom>
+        </p:spPr>
+      </p:pic>
+      <p:sp>
+        <p:nvSpPr>
+          <p:cNvPr id="18" name="Text 0"/>
+          <p:cNvSpPr txBox="1"/>
+          <p:nvPr>
+            <p:ph idx="117" type="body" hasCustomPrompt="1"/>
+          </p:nvPr>
+        </p:nvSpPr>
+        <p:spPr>
+          <a:xfrm>
+            <a:off x="6876288" y="4014216"/>
+            <a:ext cx="1700784" cy="274320"/>
+          </a:xfrm>
+          <a:prstGeom prst="rect">
+            <a:avLst/>
+          </a:prstGeom>
+          <a:noFill/>
+          <a:ln/>
+        </p:spPr>
+        <p:txBody>
+          <a:bodyPr wrap="square" lIns="0" tIns="0" rIns="0" bIns="0" rtlCol="0" anchor="ctr"/>
+          <a:lstStyle/>
+          <a:p>
+            <a:pPr algn="ctr" indent="0" marL="0">
+              <a:buNone/>
+            </a:pPr>
+            <a:r>
+              <a:rPr lang="en-US" sz="1100" b="1" dirty="0">
+                <a:solidFill>
+                  <a:srgbClr val="0F0F0F"/>
+                </a:solidFill>
+                <a:latin typeface="Inter" pitchFamily="34" charset="0"/>
+                <a:ea typeface="Inter" pitchFamily="34" charset="-122"/>
+                <a:cs typeface="Inter" pitchFamily="34" charset="-120"/>
+              </a:rPr>
+              <a:t>Tennisclub Wurmlingen</a:t>
+            </a:r>
+            <a:endParaRPr lang="en-US" sz="1100" dirty="0"/>
           </a:p>
         </p:txBody>
       </p:sp>
@@ -14804,145 +15071,50 @@
                 <a:ea typeface="Inter" pitchFamily="34" charset="-122"/>
                 <a:cs typeface="Inter" pitchFamily="34" charset="-120"/>
               </a:rPr>
-              <a:t>Auftragsvolumen nach Produktgruppe</a:t>
+              <a:t>Stickerei im Detail</a:t>
             </a:r>
             <a:endParaRPr lang="en-US" sz="2800" dirty="0"/>
           </a:p>
         </p:txBody>
       </p:sp>
-      <p:graphicFrame>
-        <p:nvGraphicFramePr>
-          <p:cNvPr id="3" name="Chart 0" descr=""/>
-          <p:cNvGraphicFramePr/>
-          <p:nvPr/>
-        </p:nvGraphicFramePr>
-        <p:xfrm>
-          <a:off x="457200" y="1188720"/>
-          <a:ext cx="5303520" cy="3291840"/>
-        </p:xfrm>
-        <a:graphic xmlns:a="http://schemas.openxmlformats.org/drawingml/2006/main">
-          <a:graphicData uri="http://schemas.openxmlformats.org/drawingml/2006/chart">
-            <c:chart xmlns:c="http://schemas.openxmlformats.org/drawingml/2006/chart" r:id="rId1"/>
-          </a:graphicData>
-        </a:graphic>
-      </p:graphicFrame>
-      <p:sp>
-        <p:nvSpPr>
-          <p:cNvPr id="4" name="Shape 1"/>
-          <p:cNvSpPr/>
-          <p:nvPr/>
-        </p:nvSpPr>
-        <p:spPr>
-          <a:xfrm>
-            <a:off x="6035040" y="1188720"/>
-            <a:ext cx="2651760" cy="3291840"/>
-          </a:xfrm>
-          <a:prstGeom prst="roundRect">
-            <a:avLst>
-              <a:gd name="adj" fmla="val 4138"/>
-            </a:avLst>
-          </a:prstGeom>
-          <a:solidFill>
-            <a:srgbClr val="E8DFD0"/>
-          </a:solidFill>
-          <a:ln w="12700">
-            <a:solidFill>
-              <a:srgbClr val="E8DFD0"/>
-            </a:solidFill>
-            <a:prstDash val="solid"/>
-          </a:ln>
-        </p:spPr>
-      </p:sp>
-      <p:sp>
-        <p:nvSpPr>
-          <p:cNvPr id="5" name="Text 2"/>
+      <p:pic>
+        <p:nvPicPr>
+          <p:cNvPr id="3" name="Image 0" descr="/var/folders/hm/sgq6d80d0vq133k7n8dc9bnw0000gn/T/maiershirts-Os5V18/ph-foto-1056x840.png">    </p:cNvPr>
+          <p:cNvPicPr>
+            <a:picLocks noChangeAspect="1"/>
+          </p:cNvPicPr>
+          <p:nvPr>
+            <p:ph idx="102" type="pic" hasCustomPrompt="1"/>
+          </p:nvPr>
+        </p:nvPicPr>
+        <p:blipFill>
+          <a:blip r:embed="rId1"/>
+          <a:stretch>
+            <a:fillRect/>
+          </a:stretch>
+        </p:blipFill>
+        <p:spPr>
+          <a:xfrm>
+            <a:off x="457200" y="1234440"/>
+            <a:ext cx="4023360" cy="3200400"/>
+          </a:xfrm>
+          <a:prstGeom prst="rect">
+            <a:avLst/>
+          </a:prstGeom>
+        </p:spPr>
+      </p:pic>
+      <p:sp>
+        <p:nvSpPr>
+          <p:cNvPr id="4" name="Text 0"/>
           <p:cNvSpPr txBox="1"/>
-          <p:nvPr/>
-        </p:nvSpPr>
-        <p:spPr>
-          <a:xfrm>
-            <a:off x="6263640" y="1371600"/>
-            <a:ext cx="2194560" cy="274320"/>
-          </a:xfrm>
-          <a:prstGeom prst="rect">
-            <a:avLst/>
-          </a:prstGeom>
-          <a:noFill/>
-          <a:ln/>
-        </p:spPr>
-        <p:txBody>
-          <a:bodyPr wrap="square" lIns="0" tIns="0" rIns="0" bIns="0" rtlCol="0" anchor="ctr"/>
-          <a:lstStyle/>
-          <a:p>
-            <a:pPr indent="0" marL="0">
-              <a:buNone/>
-            </a:pPr>
-            <a:r>
-              <a:rPr lang="en-US" sz="1200" dirty="0">
-                <a:solidFill>
-                  <a:srgbClr val="0F0F0F">
-                    <a:alpha val="60000"/>
-                  </a:srgbClr>
-                </a:solidFill>
-                <a:latin typeface="Inter" pitchFamily="34" charset="0"/>
-                <a:ea typeface="Inter" pitchFamily="34" charset="-122"/>
-                <a:cs typeface="Inter" pitchFamily="34" charset="-120"/>
-              </a:rPr>
-              <a:t>Beispieldaten</a:t>
-            </a:r>
-            <a:endParaRPr lang="en-US" sz="1200" dirty="0"/>
-          </a:p>
-        </p:txBody>
-      </p:sp>
-      <p:sp>
-        <p:nvSpPr>
-          <p:cNvPr id="6" name="Text 3"/>
-          <p:cNvSpPr txBox="1"/>
-          <p:nvPr/>
-        </p:nvSpPr>
-        <p:spPr>
-          <a:xfrm>
-            <a:off x="6263640" y="1691640"/>
-            <a:ext cx="2194560" cy="640080"/>
-          </a:xfrm>
-          <a:prstGeom prst="rect">
-            <a:avLst/>
-          </a:prstGeom>
-          <a:noFill/>
-          <a:ln/>
-        </p:spPr>
-        <p:txBody>
-          <a:bodyPr wrap="square" lIns="0" tIns="0" rIns="0" bIns="0" rtlCol="0" anchor="ctr"/>
-          <a:lstStyle/>
-          <a:p>
-            <a:pPr indent="0" marL="0">
-              <a:buNone/>
-            </a:pPr>
-            <a:r>
-              <a:rPr lang="en-US" sz="1600" b="1" dirty="0">
-                <a:solidFill>
-                  <a:srgbClr val="0F0F0F"/>
-                </a:solidFill>
-                <a:latin typeface="Inter" pitchFamily="34" charset="0"/>
-                <a:ea typeface="Inter" pitchFamily="34" charset="-122"/>
-                <a:cs typeface="Inter" pitchFamily="34" charset="-120"/>
-              </a:rPr>
-              <a:t>T-Shirts machen den größten Anteil aus</a:t>
-            </a:r>
-            <a:endParaRPr lang="en-US" sz="1600" dirty="0"/>
-          </a:p>
-        </p:txBody>
-      </p:sp>
-      <p:sp>
-        <p:nvSpPr>
-          <p:cNvPr id="7" name="Text 4"/>
-          <p:cNvSpPr txBox="1"/>
-          <p:nvPr/>
-        </p:nvSpPr>
-        <p:spPr>
-          <a:xfrm>
-            <a:off x="6263640" y="2423160"/>
-            <a:ext cx="2194560" cy="1097280"/>
+          <p:nvPr>
+            <p:ph idx="103" type="body" hasCustomPrompt="1"/>
+          </p:nvPr>
+        </p:nvSpPr>
+        <p:spPr>
+          <a:xfrm>
+            <a:off x="4846320" y="1234440"/>
+            <a:ext cx="3840480" cy="3200400"/>
           </a:xfrm>
           <a:prstGeom prst="rect">
             <a:avLst/>
@@ -14954,23 +15126,88 @@
           <a:bodyPr wrap="square" lIns="0" tIns="0" rIns="0" bIns="0" rtlCol="0" anchor="t"/>
           <a:lstStyle/>
           <a:p>
-            <a:pPr indent="0" marL="0">
-              <a:buNone/>
-            </a:pPr>
-            <a:r>
-              <a:rPr lang="en-US" sz="1200" dirty="0">
-                <a:solidFill>
-                  <a:srgbClr val="0F0F0F">
-                    <a:alpha val="60000"/>
-                  </a:srgbClr>
-                </a:solidFill>
-                <a:latin typeface="Inter" pitchFamily="34" charset="0"/>
-                <a:ea typeface="Inter" pitchFamily="34" charset="-122"/>
-                <a:cs typeface="Inter" pitchFamily="34" charset="-120"/>
-              </a:rPr>
-              <a:t>Natives Diagramm: Werte per Rechtsklick → „Daten bearbeiten“ ändern.</a:t>
-            </a:r>
-            <a:endParaRPr lang="en-US" sz="1200" dirty="0"/>
+            <a:pPr algn="l" marL="342900" indent="-342900">
+              <a:spcAft>
+                <a:spcPts val="800"/>
+              </a:spcAft>
+              <a:buSzPct val="100000"/>
+              <a:buChar char="•"/>
+            </a:pPr>
+            <a:r>
+              <a:rPr lang="en-US" sz="1600" dirty="0">
+                <a:solidFill>
+                  <a:srgbClr val="0F0F0F"/>
+                </a:solidFill>
+                <a:latin typeface="Inter" pitchFamily="34" charset="0"/>
+                <a:ea typeface="Inter" pitchFamily="34" charset="-122"/>
+                <a:cs typeface="Inter" pitchFamily="34" charset="-120"/>
+              </a:rPr>
+              <a:t>Bis zu 12 Garnfarben pro Motiv</a:t>
+            </a:r>
+            <a:endParaRPr lang="en-US" sz="1600" dirty="0"/>
+          </a:p>
+          <a:p>
+            <a:pPr algn="l" marL="342900" indent="-342900">
+              <a:spcAft>
+                <a:spcPts val="800"/>
+              </a:spcAft>
+              <a:buSzPct val="100000"/>
+              <a:buChar char="•"/>
+            </a:pPr>
+            <a:r>
+              <a:rPr lang="en-US" sz="1600" dirty="0">
+                <a:solidFill>
+                  <a:srgbClr val="0F0F0F"/>
+                </a:solidFill>
+                <a:latin typeface="Inter" pitchFamily="34" charset="0"/>
+                <a:ea typeface="Inter" pitchFamily="34" charset="-122"/>
+                <a:cs typeface="Inter" pitchFamily="34" charset="-120"/>
+              </a:rPr>
+              <a:t>Waschbeständig bis 60 °C</a:t>
+            </a:r>
+            <a:endParaRPr lang="en-US" sz="1600" dirty="0"/>
+          </a:p>
+          <a:p>
+            <a:pPr algn="l" marL="342900" indent="-342900">
+              <a:spcAft>
+                <a:spcPts val="800"/>
+              </a:spcAft>
+              <a:buSzPct val="100000"/>
+              <a:buChar char="•"/>
+            </a:pPr>
+            <a:r>
+              <a:rPr lang="en-US" sz="1600" dirty="0">
+                <a:solidFill>
+                  <a:srgbClr val="0F0F0F"/>
+                </a:solidFill>
+                <a:latin typeface="Inter" pitchFamily="34" charset="0"/>
+                <a:ea typeface="Inter" pitchFamily="34" charset="-122"/>
+                <a:cs typeface="Inter" pitchFamily="34" charset="-120"/>
+              </a:rPr>
+              <a:t>Ideal für Polos, Jacken und Caps</a:t>
+            </a:r>
+            <a:endParaRPr lang="en-US" sz="1600" dirty="0"/>
+          </a:p>
+          <a:p>
+            <a:pPr algn="l" marL="342900" indent="-342900">
+              <a:spcAft>
+                <a:spcPts val="800"/>
+              </a:spcAft>
+              <a:buSzPct val="100000"/>
+              <a:buChar char="•"/>
+            </a:pPr>
+            <a:r>
+              <a:rPr lang="en-US" sz="1600" dirty="0">
+                <a:solidFill>
+                  <a:srgbClr val="0F0F0F"/>
+                </a:solidFill>
+                <a:latin typeface="Inter" pitchFamily="34" charset="0"/>
+                <a:ea typeface="Inter" pitchFamily="34" charset="-122"/>
+                <a:cs typeface="Inter" pitchFamily="34" charset="-120"/>
+              </a:rPr>
+              <a:t>Motivdigitalisierung im Haus</a:t>
+            </a:r>
+            <a:endParaRPr lang="en-US" sz="1600" dirty="0"/>
           </a:p>
         </p:txBody>
       </p:sp>
@@ -15082,24 +15319,145 @@
                 <a:ea typeface="Inter" pitchFamily="34" charset="-122"/>
                 <a:cs typeface="Inter" pitchFamily="34" charset="-120"/>
               </a:rPr>
-              <a:t>Folientitel</a:t>
+              <a:t>Auftragsvolumen nach Produktgruppe</a:t>
             </a:r>
             <a:endParaRPr lang="en-US" sz="2800" dirty="0"/>
           </a:p>
         </p:txBody>
       </p:sp>
-      <p:sp>
-        <p:nvSpPr>
-          <p:cNvPr id="3" name="Text 0"/>
+      <p:graphicFrame>
+        <p:nvGraphicFramePr>
+          <p:cNvPr id="3" name="Chart 0" descr=""/>
+          <p:cNvGraphicFramePr/>
+          <p:nvPr/>
+        </p:nvGraphicFramePr>
+        <p:xfrm>
+          <a:off x="457200" y="1188720"/>
+          <a:ext cx="5303520" cy="3291840"/>
+        </p:xfrm>
+        <a:graphic xmlns:a="http://schemas.openxmlformats.org/drawingml/2006/main">
+          <a:graphicData uri="http://schemas.openxmlformats.org/drawingml/2006/chart">
+            <c:chart xmlns:c="http://schemas.openxmlformats.org/drawingml/2006/chart" r:id="rId1"/>
+          </a:graphicData>
+        </a:graphic>
+      </p:graphicFrame>
+      <p:sp>
+        <p:nvSpPr>
+          <p:cNvPr id="4" name="Shape 1"/>
+          <p:cNvSpPr/>
+          <p:nvPr/>
+        </p:nvSpPr>
+        <p:spPr>
+          <a:xfrm>
+            <a:off x="6035040" y="1188720"/>
+            <a:ext cx="2651760" cy="3291840"/>
+          </a:xfrm>
+          <a:prstGeom prst="roundRect">
+            <a:avLst>
+              <a:gd name="adj" fmla="val 4138"/>
+            </a:avLst>
+          </a:prstGeom>
+          <a:solidFill>
+            <a:srgbClr val="E8DFD0"/>
+          </a:solidFill>
+          <a:ln w="12700">
+            <a:solidFill>
+              <a:srgbClr val="E8DFD0"/>
+            </a:solidFill>
+            <a:prstDash val="solid"/>
+          </a:ln>
+        </p:spPr>
+      </p:sp>
+      <p:sp>
+        <p:nvSpPr>
+          <p:cNvPr id="5" name="Text 2"/>
           <p:cNvSpPr txBox="1"/>
-          <p:nvPr>
-            <p:ph idx="102" type="body" hasCustomPrompt="1"/>
-          </p:nvPr>
-        </p:nvSpPr>
-        <p:spPr>
-          <a:xfrm>
-            <a:off x="457200" y="1234440"/>
-            <a:ext cx="8229600" cy="3200400"/>
+          <p:nvPr/>
+        </p:nvSpPr>
+        <p:spPr>
+          <a:xfrm>
+            <a:off x="6263640" y="1371600"/>
+            <a:ext cx="2194560" cy="274320"/>
+          </a:xfrm>
+          <a:prstGeom prst="rect">
+            <a:avLst/>
+          </a:prstGeom>
+          <a:noFill/>
+          <a:ln/>
+        </p:spPr>
+        <p:txBody>
+          <a:bodyPr wrap="square" lIns="0" tIns="0" rIns="0" bIns="0" rtlCol="0" anchor="ctr"/>
+          <a:lstStyle/>
+          <a:p>
+            <a:pPr indent="0" marL="0">
+              <a:buNone/>
+            </a:pPr>
+            <a:r>
+              <a:rPr lang="en-US" sz="1200" dirty="0">
+                <a:solidFill>
+                  <a:srgbClr val="0F0F0F">
+                    <a:alpha val="60000"/>
+                  </a:srgbClr>
+                </a:solidFill>
+                <a:latin typeface="Inter" pitchFamily="34" charset="0"/>
+                <a:ea typeface="Inter" pitchFamily="34" charset="-122"/>
+                <a:cs typeface="Inter" pitchFamily="34" charset="-120"/>
+              </a:rPr>
+              <a:t>Beispieldaten</a:t>
+            </a:r>
+            <a:endParaRPr lang="en-US" sz="1200" dirty="0"/>
+          </a:p>
+        </p:txBody>
+      </p:sp>
+      <p:sp>
+        <p:nvSpPr>
+          <p:cNvPr id="6" name="Text 3"/>
+          <p:cNvSpPr txBox="1"/>
+          <p:nvPr/>
+        </p:nvSpPr>
+        <p:spPr>
+          <a:xfrm>
+            <a:off x="6263640" y="1691640"/>
+            <a:ext cx="2194560" cy="640080"/>
+          </a:xfrm>
+          <a:prstGeom prst="rect">
+            <a:avLst/>
+          </a:prstGeom>
+          <a:noFill/>
+          <a:ln/>
+        </p:spPr>
+        <p:txBody>
+          <a:bodyPr wrap="square" lIns="0" tIns="0" rIns="0" bIns="0" rtlCol="0" anchor="ctr"/>
+          <a:lstStyle/>
+          <a:p>
+            <a:pPr indent="0" marL="0">
+              <a:buNone/>
+            </a:pPr>
+            <a:r>
+              <a:rPr lang="en-US" sz="1600" b="1" dirty="0">
+                <a:solidFill>
+                  <a:srgbClr val="0F0F0F"/>
+                </a:solidFill>
+                <a:latin typeface="Inter" pitchFamily="34" charset="0"/>
+                <a:ea typeface="Inter" pitchFamily="34" charset="-122"/>
+                <a:cs typeface="Inter" pitchFamily="34" charset="-120"/>
+              </a:rPr>
+              <a:t>T-Shirts machen den größten Anteil aus</a:t>
+            </a:r>
+            <a:endParaRPr lang="en-US" sz="1600" dirty="0"/>
+          </a:p>
+        </p:txBody>
+      </p:sp>
+      <p:sp>
+        <p:nvSpPr>
+          <p:cNvPr id="7" name="Text 4"/>
+          <p:cNvSpPr txBox="1"/>
+          <p:nvPr/>
+        </p:nvSpPr>
+        <p:spPr>
+          <a:xfrm>
+            <a:off x="6263640" y="2423160"/>
+            <a:ext cx="2194560" cy="1097280"/>
           </a:xfrm>
           <a:prstGeom prst="rect">
             <a:avLst/>
@@ -15111,109 +15469,23 @@
           <a:bodyPr wrap="square" lIns="0" tIns="0" rIns="0" bIns="0" rtlCol="0" anchor="t"/>
           <a:lstStyle/>
           <a:p>
-            <a:pPr algn="l" marL="342900" indent="-342900">
-              <a:spcAft>
-                <a:spcPts val="800"/>
-              </a:spcAft>
-              <a:buSzPct val="100000"/>
-              <a:buChar char="•"/>
-            </a:pPr>
-            <a:r>
-              <a:rPr lang="en-US" sz="1600" dirty="0">
-                <a:solidFill>
-                  <a:srgbClr val="0F0F0F"/>
-                </a:solidFill>
-                <a:latin typeface="Inter" pitchFamily="34" charset="0"/>
-                <a:ea typeface="Inter" pitchFamily="34" charset="-122"/>
-                <a:cs typeface="Inter" pitchFamily="34" charset="-120"/>
-              </a:rPr>
-              <a:t>Erste Aussage der Folie</a:t>
-            </a:r>
-            <a:endParaRPr lang="en-US" sz="1600" dirty="0"/>
-          </a:p>
-          <a:p>
-            <a:pPr algn="l" marL="342900" indent="-342900">
-              <a:spcAft>
-                <a:spcPts val="800"/>
-              </a:spcAft>
-              <a:buSzPct val="100000"/>
-              <a:buChar char="•"/>
-            </a:pPr>
-            <a:r>
-              <a:rPr lang="en-US" sz="1600" dirty="0">
-                <a:solidFill>
-                  <a:srgbClr val="0F0F0F"/>
-                </a:solidFill>
-                <a:latin typeface="Inter" pitchFamily="34" charset="0"/>
-                <a:ea typeface="Inter" pitchFamily="34" charset="-122"/>
-                <a:cs typeface="Inter" pitchFamily="34" charset="-120"/>
-              </a:rPr>
-              <a:t>Zweite Aussage mit einer kurzen Erläuterung</a:t>
-            </a:r>
-            <a:endParaRPr lang="en-US" sz="1600" dirty="0"/>
-          </a:p>
-          <a:p>
-            <a:pPr algn="l" marL="342900" indent="-342900">
-              <a:spcAft>
-                <a:spcPts val="800"/>
-              </a:spcAft>
-              <a:buSzPct val="100000"/>
-              <a:buChar char="•"/>
-            </a:pPr>
-            <a:r>
-              <a:rPr lang="en-US" sz="1600" dirty="0">
-                <a:solidFill>
-                  <a:srgbClr val="0F0F0F"/>
-                </a:solidFill>
-                <a:latin typeface="Inter" pitchFamily="34" charset="0"/>
-                <a:ea typeface="Inter" pitchFamily="34" charset="-122"/>
-                <a:cs typeface="Inter" pitchFamily="34" charset="-120"/>
-              </a:rPr>
-              <a:t>Dritte Aussage</a:t>
-            </a:r>
-            <a:endParaRPr lang="en-US" sz="1600" dirty="0"/>
-          </a:p>
-          <a:p>
-            <a:pPr algn="l" lvl="1" marL="685800" indent="-342900">
-              <a:spcAft>
-                <a:spcPts val="800"/>
-              </a:spcAft>
-              <a:buSzPct val="100000"/>
-              <a:buChar char="•"/>
-            </a:pPr>
-            <a:r>
-              <a:rPr lang="en-US" sz="1600" dirty="0">
-                <a:solidFill>
-                  <a:srgbClr val="0F0F0F"/>
-                </a:solidFill>
-                <a:latin typeface="Inter" pitchFamily="34" charset="0"/>
-                <a:ea typeface="Inter" pitchFamily="34" charset="-122"/>
-                <a:cs typeface="Inter" pitchFamily="34" charset="-120"/>
-              </a:rPr>
-              <a:t>Unterpunkt zur dritten Aussage</a:t>
-            </a:r>
-            <a:endParaRPr lang="en-US" sz="1600" dirty="0"/>
-          </a:p>
-          <a:p>
-            <a:pPr algn="l" lvl="1" marL="685800" indent="-342900">
-              <a:spcAft>
-                <a:spcPts val="800"/>
-              </a:spcAft>
-              <a:buSzPct val="100000"/>
-              <a:buChar char="•"/>
-            </a:pPr>
-            <a:r>
-              <a:rPr lang="en-US" sz="1600" dirty="0">
-                <a:solidFill>
-                  <a:srgbClr val="0F0F0F"/>
-                </a:solidFill>
-                <a:latin typeface="Inter" pitchFamily="34" charset="0"/>
-                <a:ea typeface="Inter" pitchFamily="34" charset="-122"/>
-                <a:cs typeface="Inter" pitchFamily="34" charset="-120"/>
-              </a:rPr>
-              <a:t>Weiterer Unterpunkt</a:t>
-            </a:r>
-            <a:endParaRPr lang="en-US" sz="1600" dirty="0"/>
+            <a:pPr indent="0" marL="0">
+              <a:buNone/>
+            </a:pPr>
+            <a:r>
+              <a:rPr lang="en-US" sz="1200" dirty="0">
+                <a:solidFill>
+                  <a:srgbClr val="0F0F0F">
+                    <a:alpha val="60000"/>
+                  </a:srgbClr>
+                </a:solidFill>
+                <a:latin typeface="Inter" pitchFamily="34" charset="0"/>
+                <a:ea typeface="Inter" pitchFamily="34" charset="-122"/>
+                <a:cs typeface="Inter" pitchFamily="34" charset="-120"/>
+              </a:rPr>
+              <a:t>Natives Diagramm: Werte per Rechtsklick → „Daten bearbeiten“ ändern.</a:t>
+            </a:r>
+            <a:endParaRPr lang="en-US" sz="1200" dirty="0"/>
           </a:p>
         </p:txBody>
       </p:sp>
@@ -15300,6 +15572,249 @@
         </p:nvSpPr>
         <p:spPr>
           <a:xfrm>
+            <a:off x="457200" y="320040"/>
+            <a:ext cx="7132320" cy="640080"/>
+          </a:xfrm>
+          <a:prstGeom prst="rect">
+            <a:avLst/>
+          </a:prstGeom>
+          <a:noFill/>
+          <a:ln/>
+        </p:spPr>
+        <p:txBody>
+          <a:bodyPr wrap="square" lIns="0" tIns="0" rIns="0" bIns="0" rtlCol="0" anchor="ctr"/>
+          <a:lstStyle/>
+          <a:p>
+            <a:pPr algn="l" indent="0" marL="0">
+              <a:buNone/>
+            </a:pPr>
+            <a:r>
+              <a:rPr lang="en-US" sz="2800" b="1" dirty="0">
+                <a:solidFill>
+                  <a:srgbClr val="0F0F0F"/>
+                </a:solidFill>
+                <a:latin typeface="Inter" pitchFamily="34" charset="0"/>
+                <a:ea typeface="Inter" pitchFamily="34" charset="-122"/>
+                <a:cs typeface="Inter" pitchFamily="34" charset="-120"/>
+              </a:rPr>
+              <a:t>Folientitel</a:t>
+            </a:r>
+            <a:endParaRPr lang="en-US" sz="2800" dirty="0"/>
+          </a:p>
+        </p:txBody>
+      </p:sp>
+      <p:sp>
+        <p:nvSpPr>
+          <p:cNvPr id="3" name="Text 0"/>
+          <p:cNvSpPr txBox="1"/>
+          <p:nvPr>
+            <p:ph idx="102" type="body" hasCustomPrompt="1"/>
+          </p:nvPr>
+        </p:nvSpPr>
+        <p:spPr>
+          <a:xfrm>
+            <a:off x="457200" y="1234440"/>
+            <a:ext cx="8229600" cy="3200400"/>
+          </a:xfrm>
+          <a:prstGeom prst="rect">
+            <a:avLst/>
+          </a:prstGeom>
+          <a:noFill/>
+          <a:ln/>
+        </p:spPr>
+        <p:txBody>
+          <a:bodyPr wrap="square" lIns="0" tIns="0" rIns="0" bIns="0" rtlCol="0" anchor="t"/>
+          <a:lstStyle/>
+          <a:p>
+            <a:pPr algn="l" marL="342900" indent="-342900">
+              <a:spcAft>
+                <a:spcPts val="800"/>
+              </a:spcAft>
+              <a:buSzPct val="100000"/>
+              <a:buChar char="•"/>
+            </a:pPr>
+            <a:r>
+              <a:rPr lang="en-US" sz="1600" dirty="0">
+                <a:solidFill>
+                  <a:srgbClr val="0F0F0F"/>
+                </a:solidFill>
+                <a:latin typeface="Inter" pitchFamily="34" charset="0"/>
+                <a:ea typeface="Inter" pitchFamily="34" charset="-122"/>
+                <a:cs typeface="Inter" pitchFamily="34" charset="-120"/>
+              </a:rPr>
+              <a:t>Erste Aussage der Folie</a:t>
+            </a:r>
+            <a:endParaRPr lang="en-US" sz="1600" dirty="0"/>
+          </a:p>
+          <a:p>
+            <a:pPr algn="l" marL="342900" indent="-342900">
+              <a:spcAft>
+                <a:spcPts val="800"/>
+              </a:spcAft>
+              <a:buSzPct val="100000"/>
+              <a:buChar char="•"/>
+            </a:pPr>
+            <a:r>
+              <a:rPr lang="en-US" sz="1600" dirty="0">
+                <a:solidFill>
+                  <a:srgbClr val="0F0F0F"/>
+                </a:solidFill>
+                <a:latin typeface="Inter" pitchFamily="34" charset="0"/>
+                <a:ea typeface="Inter" pitchFamily="34" charset="-122"/>
+                <a:cs typeface="Inter" pitchFamily="34" charset="-120"/>
+              </a:rPr>
+              <a:t>Zweite Aussage mit einer kurzen Erläuterung</a:t>
+            </a:r>
+            <a:endParaRPr lang="en-US" sz="1600" dirty="0"/>
+          </a:p>
+          <a:p>
+            <a:pPr algn="l" marL="342900" indent="-342900">
+              <a:spcAft>
+                <a:spcPts val="800"/>
+              </a:spcAft>
+              <a:buSzPct val="100000"/>
+              <a:buChar char="•"/>
+            </a:pPr>
+            <a:r>
+              <a:rPr lang="en-US" sz="1600" dirty="0">
+                <a:solidFill>
+                  <a:srgbClr val="0F0F0F"/>
+                </a:solidFill>
+                <a:latin typeface="Inter" pitchFamily="34" charset="0"/>
+                <a:ea typeface="Inter" pitchFamily="34" charset="-122"/>
+                <a:cs typeface="Inter" pitchFamily="34" charset="-120"/>
+              </a:rPr>
+              <a:t>Dritte Aussage</a:t>
+            </a:r>
+            <a:endParaRPr lang="en-US" sz="1600" dirty="0"/>
+          </a:p>
+          <a:p>
+            <a:pPr algn="l" lvl="1" marL="685800" indent="-342900">
+              <a:spcAft>
+                <a:spcPts val="800"/>
+              </a:spcAft>
+              <a:buSzPct val="100000"/>
+              <a:buChar char="•"/>
+            </a:pPr>
+            <a:r>
+              <a:rPr lang="en-US" sz="1600" dirty="0">
+                <a:solidFill>
+                  <a:srgbClr val="0F0F0F"/>
+                </a:solidFill>
+                <a:latin typeface="Inter" pitchFamily="34" charset="0"/>
+                <a:ea typeface="Inter" pitchFamily="34" charset="-122"/>
+                <a:cs typeface="Inter" pitchFamily="34" charset="-120"/>
+              </a:rPr>
+              <a:t>Unterpunkt zur dritten Aussage</a:t>
+            </a:r>
+            <a:endParaRPr lang="en-US" sz="1600" dirty="0"/>
+          </a:p>
+          <a:p>
+            <a:pPr algn="l" lvl="1" marL="685800" indent="-342900">
+              <a:spcAft>
+                <a:spcPts val="800"/>
+              </a:spcAft>
+              <a:buSzPct val="100000"/>
+              <a:buChar char="•"/>
+            </a:pPr>
+            <a:r>
+              <a:rPr lang="en-US" sz="1600" dirty="0">
+                <a:solidFill>
+                  <a:srgbClr val="0F0F0F"/>
+                </a:solidFill>
+                <a:latin typeface="Inter" pitchFamily="34" charset="0"/>
+                <a:ea typeface="Inter" pitchFamily="34" charset="-122"/>
+                <a:cs typeface="Inter" pitchFamily="34" charset="-120"/>
+              </a:rPr>
+              <a:t>Weiterer Unterpunkt</a:t>
+            </a:r>
+            <a:endParaRPr lang="en-US" sz="1600" dirty="0"/>
+          </a:p>
+        </p:txBody>
+      </p:sp>
+      <p:sp>
+        <p:nvSpPr>
+          <p:cNvPr id="25" name="Slide Number Placeholder 0"/>
+          <p:cNvSpPr>
+            <a:spLocks noGrp="1"/>
+          </p:cNvSpPr>
+          <p:nvPr>
+            <p:ph type="sldNum" sz="quarter" idx="4294967295"/>
+          </p:nvPr>
+        </p:nvSpPr>
+        <p:spPr>
+          <a:xfrm>
+            <a:off x="8229600" y="4709160"/>
+            <a:ext cx="457200" cy="274320"/>
+          </a:xfrm>
+          <a:prstGeom prst="rect">
+            <a:avLst/>
+          </a:prstGeom>
+          <a:extLst>
+            <a:ext uri="{C572A759-6A51-4108-AA02-DFA0A04FC94B}">
+              <ma14:wrappingTextBoxFlag xmlns:ma14="http://schemas.microsoft.com/office/mac/drawingml/2011/main" val="0"/>
+            </a:ext>
+          </a:extLst>
+        </p:spPr>
+        <p:txBody>
+          <a:bodyPr lIns="0" tIns="0" rIns="0" bIns="0"/>
+          <a:lstStyle>
+            <a:lvl1pPr>
+              <a:defRPr sz="1000">
+                <a:solidFill>
+                  <a:srgbClr val="0F0F0F"/>
+                </a:solidFill>
+                <a:latin typeface="Inter"/>
+                <a:ea typeface="Inter"/>
+                <a:cs typeface="Inter"/>
+              </a:defRPr>
+            </a:lvl1pPr>
+          </a:lstStyle>
+          <a:p>
+            <a:pPr algn="r"/>
+            <a:fld id="{F7021451-1387-4CA6-816F-3879F97B5CBC}" type="slidenum">
+              <a:rPr b="0" lang="en-US"/>
+              <a:t>16</a:t>
+            </a:fld>
+            <a:endParaRPr lang="en-US"/>
+          </a:p>
+        </p:txBody>
+      </p:sp>
+    </p:spTree>
+  </p:cSld>
+  <p:clrMapOvr>
+    <a:masterClrMapping/>
+  </p:clrMapOvr>
+</p:sld>
+</file>
+
+<file path=ppt/slides/slide17.xml><?xml version="1.0" encoding="utf-8"?>
+<p:sld xmlns:a="http://schemas.openxmlformats.org/drawingml/2006/main" xmlns:r="http://schemas.openxmlformats.org/officeDocument/2006/relationships" xmlns:p="http://schemas.openxmlformats.org/presentationml/2006/main">
+  <p:cSld name="Slide 17">
+    <p:spTree>
+      <p:nvGrpSpPr>
+        <p:cNvPr id="1" name=""/>
+        <p:cNvGrpSpPr/>
+        <p:nvPr/>
+      </p:nvGrpSpPr>
+      <p:grpSpPr>
+        <a:xfrm>
+          <a:off x="0" y="0"/>
+          <a:ext cx="0" cy="0"/>
+          <a:chOff x="0" y="0"/>
+          <a:chExt cx="0" cy="0"/>
+        </a:xfrm>
+      </p:grpSpPr>
+      <p:sp>
+        <p:nvSpPr>
+          <p:cNvPr id="2" name="Text 0"/>
+          <p:cNvSpPr txBox="1"/>
+          <p:nvPr>
+            <p:ph idx="101" type="title" hasCustomPrompt="1"/>
+          </p:nvPr>
+        </p:nvSpPr>
+        <p:spPr>
+          <a:xfrm>
             <a:off x="548640" y="1371600"/>
             <a:ext cx="4846320" cy="1005840"/>
           </a:xfrm>
@@ -15376,7 +15891,7 @@
       </p:sp>
       <p:pic>
         <p:nvPicPr>
-          <p:cNvPr id="4" name="Image 0" descr="/var/folders/hm/sgq6d80d0vq133k7n8dc9bnw0000gn/T/maiershirts-2HUvCI/ph-portrait-252x252.png">    </p:cNvPr>
+          <p:cNvPr id="4" name="Image 0" descr="/var/folders/hm/sgq6d80d0vq133k7n8dc9bnw0000gn/T/maiershirts-Os5V18/ph-portrait-252x252.png">    </p:cNvPr>
           <p:cNvPicPr>
             <a:picLocks noChangeAspect="1"/>
           </p:cNvPicPr>
@@ -15585,7 +16100,7 @@
       </p:sp>
       <p:pic>
         <p:nvPicPr>
-          <p:cNvPr id="9" name="Image 1" descr="/var/folders/hm/sgq6d80d0vq133k7n8dc9bnw0000gn/T/maiershirts-2HUvCI/ph-qr-240x240.png">    </p:cNvPr>
+          <p:cNvPr id="9" name="Image 1" descr="/var/folders/hm/sgq6d80d0vq133k7n8dc9bnw0000gn/T/maiershirts-Os5V18/ph-qr-240x240.png">    </p:cNvPr>
           <p:cNvPicPr>
             <a:picLocks noChangeAspect="1"/>
           </p:cNvPicPr>
@@ -17001,7 +17516,7 @@
       </p:grpSpPr>
       <p:pic>
         <p:nvPicPr>
-          <p:cNvPr id="2" name="Image 0" descr="/var/folders/hm/sgq6d80d0vq133k7n8dc9bnw0000gn/T/maiershirts-2HUvCI/ph-foto-2400x1008.png">    </p:cNvPr>
+          <p:cNvPr id="2" name="Image 0" descr="/var/folders/hm/sgq6d80d0vq133k7n8dc9bnw0000gn/T/maiershirts-Os5V18/ph-foto-2400x1008.png">    </p:cNvPr>
           <p:cNvPicPr>
             <a:picLocks noChangeAspect="1"/>
           </p:cNvPicPr>
@@ -18159,7 +18674,7 @@
       </p:sp>
       <p:pic>
         <p:nvPicPr>
-          <p:cNvPr id="3" name="Image 0" descr="/var/folders/hm/sgq6d80d0vq133k7n8dc9bnw0000gn/T/maiershirts-2HUvCI/ph-foto-696x456.png">    </p:cNvPr>
+          <p:cNvPr id="3" name="Image 0" descr="/var/folders/hm/sgq6d80d0vq133k7n8dc9bnw0000gn/T/maiershirts-Os5V18/ph-foto-696x456.png">    </p:cNvPr>
           <p:cNvPicPr>
             <a:picLocks noChangeAspect="1"/>
           </p:cNvPicPr>
@@ -18329,7 +18844,7 @@
       </p:sp>
       <p:pic>
         <p:nvPicPr>
-          <p:cNvPr id="7" name="Image 1" descr="/var/folders/hm/sgq6d80d0vq133k7n8dc9bnw0000gn/T/maiershirts-2HUvCI/ph-foto-696x456.png">    </p:cNvPr>
+          <p:cNvPr id="7" name="Image 1" descr="/var/folders/hm/sgq6d80d0vq133k7n8dc9bnw0000gn/T/maiershirts-Os5V18/ph-foto-696x456.png">    </p:cNvPr>
           <p:cNvPicPr>
             <a:picLocks noChangeAspect="1"/>
           </p:cNvPicPr>
@@ -18499,7 +19014,7 @@
       </p:sp>
       <p:pic>
         <p:nvPicPr>
-          <p:cNvPr id="11" name="Image 2" descr="/var/folders/hm/sgq6d80d0vq133k7n8dc9bnw0000gn/T/maiershirts-2HUvCI/ph-foto-696x456.png">    </p:cNvPr>
+          <p:cNvPr id="11" name="Image 2" descr="/var/folders/hm/sgq6d80d0vq133k7n8dc9bnw0000gn/T/maiershirts-Os5V18/ph-foto-696x456.png">    </p:cNvPr>
           <p:cNvPicPr>
             <a:picLocks noChangeAspect="1"/>
           </p:cNvPicPr>

</xml_diff>

<commit_message>
Referenzfolien: Unterzeile "Eine Auswahl" als Platzhalter
Co-Authored-By: Claude Fable 5.1 <noreply@anthropic.com>
</commit_message>
<xml_diff>
--- a/presentation/dist/Maiershirts_Master.pptx
+++ b/presentation/dist/Maiershirts_Master.pptx
@@ -6215,7 +6215,64 @@
           <p:cNvPr id="4" name="Text 0"/>
           <p:cNvSpPr/>
           <p:nvPr>
-            <p:ph idx="102" type="pic" hasCustomPrompt="1"/>
+            <p:ph idx="102" type="body" hasCustomPrompt="1"/>
+          </p:nvPr>
+        </p:nvSpPr>
+        <p:spPr>
+          <a:xfrm>
+            <a:off x="457200" y="914400"/>
+            <a:ext cx="7132320" cy="274320"/>
+          </a:xfrm>
+          <a:prstGeom prst="rect">
+            <a:avLst/>
+          </a:prstGeom>
+          <a:noFill/>
+          <a:ln/>
+        </p:spPr>
+        <p:txBody>
+          <a:bodyPr wrap="square" rtlCol="0"/>
+          <a:lstStyle>
+            <a:lvl1pPr algn="l" indent="0" marL="0">
+              <a:buNone/>
+              <a:defRPr lang="en-US" sz="1200" dirty="0">
+                <a:solidFill>
+                  <a:srgbClr val="0F0F0F">
+                    <a:alpha val="60000"/>
+                  </a:srgbClr>
+                </a:solidFill>
+                <a:latin typeface="Inter" pitchFamily="34" charset="0"/>
+                <a:ea typeface="Inter" pitchFamily="34" charset="-122"/>
+                <a:cs typeface="Inter" pitchFamily="34" charset="-120"/>
+              </a:defRPr>
+            </a:lvl1pPr>
+          </a:lstStyle>
+          <a:p>
+            <a:pPr algn="l" indent="0" marL="0">
+              <a:buNone/>
+            </a:pPr>
+            <a:r>
+              <a:rPr lang="en-US" sz="1200" dirty="0">
+                <a:solidFill>
+                  <a:srgbClr val="0F0F0F">
+                    <a:alpha val="60000"/>
+                  </a:srgbClr>
+                </a:solidFill>
+                <a:latin typeface="Inter" pitchFamily="34" charset="0"/>
+                <a:ea typeface="Inter" pitchFamily="34" charset="-122"/>
+                <a:cs typeface="Inter" pitchFamily="34" charset="-120"/>
+              </a:rPr>
+              <a:t>Eine Auswahl unserer Kunden</a:t>
+            </a:r>
+            <a:endParaRPr lang="en-US" sz="1200" dirty="0"/>
+          </a:p>
+        </p:txBody>
+      </p:sp>
+      <p:sp>
+        <p:nvSpPr>
+          <p:cNvPr id="5" name="Text 0"/>
+          <p:cNvSpPr/>
+          <p:nvPr>
+            <p:ph idx="103" type="pic" hasCustomPrompt="1"/>
           </p:nvPr>
         </p:nvSpPr>
         <p:spPr>
@@ -6269,10 +6326,10 @@
       </p:sp>
       <p:sp>
         <p:nvSpPr>
-          <p:cNvPr id="5" name="Text 0"/>
+          <p:cNvPr id="6" name="Text 0"/>
           <p:cNvSpPr/>
           <p:nvPr>
-            <p:ph idx="103" type="pic" hasCustomPrompt="1"/>
+            <p:ph idx="104" type="pic" hasCustomPrompt="1"/>
           </p:nvPr>
         </p:nvSpPr>
         <p:spPr>
@@ -6326,10 +6383,10 @@
       </p:sp>
       <p:sp>
         <p:nvSpPr>
-          <p:cNvPr id="6" name="Text 0"/>
+          <p:cNvPr id="7" name="Text 0"/>
           <p:cNvSpPr/>
           <p:nvPr>
-            <p:ph idx="104" type="pic" hasCustomPrompt="1"/>
+            <p:ph idx="105" type="pic" hasCustomPrompt="1"/>
           </p:nvPr>
         </p:nvSpPr>
         <p:spPr>
@@ -6383,10 +6440,10 @@
       </p:sp>
       <p:sp>
         <p:nvSpPr>
-          <p:cNvPr id="7" name="Text 0"/>
+          <p:cNvPr id="8" name="Text 0"/>
           <p:cNvSpPr/>
           <p:nvPr>
-            <p:ph idx="105" type="pic" hasCustomPrompt="1"/>
+            <p:ph idx="106" type="pic" hasCustomPrompt="1"/>
           </p:nvPr>
         </p:nvSpPr>
         <p:spPr>
@@ -6440,10 +6497,10 @@
       </p:sp>
       <p:sp>
         <p:nvSpPr>
-          <p:cNvPr id="8" name="Text 0"/>
+          <p:cNvPr id="9" name="Text 0"/>
           <p:cNvSpPr/>
           <p:nvPr>
-            <p:ph idx="106" type="pic" hasCustomPrompt="1"/>
+            <p:ph idx="107" type="pic" hasCustomPrompt="1"/>
           </p:nvPr>
         </p:nvSpPr>
         <p:spPr>
@@ -6497,10 +6554,10 @@
       </p:sp>
       <p:sp>
         <p:nvSpPr>
-          <p:cNvPr id="9" name="Text 0"/>
+          <p:cNvPr id="10" name="Text 0"/>
           <p:cNvSpPr/>
           <p:nvPr>
-            <p:ph idx="107" type="pic" hasCustomPrompt="1"/>
+            <p:ph idx="108" type="pic" hasCustomPrompt="1"/>
           </p:nvPr>
         </p:nvSpPr>
         <p:spPr>
@@ -6554,10 +6611,10 @@
       </p:sp>
       <p:sp>
         <p:nvSpPr>
-          <p:cNvPr id="10" name="Text 0"/>
+          <p:cNvPr id="11" name="Text 0"/>
           <p:cNvSpPr/>
           <p:nvPr>
-            <p:ph idx="108" type="pic" hasCustomPrompt="1"/>
+            <p:ph idx="109" type="pic" hasCustomPrompt="1"/>
           </p:nvPr>
         </p:nvSpPr>
         <p:spPr>
@@ -6611,10 +6668,10 @@
       </p:sp>
       <p:sp>
         <p:nvSpPr>
-          <p:cNvPr id="11" name="Text 0"/>
+          <p:cNvPr id="12" name="Text 0"/>
           <p:cNvSpPr/>
           <p:nvPr>
-            <p:ph idx="109" type="pic" hasCustomPrompt="1"/>
+            <p:ph idx="110" type="pic" hasCustomPrompt="1"/>
           </p:nvPr>
         </p:nvSpPr>
         <p:spPr>
@@ -6668,10 +6725,10 @@
       </p:sp>
       <p:sp>
         <p:nvSpPr>
-          <p:cNvPr id="12" name="Text 0"/>
+          <p:cNvPr id="13" name="Text 0"/>
           <p:cNvSpPr/>
           <p:nvPr>
-            <p:ph idx="110" type="pic" hasCustomPrompt="1"/>
+            <p:ph idx="111" type="pic" hasCustomPrompt="1"/>
           </p:nvPr>
         </p:nvSpPr>
         <p:spPr>
@@ -6725,10 +6782,10 @@
       </p:sp>
       <p:sp>
         <p:nvSpPr>
-          <p:cNvPr id="13" name="Text 0"/>
+          <p:cNvPr id="14" name="Text 0"/>
           <p:cNvSpPr/>
           <p:nvPr>
-            <p:ph idx="111" type="pic" hasCustomPrompt="1"/>
+            <p:ph idx="112" type="pic" hasCustomPrompt="1"/>
           </p:nvPr>
         </p:nvSpPr>
         <p:spPr>
@@ -6782,10 +6839,10 @@
       </p:sp>
       <p:sp>
         <p:nvSpPr>
-          <p:cNvPr id="14" name="Text 0"/>
+          <p:cNvPr id="15" name="Text 0"/>
           <p:cNvSpPr/>
           <p:nvPr>
-            <p:ph idx="112" type="pic" hasCustomPrompt="1"/>
+            <p:ph idx="113" type="pic" hasCustomPrompt="1"/>
           </p:nvPr>
         </p:nvSpPr>
         <p:spPr>
@@ -6839,10 +6896,10 @@
       </p:sp>
       <p:sp>
         <p:nvSpPr>
-          <p:cNvPr id="15" name="Text 0"/>
+          <p:cNvPr id="16" name="Text 0"/>
           <p:cNvSpPr/>
           <p:nvPr>
-            <p:ph idx="113" type="pic" hasCustomPrompt="1"/>
+            <p:ph idx="114" type="pic" hasCustomPrompt="1"/>
           </p:nvPr>
         </p:nvSpPr>
         <p:spPr>
@@ -6896,7 +6953,7 @@
       </p:sp>
       <p:sp>
         <p:nvSpPr>
-          <p:cNvPr id="16" name="Text 0"/>
+          <p:cNvPr id="17" name="Text 0"/>
           <p:cNvSpPr/>
           <p:nvPr/>
         </p:nvSpPr>
@@ -7103,7 +7160,64 @@
           <p:cNvPr id="4" name="Text 0"/>
           <p:cNvSpPr/>
           <p:nvPr>
-            <p:ph idx="102" type="pic" hasCustomPrompt="1"/>
+            <p:ph idx="102" type="body" hasCustomPrompt="1"/>
+          </p:nvPr>
+        </p:nvSpPr>
+        <p:spPr>
+          <a:xfrm>
+            <a:off x="457200" y="914400"/>
+            <a:ext cx="7132320" cy="274320"/>
+          </a:xfrm>
+          <a:prstGeom prst="rect">
+            <a:avLst/>
+          </a:prstGeom>
+          <a:noFill/>
+          <a:ln/>
+        </p:spPr>
+        <p:txBody>
+          <a:bodyPr wrap="square" rtlCol="0"/>
+          <a:lstStyle>
+            <a:lvl1pPr algn="l" indent="0" marL="0">
+              <a:buNone/>
+              <a:defRPr lang="en-US" sz="1200" dirty="0">
+                <a:solidFill>
+                  <a:srgbClr val="0F0F0F">
+                    <a:alpha val="60000"/>
+                  </a:srgbClr>
+                </a:solidFill>
+                <a:latin typeface="Inter" pitchFamily="34" charset="0"/>
+                <a:ea typeface="Inter" pitchFamily="34" charset="-122"/>
+                <a:cs typeface="Inter" pitchFamily="34" charset="-120"/>
+              </a:defRPr>
+            </a:lvl1pPr>
+          </a:lstStyle>
+          <a:p>
+            <a:pPr algn="l" indent="0" marL="0">
+              <a:buNone/>
+            </a:pPr>
+            <a:r>
+              <a:rPr lang="en-US" sz="1200" dirty="0">
+                <a:solidFill>
+                  <a:srgbClr val="0F0F0F">
+                    <a:alpha val="60000"/>
+                  </a:srgbClr>
+                </a:solidFill>
+                <a:latin typeface="Inter" pitchFamily="34" charset="0"/>
+                <a:ea typeface="Inter" pitchFamily="34" charset="-122"/>
+                <a:cs typeface="Inter" pitchFamily="34" charset="-120"/>
+              </a:rPr>
+              <a:t>Eine Auswahl unserer Kunden</a:t>
+            </a:r>
+            <a:endParaRPr lang="en-US" sz="1200" dirty="0"/>
+          </a:p>
+        </p:txBody>
+      </p:sp>
+      <p:sp>
+        <p:nvSpPr>
+          <p:cNvPr id="5" name="Text 0"/>
+          <p:cNvSpPr/>
+          <p:nvPr>
+            <p:ph idx="103" type="pic" hasCustomPrompt="1"/>
           </p:nvPr>
         </p:nvSpPr>
         <p:spPr>
@@ -7157,10 +7271,10 @@
       </p:sp>
       <p:sp>
         <p:nvSpPr>
-          <p:cNvPr id="5" name="Text 0"/>
+          <p:cNvPr id="6" name="Text 0"/>
           <p:cNvSpPr/>
           <p:nvPr>
-            <p:ph idx="103" type="body" hasCustomPrompt="1"/>
+            <p:ph idx="104" type="body" hasCustomPrompt="1"/>
           </p:nvPr>
         </p:nvSpPr>
         <p:spPr>
@@ -7210,10 +7324,10 @@
       </p:sp>
       <p:sp>
         <p:nvSpPr>
-          <p:cNvPr id="6" name="Text 0"/>
+          <p:cNvPr id="7" name="Text 0"/>
           <p:cNvSpPr/>
           <p:nvPr>
-            <p:ph idx="104" type="pic" hasCustomPrompt="1"/>
+            <p:ph idx="105" type="pic" hasCustomPrompt="1"/>
           </p:nvPr>
         </p:nvSpPr>
         <p:spPr>
@@ -7267,10 +7381,10 @@
       </p:sp>
       <p:sp>
         <p:nvSpPr>
-          <p:cNvPr id="7" name="Text 0"/>
+          <p:cNvPr id="8" name="Text 0"/>
           <p:cNvSpPr/>
           <p:nvPr>
-            <p:ph idx="105" type="body" hasCustomPrompt="1"/>
+            <p:ph idx="106" type="body" hasCustomPrompt="1"/>
           </p:nvPr>
         </p:nvSpPr>
         <p:spPr>
@@ -7320,10 +7434,10 @@
       </p:sp>
       <p:sp>
         <p:nvSpPr>
-          <p:cNvPr id="8" name="Text 0"/>
+          <p:cNvPr id="9" name="Text 0"/>
           <p:cNvSpPr/>
           <p:nvPr>
-            <p:ph idx="106" type="pic" hasCustomPrompt="1"/>
+            <p:ph idx="107" type="pic" hasCustomPrompt="1"/>
           </p:nvPr>
         </p:nvSpPr>
         <p:spPr>
@@ -7377,10 +7491,10 @@
       </p:sp>
       <p:sp>
         <p:nvSpPr>
-          <p:cNvPr id="9" name="Text 0"/>
+          <p:cNvPr id="10" name="Text 0"/>
           <p:cNvSpPr/>
           <p:nvPr>
-            <p:ph idx="107" type="body" hasCustomPrompt="1"/>
+            <p:ph idx="108" type="body" hasCustomPrompt="1"/>
           </p:nvPr>
         </p:nvSpPr>
         <p:spPr>
@@ -7430,10 +7544,10 @@
       </p:sp>
       <p:sp>
         <p:nvSpPr>
-          <p:cNvPr id="10" name="Text 0"/>
+          <p:cNvPr id="11" name="Text 0"/>
           <p:cNvSpPr/>
           <p:nvPr>
-            <p:ph idx="108" type="pic" hasCustomPrompt="1"/>
+            <p:ph idx="109" type="pic" hasCustomPrompt="1"/>
           </p:nvPr>
         </p:nvSpPr>
         <p:spPr>
@@ -7487,10 +7601,10 @@
       </p:sp>
       <p:sp>
         <p:nvSpPr>
-          <p:cNvPr id="11" name="Text 0"/>
+          <p:cNvPr id="12" name="Text 0"/>
           <p:cNvSpPr/>
           <p:nvPr>
-            <p:ph idx="109" type="body" hasCustomPrompt="1"/>
+            <p:ph idx="110" type="body" hasCustomPrompt="1"/>
           </p:nvPr>
         </p:nvSpPr>
         <p:spPr>
@@ -7540,10 +7654,10 @@
       </p:sp>
       <p:sp>
         <p:nvSpPr>
-          <p:cNvPr id="12" name="Text 0"/>
+          <p:cNvPr id="13" name="Text 0"/>
           <p:cNvSpPr/>
           <p:nvPr>
-            <p:ph idx="110" type="pic" hasCustomPrompt="1"/>
+            <p:ph idx="111" type="pic" hasCustomPrompt="1"/>
           </p:nvPr>
         </p:nvSpPr>
         <p:spPr>
@@ -7597,10 +7711,10 @@
       </p:sp>
       <p:sp>
         <p:nvSpPr>
-          <p:cNvPr id="13" name="Text 0"/>
+          <p:cNvPr id="14" name="Text 0"/>
           <p:cNvSpPr/>
           <p:nvPr>
-            <p:ph idx="111" type="body" hasCustomPrompt="1"/>
+            <p:ph idx="112" type="body" hasCustomPrompt="1"/>
           </p:nvPr>
         </p:nvSpPr>
         <p:spPr>
@@ -7650,10 +7764,10 @@
       </p:sp>
       <p:sp>
         <p:nvSpPr>
-          <p:cNvPr id="14" name="Text 0"/>
+          <p:cNvPr id="15" name="Text 0"/>
           <p:cNvSpPr/>
           <p:nvPr>
-            <p:ph idx="112" type="pic" hasCustomPrompt="1"/>
+            <p:ph idx="113" type="pic" hasCustomPrompt="1"/>
           </p:nvPr>
         </p:nvSpPr>
         <p:spPr>
@@ -7707,10 +7821,10 @@
       </p:sp>
       <p:sp>
         <p:nvSpPr>
-          <p:cNvPr id="15" name="Text 0"/>
+          <p:cNvPr id="16" name="Text 0"/>
           <p:cNvSpPr/>
           <p:nvPr>
-            <p:ph idx="113" type="body" hasCustomPrompt="1"/>
+            <p:ph idx="114" type="body" hasCustomPrompt="1"/>
           </p:nvPr>
         </p:nvSpPr>
         <p:spPr>
@@ -7760,10 +7874,10 @@
       </p:sp>
       <p:sp>
         <p:nvSpPr>
-          <p:cNvPr id="16" name="Text 0"/>
+          <p:cNvPr id="17" name="Text 0"/>
           <p:cNvSpPr/>
           <p:nvPr>
-            <p:ph idx="114" type="pic" hasCustomPrompt="1"/>
+            <p:ph idx="115" type="pic" hasCustomPrompt="1"/>
           </p:nvPr>
         </p:nvSpPr>
         <p:spPr>
@@ -7817,10 +7931,10 @@
       </p:sp>
       <p:sp>
         <p:nvSpPr>
-          <p:cNvPr id="17" name="Text 0"/>
+          <p:cNvPr id="18" name="Text 0"/>
           <p:cNvSpPr/>
           <p:nvPr>
-            <p:ph idx="115" type="body" hasCustomPrompt="1"/>
+            <p:ph idx="116" type="body" hasCustomPrompt="1"/>
           </p:nvPr>
         </p:nvSpPr>
         <p:spPr>
@@ -7870,10 +7984,10 @@
       </p:sp>
       <p:sp>
         <p:nvSpPr>
-          <p:cNvPr id="18" name="Text 0"/>
+          <p:cNvPr id="19" name="Text 0"/>
           <p:cNvSpPr/>
           <p:nvPr>
-            <p:ph idx="116" type="pic" hasCustomPrompt="1"/>
+            <p:ph idx="117" type="pic" hasCustomPrompt="1"/>
           </p:nvPr>
         </p:nvSpPr>
         <p:spPr>
@@ -7927,10 +8041,10 @@
       </p:sp>
       <p:sp>
         <p:nvSpPr>
-          <p:cNvPr id="19" name="Text 0"/>
+          <p:cNvPr id="20" name="Text 0"/>
           <p:cNvSpPr/>
           <p:nvPr>
-            <p:ph idx="117" type="body" hasCustomPrompt="1"/>
+            <p:ph idx="118" type="body" hasCustomPrompt="1"/>
           </p:nvPr>
         </p:nvSpPr>
         <p:spPr>
@@ -7980,7 +8094,7 @@
       </p:sp>
       <p:sp>
         <p:nvSpPr>
-          <p:cNvPr id="20" name="Text 0"/>
+          <p:cNvPr id="21" name="Text 0"/>
           <p:cNvSpPr/>
           <p:nvPr/>
         </p:nvSpPr>
@@ -13575,14 +13689,57 @@
           </a:p>
         </p:txBody>
       </p:sp>
+      <p:sp>
+        <p:nvSpPr>
+          <p:cNvPr id="3" name="Text 0"/>
+          <p:cNvSpPr txBox="1"/>
+          <p:nvPr>
+            <p:ph idx="102" type="body" hasCustomPrompt="1"/>
+          </p:nvPr>
+        </p:nvSpPr>
+        <p:spPr>
+          <a:xfrm>
+            <a:off x="457200" y="914400"/>
+            <a:ext cx="7132320" cy="274320"/>
+          </a:xfrm>
+          <a:prstGeom prst="rect">
+            <a:avLst/>
+          </a:prstGeom>
+          <a:noFill/>
+          <a:ln/>
+        </p:spPr>
+        <p:txBody>
+          <a:bodyPr wrap="square" lIns="0" tIns="0" rIns="0" bIns="0" rtlCol="0" anchor="ctr"/>
+          <a:lstStyle/>
+          <a:p>
+            <a:pPr algn="l" indent="0" marL="0">
+              <a:buNone/>
+            </a:pPr>
+            <a:r>
+              <a:rPr lang="en-US" sz="1200" dirty="0">
+                <a:solidFill>
+                  <a:srgbClr val="0F0F0F">
+                    <a:alpha val="60000"/>
+                  </a:srgbClr>
+                </a:solidFill>
+                <a:latin typeface="Inter" pitchFamily="34" charset="0"/>
+                <a:ea typeface="Inter" pitchFamily="34" charset="-122"/>
+                <a:cs typeface="Inter" pitchFamily="34" charset="-120"/>
+              </a:rPr>
+              <a:t>Eine Auswahl. Viele weitere Unternehmen und Teams aus der Region lassen bei uns veredeln.</a:t>
+            </a:r>
+            <a:endParaRPr lang="en-US" sz="1200" dirty="0"/>
+          </a:p>
+        </p:txBody>
+      </p:sp>
       <p:pic>
         <p:nvPicPr>
-          <p:cNvPr id="3" name="Image 0" descr="/var/folders/hm/sgq6d80d0vq133k7n8dc9bnw0000gn/T/maiershirts-Os5V18/ref-unternehmen-0-0.png">    </p:cNvPr>
+          <p:cNvPr id="4" name="Image 0" descr="/var/folders/hm/sgq6d80d0vq133k7n8dc9bnw0000gn/T/maiershirts-fAJE9f/ref-unternehmen-0-0.png">    </p:cNvPr>
           <p:cNvPicPr>
             <a:picLocks noChangeAspect="1"/>
           </p:cNvPicPr>
           <p:nvPr>
-            <p:ph idx="102" type="pic" hasCustomPrompt="1"/>
+            <p:ph idx="103" type="pic" hasCustomPrompt="1"/>
           </p:nvPr>
         </p:nvPicPr>
         <p:blipFill>
@@ -13603,12 +13760,12 @@
       </p:pic>
       <p:pic>
         <p:nvPicPr>
-          <p:cNvPr id="4" name="Image 1" descr="/var/folders/hm/sgq6d80d0vq133k7n8dc9bnw0000gn/T/maiershirts-Os5V18/ref-unternehmen-0-1.png">    </p:cNvPr>
+          <p:cNvPr id="5" name="Image 1" descr="/var/folders/hm/sgq6d80d0vq133k7n8dc9bnw0000gn/T/maiershirts-fAJE9f/ref-unternehmen-0-1.png">    </p:cNvPr>
           <p:cNvPicPr>
             <a:picLocks noChangeAspect="1"/>
           </p:cNvPicPr>
           <p:nvPr>
-            <p:ph idx="103" type="pic" hasCustomPrompt="1"/>
+            <p:ph idx="104" type="pic" hasCustomPrompt="1"/>
           </p:nvPr>
         </p:nvPicPr>
         <p:blipFill>
@@ -13629,12 +13786,12 @@
       </p:pic>
       <p:pic>
         <p:nvPicPr>
-          <p:cNvPr id="5" name="Image 2" descr="/var/folders/hm/sgq6d80d0vq133k7n8dc9bnw0000gn/T/maiershirts-Os5V18/ref-unternehmen-0-2.png">    </p:cNvPr>
+          <p:cNvPr id="6" name="Image 2" descr="/var/folders/hm/sgq6d80d0vq133k7n8dc9bnw0000gn/T/maiershirts-fAJE9f/ref-unternehmen-0-2.png">    </p:cNvPr>
           <p:cNvPicPr>
             <a:picLocks noChangeAspect="1"/>
           </p:cNvPicPr>
           <p:nvPr>
-            <p:ph idx="104" type="pic" hasCustomPrompt="1"/>
+            <p:ph idx="105" type="pic" hasCustomPrompt="1"/>
           </p:nvPr>
         </p:nvPicPr>
         <p:blipFill>
@@ -13655,12 +13812,12 @@
       </p:pic>
       <p:pic>
         <p:nvPicPr>
-          <p:cNvPr id="6" name="Image 3" descr="/var/folders/hm/sgq6d80d0vq133k7n8dc9bnw0000gn/T/maiershirts-Os5V18/ref-unternehmen-0-3.png">    </p:cNvPr>
+          <p:cNvPr id="7" name="Image 3" descr="/var/folders/hm/sgq6d80d0vq133k7n8dc9bnw0000gn/T/maiershirts-fAJE9f/ref-unternehmen-0-3.png">    </p:cNvPr>
           <p:cNvPicPr>
             <a:picLocks noChangeAspect="1"/>
           </p:cNvPicPr>
           <p:nvPr>
-            <p:ph idx="105" type="pic" hasCustomPrompt="1"/>
+            <p:ph idx="106" type="pic" hasCustomPrompt="1"/>
           </p:nvPr>
         </p:nvPicPr>
         <p:blipFill>
@@ -13681,12 +13838,12 @@
       </p:pic>
       <p:pic>
         <p:nvPicPr>
-          <p:cNvPr id="7" name="Image 4" descr="/var/folders/hm/sgq6d80d0vq133k7n8dc9bnw0000gn/T/maiershirts-Os5V18/ref-unternehmen-0-4.png">    </p:cNvPr>
+          <p:cNvPr id="8" name="Image 4" descr="/var/folders/hm/sgq6d80d0vq133k7n8dc9bnw0000gn/T/maiershirts-fAJE9f/ref-unternehmen-0-4.png">    </p:cNvPr>
           <p:cNvPicPr>
             <a:picLocks noChangeAspect="1"/>
           </p:cNvPicPr>
           <p:nvPr>
-            <p:ph idx="106" type="pic" hasCustomPrompt="1"/>
+            <p:ph idx="107" type="pic" hasCustomPrompt="1"/>
           </p:nvPr>
         </p:nvPicPr>
         <p:blipFill>
@@ -13707,12 +13864,12 @@
       </p:pic>
       <p:pic>
         <p:nvPicPr>
-          <p:cNvPr id="8" name="Image 5" descr="/var/folders/hm/sgq6d80d0vq133k7n8dc9bnw0000gn/T/maiershirts-Os5V18/ref-unternehmen-0-5.png">    </p:cNvPr>
+          <p:cNvPr id="9" name="Image 5" descr="/var/folders/hm/sgq6d80d0vq133k7n8dc9bnw0000gn/T/maiershirts-fAJE9f/ref-unternehmen-0-5.png">    </p:cNvPr>
           <p:cNvPicPr>
             <a:picLocks noChangeAspect="1"/>
           </p:cNvPicPr>
           <p:nvPr>
-            <p:ph idx="107" type="pic" hasCustomPrompt="1"/>
+            <p:ph idx="108" type="pic" hasCustomPrompt="1"/>
           </p:nvPr>
         </p:nvPicPr>
         <p:blipFill>
@@ -13733,12 +13890,12 @@
       </p:pic>
       <p:pic>
         <p:nvPicPr>
-          <p:cNvPr id="9" name="Image 6" descr="/var/folders/hm/sgq6d80d0vq133k7n8dc9bnw0000gn/T/maiershirts-Os5V18/ref-unternehmen-0-6.png">    </p:cNvPr>
+          <p:cNvPr id="10" name="Image 6" descr="/var/folders/hm/sgq6d80d0vq133k7n8dc9bnw0000gn/T/maiershirts-fAJE9f/ref-unternehmen-0-6.png">    </p:cNvPr>
           <p:cNvPicPr>
             <a:picLocks noChangeAspect="1"/>
           </p:cNvPicPr>
           <p:nvPr>
-            <p:ph idx="108" type="pic" hasCustomPrompt="1"/>
+            <p:ph idx="109" type="pic" hasCustomPrompt="1"/>
           </p:nvPr>
         </p:nvPicPr>
         <p:blipFill>
@@ -13759,12 +13916,12 @@
       </p:pic>
       <p:pic>
         <p:nvPicPr>
-          <p:cNvPr id="10" name="Image 7" descr="/var/folders/hm/sgq6d80d0vq133k7n8dc9bnw0000gn/T/maiershirts-Os5V18/ref-unternehmen-0-7.png">    </p:cNvPr>
+          <p:cNvPr id="11" name="Image 7" descr="/var/folders/hm/sgq6d80d0vq133k7n8dc9bnw0000gn/T/maiershirts-fAJE9f/ref-unternehmen-0-7.png">    </p:cNvPr>
           <p:cNvPicPr>
             <a:picLocks noChangeAspect="1"/>
           </p:cNvPicPr>
           <p:nvPr>
-            <p:ph idx="109" type="pic" hasCustomPrompt="1"/>
+            <p:ph idx="110" type="pic" hasCustomPrompt="1"/>
           </p:nvPr>
         </p:nvPicPr>
         <p:blipFill>
@@ -13785,12 +13942,12 @@
       </p:pic>
       <p:pic>
         <p:nvPicPr>
-          <p:cNvPr id="11" name="Image 8" descr="/var/folders/hm/sgq6d80d0vq133k7n8dc9bnw0000gn/T/maiershirts-Os5V18/ref-unternehmen-0-8.png">    </p:cNvPr>
+          <p:cNvPr id="12" name="Image 8" descr="/var/folders/hm/sgq6d80d0vq133k7n8dc9bnw0000gn/T/maiershirts-fAJE9f/ref-unternehmen-0-8.png">    </p:cNvPr>
           <p:cNvPicPr>
             <a:picLocks noChangeAspect="1"/>
           </p:cNvPicPr>
           <p:nvPr>
-            <p:ph idx="110" type="pic" hasCustomPrompt="1"/>
+            <p:ph idx="111" type="pic" hasCustomPrompt="1"/>
           </p:nvPr>
         </p:nvPicPr>
         <p:blipFill>
@@ -13811,12 +13968,12 @@
       </p:pic>
       <p:pic>
         <p:nvPicPr>
-          <p:cNvPr id="12" name="Image 9" descr="/var/folders/hm/sgq6d80d0vq133k7n8dc9bnw0000gn/T/maiershirts-Os5V18/ref-unternehmen-0-9.png">    </p:cNvPr>
+          <p:cNvPr id="13" name="Image 9" descr="/var/folders/hm/sgq6d80d0vq133k7n8dc9bnw0000gn/T/maiershirts-fAJE9f/ref-unternehmen-0-9.png">    </p:cNvPr>
           <p:cNvPicPr>
             <a:picLocks noChangeAspect="1"/>
           </p:cNvPicPr>
           <p:nvPr>
-            <p:ph idx="111" type="pic" hasCustomPrompt="1"/>
+            <p:ph idx="112" type="pic" hasCustomPrompt="1"/>
           </p:nvPr>
         </p:nvPicPr>
         <p:blipFill>
@@ -13837,12 +13994,12 @@
       </p:pic>
       <p:pic>
         <p:nvPicPr>
-          <p:cNvPr id="13" name="Image 10" descr="/var/folders/hm/sgq6d80d0vq133k7n8dc9bnw0000gn/T/maiershirts-Os5V18/ref-unternehmen-0-10.png">    </p:cNvPr>
+          <p:cNvPr id="14" name="Image 10" descr="/var/folders/hm/sgq6d80d0vq133k7n8dc9bnw0000gn/T/maiershirts-fAJE9f/ref-unternehmen-0-10.png">    </p:cNvPr>
           <p:cNvPicPr>
             <a:picLocks noChangeAspect="1"/>
           </p:cNvPicPr>
           <p:nvPr>
-            <p:ph idx="112" type="pic" hasCustomPrompt="1"/>
+            <p:ph idx="113" type="pic" hasCustomPrompt="1"/>
           </p:nvPr>
         </p:nvPicPr>
         <p:blipFill>
@@ -13863,12 +14020,12 @@
       </p:pic>
       <p:pic>
         <p:nvPicPr>
-          <p:cNvPr id="14" name="Image 11" descr="/var/folders/hm/sgq6d80d0vq133k7n8dc9bnw0000gn/T/maiershirts-Os5V18/ref-unternehmen-0-11.png">    </p:cNvPr>
+          <p:cNvPr id="15" name="Image 11" descr="/var/folders/hm/sgq6d80d0vq133k7n8dc9bnw0000gn/T/maiershirts-fAJE9f/ref-unternehmen-0-11.png">    </p:cNvPr>
           <p:cNvPicPr>
             <a:picLocks noChangeAspect="1"/>
           </p:cNvPicPr>
           <p:nvPr>
-            <p:ph idx="113" type="pic" hasCustomPrompt="1"/>
+            <p:ph idx="114" type="pic" hasCustomPrompt="1"/>
           </p:nvPr>
         </p:nvPicPr>
         <p:blipFill>
@@ -14001,14 +14158,57 @@
           </a:p>
         </p:txBody>
       </p:sp>
+      <p:sp>
+        <p:nvSpPr>
+          <p:cNvPr id="3" name="Text 0"/>
+          <p:cNvSpPr txBox="1"/>
+          <p:nvPr>
+            <p:ph idx="102" type="body" hasCustomPrompt="1"/>
+          </p:nvPr>
+        </p:nvSpPr>
+        <p:spPr>
+          <a:xfrm>
+            <a:off x="457200" y="914400"/>
+            <a:ext cx="7132320" cy="274320"/>
+          </a:xfrm>
+          <a:prstGeom prst="rect">
+            <a:avLst/>
+          </a:prstGeom>
+          <a:noFill/>
+          <a:ln/>
+        </p:spPr>
+        <p:txBody>
+          <a:bodyPr wrap="square" lIns="0" tIns="0" rIns="0" bIns="0" rtlCol="0" anchor="ctr"/>
+          <a:lstStyle/>
+          <a:p>
+            <a:pPr algn="l" indent="0" marL="0">
+              <a:buNone/>
+            </a:pPr>
+            <a:r>
+              <a:rPr lang="en-US" sz="1200" dirty="0">
+                <a:solidFill>
+                  <a:srgbClr val="0F0F0F">
+                    <a:alpha val="60000"/>
+                  </a:srgbClr>
+                </a:solidFill>
+                <a:latin typeface="Inter" pitchFamily="34" charset="0"/>
+                <a:ea typeface="Inter" pitchFamily="34" charset="-122"/>
+                <a:cs typeface="Inter" pitchFamily="34" charset="-120"/>
+              </a:rPr>
+              <a:t>Eine Auswahl. Viele weitere Unternehmen und Teams aus der Region lassen bei uns veredeln.</a:t>
+            </a:r>
+            <a:endParaRPr lang="en-US" sz="1200" dirty="0"/>
+          </a:p>
+        </p:txBody>
+      </p:sp>
       <p:pic>
         <p:nvPicPr>
-          <p:cNvPr id="3" name="Image 0" descr="/var/folders/hm/sgq6d80d0vq133k7n8dc9bnw0000gn/T/maiershirts-Os5V18/ref-unternehmen-1-0.png">    </p:cNvPr>
+          <p:cNvPr id="4" name="Image 0" descr="/var/folders/hm/sgq6d80d0vq133k7n8dc9bnw0000gn/T/maiershirts-fAJE9f/ref-unternehmen-1-0.png">    </p:cNvPr>
           <p:cNvPicPr>
             <a:picLocks noChangeAspect="1"/>
           </p:cNvPicPr>
           <p:nvPr>
-            <p:ph idx="102" type="pic" hasCustomPrompt="1"/>
+            <p:ph idx="103" type="pic" hasCustomPrompt="1"/>
           </p:nvPr>
         </p:nvPicPr>
         <p:blipFill>
@@ -14029,12 +14229,12 @@
       </p:pic>
       <p:pic>
         <p:nvPicPr>
-          <p:cNvPr id="4" name="Image 1" descr="/var/folders/hm/sgq6d80d0vq133k7n8dc9bnw0000gn/T/maiershirts-Os5V18/ph-logo-446x194.png">    </p:cNvPr>
+          <p:cNvPr id="5" name="Image 1" descr="/var/folders/hm/sgq6d80d0vq133k7n8dc9bnw0000gn/T/maiershirts-fAJE9f/ph-logo-446x194.png">    </p:cNvPr>
           <p:cNvPicPr>
             <a:picLocks noChangeAspect="1"/>
           </p:cNvPicPr>
           <p:nvPr>
-            <p:ph idx="103" type="pic" hasCustomPrompt="1"/>
+            <p:ph idx="104" type="pic" hasCustomPrompt="1"/>
           </p:nvPr>
         </p:nvPicPr>
         <p:blipFill>
@@ -14055,12 +14255,12 @@
       </p:pic>
       <p:pic>
         <p:nvPicPr>
-          <p:cNvPr id="5" name="Image 2" descr="/var/folders/hm/sgq6d80d0vq133k7n8dc9bnw0000gn/T/maiershirts-Os5V18/ph-logo-446x194.png">    </p:cNvPr>
+          <p:cNvPr id="6" name="Image 2" descr="/var/folders/hm/sgq6d80d0vq133k7n8dc9bnw0000gn/T/maiershirts-fAJE9f/ph-logo-446x194.png">    </p:cNvPr>
           <p:cNvPicPr>
             <a:picLocks noChangeAspect="1"/>
           </p:cNvPicPr>
           <p:nvPr>
-            <p:ph idx="104" type="pic" hasCustomPrompt="1"/>
+            <p:ph idx="105" type="pic" hasCustomPrompt="1"/>
           </p:nvPr>
         </p:nvPicPr>
         <p:blipFill>
@@ -14081,12 +14281,12 @@
       </p:pic>
       <p:pic>
         <p:nvPicPr>
-          <p:cNvPr id="6" name="Image 3" descr="/var/folders/hm/sgq6d80d0vq133k7n8dc9bnw0000gn/T/maiershirts-Os5V18/ph-logo-446x194.png">    </p:cNvPr>
+          <p:cNvPr id="7" name="Image 3" descr="/var/folders/hm/sgq6d80d0vq133k7n8dc9bnw0000gn/T/maiershirts-fAJE9f/ph-logo-446x194.png">    </p:cNvPr>
           <p:cNvPicPr>
             <a:picLocks noChangeAspect="1"/>
           </p:cNvPicPr>
           <p:nvPr>
-            <p:ph idx="105" type="pic" hasCustomPrompt="1"/>
+            <p:ph idx="106" type="pic" hasCustomPrompt="1"/>
           </p:nvPr>
         </p:nvPicPr>
         <p:blipFill>
@@ -14107,12 +14307,12 @@
       </p:pic>
       <p:pic>
         <p:nvPicPr>
-          <p:cNvPr id="7" name="Image 4" descr="/var/folders/hm/sgq6d80d0vq133k7n8dc9bnw0000gn/T/maiershirts-Os5V18/ph-logo-446x194.png">    </p:cNvPr>
+          <p:cNvPr id="8" name="Image 4" descr="/var/folders/hm/sgq6d80d0vq133k7n8dc9bnw0000gn/T/maiershirts-fAJE9f/ph-logo-446x194.png">    </p:cNvPr>
           <p:cNvPicPr>
             <a:picLocks noChangeAspect="1"/>
           </p:cNvPicPr>
           <p:nvPr>
-            <p:ph idx="106" type="pic" hasCustomPrompt="1"/>
+            <p:ph idx="107" type="pic" hasCustomPrompt="1"/>
           </p:nvPr>
         </p:nvPicPr>
         <p:blipFill>
@@ -14133,12 +14333,12 @@
       </p:pic>
       <p:pic>
         <p:nvPicPr>
-          <p:cNvPr id="8" name="Image 5" descr="/var/folders/hm/sgq6d80d0vq133k7n8dc9bnw0000gn/T/maiershirts-Os5V18/ph-logo-446x194.png">    </p:cNvPr>
+          <p:cNvPr id="9" name="Image 5" descr="/var/folders/hm/sgq6d80d0vq133k7n8dc9bnw0000gn/T/maiershirts-fAJE9f/ph-logo-446x194.png">    </p:cNvPr>
           <p:cNvPicPr>
             <a:picLocks noChangeAspect="1"/>
           </p:cNvPicPr>
           <p:nvPr>
-            <p:ph idx="107" type="pic" hasCustomPrompt="1"/>
+            <p:ph idx="108" type="pic" hasCustomPrompt="1"/>
           </p:nvPr>
         </p:nvPicPr>
         <p:blipFill>
@@ -14159,12 +14359,12 @@
       </p:pic>
       <p:pic>
         <p:nvPicPr>
-          <p:cNvPr id="9" name="Image 6" descr="/var/folders/hm/sgq6d80d0vq133k7n8dc9bnw0000gn/T/maiershirts-Os5V18/ph-logo-446x194.png">    </p:cNvPr>
+          <p:cNvPr id="10" name="Image 6" descr="/var/folders/hm/sgq6d80d0vq133k7n8dc9bnw0000gn/T/maiershirts-fAJE9f/ph-logo-446x194.png">    </p:cNvPr>
           <p:cNvPicPr>
             <a:picLocks noChangeAspect="1"/>
           </p:cNvPicPr>
           <p:nvPr>
-            <p:ph idx="108" type="pic" hasCustomPrompt="1"/>
+            <p:ph idx="109" type="pic" hasCustomPrompt="1"/>
           </p:nvPr>
         </p:nvPicPr>
         <p:blipFill>
@@ -14185,12 +14385,12 @@
       </p:pic>
       <p:pic>
         <p:nvPicPr>
-          <p:cNvPr id="10" name="Image 7" descr="/var/folders/hm/sgq6d80d0vq133k7n8dc9bnw0000gn/T/maiershirts-Os5V18/ph-logo-446x194.png">    </p:cNvPr>
+          <p:cNvPr id="11" name="Image 7" descr="/var/folders/hm/sgq6d80d0vq133k7n8dc9bnw0000gn/T/maiershirts-fAJE9f/ph-logo-446x194.png">    </p:cNvPr>
           <p:cNvPicPr>
             <a:picLocks noChangeAspect="1"/>
           </p:cNvPicPr>
           <p:nvPr>
-            <p:ph idx="109" type="pic" hasCustomPrompt="1"/>
+            <p:ph idx="110" type="pic" hasCustomPrompt="1"/>
           </p:nvPr>
         </p:nvPicPr>
         <p:blipFill>
@@ -14211,12 +14411,12 @@
       </p:pic>
       <p:pic>
         <p:nvPicPr>
-          <p:cNvPr id="11" name="Image 8" descr="/var/folders/hm/sgq6d80d0vq133k7n8dc9bnw0000gn/T/maiershirts-Os5V18/ph-logo-446x194.png">    </p:cNvPr>
+          <p:cNvPr id="12" name="Image 8" descr="/var/folders/hm/sgq6d80d0vq133k7n8dc9bnw0000gn/T/maiershirts-fAJE9f/ph-logo-446x194.png">    </p:cNvPr>
           <p:cNvPicPr>
             <a:picLocks noChangeAspect="1"/>
           </p:cNvPicPr>
           <p:nvPr>
-            <p:ph idx="110" type="pic" hasCustomPrompt="1"/>
+            <p:ph idx="111" type="pic" hasCustomPrompt="1"/>
           </p:nvPr>
         </p:nvPicPr>
         <p:blipFill>
@@ -14237,12 +14437,12 @@
       </p:pic>
       <p:pic>
         <p:nvPicPr>
-          <p:cNvPr id="12" name="Image 9" descr="/var/folders/hm/sgq6d80d0vq133k7n8dc9bnw0000gn/T/maiershirts-Os5V18/ph-logo-446x194.png">    </p:cNvPr>
+          <p:cNvPr id="13" name="Image 9" descr="/var/folders/hm/sgq6d80d0vq133k7n8dc9bnw0000gn/T/maiershirts-fAJE9f/ph-logo-446x194.png">    </p:cNvPr>
           <p:cNvPicPr>
             <a:picLocks noChangeAspect="1"/>
           </p:cNvPicPr>
           <p:nvPr>
-            <p:ph idx="111" type="pic" hasCustomPrompt="1"/>
+            <p:ph idx="112" type="pic" hasCustomPrompt="1"/>
           </p:nvPr>
         </p:nvPicPr>
         <p:blipFill>
@@ -14263,12 +14463,12 @@
       </p:pic>
       <p:pic>
         <p:nvPicPr>
-          <p:cNvPr id="13" name="Image 10" descr="/var/folders/hm/sgq6d80d0vq133k7n8dc9bnw0000gn/T/maiershirts-Os5V18/ph-logo-446x194.png">    </p:cNvPr>
+          <p:cNvPr id="14" name="Image 10" descr="/var/folders/hm/sgq6d80d0vq133k7n8dc9bnw0000gn/T/maiershirts-fAJE9f/ph-logo-446x194.png">    </p:cNvPr>
           <p:cNvPicPr>
             <a:picLocks noChangeAspect="1"/>
           </p:cNvPicPr>
           <p:nvPr>
-            <p:ph idx="112" type="pic" hasCustomPrompt="1"/>
+            <p:ph idx="113" type="pic" hasCustomPrompt="1"/>
           </p:nvPr>
         </p:nvPicPr>
         <p:blipFill>
@@ -14289,12 +14489,12 @@
       </p:pic>
       <p:pic>
         <p:nvPicPr>
-          <p:cNvPr id="14" name="Image 11" descr="/var/folders/hm/sgq6d80d0vq133k7n8dc9bnw0000gn/T/maiershirts-Os5V18/ph-logo-446x194.png">    </p:cNvPr>
+          <p:cNvPr id="15" name="Image 11" descr="/var/folders/hm/sgq6d80d0vq133k7n8dc9bnw0000gn/T/maiershirts-fAJE9f/ph-logo-446x194.png">    </p:cNvPr>
           <p:cNvPicPr>
             <a:picLocks noChangeAspect="1"/>
           </p:cNvPicPr>
           <p:nvPr>
-            <p:ph idx="113" type="pic" hasCustomPrompt="1"/>
+            <p:ph idx="114" type="pic" hasCustomPrompt="1"/>
           </p:nvPr>
         </p:nvPicPr>
         <p:blipFill>
@@ -14427,14 +14627,57 @@
           </a:p>
         </p:txBody>
       </p:sp>
+      <p:sp>
+        <p:nvSpPr>
+          <p:cNvPr id="3" name="Text 0"/>
+          <p:cNvSpPr txBox="1"/>
+          <p:nvPr>
+            <p:ph idx="102" type="body" hasCustomPrompt="1"/>
+          </p:nvPr>
+        </p:nvSpPr>
+        <p:spPr>
+          <a:xfrm>
+            <a:off x="457200" y="914400"/>
+            <a:ext cx="7132320" cy="274320"/>
+          </a:xfrm>
+          <a:prstGeom prst="rect">
+            <a:avLst/>
+          </a:prstGeom>
+          <a:noFill/>
+          <a:ln/>
+        </p:spPr>
+        <p:txBody>
+          <a:bodyPr wrap="square" lIns="0" tIns="0" rIns="0" bIns="0" rtlCol="0" anchor="ctr"/>
+          <a:lstStyle/>
+          <a:p>
+            <a:pPr algn="l" indent="0" marL="0">
+              <a:buNone/>
+            </a:pPr>
+            <a:r>
+              <a:rPr lang="en-US" sz="1200" dirty="0">
+                <a:solidFill>
+                  <a:srgbClr val="0F0F0F">
+                    <a:alpha val="60000"/>
+                  </a:srgbClr>
+                </a:solidFill>
+                <a:latin typeface="Inter" pitchFamily="34" charset="0"/>
+                <a:ea typeface="Inter" pitchFamily="34" charset="-122"/>
+                <a:cs typeface="Inter" pitchFamily="34" charset="-120"/>
+              </a:rPr>
+              <a:t>Eine Auswahl. Vom Trikotsatz bis zur Fanausstattung, für Vereine aus der ganzen Region.</a:t>
+            </a:r>
+            <a:endParaRPr lang="en-US" sz="1200" dirty="0"/>
+          </a:p>
+        </p:txBody>
+      </p:sp>
       <p:pic>
         <p:nvPicPr>
-          <p:cNvPr id="3" name="Image 0" descr="/var/folders/hm/sgq6d80d0vq133k7n8dc9bnw0000gn/T/maiershirts-Os5V18/ref-vereine-0-0.png">    </p:cNvPr>
+          <p:cNvPr id="4" name="Image 0" descr="/var/folders/hm/sgq6d80d0vq133k7n8dc9bnw0000gn/T/maiershirts-fAJE9f/ref-vereine-0-0.png">    </p:cNvPr>
           <p:cNvPicPr>
             <a:picLocks noChangeAspect="1"/>
           </p:cNvPicPr>
           <p:nvPr>
-            <p:ph idx="102" type="pic" hasCustomPrompt="1"/>
+            <p:ph idx="103" type="pic" hasCustomPrompt="1"/>
           </p:nvPr>
         </p:nvPicPr>
         <p:blipFill>
@@ -14455,10 +14698,10 @@
       </p:pic>
       <p:sp>
         <p:nvSpPr>
-          <p:cNvPr id="4" name="Text 0"/>
+          <p:cNvPr id="5" name="Text 0"/>
           <p:cNvSpPr txBox="1"/>
           <p:nvPr>
-            <p:ph idx="103" type="body" hasCustomPrompt="1"/>
+            <p:ph idx="104" type="body" hasCustomPrompt="1"/>
           </p:nvPr>
         </p:nvSpPr>
         <p:spPr>
@@ -14496,12 +14739,12 @@
       </p:sp>
       <p:pic>
         <p:nvPicPr>
-          <p:cNvPr id="5" name="Image 1" descr="/var/folders/hm/sgq6d80d0vq133k7n8dc9bnw0000gn/T/maiershirts-Os5V18/ref-vereine-0-1.png">    </p:cNvPr>
+          <p:cNvPr id="6" name="Image 1" descr="/var/folders/hm/sgq6d80d0vq133k7n8dc9bnw0000gn/T/maiershirts-fAJE9f/ref-vereine-0-1.png">    </p:cNvPr>
           <p:cNvPicPr>
             <a:picLocks noChangeAspect="1"/>
           </p:cNvPicPr>
           <p:nvPr>
-            <p:ph idx="104" type="pic" hasCustomPrompt="1"/>
+            <p:ph idx="105" type="pic" hasCustomPrompt="1"/>
           </p:nvPr>
         </p:nvPicPr>
         <p:blipFill>
@@ -14522,10 +14765,10 @@
       </p:pic>
       <p:sp>
         <p:nvSpPr>
-          <p:cNvPr id="6" name="Text 0"/>
+          <p:cNvPr id="7" name="Text 0"/>
           <p:cNvSpPr txBox="1"/>
           <p:nvPr>
-            <p:ph idx="105" type="body" hasCustomPrompt="1"/>
+            <p:ph idx="106" type="body" hasCustomPrompt="1"/>
           </p:nvPr>
         </p:nvSpPr>
         <p:spPr>
@@ -14563,12 +14806,12 @@
       </p:sp>
       <p:pic>
         <p:nvPicPr>
-          <p:cNvPr id="7" name="Image 2" descr="/var/folders/hm/sgq6d80d0vq133k7n8dc9bnw0000gn/T/maiershirts-Os5V18/ref-vereine-0-2.png">    </p:cNvPr>
+          <p:cNvPr id="8" name="Image 2" descr="/var/folders/hm/sgq6d80d0vq133k7n8dc9bnw0000gn/T/maiershirts-fAJE9f/ref-vereine-0-2.png">    </p:cNvPr>
           <p:cNvPicPr>
             <a:picLocks noChangeAspect="1"/>
           </p:cNvPicPr>
           <p:nvPr>
-            <p:ph idx="106" type="pic" hasCustomPrompt="1"/>
+            <p:ph idx="107" type="pic" hasCustomPrompt="1"/>
           </p:nvPr>
         </p:nvPicPr>
         <p:blipFill>
@@ -14589,10 +14832,10 @@
       </p:pic>
       <p:sp>
         <p:nvSpPr>
-          <p:cNvPr id="8" name="Text 0"/>
+          <p:cNvPr id="9" name="Text 0"/>
           <p:cNvSpPr txBox="1"/>
           <p:nvPr>
-            <p:ph idx="107" type="body" hasCustomPrompt="1"/>
+            <p:ph idx="108" type="body" hasCustomPrompt="1"/>
           </p:nvPr>
         </p:nvSpPr>
         <p:spPr>
@@ -14630,12 +14873,12 @@
       </p:sp>
       <p:pic>
         <p:nvPicPr>
-          <p:cNvPr id="9" name="Image 3" descr="/var/folders/hm/sgq6d80d0vq133k7n8dc9bnw0000gn/T/maiershirts-Os5V18/ref-vereine-0-3.png">    </p:cNvPr>
+          <p:cNvPr id="10" name="Image 3" descr="/var/folders/hm/sgq6d80d0vq133k7n8dc9bnw0000gn/T/maiershirts-fAJE9f/ref-vereine-0-3.png">    </p:cNvPr>
           <p:cNvPicPr>
             <a:picLocks noChangeAspect="1"/>
           </p:cNvPicPr>
           <p:nvPr>
-            <p:ph idx="108" type="pic" hasCustomPrompt="1"/>
+            <p:ph idx="109" type="pic" hasCustomPrompt="1"/>
           </p:nvPr>
         </p:nvPicPr>
         <p:blipFill>
@@ -14656,10 +14899,10 @@
       </p:pic>
       <p:sp>
         <p:nvSpPr>
-          <p:cNvPr id="10" name="Text 0"/>
+          <p:cNvPr id="11" name="Text 0"/>
           <p:cNvSpPr txBox="1"/>
           <p:nvPr>
-            <p:ph idx="109" type="body" hasCustomPrompt="1"/>
+            <p:ph idx="110" type="body" hasCustomPrompt="1"/>
           </p:nvPr>
         </p:nvSpPr>
         <p:spPr>
@@ -14697,12 +14940,12 @@
       </p:sp>
       <p:pic>
         <p:nvPicPr>
-          <p:cNvPr id="11" name="Image 4" descr="/var/folders/hm/sgq6d80d0vq133k7n8dc9bnw0000gn/T/maiershirts-Os5V18/ref-vereine-0-4.png">    </p:cNvPr>
+          <p:cNvPr id="12" name="Image 4" descr="/var/folders/hm/sgq6d80d0vq133k7n8dc9bnw0000gn/T/maiershirts-fAJE9f/ref-vereine-0-4.png">    </p:cNvPr>
           <p:cNvPicPr>
             <a:picLocks noChangeAspect="1"/>
           </p:cNvPicPr>
           <p:nvPr>
-            <p:ph idx="110" type="pic" hasCustomPrompt="1"/>
+            <p:ph idx="111" type="pic" hasCustomPrompt="1"/>
           </p:nvPr>
         </p:nvPicPr>
         <p:blipFill>
@@ -14723,10 +14966,10 @@
       </p:pic>
       <p:sp>
         <p:nvSpPr>
-          <p:cNvPr id="12" name="Text 0"/>
+          <p:cNvPr id="13" name="Text 0"/>
           <p:cNvSpPr txBox="1"/>
           <p:nvPr>
-            <p:ph idx="111" type="body" hasCustomPrompt="1"/>
+            <p:ph idx="112" type="body" hasCustomPrompt="1"/>
           </p:nvPr>
         </p:nvSpPr>
         <p:spPr>
@@ -14764,12 +15007,12 @@
       </p:sp>
       <p:pic>
         <p:nvPicPr>
-          <p:cNvPr id="13" name="Image 5" descr="/var/folders/hm/sgq6d80d0vq133k7n8dc9bnw0000gn/T/maiershirts-Os5V18/ref-vereine-0-5.png">    </p:cNvPr>
+          <p:cNvPr id="14" name="Image 5" descr="/var/folders/hm/sgq6d80d0vq133k7n8dc9bnw0000gn/T/maiershirts-fAJE9f/ref-vereine-0-5.png">    </p:cNvPr>
           <p:cNvPicPr>
             <a:picLocks noChangeAspect="1"/>
           </p:cNvPicPr>
           <p:nvPr>
-            <p:ph idx="112" type="pic" hasCustomPrompt="1"/>
+            <p:ph idx="113" type="pic" hasCustomPrompt="1"/>
           </p:nvPr>
         </p:nvPicPr>
         <p:blipFill>
@@ -14790,10 +15033,10 @@
       </p:pic>
       <p:sp>
         <p:nvSpPr>
-          <p:cNvPr id="14" name="Text 0"/>
+          <p:cNvPr id="15" name="Text 0"/>
           <p:cNvSpPr txBox="1"/>
           <p:nvPr>
-            <p:ph idx="113" type="body" hasCustomPrompt="1"/>
+            <p:ph idx="114" type="body" hasCustomPrompt="1"/>
           </p:nvPr>
         </p:nvSpPr>
         <p:spPr>
@@ -14831,12 +15074,12 @@
       </p:sp>
       <p:pic>
         <p:nvPicPr>
-          <p:cNvPr id="15" name="Image 6" descr="/var/folders/hm/sgq6d80d0vq133k7n8dc9bnw0000gn/T/maiershirts-Os5V18/ref-vereine-0-6.png">    </p:cNvPr>
+          <p:cNvPr id="16" name="Image 6" descr="/var/folders/hm/sgq6d80d0vq133k7n8dc9bnw0000gn/T/maiershirts-fAJE9f/ref-vereine-0-6.png">    </p:cNvPr>
           <p:cNvPicPr>
             <a:picLocks noChangeAspect="1"/>
           </p:cNvPicPr>
           <p:nvPr>
-            <p:ph idx="114" type="pic" hasCustomPrompt="1"/>
+            <p:ph idx="115" type="pic" hasCustomPrompt="1"/>
           </p:nvPr>
         </p:nvPicPr>
         <p:blipFill>
@@ -14857,10 +15100,10 @@
       </p:pic>
       <p:sp>
         <p:nvSpPr>
-          <p:cNvPr id="16" name="Text 0"/>
+          <p:cNvPr id="17" name="Text 0"/>
           <p:cNvSpPr txBox="1"/>
           <p:nvPr>
-            <p:ph idx="115" type="body" hasCustomPrompt="1"/>
+            <p:ph idx="116" type="body" hasCustomPrompt="1"/>
           </p:nvPr>
         </p:nvSpPr>
         <p:spPr>
@@ -14898,12 +15141,12 @@
       </p:sp>
       <p:pic>
         <p:nvPicPr>
-          <p:cNvPr id="17" name="Image 7" descr="/var/folders/hm/sgq6d80d0vq133k7n8dc9bnw0000gn/T/maiershirts-Os5V18/ref-vereine-0-7.png">    </p:cNvPr>
+          <p:cNvPr id="18" name="Image 7" descr="/var/folders/hm/sgq6d80d0vq133k7n8dc9bnw0000gn/T/maiershirts-fAJE9f/ref-vereine-0-7.png">    </p:cNvPr>
           <p:cNvPicPr>
             <a:picLocks noChangeAspect="1"/>
           </p:cNvPicPr>
           <p:nvPr>
-            <p:ph idx="116" type="pic" hasCustomPrompt="1"/>
+            <p:ph idx="117" type="pic" hasCustomPrompt="1"/>
           </p:nvPr>
         </p:nvPicPr>
         <p:blipFill>
@@ -14924,10 +15167,10 @@
       </p:pic>
       <p:sp>
         <p:nvSpPr>
-          <p:cNvPr id="18" name="Text 0"/>
+          <p:cNvPr id="19" name="Text 0"/>
           <p:cNvSpPr txBox="1"/>
           <p:nvPr>
-            <p:ph idx="117" type="body" hasCustomPrompt="1"/>
+            <p:ph idx="118" type="body" hasCustomPrompt="1"/>
           </p:nvPr>
         </p:nvSpPr>
         <p:spPr>
@@ -15079,7 +15322,7 @@
       </p:sp>
       <p:pic>
         <p:nvPicPr>
-          <p:cNvPr id="3" name="Image 0" descr="/var/folders/hm/sgq6d80d0vq133k7n8dc9bnw0000gn/T/maiershirts-Os5V18/ph-foto-1056x840.png">    </p:cNvPr>
+          <p:cNvPr id="3" name="Image 0" descr="/var/folders/hm/sgq6d80d0vq133k7n8dc9bnw0000gn/T/maiershirts-fAJE9f/ph-foto-1056x840.png">    </p:cNvPr>
           <p:cNvPicPr>
             <a:picLocks noChangeAspect="1"/>
           </p:cNvPicPr>
@@ -15891,7 +16134,7 @@
       </p:sp>
       <p:pic>
         <p:nvPicPr>
-          <p:cNvPr id="4" name="Image 0" descr="/var/folders/hm/sgq6d80d0vq133k7n8dc9bnw0000gn/T/maiershirts-Os5V18/ph-portrait-252x252.png">    </p:cNvPr>
+          <p:cNvPr id="4" name="Image 0" descr="/var/folders/hm/sgq6d80d0vq133k7n8dc9bnw0000gn/T/maiershirts-fAJE9f/ph-portrait-252x252.png">    </p:cNvPr>
           <p:cNvPicPr>
             <a:picLocks noChangeAspect="1"/>
           </p:cNvPicPr>
@@ -16100,7 +16343,7 @@
       </p:sp>
       <p:pic>
         <p:nvPicPr>
-          <p:cNvPr id="9" name="Image 1" descr="/var/folders/hm/sgq6d80d0vq133k7n8dc9bnw0000gn/T/maiershirts-Os5V18/ph-qr-240x240.png">    </p:cNvPr>
+          <p:cNvPr id="9" name="Image 1" descr="/var/folders/hm/sgq6d80d0vq133k7n8dc9bnw0000gn/T/maiershirts-fAJE9f/ph-qr-240x240.png">    </p:cNvPr>
           <p:cNvPicPr>
             <a:picLocks noChangeAspect="1"/>
           </p:cNvPicPr>
@@ -17516,7 +17759,7 @@
       </p:grpSpPr>
       <p:pic>
         <p:nvPicPr>
-          <p:cNvPr id="2" name="Image 0" descr="/var/folders/hm/sgq6d80d0vq133k7n8dc9bnw0000gn/T/maiershirts-Os5V18/ph-foto-2400x1008.png">    </p:cNvPr>
+          <p:cNvPr id="2" name="Image 0" descr="/var/folders/hm/sgq6d80d0vq133k7n8dc9bnw0000gn/T/maiershirts-fAJE9f/ph-foto-2400x1008.png">    </p:cNvPr>
           <p:cNvPicPr>
             <a:picLocks noChangeAspect="1"/>
           </p:cNvPicPr>
@@ -18674,7 +18917,7 @@
       </p:sp>
       <p:pic>
         <p:nvPicPr>
-          <p:cNvPr id="3" name="Image 0" descr="/var/folders/hm/sgq6d80d0vq133k7n8dc9bnw0000gn/T/maiershirts-Os5V18/ph-foto-696x456.png">    </p:cNvPr>
+          <p:cNvPr id="3" name="Image 0" descr="/var/folders/hm/sgq6d80d0vq133k7n8dc9bnw0000gn/T/maiershirts-fAJE9f/ph-foto-696x456.png">    </p:cNvPr>
           <p:cNvPicPr>
             <a:picLocks noChangeAspect="1"/>
           </p:cNvPicPr>
@@ -18844,7 +19087,7 @@
       </p:sp>
       <p:pic>
         <p:nvPicPr>
-          <p:cNvPr id="7" name="Image 1" descr="/var/folders/hm/sgq6d80d0vq133k7n8dc9bnw0000gn/T/maiershirts-Os5V18/ph-foto-696x456.png">    </p:cNvPr>
+          <p:cNvPr id="7" name="Image 1" descr="/var/folders/hm/sgq6d80d0vq133k7n8dc9bnw0000gn/T/maiershirts-fAJE9f/ph-foto-696x456.png">    </p:cNvPr>
           <p:cNvPicPr>
             <a:picLocks noChangeAspect="1"/>
           </p:cNvPicPr>
@@ -19014,7 +19257,7 @@
       </p:sp>
       <p:pic>
         <p:nvPicPr>
-          <p:cNvPr id="11" name="Image 2" descr="/var/folders/hm/sgq6d80d0vq133k7n8dc9bnw0000gn/T/maiershirts-Os5V18/ph-foto-696x456.png">    </p:cNvPr>
+          <p:cNvPr id="11" name="Image 2" descr="/var/folders/hm/sgq6d80d0vq133k7n8dc9bnw0000gn/T/maiershirts-fAJE9f/ph-foto-696x456.png">    </p:cNvPr>
           <p:cNvPicPr>
             <a:picLocks noChangeAspect="1"/>
           </p:cNvPicPr>

</xml_diff>